<commit_message>
Policy deck v2: visual data slide, comparables table, early-career margins
The data slide becomes four stat tiles (28 years, 100,000+ adults per
March, 104,545 teachers observed, 51 jurisdictions) over a two-line
plain definition. Adds the comparable-professions composition table
after the professions chart, and a new by-age coefficient plot: the
full specification estimated separately for teachers under 35 and
35-70, where a public-school job retains the young three times more
strongly (-4.5 vs -1.6 points) and the pension margin is also larger.
18 slides.

Co-Authored-By: Claude Fable 5 <noreply@anthropic.com>
Claude-Session: https://claude.ai/code/session_01DNzQPDcr3zfLTraMHUHqUn
</commit_message>
<xml_diff>
--- a/report/data_cluster/Proyect_US_policy.pptx
+++ b/report/data_cluster/Proyect_US_policy.pptx
@@ -21,6 +21,8 @@
     <p:sldId id="269" r:id="rId20"/>
     <p:sldId id="270" r:id="rId21"/>
     <p:sldId id="271" r:id="rId22"/>
+    <p:sldId id="272" r:id="rId23"/>
+    <p:sldId id="273" r:id="rId24"/>
   </p:sldIdLst>
   <p:sldSz cx="12191695" cy="6858000" type="screen4x3"/>
   <p:notesSz cx="6858000" cy="9144000"/>
@@ -3380,7 +3382,7 @@
                 </a:solidFill>
                 <a:latin typeface="Garamond"/>
               </a:rPr>
-              <a:t>Leaving, over the life cycle</a:t>
+              <a:t>And the youngest of them leave to study</a:t>
             </a:r>
           </a:p>
         </p:txBody>
@@ -3422,7 +3424,7 @@
       </p:sp>
       <p:pic>
         <p:nvPicPr>
-          <p:cNvPr id="4" name="Picture 3" descr="u_routes_deck.png"/>
+          <p:cNvPr id="4" name="Picture 3" descr="study_bygroup.png"/>
           <p:cNvPicPr>
             <a:picLocks noChangeAspect="1"/>
           </p:cNvPicPr>
@@ -3436,8 +3438,8 @@
         </p:blipFill>
         <p:spPr>
           <a:xfrm>
-            <a:off x="640080" y="1501140"/>
-            <a:ext cx="10881360" cy="3627120"/>
+            <a:off x="1357685" y="1051560"/>
+            <a:ext cx="9446149" cy="4526280"/>
           </a:xfrm>
           <a:prstGeom prst="rect">
             <a:avLst/>
@@ -3534,7 +3536,7 @@
                 </a:solidFill>
                 <a:latin typeface="Garamond"/>
               </a:rPr>
-              <a:t>Put retention efforts where they can work: the first years of the career (mentoring, stable placements). Retirements can only be planned for, not prevented.</a:t>
+              <a:t>Studying is the exit of the young and the childless, not of the mothers. Among leavers under 30, almost half are enrolled in school.</a:t>
             </a:r>
           </a:p>
         </p:txBody>
@@ -3584,7 +3586,7 @@
                 </a:solidFill>
                 <a:latin typeface="Garamond"/>
               </a:rPr>
-              <a:t>What this says for policy: three margins, quantified</a:t>
+              <a:t>Leaving, over the life cycle</a:t>
             </a:r>
           </a:p>
         </p:txBody>
@@ -3624,16 +3626,84 @@
           </a:p>
         </p:txBody>
       </p:sp>
-      <p:sp>
-        <p:nvSpPr>
-          <p:cNvPr id="4" name="TextBox 3"/>
+      <p:pic>
+        <p:nvPicPr>
+          <p:cNvPr id="4" name="Picture 3" descr="u_routes_deck.png"/>
+          <p:cNvPicPr>
+            <a:picLocks noChangeAspect="1"/>
+          </p:cNvPicPr>
+          <p:nvPr/>
+        </p:nvPicPr>
+        <p:blipFill>
+          <a:blip r:embed="rId2"/>
+          <a:stretch>
+            <a:fillRect/>
+          </a:stretch>
+        </p:blipFill>
+        <p:spPr>
+          <a:xfrm>
+            <a:off x="640080" y="1501140"/>
+            <a:ext cx="10881360" cy="3627120"/>
+          </a:xfrm>
+          <a:prstGeom prst="rect">
+            <a:avLst/>
+          </a:prstGeom>
+        </p:spPr>
+      </p:pic>
+      <p:sp>
+        <p:nvSpPr>
+          <p:cNvPr id="5" name="Rectangle 4"/>
+          <p:cNvSpPr/>
+          <p:nvPr/>
+        </p:nvSpPr>
+        <p:spPr>
+          <a:xfrm>
+            <a:off x="0" y="5559552"/>
+            <a:ext cx="12191695" cy="960120"/>
+          </a:xfrm>
+          <a:prstGeom prst="rect">
+            <a:avLst/>
+          </a:prstGeom>
+          <a:solidFill>
+            <a:srgbClr val="ECF2F9"/>
+          </a:solidFill>
+          <a:ln>
+            <a:noFill/>
+          </a:ln>
+          <a:effectLst/>
+        </p:spPr>
+        <p:style>
+          <a:lnRef idx="1">
+            <a:schemeClr val="accent1"/>
+          </a:lnRef>
+          <a:fillRef idx="3">
+            <a:schemeClr val="accent1"/>
+          </a:fillRef>
+          <a:effectRef idx="2">
+            <a:schemeClr val="accent1"/>
+          </a:effectRef>
+          <a:fontRef idx="minor">
+            <a:schemeClr val="lt1"/>
+          </a:fontRef>
+        </p:style>
+        <p:txBody>
+          <a:bodyPr rtlCol="0" anchor="ctr"/>
+          <a:lstStyle/>
+          <a:p>
+            <a:pPr algn="ctr"/>
+          </a:p>
+        </p:txBody>
+      </p:sp>
+      <p:sp>
+        <p:nvSpPr>
+          <p:cNvPr id="6" name="TextBox 5"/>
           <p:cNvSpPr txBox="1"/>
           <p:nvPr/>
         </p:nvSpPr>
         <p:spPr>
           <a:xfrm>
-            <a:off x="822960" y="1234440"/>
-            <a:ext cx="10789920" cy="457200"/>
+            <a:off x="822960" y="5687568"/>
+            <a:ext cx="10789920" cy="822960"/>
           </a:xfrm>
           <a:prstGeom prst="rect">
             <a:avLst/>
@@ -3648,257 +3718,29 @@
           <a:p>
             <a:pPr algn="l">
               <a:lnSpc>
-                <a:spcPts val="2816"/>
+                <a:spcPts val="2048"/>
               </a:lnSpc>
               <a:spcAft>
                 <a:spcPts val="0"/>
               </a:spcAft>
             </a:pPr>
             <a:r>
-              <a:rPr sz="2200" b="1" i="0">
-                <a:solidFill>
-                  <a:srgbClr val="2D6CB5"/>
-                </a:solidFill>
-                <a:latin typeface="Garamond"/>
-              </a:rPr>
-              <a:t>Retirees </a:t>
-            </a:r>
-            <a:r>
-              <a:rPr sz="1800" b="0" i="0">
-                <a:solidFill>
-                  <a:srgbClr val="6B7480"/>
-                </a:solidFill>
-                <a:latin typeface="Garamond"/>
-              </a:rPr>
-              <a:t>(out of the labor force, over 55)</a:t>
-            </a:r>
-          </a:p>
-        </p:txBody>
-      </p:sp>
-      <p:sp>
-        <p:nvSpPr>
-          <p:cNvPr id="5" name="TextBox 4"/>
-          <p:cNvSpPr txBox="1"/>
-          <p:nvPr/>
-        </p:nvSpPr>
-        <p:spPr>
-          <a:xfrm>
-            <a:off x="822960" y="1737360"/>
-            <a:ext cx="10789920" cy="914400"/>
-          </a:xfrm>
-          <a:prstGeom prst="rect">
-            <a:avLst/>
-          </a:prstGeom>
-          <a:noFill/>
-        </p:spPr>
-        <p:txBody>
-          <a:bodyPr wrap="square" lIns="0" rIns="0" tIns="0" bIns="0">
-            <a:spAutoFit/>
-          </a:bodyPr>
-          <a:lstStyle/>
-          <a:p>
-            <a:pPr algn="l">
-              <a:lnSpc>
-                <a:spcPts val="2432"/>
-              </a:lnSpc>
-              <a:spcAft>
-                <a:spcPts val="0"/>
-              </a:spcAft>
-            </a:pPr>
-            <a:r>
-              <a:rPr sz="1900" b="0" i="0">
+              <a:rPr sz="1600" b="1" i="0">
+                <a:solidFill>
+                  <a:srgbClr val="102D5E"/>
+                </a:solidFill>
+                <a:latin typeface="Garamond"/>
+              </a:rPr>
+              <a:t>Key message.  </a:t>
+            </a:r>
+            <a:r>
+              <a:rPr sz="1600" b="0" i="0">
                 <a:solidFill>
                   <a:srgbClr val="212529"/>
                 </a:solidFill>
                 <a:latin typeface="Garamond"/>
               </a:rPr>
-              <a:t>About 3% of teachers retire each year, a third of all exits. Delaying retirement extends careers but does not reintegrate anyone.</a:t>
-            </a:r>
-          </a:p>
-        </p:txBody>
-      </p:sp>
-      <p:sp>
-        <p:nvSpPr>
-          <p:cNvPr id="6" name="TextBox 5"/>
-          <p:cNvSpPr txBox="1"/>
-          <p:nvPr/>
-        </p:nvSpPr>
-        <p:spPr>
-          <a:xfrm>
-            <a:off x="822960" y="2834640"/>
-            <a:ext cx="10789920" cy="457200"/>
-          </a:xfrm>
-          <a:prstGeom prst="rect">
-            <a:avLst/>
-          </a:prstGeom>
-          <a:noFill/>
-        </p:spPr>
-        <p:txBody>
-          <a:bodyPr wrap="square" lIns="0" rIns="0" tIns="0" bIns="0">
-            <a:spAutoFit/>
-          </a:bodyPr>
-          <a:lstStyle/>
-          <a:p>
-            <a:pPr algn="l">
-              <a:lnSpc>
-                <a:spcPts val="2816"/>
-              </a:lnSpc>
-              <a:spcAft>
-                <a:spcPts val="0"/>
-              </a:spcAft>
-            </a:pPr>
-            <a:r>
-              <a:rPr sz="2200" b="1" i="0">
-                <a:solidFill>
-                  <a:srgbClr val="2D6CB5"/>
-                </a:solidFill>
-                <a:latin typeface="Garamond"/>
-              </a:rPr>
-              <a:t>Switchers </a:t>
-            </a:r>
-            <a:r>
-              <a:rPr sz="1800" b="0" i="0">
-                <a:solidFill>
-                  <a:srgbClr val="6B7480"/>
-                </a:solidFill>
-                <a:latin typeface="Garamond"/>
-              </a:rPr>
-              <a:t>(employed in another job)</a:t>
-            </a:r>
-          </a:p>
-        </p:txBody>
-      </p:sp>
-      <p:sp>
-        <p:nvSpPr>
-          <p:cNvPr id="7" name="TextBox 6"/>
-          <p:cNvSpPr txBox="1"/>
-          <p:nvPr/>
-        </p:nvSpPr>
-        <p:spPr>
-          <a:xfrm>
-            <a:off x="822960" y="3337560"/>
-            <a:ext cx="10789920" cy="914400"/>
-          </a:xfrm>
-          <a:prstGeom prst="rect">
-            <a:avLst/>
-          </a:prstGeom>
-          <a:noFill/>
-        </p:spPr>
-        <p:txBody>
-          <a:bodyPr wrap="square" lIns="0" rIns="0" tIns="0" bIns="0">
-            <a:spAutoFit/>
-          </a:bodyPr>
-          <a:lstStyle/>
-          <a:p>
-            <a:pPr algn="l">
-              <a:lnSpc>
-                <a:spcPts val="2432"/>
-              </a:lnSpc>
-              <a:spcAft>
-                <a:spcPts val="0"/>
-              </a:spcAft>
-            </a:pPr>
-            <a:r>
-              <a:rPr sz="1900" b="0" i="0">
-                <a:solidFill>
-                  <a:srgbClr val="212529"/>
-                </a:solidFill>
-                <a:latin typeface="Garamond"/>
-              </a:rPr>
-              <a:t>About 2% move to another job each year, often to jobs that do not require a degree. A real margin, but shortages cannot be closed through retention alone.</a:t>
-            </a:r>
-          </a:p>
-        </p:txBody>
-      </p:sp>
-      <p:sp>
-        <p:nvSpPr>
-          <p:cNvPr id="8" name="TextBox 7"/>
-          <p:cNvSpPr txBox="1"/>
-          <p:nvPr/>
-        </p:nvSpPr>
-        <p:spPr>
-          <a:xfrm>
-            <a:off x="822960" y="4526280"/>
-            <a:ext cx="10789920" cy="457200"/>
-          </a:xfrm>
-          <a:prstGeom prst="rect">
-            <a:avLst/>
-          </a:prstGeom>
-          <a:noFill/>
-        </p:spPr>
-        <p:txBody>
-          <a:bodyPr wrap="square" lIns="0" rIns="0" tIns="0" bIns="0">
-            <a:spAutoFit/>
-          </a:bodyPr>
-          <a:lstStyle/>
-          <a:p>
-            <a:pPr algn="l">
-              <a:lnSpc>
-                <a:spcPts val="2816"/>
-              </a:lnSpc>
-              <a:spcAft>
-                <a:spcPts val="0"/>
-              </a:spcAft>
-            </a:pPr>
-            <a:r>
-              <a:rPr sz="2200" b="1" i="0">
-                <a:solidFill>
-                  <a:srgbClr val="2D6CB5"/>
-                </a:solidFill>
-                <a:latin typeface="Garamond"/>
-              </a:rPr>
-              <a:t>Early exits </a:t>
-            </a:r>
-            <a:r>
-              <a:rPr sz="1800" b="0" i="0">
-                <a:solidFill>
-                  <a:srgbClr val="6B7480"/>
-                </a:solidFill>
-                <a:latin typeface="Garamond"/>
-              </a:rPr>
-              <a:t>(out of the labor force, under 55)</a:t>
-            </a:r>
-          </a:p>
-        </p:txBody>
-      </p:sp>
-      <p:sp>
-        <p:nvSpPr>
-          <p:cNvPr id="9" name="TextBox 8"/>
-          <p:cNvSpPr txBox="1"/>
-          <p:nvPr/>
-        </p:nvSpPr>
-        <p:spPr>
-          <a:xfrm>
-            <a:off x="822960" y="5029200"/>
-            <a:ext cx="10789920" cy="1097280"/>
-          </a:xfrm>
-          <a:prstGeom prst="rect">
-            <a:avLst/>
-          </a:prstGeom>
-          <a:noFill/>
-        </p:spPr>
-        <p:txBody>
-          <a:bodyPr wrap="square" lIns="0" rIns="0" tIns="0" bIns="0">
-            <a:spAutoFit/>
-          </a:bodyPr>
-          <a:lstStyle/>
-          <a:p>
-            <a:pPr algn="l">
-              <a:lnSpc>
-                <a:spcPts val="2432"/>
-              </a:lnSpc>
-              <a:spcAft>
-                <a:spcPts val="0"/>
-              </a:spcAft>
-            </a:pPr>
-            <a:r>
-              <a:rPr sz="1900" b="0" i="0">
-                <a:solidFill>
-                  <a:srgbClr val="212529"/>
-                </a:solidFill>
-                <a:latin typeface="Garamond"/>
-              </a:rPr>
-              <a:t>About 2% leave the labor force before 55 each year. Most are mothers at home, for whom flexibility may be the missing piece. The young and childless leave to study and need re-entry paths.</a:t>
+              <a:t>Put retention efforts where they can work: the first years of the career (mentoring, stable placements). Retirements can only be planned for, not prevented.</a:t>
             </a:r>
           </a:p>
         </p:txBody>
@@ -3948,7 +3790,7 @@
                 </a:solidFill>
                 <a:latin typeface="Garamond"/>
               </a:rPr>
-              <a:t>What correlates with leaving</a:t>
+              <a:t>What this says for policy: three margins, quantified</a:t>
             </a:r>
           </a:p>
         </p:txBody>
@@ -3988,30 +3830,285 @@
           </a:p>
         </p:txBody>
       </p:sp>
-      <p:pic>
-        <p:nvPicPr>
-          <p:cNvPr id="4" name="Picture 3" descr="ame_ext.png"/>
-          <p:cNvPicPr>
-            <a:picLocks noChangeAspect="1"/>
-          </p:cNvPicPr>
-          <p:nvPr/>
-        </p:nvPicPr>
-        <p:blipFill>
-          <a:blip r:embed="rId2"/>
-          <a:stretch>
-            <a:fillRect/>
-          </a:stretch>
-        </p:blipFill>
-        <p:spPr>
-          <a:xfrm>
-            <a:off x="1587500" y="1024128"/>
-            <a:ext cx="8986520" cy="5577840"/>
-          </a:xfrm>
-          <a:prstGeom prst="rect">
-            <a:avLst/>
-          </a:prstGeom>
-        </p:spPr>
-      </p:pic>
+      <p:sp>
+        <p:nvSpPr>
+          <p:cNvPr id="4" name="TextBox 3"/>
+          <p:cNvSpPr txBox="1"/>
+          <p:nvPr/>
+        </p:nvSpPr>
+        <p:spPr>
+          <a:xfrm>
+            <a:off x="822960" y="1234440"/>
+            <a:ext cx="10789920" cy="457200"/>
+          </a:xfrm>
+          <a:prstGeom prst="rect">
+            <a:avLst/>
+          </a:prstGeom>
+          <a:noFill/>
+        </p:spPr>
+        <p:txBody>
+          <a:bodyPr wrap="square" lIns="0" rIns="0" tIns="0" bIns="0">
+            <a:spAutoFit/>
+          </a:bodyPr>
+          <a:lstStyle/>
+          <a:p>
+            <a:pPr algn="l">
+              <a:lnSpc>
+                <a:spcPts val="2816"/>
+              </a:lnSpc>
+              <a:spcAft>
+                <a:spcPts val="0"/>
+              </a:spcAft>
+            </a:pPr>
+            <a:r>
+              <a:rPr sz="2200" b="1" i="0">
+                <a:solidFill>
+                  <a:srgbClr val="2D6CB5"/>
+                </a:solidFill>
+                <a:latin typeface="Garamond"/>
+              </a:rPr>
+              <a:t>Retirees </a:t>
+            </a:r>
+            <a:r>
+              <a:rPr sz="1800" b="0" i="0">
+                <a:solidFill>
+                  <a:srgbClr val="6B7480"/>
+                </a:solidFill>
+                <a:latin typeface="Garamond"/>
+              </a:rPr>
+              <a:t>(out of the labor force, over 55)</a:t>
+            </a:r>
+          </a:p>
+        </p:txBody>
+      </p:sp>
+      <p:sp>
+        <p:nvSpPr>
+          <p:cNvPr id="5" name="TextBox 4"/>
+          <p:cNvSpPr txBox="1"/>
+          <p:nvPr/>
+        </p:nvSpPr>
+        <p:spPr>
+          <a:xfrm>
+            <a:off x="822960" y="1737360"/>
+            <a:ext cx="10789920" cy="914400"/>
+          </a:xfrm>
+          <a:prstGeom prst="rect">
+            <a:avLst/>
+          </a:prstGeom>
+          <a:noFill/>
+        </p:spPr>
+        <p:txBody>
+          <a:bodyPr wrap="square" lIns="0" rIns="0" tIns="0" bIns="0">
+            <a:spAutoFit/>
+          </a:bodyPr>
+          <a:lstStyle/>
+          <a:p>
+            <a:pPr algn="l">
+              <a:lnSpc>
+                <a:spcPts val="2432"/>
+              </a:lnSpc>
+              <a:spcAft>
+                <a:spcPts val="0"/>
+              </a:spcAft>
+            </a:pPr>
+            <a:r>
+              <a:rPr sz="1900" b="0" i="0">
+                <a:solidFill>
+                  <a:srgbClr val="212529"/>
+                </a:solidFill>
+                <a:latin typeface="Garamond"/>
+              </a:rPr>
+              <a:t>About 3% of teachers retire each year, a third of all exits. Delaying retirement extends careers but does not reintegrate anyone.</a:t>
+            </a:r>
+          </a:p>
+        </p:txBody>
+      </p:sp>
+      <p:sp>
+        <p:nvSpPr>
+          <p:cNvPr id="6" name="TextBox 5"/>
+          <p:cNvSpPr txBox="1"/>
+          <p:nvPr/>
+        </p:nvSpPr>
+        <p:spPr>
+          <a:xfrm>
+            <a:off x="822960" y="2834640"/>
+            <a:ext cx="10789920" cy="457200"/>
+          </a:xfrm>
+          <a:prstGeom prst="rect">
+            <a:avLst/>
+          </a:prstGeom>
+          <a:noFill/>
+        </p:spPr>
+        <p:txBody>
+          <a:bodyPr wrap="square" lIns="0" rIns="0" tIns="0" bIns="0">
+            <a:spAutoFit/>
+          </a:bodyPr>
+          <a:lstStyle/>
+          <a:p>
+            <a:pPr algn="l">
+              <a:lnSpc>
+                <a:spcPts val="2816"/>
+              </a:lnSpc>
+              <a:spcAft>
+                <a:spcPts val="0"/>
+              </a:spcAft>
+            </a:pPr>
+            <a:r>
+              <a:rPr sz="2200" b="1" i="0">
+                <a:solidFill>
+                  <a:srgbClr val="2D6CB5"/>
+                </a:solidFill>
+                <a:latin typeface="Garamond"/>
+              </a:rPr>
+              <a:t>Switchers </a:t>
+            </a:r>
+            <a:r>
+              <a:rPr sz="1800" b="0" i="0">
+                <a:solidFill>
+                  <a:srgbClr val="6B7480"/>
+                </a:solidFill>
+                <a:latin typeface="Garamond"/>
+              </a:rPr>
+              <a:t>(employed in another job)</a:t>
+            </a:r>
+          </a:p>
+        </p:txBody>
+      </p:sp>
+      <p:sp>
+        <p:nvSpPr>
+          <p:cNvPr id="7" name="TextBox 6"/>
+          <p:cNvSpPr txBox="1"/>
+          <p:nvPr/>
+        </p:nvSpPr>
+        <p:spPr>
+          <a:xfrm>
+            <a:off x="822960" y="3337560"/>
+            <a:ext cx="10789920" cy="914400"/>
+          </a:xfrm>
+          <a:prstGeom prst="rect">
+            <a:avLst/>
+          </a:prstGeom>
+          <a:noFill/>
+        </p:spPr>
+        <p:txBody>
+          <a:bodyPr wrap="square" lIns="0" rIns="0" tIns="0" bIns="0">
+            <a:spAutoFit/>
+          </a:bodyPr>
+          <a:lstStyle/>
+          <a:p>
+            <a:pPr algn="l">
+              <a:lnSpc>
+                <a:spcPts val="2432"/>
+              </a:lnSpc>
+              <a:spcAft>
+                <a:spcPts val="0"/>
+              </a:spcAft>
+            </a:pPr>
+            <a:r>
+              <a:rPr sz="1900" b="0" i="0">
+                <a:solidFill>
+                  <a:srgbClr val="212529"/>
+                </a:solidFill>
+                <a:latin typeface="Garamond"/>
+              </a:rPr>
+              <a:t>About 2% move to another job each year, often to jobs that do not require a degree. A real margin, but shortages cannot be closed through retention alone.</a:t>
+            </a:r>
+          </a:p>
+        </p:txBody>
+      </p:sp>
+      <p:sp>
+        <p:nvSpPr>
+          <p:cNvPr id="8" name="TextBox 7"/>
+          <p:cNvSpPr txBox="1"/>
+          <p:nvPr/>
+        </p:nvSpPr>
+        <p:spPr>
+          <a:xfrm>
+            <a:off x="822960" y="4526280"/>
+            <a:ext cx="10789920" cy="457200"/>
+          </a:xfrm>
+          <a:prstGeom prst="rect">
+            <a:avLst/>
+          </a:prstGeom>
+          <a:noFill/>
+        </p:spPr>
+        <p:txBody>
+          <a:bodyPr wrap="square" lIns="0" rIns="0" tIns="0" bIns="0">
+            <a:spAutoFit/>
+          </a:bodyPr>
+          <a:lstStyle/>
+          <a:p>
+            <a:pPr algn="l">
+              <a:lnSpc>
+                <a:spcPts val="2816"/>
+              </a:lnSpc>
+              <a:spcAft>
+                <a:spcPts val="0"/>
+              </a:spcAft>
+            </a:pPr>
+            <a:r>
+              <a:rPr sz="2200" b="1" i="0">
+                <a:solidFill>
+                  <a:srgbClr val="2D6CB5"/>
+                </a:solidFill>
+                <a:latin typeface="Garamond"/>
+              </a:rPr>
+              <a:t>Early exits </a:t>
+            </a:r>
+            <a:r>
+              <a:rPr sz="1800" b="0" i="0">
+                <a:solidFill>
+                  <a:srgbClr val="6B7480"/>
+                </a:solidFill>
+                <a:latin typeface="Garamond"/>
+              </a:rPr>
+              <a:t>(out of the labor force, under 55)</a:t>
+            </a:r>
+          </a:p>
+        </p:txBody>
+      </p:sp>
+      <p:sp>
+        <p:nvSpPr>
+          <p:cNvPr id="9" name="TextBox 8"/>
+          <p:cNvSpPr txBox="1"/>
+          <p:nvPr/>
+        </p:nvSpPr>
+        <p:spPr>
+          <a:xfrm>
+            <a:off x="822960" y="5029200"/>
+            <a:ext cx="10789920" cy="1097280"/>
+          </a:xfrm>
+          <a:prstGeom prst="rect">
+            <a:avLst/>
+          </a:prstGeom>
+          <a:noFill/>
+        </p:spPr>
+        <p:txBody>
+          <a:bodyPr wrap="square" lIns="0" rIns="0" tIns="0" bIns="0">
+            <a:spAutoFit/>
+          </a:bodyPr>
+          <a:lstStyle/>
+          <a:p>
+            <a:pPr algn="l">
+              <a:lnSpc>
+                <a:spcPts val="2432"/>
+              </a:lnSpc>
+              <a:spcAft>
+                <a:spcPts val="0"/>
+              </a:spcAft>
+            </a:pPr>
+            <a:r>
+              <a:rPr sz="1900" b="0" i="0">
+                <a:solidFill>
+                  <a:srgbClr val="212529"/>
+                </a:solidFill>
+                <a:latin typeface="Garamond"/>
+              </a:rPr>
+              <a:t>About 2% leave the labor force before 55 each year. Most are mothers at home, for whom flexibility may be the missing piece. The young and childless leave to study and need re-entry paths.</a:t>
+            </a:r>
+          </a:p>
+        </p:txBody>
+      </p:sp>
     </p:spTree>
   </p:cSld>
   <p:clrMapOvr>
@@ -4057,7 +4154,7 @@
                 </a:solidFill>
                 <a:latin typeface="Garamond"/>
               </a:rPr>
-              <a:t>Relative pay since 1997</a:t>
+              <a:t>What correlates with leaving</a:t>
             </a:r>
           </a:p>
         </p:txBody>
@@ -4099,7 +4196,7 @@
       </p:sp>
       <p:pic>
         <p:nvPicPr>
-          <p:cNvPr id="4" name="Picture 3" descr="msgA3.png"/>
+          <p:cNvPr id="4" name="Picture 3" descr="ame_ext.png"/>
           <p:cNvPicPr>
             <a:picLocks noChangeAspect="1"/>
           </p:cNvPicPr>
@@ -4113,109 +4210,14 @@
         </p:blipFill>
         <p:spPr>
           <a:xfrm>
-            <a:off x="702337" y="1097280"/>
-            <a:ext cx="10756845" cy="4434840"/>
+            <a:off x="1587500" y="1024128"/>
+            <a:ext cx="8986520" cy="5577840"/>
           </a:xfrm>
           <a:prstGeom prst="rect">
             <a:avLst/>
           </a:prstGeom>
         </p:spPr>
       </p:pic>
-      <p:sp>
-        <p:nvSpPr>
-          <p:cNvPr id="5" name="Rectangle 4"/>
-          <p:cNvSpPr/>
-          <p:nvPr/>
-        </p:nvSpPr>
-        <p:spPr>
-          <a:xfrm>
-            <a:off x="0" y="5559552"/>
-            <a:ext cx="12191695" cy="960120"/>
-          </a:xfrm>
-          <a:prstGeom prst="rect">
-            <a:avLst/>
-          </a:prstGeom>
-          <a:solidFill>
-            <a:srgbClr val="ECF2F9"/>
-          </a:solidFill>
-          <a:ln>
-            <a:noFill/>
-          </a:ln>
-          <a:effectLst/>
-        </p:spPr>
-        <p:style>
-          <a:lnRef idx="1">
-            <a:schemeClr val="accent1"/>
-          </a:lnRef>
-          <a:fillRef idx="3">
-            <a:schemeClr val="accent1"/>
-          </a:fillRef>
-          <a:effectRef idx="2">
-            <a:schemeClr val="accent1"/>
-          </a:effectRef>
-          <a:fontRef idx="minor">
-            <a:schemeClr val="lt1"/>
-          </a:fontRef>
-        </p:style>
-        <p:txBody>
-          <a:bodyPr rtlCol="0" anchor="ctr"/>
-          <a:lstStyle/>
-          <a:p>
-            <a:pPr algn="ctr"/>
-          </a:p>
-        </p:txBody>
-      </p:sp>
-      <p:sp>
-        <p:nvSpPr>
-          <p:cNvPr id="6" name="TextBox 5"/>
-          <p:cNvSpPr txBox="1"/>
-          <p:nvPr/>
-        </p:nvSpPr>
-        <p:spPr>
-          <a:xfrm>
-            <a:off x="822960" y="5687568"/>
-            <a:ext cx="10789920" cy="822960"/>
-          </a:xfrm>
-          <a:prstGeom prst="rect">
-            <a:avLst/>
-          </a:prstGeom>
-          <a:noFill/>
-        </p:spPr>
-        <p:txBody>
-          <a:bodyPr wrap="square" lIns="0" rIns="0" tIns="0" bIns="0">
-            <a:spAutoFit/>
-          </a:bodyPr>
-          <a:lstStyle/>
-          <a:p>
-            <a:pPr algn="l">
-              <a:lnSpc>
-                <a:spcPts val="2048"/>
-              </a:lnSpc>
-              <a:spcAft>
-                <a:spcPts val="0"/>
-              </a:spcAft>
-            </a:pPr>
-            <a:r>
-              <a:rPr sz="1600" b="1" i="0">
-                <a:solidFill>
-                  <a:srgbClr val="102D5E"/>
-                </a:solidFill>
-                <a:latin typeface="Garamond"/>
-              </a:rPr>
-              <a:t>Key message.  </a:t>
-            </a:r>
-            <a:r>
-              <a:rPr sz="1600" b="0" i="0">
-                <a:solidFill>
-                  <a:srgbClr val="212529"/>
-                </a:solidFill>
-                <a:latin typeface="Garamond"/>
-              </a:rPr>
-              <a:t>Teacher pay has not grown in 25 years, and neither has it in the closest helping professions. The typical graduate now out-earns a teacher by $30,000 a year.</a:t>
-            </a:r>
-          </a:p>
-        </p:txBody>
-      </p:sp>
     </p:spTree>
   </p:cSld>
   <p:clrMapOvr>
@@ -4261,7 +4263,7 @@
                 </a:solidFill>
                 <a:latin typeface="Garamond"/>
               </a:rPr>
-              <a:t>Leaving, by position in the teacher pay distribution</a:t>
+              <a:t>Early-career teachers respond to different levers</a:t>
             </a:r>
           </a:p>
         </p:txBody>
@@ -4303,7 +4305,7 @@
       </p:sp>
       <p:pic>
         <p:nvPicPr>
-          <p:cNvPr id="4" name="Picture 3" descr="pay3_deciles_deck.png"/>
+          <p:cNvPr id="4" name="Picture 3" descr="ame_byage.png"/>
           <p:cNvPicPr>
             <a:picLocks noChangeAspect="1"/>
           </p:cNvPicPr>
@@ -4317,8 +4319,8 @@
         </p:blipFill>
         <p:spPr>
           <a:xfrm>
-            <a:off x="1645920" y="1097280"/>
-            <a:ext cx="8869680" cy="4434840"/>
+            <a:off x="2216766" y="1005840"/>
+            <a:ext cx="7727986" cy="4663440"/>
           </a:xfrm>
           <a:prstGeom prst="rect">
             <a:avLst/>
@@ -4333,7 +4335,7 @@
         </p:nvSpPr>
         <p:spPr>
           <a:xfrm>
-            <a:off x="0" y="5559552"/>
+            <a:off x="0" y="5769864"/>
             <a:ext cx="12191695" cy="960120"/>
           </a:xfrm>
           <a:prstGeom prst="rect">
@@ -4377,7 +4379,7 @@
         </p:nvSpPr>
         <p:spPr>
           <a:xfrm>
-            <a:off x="822960" y="5687568"/>
+            <a:off x="822960" y="5897880"/>
             <a:ext cx="10789920" cy="822960"/>
           </a:xfrm>
           <a:prstGeom prst="rect">
@@ -4393,14 +4395,14 @@
           <a:p>
             <a:pPr algn="l">
               <a:lnSpc>
-                <a:spcPts val="2048"/>
+                <a:spcPts val="1855"/>
               </a:lnSpc>
               <a:spcAft>
                 <a:spcPts val="0"/>
               </a:spcAft>
             </a:pPr>
             <a:r>
-              <a:rPr sz="1600" b="1" i="0">
+              <a:rPr sz="1450" b="1" i="0">
                 <a:solidFill>
                   <a:srgbClr val="102D5E"/>
                 </a:solidFill>
@@ -4409,13 +4411,13 @@
               <a:t>Key message.  </a:t>
             </a:r>
             <a:r>
-              <a:rPr sz="1600" b="0" i="0">
+              <a:rPr sz="1450" b="0" i="0">
                 <a:solidFill>
                   <a:srgbClr val="212529"/>
                 </a:solidFill>
                 <a:latin typeface="Garamond"/>
               </a:rPr>
-              <a:t>Leaving is concentrated in the bottom two pay deciles, where part-year and part-time contracts live. Above the median, pay barely matters.</a:t>
+              <a:t>For teachers under 35, a public-school job retains three times more strongly than for the rest (−4.5 vs −1.6 points), and a pension plan also retains more. Security keeps the young in the classroom.</a:t>
             </a:r>
           </a:p>
         </p:txBody>
@@ -4465,7 +4467,7 @@
                 </a:solidFill>
                 <a:latin typeface="Garamond"/>
               </a:rPr>
-              <a:t>Pension coverage and leaving, across states</a:t>
+              <a:t>Relative pay since 1997</a:t>
             </a:r>
           </a:p>
         </p:txBody>
@@ -4507,7 +4509,7 @@
       </p:sp>
       <p:pic>
         <p:nvPicPr>
-          <p:cNvPr id="4" name="Picture 3" descr="pension_scatter_deck.png"/>
+          <p:cNvPr id="4" name="Picture 3" descr="msgA3.png"/>
           <p:cNvPicPr>
             <a:picLocks noChangeAspect="1"/>
           </p:cNvPicPr>
@@ -4521,8 +4523,8 @@
         </p:blipFill>
         <p:spPr>
           <a:xfrm>
-            <a:off x="2289687" y="1097280"/>
-            <a:ext cx="7582145" cy="4434840"/>
+            <a:off x="702337" y="1097280"/>
+            <a:ext cx="10756845" cy="4434840"/>
           </a:xfrm>
           <a:prstGeom prst="rect">
             <a:avLst/>
@@ -4619,7 +4621,7 @@
                 </a:solidFill>
                 <a:latin typeface="Garamond"/>
               </a:rPr>
-              <a:t>States where more teachers have a pension plan lose fewer teachers before 55. Economic security retains.</a:t>
+              <a:t>Teacher pay has not grown in 25 years, and neither has it in the closest helping professions. The typical graduate now out-earns a teacher by $30,000 a year.</a:t>
             </a:r>
           </a:p>
         </p:txBody>
@@ -4669,7 +4671,7 @@
                 </a:solidFill>
                 <a:latin typeface="Garamond"/>
               </a:rPr>
-              <a:t>Open questions</a:t>
+              <a:t>Leaving, by position in the teacher pay distribution</a:t>
             </a:r>
           </a:p>
         </p:txBody>
@@ -4705,6 +4707,414 @@
                 <a:latin typeface="Garamond"/>
               </a:rPr>
               <a:t>16</a:t>
+            </a:r>
+          </a:p>
+        </p:txBody>
+      </p:sp>
+      <p:pic>
+        <p:nvPicPr>
+          <p:cNvPr id="4" name="Picture 3" descr="pay3_deciles_deck.png"/>
+          <p:cNvPicPr>
+            <a:picLocks noChangeAspect="1"/>
+          </p:cNvPicPr>
+          <p:nvPr/>
+        </p:nvPicPr>
+        <p:blipFill>
+          <a:blip r:embed="rId2"/>
+          <a:stretch>
+            <a:fillRect/>
+          </a:stretch>
+        </p:blipFill>
+        <p:spPr>
+          <a:xfrm>
+            <a:off x="1645920" y="1097280"/>
+            <a:ext cx="8869680" cy="4434840"/>
+          </a:xfrm>
+          <a:prstGeom prst="rect">
+            <a:avLst/>
+          </a:prstGeom>
+        </p:spPr>
+      </p:pic>
+      <p:sp>
+        <p:nvSpPr>
+          <p:cNvPr id="5" name="Rectangle 4"/>
+          <p:cNvSpPr/>
+          <p:nvPr/>
+        </p:nvSpPr>
+        <p:spPr>
+          <a:xfrm>
+            <a:off x="0" y="5559552"/>
+            <a:ext cx="12191695" cy="960120"/>
+          </a:xfrm>
+          <a:prstGeom prst="rect">
+            <a:avLst/>
+          </a:prstGeom>
+          <a:solidFill>
+            <a:srgbClr val="ECF2F9"/>
+          </a:solidFill>
+          <a:ln>
+            <a:noFill/>
+          </a:ln>
+          <a:effectLst/>
+        </p:spPr>
+        <p:style>
+          <a:lnRef idx="1">
+            <a:schemeClr val="accent1"/>
+          </a:lnRef>
+          <a:fillRef idx="3">
+            <a:schemeClr val="accent1"/>
+          </a:fillRef>
+          <a:effectRef idx="2">
+            <a:schemeClr val="accent1"/>
+          </a:effectRef>
+          <a:fontRef idx="minor">
+            <a:schemeClr val="lt1"/>
+          </a:fontRef>
+        </p:style>
+        <p:txBody>
+          <a:bodyPr rtlCol="0" anchor="ctr"/>
+          <a:lstStyle/>
+          <a:p>
+            <a:pPr algn="ctr"/>
+          </a:p>
+        </p:txBody>
+      </p:sp>
+      <p:sp>
+        <p:nvSpPr>
+          <p:cNvPr id="6" name="TextBox 5"/>
+          <p:cNvSpPr txBox="1"/>
+          <p:nvPr/>
+        </p:nvSpPr>
+        <p:spPr>
+          <a:xfrm>
+            <a:off x="822960" y="5687568"/>
+            <a:ext cx="10789920" cy="822960"/>
+          </a:xfrm>
+          <a:prstGeom prst="rect">
+            <a:avLst/>
+          </a:prstGeom>
+          <a:noFill/>
+        </p:spPr>
+        <p:txBody>
+          <a:bodyPr wrap="square" lIns="0" rIns="0" tIns="0" bIns="0">
+            <a:spAutoFit/>
+          </a:bodyPr>
+          <a:lstStyle/>
+          <a:p>
+            <a:pPr algn="l">
+              <a:lnSpc>
+                <a:spcPts val="2048"/>
+              </a:lnSpc>
+              <a:spcAft>
+                <a:spcPts val="0"/>
+              </a:spcAft>
+            </a:pPr>
+            <a:r>
+              <a:rPr sz="1600" b="1" i="0">
+                <a:solidFill>
+                  <a:srgbClr val="102D5E"/>
+                </a:solidFill>
+                <a:latin typeface="Garamond"/>
+              </a:rPr>
+              <a:t>Key message.  </a:t>
+            </a:r>
+            <a:r>
+              <a:rPr sz="1600" b="0" i="0">
+                <a:solidFill>
+                  <a:srgbClr val="212529"/>
+                </a:solidFill>
+                <a:latin typeface="Garamond"/>
+              </a:rPr>
+              <a:t>Leaving is concentrated in the bottom two pay deciles, where part-year and part-time contracts live. Above the median, pay barely matters.</a:t>
+            </a:r>
+          </a:p>
+        </p:txBody>
+      </p:sp>
+    </p:spTree>
+  </p:cSld>
+  <p:clrMapOvr>
+    <a:masterClrMapping/>
+  </p:clrMapOvr>
+</p:sld>
+</file>
+
+<file path=ppt/slides/slide17.xml><?xml version="1.0" encoding="utf-8"?>
+<p:sld xmlns:a="http://schemas.openxmlformats.org/drawingml/2006/main" xmlns:p="http://schemas.openxmlformats.org/presentationml/2006/main" xmlns:r="http://schemas.openxmlformats.org/officeDocument/2006/relationships">
+  <p:cSld>
+    <p:spTree>
+      <p:nvGrpSpPr>
+        <p:cNvPr id="1" name=""/>
+        <p:cNvGrpSpPr/>
+        <p:nvPr/>
+      </p:nvGrpSpPr>
+      <p:grpSpPr/>
+      <p:sp>
+        <p:nvSpPr>
+          <p:cNvPr id="2" name="TextBox 1"/>
+          <p:cNvSpPr txBox="1"/>
+          <p:nvPr/>
+        </p:nvSpPr>
+        <p:spPr>
+          <a:xfrm>
+            <a:off x="502920" y="219456"/>
+            <a:ext cx="11247120" cy="566928"/>
+          </a:xfrm>
+          <a:prstGeom prst="rect">
+            <a:avLst/>
+          </a:prstGeom>
+          <a:noFill/>
+        </p:spPr>
+        <p:txBody>
+          <a:bodyPr wrap="square" lIns="0" rIns="0" tIns="0" bIns="0"/>
+          <a:lstStyle/>
+          <a:p>
+            <a:r>
+              <a:rPr sz="2800" b="1">
+                <a:solidFill>
+                  <a:srgbClr val="102D5E"/>
+                </a:solidFill>
+                <a:latin typeface="Garamond"/>
+              </a:rPr>
+              <a:t>Pension coverage and leaving, across states</a:t>
+            </a:r>
+          </a:p>
+        </p:txBody>
+      </p:sp>
+      <p:sp>
+        <p:nvSpPr>
+          <p:cNvPr id="3" name="TextBox 2"/>
+          <p:cNvSpPr txBox="1"/>
+          <p:nvPr/>
+        </p:nvSpPr>
+        <p:spPr>
+          <a:xfrm>
+            <a:off x="11384280" y="6446520"/>
+            <a:ext cx="640080" cy="292608"/>
+          </a:xfrm>
+          <a:prstGeom prst="rect">
+            <a:avLst/>
+          </a:prstGeom>
+          <a:noFill/>
+        </p:spPr>
+        <p:txBody>
+          <a:bodyPr wrap="none" lIns="0" rIns="0" tIns="0" bIns="0">
+            <a:spAutoFit/>
+          </a:bodyPr>
+          <a:lstStyle/>
+          <a:p>
+            <a:pPr algn="r"/>
+            <a:r>
+              <a:rPr sz="1100">
+                <a:solidFill>
+                  <a:srgbClr val="6B7480"/>
+                </a:solidFill>
+                <a:latin typeface="Garamond"/>
+              </a:rPr>
+              <a:t>17</a:t>
+            </a:r>
+          </a:p>
+        </p:txBody>
+      </p:sp>
+      <p:pic>
+        <p:nvPicPr>
+          <p:cNvPr id="4" name="Picture 3" descr="pension_scatter_deck.png"/>
+          <p:cNvPicPr>
+            <a:picLocks noChangeAspect="1"/>
+          </p:cNvPicPr>
+          <p:nvPr/>
+        </p:nvPicPr>
+        <p:blipFill>
+          <a:blip r:embed="rId2"/>
+          <a:stretch>
+            <a:fillRect/>
+          </a:stretch>
+        </p:blipFill>
+        <p:spPr>
+          <a:xfrm>
+            <a:off x="2289687" y="1097280"/>
+            <a:ext cx="7582145" cy="4434840"/>
+          </a:xfrm>
+          <a:prstGeom prst="rect">
+            <a:avLst/>
+          </a:prstGeom>
+        </p:spPr>
+      </p:pic>
+      <p:sp>
+        <p:nvSpPr>
+          <p:cNvPr id="5" name="Rectangle 4"/>
+          <p:cNvSpPr/>
+          <p:nvPr/>
+        </p:nvSpPr>
+        <p:spPr>
+          <a:xfrm>
+            <a:off x="0" y="5559552"/>
+            <a:ext cx="12191695" cy="960120"/>
+          </a:xfrm>
+          <a:prstGeom prst="rect">
+            <a:avLst/>
+          </a:prstGeom>
+          <a:solidFill>
+            <a:srgbClr val="ECF2F9"/>
+          </a:solidFill>
+          <a:ln>
+            <a:noFill/>
+          </a:ln>
+          <a:effectLst/>
+        </p:spPr>
+        <p:style>
+          <a:lnRef idx="1">
+            <a:schemeClr val="accent1"/>
+          </a:lnRef>
+          <a:fillRef idx="3">
+            <a:schemeClr val="accent1"/>
+          </a:fillRef>
+          <a:effectRef idx="2">
+            <a:schemeClr val="accent1"/>
+          </a:effectRef>
+          <a:fontRef idx="minor">
+            <a:schemeClr val="lt1"/>
+          </a:fontRef>
+        </p:style>
+        <p:txBody>
+          <a:bodyPr rtlCol="0" anchor="ctr"/>
+          <a:lstStyle/>
+          <a:p>
+            <a:pPr algn="ctr"/>
+          </a:p>
+        </p:txBody>
+      </p:sp>
+      <p:sp>
+        <p:nvSpPr>
+          <p:cNvPr id="6" name="TextBox 5"/>
+          <p:cNvSpPr txBox="1"/>
+          <p:nvPr/>
+        </p:nvSpPr>
+        <p:spPr>
+          <a:xfrm>
+            <a:off x="822960" y="5687568"/>
+            <a:ext cx="10789920" cy="822960"/>
+          </a:xfrm>
+          <a:prstGeom prst="rect">
+            <a:avLst/>
+          </a:prstGeom>
+          <a:noFill/>
+        </p:spPr>
+        <p:txBody>
+          <a:bodyPr wrap="square" lIns="0" rIns="0" tIns="0" bIns="0">
+            <a:spAutoFit/>
+          </a:bodyPr>
+          <a:lstStyle/>
+          <a:p>
+            <a:pPr algn="l">
+              <a:lnSpc>
+                <a:spcPts val="2048"/>
+              </a:lnSpc>
+              <a:spcAft>
+                <a:spcPts val="0"/>
+              </a:spcAft>
+            </a:pPr>
+            <a:r>
+              <a:rPr sz="1600" b="1" i="0">
+                <a:solidFill>
+                  <a:srgbClr val="102D5E"/>
+                </a:solidFill>
+                <a:latin typeface="Garamond"/>
+              </a:rPr>
+              <a:t>Key message.  </a:t>
+            </a:r>
+            <a:r>
+              <a:rPr sz="1600" b="0" i="0">
+                <a:solidFill>
+                  <a:srgbClr val="212529"/>
+                </a:solidFill>
+                <a:latin typeface="Garamond"/>
+              </a:rPr>
+              <a:t>States where more teachers have a pension plan lose fewer teachers before 55. Economic security retains.</a:t>
+            </a:r>
+          </a:p>
+        </p:txBody>
+      </p:sp>
+    </p:spTree>
+  </p:cSld>
+  <p:clrMapOvr>
+    <a:masterClrMapping/>
+  </p:clrMapOvr>
+</p:sld>
+</file>
+
+<file path=ppt/slides/slide18.xml><?xml version="1.0" encoding="utf-8"?>
+<p:sld xmlns:a="http://schemas.openxmlformats.org/drawingml/2006/main" xmlns:p="http://schemas.openxmlformats.org/presentationml/2006/main" xmlns:r="http://schemas.openxmlformats.org/officeDocument/2006/relationships">
+  <p:cSld>
+    <p:spTree>
+      <p:nvGrpSpPr>
+        <p:cNvPr id="1" name=""/>
+        <p:cNvGrpSpPr/>
+        <p:nvPr/>
+      </p:nvGrpSpPr>
+      <p:grpSpPr/>
+      <p:sp>
+        <p:nvSpPr>
+          <p:cNvPr id="2" name="TextBox 1"/>
+          <p:cNvSpPr txBox="1"/>
+          <p:nvPr/>
+        </p:nvSpPr>
+        <p:spPr>
+          <a:xfrm>
+            <a:off x="502920" y="219456"/>
+            <a:ext cx="11247120" cy="566928"/>
+          </a:xfrm>
+          <a:prstGeom prst="rect">
+            <a:avLst/>
+          </a:prstGeom>
+          <a:noFill/>
+        </p:spPr>
+        <p:txBody>
+          <a:bodyPr wrap="square" lIns="0" rIns="0" tIns="0" bIns="0"/>
+          <a:lstStyle/>
+          <a:p>
+            <a:r>
+              <a:rPr sz="2800" b="1">
+                <a:solidFill>
+                  <a:srgbClr val="102D5E"/>
+                </a:solidFill>
+                <a:latin typeface="Garamond"/>
+              </a:rPr>
+              <a:t>Open questions</a:t>
+            </a:r>
+          </a:p>
+        </p:txBody>
+      </p:sp>
+      <p:sp>
+        <p:nvSpPr>
+          <p:cNvPr id="3" name="TextBox 2"/>
+          <p:cNvSpPr txBox="1"/>
+          <p:nvPr/>
+        </p:nvSpPr>
+        <p:spPr>
+          <a:xfrm>
+            <a:off x="11384280" y="6446520"/>
+            <a:ext cx="640080" cy="292608"/>
+          </a:xfrm>
+          <a:prstGeom prst="rect">
+            <a:avLst/>
+          </a:prstGeom>
+          <a:noFill/>
+        </p:spPr>
+        <p:txBody>
+          <a:bodyPr wrap="none" lIns="0" rIns="0" tIns="0" bIns="0">
+            <a:spAutoFit/>
+          </a:bodyPr>
+          <a:lstStyle/>
+          <a:p>
+            <a:pPr algn="r"/>
+            <a:r>
+              <a:rPr sz="1100">
+                <a:solidFill>
+                  <a:srgbClr val="6B7480"/>
+                </a:solidFill>
+                <a:latin typeface="Garamond"/>
+              </a:rPr>
+              <a:t>18</a:t>
             </a:r>
           </a:p>
         </p:txBody>
@@ -5331,14 +5741,354 @@
       </p:sp>
       <p:sp>
         <p:nvSpPr>
-          <p:cNvPr id="4" name="TextBox 3"/>
+          <p:cNvPr id="4" name="Rounded Rectangle 3"/>
+          <p:cNvSpPr/>
+          <p:nvPr/>
+        </p:nvSpPr>
+        <p:spPr>
+          <a:xfrm>
+            <a:off x="667512" y="1554480"/>
+            <a:ext cx="2670048" cy="2148840"/>
+          </a:xfrm>
+          <a:prstGeom prst="roundRect">
+            <a:avLst/>
+          </a:prstGeom>
+          <a:solidFill>
+            <a:srgbClr val="ECF2F9"/>
+          </a:solidFill>
+          <a:ln>
+            <a:noFill/>
+          </a:ln>
+          <a:effectLst/>
+        </p:spPr>
+        <p:style>
+          <a:lnRef idx="1">
+            <a:schemeClr val="accent1"/>
+          </a:lnRef>
+          <a:fillRef idx="3">
+            <a:schemeClr val="accent1"/>
+          </a:fillRef>
+          <a:effectRef idx="2">
+            <a:schemeClr val="accent1"/>
+          </a:effectRef>
+          <a:fontRef idx="minor">
+            <a:schemeClr val="lt1"/>
+          </a:fontRef>
+        </p:style>
+        <p:txBody>
+          <a:bodyPr rtlCol="0" anchor="ctr" wrap="square" lIns="73152" rIns="73152" tIns="274320" bIns="0"/>
+          <a:lstStyle/>
+          <a:p>
+            <a:pPr algn="ctr"/>
+            <a:r>
+              <a:rPr sz="4400" b="1">
+                <a:solidFill>
+                  <a:srgbClr val="102D5E"/>
+                </a:solidFill>
+                <a:latin typeface="Garamond"/>
+              </a:rPr>
+              <a:t>28</a:t>
+            </a:r>
+          </a:p>
+          <a:p>
+            <a:pPr algn="ctr">
+              <a:spcBef>
+                <a:spcPts val="1000"/>
+              </a:spcBef>
+            </a:pPr>
+            <a:r>
+              <a:rPr sz="1450">
+                <a:solidFill>
+                  <a:srgbClr val="212529"/>
+                </a:solidFill>
+                <a:latin typeface="Garamond"/>
+              </a:rPr>
+              <a:t>consecutive years</a:t>
+            </a:r>
+          </a:p>
+          <a:p>
+            <a:pPr algn="ctr">
+              <a:spcBef>
+                <a:spcPts val="0"/>
+              </a:spcBef>
+            </a:pPr>
+            <a:r>
+              <a:rPr sz="1450">
+                <a:solidFill>
+                  <a:srgbClr val="212529"/>
+                </a:solidFill>
+                <a:latin typeface="Garamond"/>
+              </a:rPr>
+              <a:t>(1998–2025)</a:t>
+            </a:r>
+          </a:p>
+        </p:txBody>
+      </p:sp>
+      <p:sp>
+        <p:nvSpPr>
+          <p:cNvPr id="5" name="Rounded Rectangle 4"/>
+          <p:cNvSpPr/>
+          <p:nvPr/>
+        </p:nvSpPr>
+        <p:spPr>
+          <a:xfrm>
+            <a:off x="3465576" y="1554480"/>
+            <a:ext cx="2670048" cy="2148840"/>
+          </a:xfrm>
+          <a:prstGeom prst="roundRect">
+            <a:avLst/>
+          </a:prstGeom>
+          <a:solidFill>
+            <a:srgbClr val="ECF2F9"/>
+          </a:solidFill>
+          <a:ln>
+            <a:noFill/>
+          </a:ln>
+          <a:effectLst/>
+        </p:spPr>
+        <p:style>
+          <a:lnRef idx="1">
+            <a:schemeClr val="accent1"/>
+          </a:lnRef>
+          <a:fillRef idx="3">
+            <a:schemeClr val="accent1"/>
+          </a:fillRef>
+          <a:effectRef idx="2">
+            <a:schemeClr val="accent1"/>
+          </a:effectRef>
+          <a:fontRef idx="minor">
+            <a:schemeClr val="lt1"/>
+          </a:fontRef>
+        </p:style>
+        <p:txBody>
+          <a:bodyPr rtlCol="0" anchor="ctr" wrap="square" lIns="73152" rIns="73152" tIns="384048" bIns="0"/>
+          <a:lstStyle/>
+          <a:p>
+            <a:pPr algn="ctr"/>
+            <a:r>
+              <a:rPr sz="3000" b="1">
+                <a:solidFill>
+                  <a:srgbClr val="102D5E"/>
+                </a:solidFill>
+                <a:latin typeface="Garamond"/>
+              </a:rPr>
+              <a:t>100,000+</a:t>
+            </a:r>
+          </a:p>
+          <a:p>
+            <a:pPr algn="ctr">
+              <a:spcBef>
+                <a:spcPts val="1000"/>
+              </a:spcBef>
+            </a:pPr>
+            <a:r>
+              <a:rPr sz="1450">
+                <a:solidFill>
+                  <a:srgbClr val="212529"/>
+                </a:solidFill>
+                <a:latin typeface="Garamond"/>
+              </a:rPr>
+              <a:t>adults interviewed</a:t>
+            </a:r>
+          </a:p>
+          <a:p>
+            <a:pPr algn="ctr">
+              <a:spcBef>
+                <a:spcPts val="0"/>
+              </a:spcBef>
+            </a:pPr>
+            <a:r>
+              <a:rPr sz="1450">
+                <a:solidFill>
+                  <a:srgbClr val="212529"/>
+                </a:solidFill>
+                <a:latin typeface="Garamond"/>
+              </a:rPr>
+              <a:t>every March</a:t>
+            </a:r>
+          </a:p>
+        </p:txBody>
+      </p:sp>
+      <p:sp>
+        <p:nvSpPr>
+          <p:cNvPr id="6" name="Rounded Rectangle 5"/>
+          <p:cNvSpPr/>
+          <p:nvPr/>
+        </p:nvSpPr>
+        <p:spPr>
+          <a:xfrm>
+            <a:off x="6263640" y="1554480"/>
+            <a:ext cx="2670048" cy="2148840"/>
+          </a:xfrm>
+          <a:prstGeom prst="roundRect">
+            <a:avLst/>
+          </a:prstGeom>
+          <a:solidFill>
+            <a:srgbClr val="ECF2F9"/>
+          </a:solidFill>
+          <a:ln>
+            <a:noFill/>
+          </a:ln>
+          <a:effectLst/>
+        </p:spPr>
+        <p:style>
+          <a:lnRef idx="1">
+            <a:schemeClr val="accent1"/>
+          </a:lnRef>
+          <a:fillRef idx="3">
+            <a:schemeClr val="accent1"/>
+          </a:fillRef>
+          <a:effectRef idx="2">
+            <a:schemeClr val="accent1"/>
+          </a:effectRef>
+          <a:fontRef idx="minor">
+            <a:schemeClr val="lt1"/>
+          </a:fontRef>
+        </p:style>
+        <p:txBody>
+          <a:bodyPr rtlCol="0" anchor="ctr" wrap="square" lIns="73152" rIns="73152" tIns="384048" bIns="0"/>
+          <a:lstStyle/>
+          <a:p>
+            <a:pPr algn="ctr"/>
+            <a:r>
+              <a:rPr sz="3000" b="1">
+                <a:solidFill>
+                  <a:srgbClr val="102D5E"/>
+                </a:solidFill>
+                <a:latin typeface="Garamond"/>
+              </a:rPr>
+              <a:t>104,545</a:t>
+            </a:r>
+          </a:p>
+          <a:p>
+            <a:pPr algn="ctr">
+              <a:spcBef>
+                <a:spcPts val="1000"/>
+              </a:spcBef>
+            </a:pPr>
+            <a:r>
+              <a:rPr sz="1450">
+                <a:solidFill>
+                  <a:srgbClr val="212529"/>
+                </a:solidFill>
+                <a:latin typeface="Garamond"/>
+              </a:rPr>
+              <a:t>teachers observed</a:t>
+            </a:r>
+          </a:p>
+          <a:p>
+            <a:pPr algn="ctr">
+              <a:spcBef>
+                <a:spcPts val="0"/>
+              </a:spcBef>
+            </a:pPr>
+            <a:r>
+              <a:rPr sz="1450">
+                <a:solidFill>
+                  <a:srgbClr val="212529"/>
+                </a:solidFill>
+                <a:latin typeface="Garamond"/>
+              </a:rPr>
+              <a:t>over the period</a:t>
+            </a:r>
+          </a:p>
+        </p:txBody>
+      </p:sp>
+      <p:sp>
+        <p:nvSpPr>
+          <p:cNvPr id="7" name="Rounded Rectangle 6"/>
+          <p:cNvSpPr/>
+          <p:nvPr/>
+        </p:nvSpPr>
+        <p:spPr>
+          <a:xfrm>
+            <a:off x="9061704" y="1554480"/>
+            <a:ext cx="2670048" cy="2148840"/>
+          </a:xfrm>
+          <a:prstGeom prst="roundRect">
+            <a:avLst/>
+          </a:prstGeom>
+          <a:solidFill>
+            <a:srgbClr val="ECF2F9"/>
+          </a:solidFill>
+          <a:ln>
+            <a:noFill/>
+          </a:ln>
+          <a:effectLst/>
+        </p:spPr>
+        <p:style>
+          <a:lnRef idx="1">
+            <a:schemeClr val="accent1"/>
+          </a:lnRef>
+          <a:fillRef idx="3">
+            <a:schemeClr val="accent1"/>
+          </a:fillRef>
+          <a:effectRef idx="2">
+            <a:schemeClr val="accent1"/>
+          </a:effectRef>
+          <a:fontRef idx="minor">
+            <a:schemeClr val="lt1"/>
+          </a:fontRef>
+        </p:style>
+        <p:txBody>
+          <a:bodyPr rtlCol="0" anchor="ctr" wrap="square" lIns="73152" rIns="73152" tIns="274320" bIns="0"/>
+          <a:lstStyle/>
+          <a:p>
+            <a:pPr algn="ctr"/>
+            <a:r>
+              <a:rPr sz="4400" b="1">
+                <a:solidFill>
+                  <a:srgbClr val="102D5E"/>
+                </a:solidFill>
+                <a:latin typeface="Garamond"/>
+              </a:rPr>
+              <a:t>51</a:t>
+            </a:r>
+          </a:p>
+          <a:p>
+            <a:pPr algn="ctr">
+              <a:spcBef>
+                <a:spcPts val="1000"/>
+              </a:spcBef>
+            </a:pPr>
+            <a:r>
+              <a:rPr sz="1450">
+                <a:solidFill>
+                  <a:srgbClr val="212529"/>
+                </a:solidFill>
+                <a:latin typeface="Garamond"/>
+              </a:rPr>
+              <a:t>states, including the</a:t>
+            </a:r>
+          </a:p>
+          <a:p>
+            <a:pPr algn="ctr">
+              <a:spcBef>
+                <a:spcPts val="0"/>
+              </a:spcBef>
+            </a:pPr>
+            <a:r>
+              <a:rPr sz="1450">
+                <a:solidFill>
+                  <a:srgbClr val="212529"/>
+                </a:solidFill>
+                <a:latin typeface="Garamond"/>
+              </a:rPr>
+              <a:t>District of Columbia</a:t>
+            </a:r>
+          </a:p>
+        </p:txBody>
+      </p:sp>
+      <p:sp>
+        <p:nvSpPr>
+          <p:cNvPr id="8" name="TextBox 7"/>
           <p:cNvSpPr txBox="1"/>
           <p:nvPr/>
         </p:nvSpPr>
         <p:spPr>
           <a:xfrm>
-            <a:off x="822960" y="2011680"/>
-            <a:ext cx="10789920" cy="5120640"/>
+            <a:off x="822960" y="4343400"/>
+            <a:ext cx="10789920" cy="1097280"/>
           </a:xfrm>
           <a:prstGeom prst="rect">
             <a:avLst/>
@@ -5353,154 +6103,66 @@
           <a:p>
             <a:pPr algn="l">
               <a:lnSpc>
-                <a:spcPts val="2816"/>
+                <a:spcPts val="2560"/>
               </a:lnSpc>
               <a:spcAft>
-                <a:spcPts val="3400"/>
+                <a:spcPts val="1000"/>
               </a:spcAft>
             </a:pPr>
             <a:r>
-              <a:rPr sz="2200" b="1" i="0">
-                <a:solidFill>
-                  <a:srgbClr val="2D6CB5"/>
-                </a:solidFill>
-                <a:latin typeface="Garamond"/>
-              </a:rPr>
-              <a:t>▪  </a:t>
-            </a:r>
-            <a:r>
-              <a:rPr sz="2200" b="1" i="0">
-                <a:solidFill>
-                  <a:srgbClr val="102D5E"/>
-                </a:solidFill>
-                <a:latin typeface="Garamond"/>
-              </a:rPr>
-              <a:t>One source.  </a:t>
-            </a:r>
-            <a:r>
-              <a:rPr sz="2200" b="0" i="0">
+              <a:rPr sz="2000" b="0" i="0">
                 <a:solidFill>
                   <a:srgbClr val="212529"/>
                 </a:solidFill>
                 <a:latin typeface="Garamond"/>
               </a:rPr>
-              <a:t>The Census Bureau's household survey (the CPS), which records every worker's occupation each year.</a:t>
+              <a:t>Every March, the Census Bureau asks each adult about last year: the main job held, weeks worked, earnings and benefits.</a:t>
             </a:r>
           </a:p>
           <a:p>
             <a:pPr algn="l">
               <a:lnSpc>
-                <a:spcPts val="2816"/>
-              </a:lnSpc>
-              <a:spcAft>
-                <a:spcPts val="3400"/>
-              </a:spcAft>
-            </a:pPr>
-            <a:r>
-              <a:rPr sz="2200" b="1" i="0">
-                <a:solidFill>
-                  <a:srgbClr val="2D6CB5"/>
-                </a:solidFill>
-                <a:latin typeface="Garamond"/>
-              </a:rPr>
-              <a:t>▪  </a:t>
-            </a:r>
-            <a:r>
-              <a:rPr sz="2200" b="1" i="0">
-                <a:solidFill>
-                  <a:srgbClr val="102D5E"/>
-                </a:solidFill>
-                <a:latin typeface="Garamond"/>
-              </a:rPr>
-              <a:t>One definition.  </a:t>
-            </a:r>
-            <a:r>
-              <a:rPr sz="2200" b="0" i="0">
-                <a:solidFill>
-                  <a:srgbClr val="212529"/>
-                </a:solidFill>
-                <a:latin typeface="Garamond"/>
-              </a:rPr>
-              <a:t>A teacher is anyone whose main job last year was school teaching; a leaver is a teacher no longer teaching a year later.</a:t>
-            </a:r>
-          </a:p>
-          <a:p>
-            <a:pPr algn="l">
-              <a:lnSpc>
-                <a:spcPts val="2816"/>
+                <a:spcPts val="2560"/>
               </a:lnSpc>
               <a:spcAft>
                 <a:spcPts val="0"/>
               </a:spcAft>
             </a:pPr>
             <a:r>
-              <a:rPr sz="2200" b="1" i="0">
-                <a:solidFill>
-                  <a:srgbClr val="2D6CB5"/>
-                </a:solidFill>
-                <a:latin typeface="Garamond"/>
-              </a:rPr>
-              <a:t>▪  </a:t>
-            </a:r>
-            <a:r>
-              <a:rPr sz="2200" b="1" i="0">
+              <a:rPr sz="2000" b="1" i="0">
                 <a:solidFill>
                   <a:srgbClr val="102D5E"/>
                 </a:solidFill>
                 <a:latin typeface="Garamond"/>
               </a:rPr>
-              <a:t>One series.  </a:t>
-            </a:r>
-            <a:r>
-              <a:rPr sz="2200" b="0" i="0">
+              <a:t>A teacher</a:t>
+            </a:r>
+            <a:r>
+              <a:rPr sz="2000" b="0" i="0">
                 <a:solidFill>
                   <a:srgbClr val="212529"/>
                 </a:solidFill>
                 <a:latin typeface="Garamond"/>
               </a:rPr>
-              <a:t>Twenty-eight consecutive years (1998–2025), matching the official benchmark where it exists and filling the years in between.</a:t>
-            </a:r>
-          </a:p>
-        </p:txBody>
-      </p:sp>
-      <p:sp>
-        <p:nvSpPr>
-          <p:cNvPr id="5" name="TextBox 4"/>
-          <p:cNvSpPr txBox="1"/>
-          <p:nvPr/>
-        </p:nvSpPr>
-        <p:spPr>
-          <a:xfrm>
-            <a:off x="822960" y="5760720"/>
-            <a:ext cx="10789920" cy="548640"/>
-          </a:xfrm>
-          <a:prstGeom prst="rect">
-            <a:avLst/>
-          </a:prstGeom>
-          <a:noFill/>
-        </p:spPr>
-        <p:txBody>
-          <a:bodyPr wrap="square" lIns="0" rIns="0" tIns="0" bIns="0">
-            <a:spAutoFit/>
-          </a:bodyPr>
-          <a:lstStyle/>
-          <a:p>
-            <a:pPr algn="l">
-              <a:lnSpc>
-                <a:spcPts val="1792"/>
-              </a:lnSpc>
-              <a:spcAft>
-                <a:spcPts val="0"/>
-              </a:spcAft>
-            </a:pPr>
-            <a:r>
-              <a:rPr sz="1400" b="0" i="1">
-                <a:solidFill>
-                  <a:srgbClr val="6B7480"/>
-                </a:solidFill>
-                <a:latin typeface="Garamond"/>
-              </a:rPr>
-              <a:t>The methodological detail is in the appendix of the long deck and in the paper.</a:t>
+              <a:t> taught as last year's main job. </a:t>
+            </a:r>
+            <a:r>
+              <a:rPr sz="2000" b="1" i="0">
+                <a:solidFill>
+                  <a:srgbClr val="102D5E"/>
+                </a:solidFill>
+                <a:latin typeface="Garamond"/>
+              </a:rPr>
+              <a:t>A leaver</a:t>
+            </a:r>
+            <a:r>
+              <a:rPr sz="2000" b="0" i="0">
+                <a:solidFill>
+                  <a:srgbClr val="212529"/>
+                </a:solidFill>
+                <a:latin typeface="Garamond"/>
+              </a:rPr>
+              <a:t> is a teacher no longer teaching this March.</a:t>
             </a:r>
           </a:p>
         </p:txBody>
@@ -5958,7 +6620,7 @@
                 </a:solidFill>
                 <a:latin typeface="Garamond"/>
               </a:rPr>
-              <a:t>Of every 100 leavers (average, 2020–2024)</a:t>
+              <a:t>Who we compare teachers with</a:t>
             </a:r>
           </a:p>
         </p:txBody>
@@ -6000,7 +6662,7 @@
       </p:sp>
       <p:pic>
         <p:nvPicPr>
-          <p:cNvPr id="4" name="Picture 3" descr="flow_employed_5yr.png"/>
+          <p:cNvPr id="4" name="Picture 3" descr="comparables_table.png"/>
           <p:cNvPicPr>
             <a:picLocks noChangeAspect="1"/>
           </p:cNvPicPr>
@@ -6014,109 +6676,14 @@
         </p:blipFill>
         <p:spPr>
           <a:xfrm>
-            <a:off x="1357685" y="1051560"/>
-            <a:ext cx="9446149" cy="4526280"/>
+            <a:off x="1463040" y="1541387"/>
+            <a:ext cx="9235440" cy="4323865"/>
           </a:xfrm>
           <a:prstGeom prst="rect">
             <a:avLst/>
           </a:prstGeom>
         </p:spPr>
       </p:pic>
-      <p:sp>
-        <p:nvSpPr>
-          <p:cNvPr id="5" name="Rectangle 4"/>
-          <p:cNvSpPr/>
-          <p:nvPr/>
-        </p:nvSpPr>
-        <p:spPr>
-          <a:xfrm>
-            <a:off x="0" y="5559552"/>
-            <a:ext cx="12191695" cy="960120"/>
-          </a:xfrm>
-          <a:prstGeom prst="rect">
-            <a:avLst/>
-          </a:prstGeom>
-          <a:solidFill>
-            <a:srgbClr val="ECF2F9"/>
-          </a:solidFill>
-          <a:ln>
-            <a:noFill/>
-          </a:ln>
-          <a:effectLst/>
-        </p:spPr>
-        <p:style>
-          <a:lnRef idx="1">
-            <a:schemeClr val="accent1"/>
-          </a:lnRef>
-          <a:fillRef idx="3">
-            <a:schemeClr val="accent1"/>
-          </a:fillRef>
-          <a:effectRef idx="2">
-            <a:schemeClr val="accent1"/>
-          </a:effectRef>
-          <a:fontRef idx="minor">
-            <a:schemeClr val="lt1"/>
-          </a:fontRef>
-        </p:style>
-        <p:txBody>
-          <a:bodyPr rtlCol="0" anchor="ctr"/>
-          <a:lstStyle/>
-          <a:p>
-            <a:pPr algn="ctr"/>
-          </a:p>
-        </p:txBody>
-      </p:sp>
-      <p:sp>
-        <p:nvSpPr>
-          <p:cNvPr id="6" name="TextBox 5"/>
-          <p:cNvSpPr txBox="1"/>
-          <p:nvPr/>
-        </p:nvSpPr>
-        <p:spPr>
-          <a:xfrm>
-            <a:off x="822960" y="5687568"/>
-            <a:ext cx="10789920" cy="822960"/>
-          </a:xfrm>
-          <a:prstGeom prst="rect">
-            <a:avLst/>
-          </a:prstGeom>
-          <a:noFill/>
-        </p:spPr>
-        <p:txBody>
-          <a:bodyPr wrap="square" lIns="0" rIns="0" tIns="0" bIns="0">
-            <a:spAutoFit/>
-          </a:bodyPr>
-          <a:lstStyle/>
-          <a:p>
-            <a:pPr algn="l">
-              <a:lnSpc>
-                <a:spcPts val="2048"/>
-              </a:lnSpc>
-              <a:spcAft>
-                <a:spcPts val="0"/>
-              </a:spcAft>
-            </a:pPr>
-            <a:r>
-              <a:rPr sz="1600" b="1" i="0">
-                <a:solidFill>
-                  <a:srgbClr val="102D5E"/>
-                </a:solidFill>
-                <a:latin typeface="Garamond"/>
-              </a:rPr>
-              <a:t>Key message.  </a:t>
-            </a:r>
-            <a:r>
-              <a:rPr sz="1600" b="0" i="0">
-                <a:solidFill>
-                  <a:srgbClr val="212529"/>
-                </a:solidFill>
-                <a:latin typeface="Garamond"/>
-              </a:rPr>
-              <a:t>Teachers are not being poached: 7 of every 10 leavers exit employment altogether — to retirement, home or unemployment. Only 3 in 10 trade teaching for another job.</a:t>
-            </a:r>
-          </a:p>
-        </p:txBody>
-      </p:sp>
     </p:spTree>
   </p:cSld>
   <p:clrMapOvr>
@@ -6162,7 +6729,7 @@
                 </a:solidFill>
                 <a:latin typeface="Garamond"/>
               </a:rPr>
-              <a:t>Where the employed leavers go</a:t>
+              <a:t>Of every 100 leavers (average, 2020–2024)</a:t>
             </a:r>
           </a:p>
         </p:txBody>
@@ -6204,7 +6771,7 @@
       </p:sp>
       <p:pic>
         <p:nvPicPr>
-          <p:cNvPr id="4" name="Picture 3" descr="occ_all_slide.png"/>
+          <p:cNvPr id="4" name="Picture 3" descr="flow_employed_5yr.png"/>
           <p:cNvPicPr>
             <a:picLocks noChangeAspect="1"/>
           </p:cNvPicPr>
@@ -6218,8 +6785,8 @@
         </p:blipFill>
         <p:spPr>
           <a:xfrm>
-            <a:off x="775562" y="1024128"/>
-            <a:ext cx="10610395" cy="4663440"/>
+            <a:off x="1357685" y="1051560"/>
+            <a:ext cx="9446149" cy="4526280"/>
           </a:xfrm>
           <a:prstGeom prst="rect">
             <a:avLst/>
@@ -6234,7 +6801,7 @@
         </p:nvSpPr>
         <p:spPr>
           <a:xfrm>
-            <a:off x="0" y="5632704"/>
+            <a:off x="0" y="5559552"/>
             <a:ext cx="12191695" cy="960120"/>
           </a:xfrm>
           <a:prstGeom prst="rect">
@@ -6278,7 +6845,7 @@
         </p:nvSpPr>
         <p:spPr>
           <a:xfrm>
-            <a:off x="822960" y="5760720"/>
+            <a:off x="822960" y="5687568"/>
             <a:ext cx="10789920" cy="822960"/>
           </a:xfrm>
           <a:prstGeom prst="rect">
@@ -6294,14 +6861,14 @@
           <a:p>
             <a:pPr algn="l">
               <a:lnSpc>
-                <a:spcPts val="1855"/>
+                <a:spcPts val="2048"/>
               </a:lnSpc>
               <a:spcAft>
                 <a:spcPts val="0"/>
               </a:spcAft>
             </a:pPr>
             <a:r>
-              <a:rPr sz="1450" b="1" i="0">
+              <a:rPr sz="1600" b="1" i="0">
                 <a:solidFill>
                   <a:srgbClr val="102D5E"/>
                 </a:solidFill>
@@ -6310,13 +6877,13 @@
               <a:t>Key message.  </a:t>
             </a:r>
             <a:r>
-              <a:rPr sz="1450" b="0" i="0">
+              <a:rPr sz="1600" b="0" i="0">
                 <a:solidFill>
                   <a:srgbClr val="212529"/>
                 </a:solidFill>
                 <a:latin typeface="Garamond"/>
               </a:rPr>
-              <a:t>More than a third of the employed leavers move to occupations where most workers hold no college degree (in red). Leaving teaching usually means leaving the profession, not moving up.</a:t>
+              <a:t>Teachers are not being poached: 7 of every 10 leavers exit employment altogether — to retirement, home or unemployment. Only 3 in 10 trade teaching for another job.</a:t>
             </a:r>
           </a:p>
         </p:txBody>
@@ -6366,7 +6933,7 @@
                 </a:solidFill>
                 <a:latin typeface="Garamond"/>
               </a:rPr>
-              <a:t>Who leaves the labor force before 55 (average, 2020–2024)</a:t>
+              <a:t>Where the employed leavers go</a:t>
             </a:r>
           </a:p>
         </p:txBody>
@@ -6408,7 +6975,7 @@
       </p:sp>
       <p:pic>
         <p:nvPicPr>
-          <p:cNvPr id="4" name="Picture 3" descr="flow_olf55_5yr.png"/>
+          <p:cNvPr id="4" name="Picture 3" descr="occ_all_slide.png"/>
           <p:cNvPicPr>
             <a:picLocks noChangeAspect="1"/>
           </p:cNvPicPr>
@@ -6422,8 +6989,8 @@
         </p:blipFill>
         <p:spPr>
           <a:xfrm>
-            <a:off x="1357685" y="1051560"/>
-            <a:ext cx="9446149" cy="4526280"/>
+            <a:off x="775562" y="1024128"/>
+            <a:ext cx="10610395" cy="4663440"/>
           </a:xfrm>
           <a:prstGeom prst="rect">
             <a:avLst/>
@@ -6438,7 +7005,7 @@
         </p:nvSpPr>
         <p:spPr>
           <a:xfrm>
-            <a:off x="0" y="5559552"/>
+            <a:off x="0" y="5632704"/>
             <a:ext cx="12191695" cy="960120"/>
           </a:xfrm>
           <a:prstGeom prst="rect">
@@ -6482,7 +7049,7 @@
         </p:nvSpPr>
         <p:spPr>
           <a:xfrm>
-            <a:off x="822960" y="5687568"/>
+            <a:off x="822960" y="5760720"/>
             <a:ext cx="10789920" cy="822960"/>
           </a:xfrm>
           <a:prstGeom prst="rect">
@@ -6498,14 +7065,14 @@
           <a:p>
             <a:pPr algn="l">
               <a:lnSpc>
-                <a:spcPts val="2048"/>
+                <a:spcPts val="1855"/>
               </a:lnSpc>
               <a:spcAft>
                 <a:spcPts val="0"/>
               </a:spcAft>
             </a:pPr>
             <a:r>
-              <a:rPr sz="1600" b="1" i="0">
+              <a:rPr sz="1450" b="1" i="0">
                 <a:solidFill>
                   <a:srgbClr val="102D5E"/>
                 </a:solidFill>
@@ -6514,13 +7081,13 @@
               <a:t>Key message.  </a:t>
             </a:r>
             <a:r>
-              <a:rPr sz="1600" b="0" i="0">
+              <a:rPr sz="1450" b="0" i="0">
                 <a:solidFill>
                   <a:srgbClr val="212529"/>
                 </a:solidFill>
                 <a:latin typeface="Garamond"/>
               </a:rPr>
-              <a:t>Early labor-force exit is mostly a family story. More than half of this group are mothers with a child at home.</a:t>
+              <a:t>More than a third of the employed leavers move to occupations where most workers hold no college degree (in red). Leaving teaching usually means leaving the profession, not moving up.</a:t>
             </a:r>
           </a:p>
         </p:txBody>
@@ -6570,7 +7137,7 @@
                 </a:solidFill>
                 <a:latin typeface="Garamond"/>
               </a:rPr>
-              <a:t>And the youngest of them leave to study</a:t>
+              <a:t>Who leaves the labor force before 55 (average, 2020–2024)</a:t>
             </a:r>
           </a:p>
         </p:txBody>
@@ -6612,7 +7179,7 @@
       </p:sp>
       <p:pic>
         <p:nvPicPr>
-          <p:cNvPr id="4" name="Picture 3" descr="study_bygroup.png"/>
+          <p:cNvPr id="4" name="Picture 3" descr="flow_olf55_5yr.png"/>
           <p:cNvPicPr>
             <a:picLocks noChangeAspect="1"/>
           </p:cNvPicPr>
@@ -6724,7 +7291,7 @@
                 </a:solidFill>
                 <a:latin typeface="Garamond"/>
               </a:rPr>
-              <a:t>Studying is the exit of the young and the childless, not of the mothers. Among leavers under 30, almost half are enrolled in school.</a:t>
+              <a:t>Early labor-force exit is mostly a family story. More than half of this group are mothers with a child at home.</a:t>
             </a:r>
           </a:p>
         </p:txBody>

</xml_diff>

<commit_message>
Policy deck: fifteen content slides, original title, sober layout
Restores the author's title and subtitle. The CPS slide shows the
verified totals: 28 years, about 5 million people of all ages in the
March surveys (2.59 million exact for 2011-2025 plus about 2.37
million for 1998-2010, from the adult counts and the 2011-2015
all-ages ratio), 103,820 teachers, 51 jurisdictions; the tiles are now
square with a navy top rule. Drops the cycle, study, three types, life
cycle and data recap slides to reach fifteen content slides, and lays
out the policy options as plain two-column text.

Co-Authored-By: Claude Opus 5.5 <noreply@anthropic.com>
Claude-Session: https://claude.ai/code/session_01DNzQPDcr3zfLTraMHUHqUn
</commit_message>
<xml_diff>
--- a/report/data_cluster/Proyect_US_policy.pptx
+++ b/report/data_cluster/Proyect_US_policy.pptx
@@ -25,11 +25,6 @@
     <p:sldId id="273" r:id="rId24"/>
     <p:sldId id="274" r:id="rId25"/>
     <p:sldId id="275" r:id="rId26"/>
-    <p:sldId id="276" r:id="rId27"/>
-    <p:sldId id="277" r:id="rId28"/>
-    <p:sldId id="278" r:id="rId29"/>
-    <p:sldId id="279" r:id="rId30"/>
-    <p:sldId id="280" r:id="rId31"/>
   </p:sldIdLst>
   <p:sldSz cx="12191695" cy="6858000" type="screen4x3"/>
   <p:notesSz cx="6858000" cy="9144000"/>
@@ -3193,7 +3188,7 @@
                 </a:solidFill>
                 <a:latin typeface="Garamond"/>
               </a:rPr>
-              <a:t>Measuring Teacher Attrition</a:t>
+              <a:t>Measuring Teacher Attrition Beyond Administrative Data</a:t>
             </a:r>
           </a:p>
           <a:p>
@@ -3212,7 +3207,7 @@
                 </a:solidFill>
                 <a:latin typeface="Garamond"/>
               </a:rPr>
-              <a:t>Beyond Administrative Data</a:t>
+              <a:t>The case of the United States</a:t>
             </a:r>
           </a:p>
         </p:txBody>
@@ -3364,20 +3359,111 @@
       <p:grpSpPr/>
       <p:sp>
         <p:nvSpPr>
-          <p:cNvPr id="2" name="Rectangle 1"/>
+          <p:cNvPr id="2" name="TextBox 1"/>
+          <p:cNvSpPr txBox="1"/>
+          <p:nvPr/>
+        </p:nvSpPr>
+        <p:spPr>
+          <a:xfrm>
+            <a:off x="502920" y="219456"/>
+            <a:ext cx="11247120" cy="566928"/>
+          </a:xfrm>
+          <a:prstGeom prst="rect">
+            <a:avLst/>
+          </a:prstGeom>
+          <a:noFill/>
+        </p:spPr>
+        <p:txBody>
+          <a:bodyPr wrap="square" lIns="0" rIns="0" tIns="0" bIns="0"/>
+          <a:lstStyle/>
+          <a:p>
+            <a:r>
+              <a:rPr sz="2800" b="1">
+                <a:solidFill>
+                  <a:srgbClr val="102D5E"/>
+                </a:solidFill>
+                <a:latin typeface="Garamond"/>
+              </a:rPr>
+              <a:t>Who leaves teaching (average, 2020–2025)</a:t>
+            </a:r>
+          </a:p>
+        </p:txBody>
+      </p:sp>
+      <p:sp>
+        <p:nvSpPr>
+          <p:cNvPr id="3" name="TextBox 2"/>
+          <p:cNvSpPr txBox="1"/>
+          <p:nvPr/>
+        </p:nvSpPr>
+        <p:spPr>
+          <a:xfrm>
+            <a:off x="11384280" y="6446520"/>
+            <a:ext cx="640080" cy="292608"/>
+          </a:xfrm>
+          <a:prstGeom prst="rect">
+            <a:avLst/>
+          </a:prstGeom>
+          <a:noFill/>
+        </p:spPr>
+        <p:txBody>
+          <a:bodyPr wrap="none" lIns="0" rIns="0" tIns="0" bIns="0">
+            <a:spAutoFit/>
+          </a:bodyPr>
+          <a:lstStyle/>
+          <a:p>
+            <a:pPr algn="r"/>
+            <a:r>
+              <a:rPr sz="1100">
+                <a:solidFill>
+                  <a:srgbClr val="6B7480"/>
+                </a:solidFill>
+                <a:latin typeface="Garamond"/>
+              </a:rPr>
+              <a:t>10</a:t>
+            </a:r>
+          </a:p>
+        </p:txBody>
+      </p:sp>
+      <p:pic>
+        <p:nvPicPr>
+          <p:cNvPr id="4" name="Picture 3" descr="flow_employed_5yr.png"/>
+          <p:cNvPicPr>
+            <a:picLocks noChangeAspect="1"/>
+          </p:cNvPicPr>
+          <p:nvPr/>
+        </p:nvPicPr>
+        <p:blipFill>
+          <a:blip r:embed="rId2"/>
+          <a:stretch>
+            <a:fillRect/>
+          </a:stretch>
+        </p:blipFill>
+        <p:spPr>
+          <a:xfrm>
+            <a:off x="1357685" y="1051560"/>
+            <a:ext cx="9446149" cy="4526280"/>
+          </a:xfrm>
+          <a:prstGeom prst="rect">
+            <a:avLst/>
+          </a:prstGeom>
+        </p:spPr>
+      </p:pic>
+      <p:sp>
+        <p:nvSpPr>
+          <p:cNvPr id="5" name="Rectangle 4"/>
           <p:cNvSpPr/>
           <p:nvPr/>
         </p:nvSpPr>
         <p:spPr>
           <a:xfrm>
-            <a:off x="0" y="0"/>
-            <a:ext cx="12191695" cy="6858000"/>
+            <a:off x="0" y="5559552"/>
+            <a:ext cx="12191695" cy="960120"/>
           </a:xfrm>
           <a:prstGeom prst="rect">
             <a:avLst/>
           </a:prstGeom>
           <a:solidFill>
-            <a:srgbClr val="102D5E"/>
+            <a:srgbClr val="ECF2F9"/>
           </a:solidFill>
           <a:ln>
             <a:noFill/>
@@ -3408,14 +3494,14 @@
       </p:sp>
       <p:sp>
         <p:nvSpPr>
-          <p:cNvPr id="3" name="TextBox 2"/>
+          <p:cNvPr id="6" name="TextBox 5"/>
           <p:cNvSpPr txBox="1"/>
           <p:nvPr/>
         </p:nvSpPr>
         <p:spPr>
           <a:xfrm>
-            <a:off x="914400" y="2240280"/>
-            <a:ext cx="10360152" cy="1188720"/>
+            <a:off x="822960" y="5687568"/>
+            <a:ext cx="10789920" cy="822960"/>
           </a:xfrm>
           <a:prstGeom prst="rect">
             <a:avLst/>
@@ -3428,64 +3514,31 @@
           </a:bodyPr>
           <a:lstStyle/>
           <a:p>
-            <a:pPr algn="ctr">
+            <a:pPr algn="l">
               <a:lnSpc>
-                <a:spcPts val="7680"/>
+                <a:spcPts val="2048"/>
               </a:lnSpc>
               <a:spcAft>
                 <a:spcPts val="0"/>
               </a:spcAft>
             </a:pPr>
             <a:r>
-              <a:rPr sz="6000" b="1" i="0">
-                <a:solidFill>
-                  <a:srgbClr val="FFFFFF"/>
-                </a:solidFill>
-                <a:latin typeface="Garamond"/>
-              </a:rPr>
-              <a:t>2</a:t>
-            </a:r>
-          </a:p>
-        </p:txBody>
-      </p:sp>
-      <p:sp>
-        <p:nvSpPr>
-          <p:cNvPr id="4" name="TextBox 3"/>
-          <p:cNvSpPr txBox="1"/>
-          <p:nvPr/>
-        </p:nvSpPr>
-        <p:spPr>
-          <a:xfrm>
-            <a:off x="914400" y="3703320"/>
-            <a:ext cx="10360152" cy="731520"/>
-          </a:xfrm>
-          <a:prstGeom prst="rect">
-            <a:avLst/>
-          </a:prstGeom>
-          <a:noFill/>
-        </p:spPr>
-        <p:txBody>
-          <a:bodyPr wrap="square" lIns="0" rIns="0" tIns="0" bIns="0">
-            <a:spAutoFit/>
-          </a:bodyPr>
-          <a:lstStyle/>
-          <a:p>
-            <a:pPr algn="ctr">
-              <a:lnSpc>
-                <a:spcPts val="3584"/>
-              </a:lnSpc>
-              <a:spcAft>
-                <a:spcPts val="0"/>
-              </a:spcAft>
-            </a:pPr>
-            <a:r>
-              <a:rPr sz="2800" b="0" i="0">
-                <a:solidFill>
-                  <a:srgbClr val="D7E3F2"/>
-                </a:solidFill>
-                <a:latin typeface="Garamond"/>
-              </a:rPr>
-              <a:t>Composition: where they go?</a:t>
+              <a:rPr sz="1600" b="1" i="0">
+                <a:solidFill>
+                  <a:srgbClr val="102D5E"/>
+                </a:solidFill>
+                <a:latin typeface="Garamond"/>
+              </a:rPr>
+              <a:t>Key messages.  </a:t>
+            </a:r>
+            <a:r>
+              <a:rPr sz="1600" b="0" i="0">
+                <a:solidFill>
+                  <a:srgbClr val="212529"/>
+                </a:solidFill>
+                <a:latin typeface="Garamond"/>
+              </a:rPr>
+              <a:t>Among the leavers, we have switchers, early exits and retirees, besides the unemployed. Among the switchers, 31% stay in education or care.</a:t>
             </a:r>
           </a:p>
         </p:txBody>
@@ -3535,7 +3588,7 @@
                 </a:solidFill>
                 <a:latin typeface="Garamond"/>
               </a:rPr>
-              <a:t>Who leaves teaching (average, 2020–2025)</a:t>
+              <a:t>Who leaves the labor force before 55 (average, 2020–2025)</a:t>
             </a:r>
           </a:p>
         </p:txBody>
@@ -3577,7 +3630,7 @@
       </p:sp>
       <p:pic>
         <p:nvPicPr>
-          <p:cNvPr id="4" name="Picture 3" descr="flow_employed_5yr.png"/>
+          <p:cNvPr id="4" name="Picture 3" descr="flow_olf55_5yr.png"/>
           <p:cNvPicPr>
             <a:picLocks noChangeAspect="1"/>
           </p:cNvPicPr>
@@ -3680,7 +3733,7 @@
                 </a:solidFill>
                 <a:latin typeface="Garamond"/>
               </a:rPr>
-              <a:t>Key messages.  </a:t>
+              <a:t>Key message.  </a:t>
             </a:r>
             <a:r>
               <a:rPr sz="1600" b="0" i="0">
@@ -3689,7 +3742,7 @@
                 </a:solidFill>
                 <a:latin typeface="Garamond"/>
               </a:rPr>
-              <a:t>Among the leavers, we have switchers, early exits and retirees, besides the unemployed. Among the switchers, 31% stay in education or care.</a:t>
+              <a:t>Among early exits, more than half (57%) are mothers with a child at home.</a:t>
             </a:r>
           </a:p>
         </p:txBody>
@@ -3714,111 +3767,20 @@
       <p:grpSpPr/>
       <p:sp>
         <p:nvSpPr>
-          <p:cNvPr id="2" name="TextBox 1"/>
-          <p:cNvSpPr txBox="1"/>
-          <p:nvPr/>
-        </p:nvSpPr>
-        <p:spPr>
-          <a:xfrm>
-            <a:off x="502920" y="219456"/>
-            <a:ext cx="11247120" cy="566928"/>
-          </a:xfrm>
-          <a:prstGeom prst="rect">
-            <a:avLst/>
-          </a:prstGeom>
-          <a:noFill/>
-        </p:spPr>
-        <p:txBody>
-          <a:bodyPr wrap="square" lIns="0" rIns="0" tIns="0" bIns="0"/>
-          <a:lstStyle/>
-          <a:p>
-            <a:r>
-              <a:rPr sz="2800" b="1">
-                <a:solidFill>
-                  <a:srgbClr val="102D5E"/>
-                </a:solidFill>
-                <a:latin typeface="Garamond"/>
-              </a:rPr>
-              <a:t>Who leaves the labor force before 55 (average, 2020–2025)</a:t>
-            </a:r>
-          </a:p>
-        </p:txBody>
-      </p:sp>
-      <p:sp>
-        <p:nvSpPr>
-          <p:cNvPr id="3" name="TextBox 2"/>
-          <p:cNvSpPr txBox="1"/>
-          <p:nvPr/>
-        </p:nvSpPr>
-        <p:spPr>
-          <a:xfrm>
-            <a:off x="11384280" y="6446520"/>
-            <a:ext cx="640080" cy="292608"/>
-          </a:xfrm>
-          <a:prstGeom prst="rect">
-            <a:avLst/>
-          </a:prstGeom>
-          <a:noFill/>
-        </p:spPr>
-        <p:txBody>
-          <a:bodyPr wrap="none" lIns="0" rIns="0" tIns="0" bIns="0">
-            <a:spAutoFit/>
-          </a:bodyPr>
-          <a:lstStyle/>
-          <a:p>
-            <a:pPr algn="r"/>
-            <a:r>
-              <a:rPr sz="1100">
-                <a:solidFill>
-                  <a:srgbClr val="6B7480"/>
-                </a:solidFill>
-                <a:latin typeface="Garamond"/>
-              </a:rPr>
-              <a:t>12</a:t>
-            </a:r>
-          </a:p>
-        </p:txBody>
-      </p:sp>
-      <p:pic>
-        <p:nvPicPr>
-          <p:cNvPr id="4" name="Picture 3" descr="flow_olf55_5yr.png"/>
-          <p:cNvPicPr>
-            <a:picLocks noChangeAspect="1"/>
-          </p:cNvPicPr>
-          <p:nvPr/>
-        </p:nvPicPr>
-        <p:blipFill>
-          <a:blip r:embed="rId2"/>
-          <a:stretch>
-            <a:fillRect/>
-          </a:stretch>
-        </p:blipFill>
-        <p:spPr>
-          <a:xfrm>
-            <a:off x="1357685" y="1051560"/>
-            <a:ext cx="9446149" cy="4526280"/>
-          </a:xfrm>
-          <a:prstGeom prst="rect">
-            <a:avLst/>
-          </a:prstGeom>
-        </p:spPr>
-      </p:pic>
-      <p:sp>
-        <p:nvSpPr>
-          <p:cNvPr id="5" name="Rectangle 4"/>
+          <p:cNvPr id="2" name="Rectangle 1"/>
           <p:cNvSpPr/>
           <p:nvPr/>
         </p:nvSpPr>
         <p:spPr>
           <a:xfrm>
-            <a:off x="0" y="5559552"/>
-            <a:ext cx="12191695" cy="960120"/>
+            <a:off x="0" y="0"/>
+            <a:ext cx="12191695" cy="6858000"/>
           </a:xfrm>
           <a:prstGeom prst="rect">
             <a:avLst/>
           </a:prstGeom>
           <a:solidFill>
-            <a:srgbClr val="ECF2F9"/>
+            <a:srgbClr val="102D5E"/>
           </a:solidFill>
           <a:ln>
             <a:noFill/>
@@ -3849,14 +3811,14 @@
       </p:sp>
       <p:sp>
         <p:nvSpPr>
-          <p:cNvPr id="6" name="TextBox 5"/>
+          <p:cNvPr id="3" name="TextBox 2"/>
           <p:cNvSpPr txBox="1"/>
           <p:nvPr/>
         </p:nvSpPr>
         <p:spPr>
           <a:xfrm>
-            <a:off x="822960" y="5687568"/>
-            <a:ext cx="10789920" cy="822960"/>
+            <a:off x="914400" y="2240280"/>
+            <a:ext cx="10360152" cy="1188720"/>
           </a:xfrm>
           <a:prstGeom prst="rect">
             <a:avLst/>
@@ -3869,31 +3831,64 @@
           </a:bodyPr>
           <a:lstStyle/>
           <a:p>
-            <a:pPr algn="l">
+            <a:pPr algn="ctr">
               <a:lnSpc>
-                <a:spcPts val="2048"/>
+                <a:spcPts val="7680"/>
               </a:lnSpc>
               <a:spcAft>
                 <a:spcPts val="0"/>
               </a:spcAft>
             </a:pPr>
             <a:r>
-              <a:rPr sz="1600" b="1" i="0">
-                <a:solidFill>
-                  <a:srgbClr val="102D5E"/>
-                </a:solidFill>
-                <a:latin typeface="Garamond"/>
-              </a:rPr>
-              <a:t>Key message.  </a:t>
-            </a:r>
-            <a:r>
-              <a:rPr sz="1600" b="0" i="0">
-                <a:solidFill>
-                  <a:srgbClr val="212529"/>
-                </a:solidFill>
-                <a:latin typeface="Garamond"/>
-              </a:rPr>
-              <a:t>Among early exits, more than half (57%) are mothers with a child at home.</a:t>
+              <a:rPr sz="6000" b="1" i="0">
+                <a:solidFill>
+                  <a:srgbClr val="FFFFFF"/>
+                </a:solidFill>
+                <a:latin typeface="Garamond"/>
+              </a:rPr>
+              <a:t>3</a:t>
+            </a:r>
+          </a:p>
+        </p:txBody>
+      </p:sp>
+      <p:sp>
+        <p:nvSpPr>
+          <p:cNvPr id="4" name="TextBox 3"/>
+          <p:cNvSpPr txBox="1"/>
+          <p:nvPr/>
+        </p:nvSpPr>
+        <p:spPr>
+          <a:xfrm>
+            <a:off x="914400" y="3703320"/>
+            <a:ext cx="10360152" cy="731520"/>
+          </a:xfrm>
+          <a:prstGeom prst="rect">
+            <a:avLst/>
+          </a:prstGeom>
+          <a:noFill/>
+        </p:spPr>
+        <p:txBody>
+          <a:bodyPr wrap="square" lIns="0" rIns="0" tIns="0" bIns="0">
+            <a:spAutoFit/>
+          </a:bodyPr>
+          <a:lstStyle/>
+          <a:p>
+            <a:pPr algn="ctr">
+              <a:lnSpc>
+                <a:spcPts val="3584"/>
+              </a:lnSpc>
+              <a:spcAft>
+                <a:spcPts val="0"/>
+              </a:spcAft>
+            </a:pPr>
+            <a:r>
+              <a:rPr sz="2800" b="0" i="0">
+                <a:solidFill>
+                  <a:srgbClr val="D7E3F2"/>
+                </a:solidFill>
+                <a:latin typeface="Garamond"/>
+              </a:rPr>
+              <a:t>Correlations: why they leave?</a:t>
             </a:r>
           </a:p>
         </p:txBody>
@@ -3943,7 +3938,7 @@
                 </a:solidFill>
                 <a:latin typeface="Garamond"/>
               </a:rPr>
-              <a:t>Who leaves the labor force before 55 (average, 2020–2025)</a:t>
+              <a:t>What correlates with leaving</a:t>
             </a:r>
           </a:p>
         </p:txBody>
@@ -3985,7 +3980,7 @@
       </p:sp>
       <p:pic>
         <p:nvPicPr>
-          <p:cNvPr id="4" name="Picture 3" descr="study_bygroup.png"/>
+          <p:cNvPr id="4" name="Picture 3" descr="ame_ext.png"/>
           <p:cNvPicPr>
             <a:picLocks noChangeAspect="1"/>
           </p:cNvPicPr>
@@ -3999,109 +3994,14 @@
         </p:blipFill>
         <p:spPr>
           <a:xfrm>
-            <a:off x="1357685" y="1051560"/>
-            <a:ext cx="9446149" cy="4526280"/>
+            <a:off x="1587500" y="1024128"/>
+            <a:ext cx="8986520" cy="5577840"/>
           </a:xfrm>
           <a:prstGeom prst="rect">
             <a:avLst/>
           </a:prstGeom>
         </p:spPr>
       </p:pic>
-      <p:sp>
-        <p:nvSpPr>
-          <p:cNvPr id="5" name="Rectangle 4"/>
-          <p:cNvSpPr/>
-          <p:nvPr/>
-        </p:nvSpPr>
-        <p:spPr>
-          <a:xfrm>
-            <a:off x="0" y="5559552"/>
-            <a:ext cx="12191695" cy="960120"/>
-          </a:xfrm>
-          <a:prstGeom prst="rect">
-            <a:avLst/>
-          </a:prstGeom>
-          <a:solidFill>
-            <a:srgbClr val="ECF2F9"/>
-          </a:solidFill>
-          <a:ln>
-            <a:noFill/>
-          </a:ln>
-          <a:effectLst/>
-        </p:spPr>
-        <p:style>
-          <a:lnRef idx="1">
-            <a:schemeClr val="accent1"/>
-          </a:lnRef>
-          <a:fillRef idx="3">
-            <a:schemeClr val="accent1"/>
-          </a:fillRef>
-          <a:effectRef idx="2">
-            <a:schemeClr val="accent1"/>
-          </a:effectRef>
-          <a:fontRef idx="minor">
-            <a:schemeClr val="lt1"/>
-          </a:fontRef>
-        </p:style>
-        <p:txBody>
-          <a:bodyPr rtlCol="0" anchor="ctr"/>
-          <a:lstStyle/>
-          <a:p>
-            <a:pPr algn="ctr"/>
-          </a:p>
-        </p:txBody>
-      </p:sp>
-      <p:sp>
-        <p:nvSpPr>
-          <p:cNvPr id="6" name="TextBox 5"/>
-          <p:cNvSpPr txBox="1"/>
-          <p:nvPr/>
-        </p:nvSpPr>
-        <p:spPr>
-          <a:xfrm>
-            <a:off x="822960" y="5687568"/>
-            <a:ext cx="10789920" cy="822960"/>
-          </a:xfrm>
-          <a:prstGeom prst="rect">
-            <a:avLst/>
-          </a:prstGeom>
-          <a:noFill/>
-        </p:spPr>
-        <p:txBody>
-          <a:bodyPr wrap="square" lIns="0" rIns="0" tIns="0" bIns="0">
-            <a:spAutoFit/>
-          </a:bodyPr>
-          <a:lstStyle/>
-          <a:p>
-            <a:pPr algn="l">
-              <a:lnSpc>
-                <a:spcPts val="2048"/>
-              </a:lnSpc>
-              <a:spcAft>
-                <a:spcPts val="0"/>
-              </a:spcAft>
-            </a:pPr>
-            <a:r>
-              <a:rPr sz="1600" b="1" i="0">
-                <a:solidFill>
-                  <a:srgbClr val="102D5E"/>
-                </a:solidFill>
-                <a:latin typeface="Garamond"/>
-              </a:rPr>
-              <a:t>Key message.  </a:t>
-            </a:r>
-            <a:r>
-              <a:rPr sz="1600" b="0" i="0">
-                <a:solidFill>
-                  <a:srgbClr val="212529"/>
-                </a:solidFill>
-                <a:latin typeface="Garamond"/>
-              </a:rPr>
-              <a:t>Among early exits, 13% are enrolled in school. Among early exits under 30, almost half (47%) are enrolled in school.</a:t>
-            </a:r>
-          </a:p>
-        </p:txBody>
-      </p:sp>
     </p:spTree>
   </p:cSld>
   <p:clrMapOvr>
@@ -4147,7 +4047,7 @@
                 </a:solidFill>
                 <a:latin typeface="Garamond"/>
               </a:rPr>
-              <a:t>Three types of leavers</a:t>
+              <a:t>Early-career teachers respond to different levers</a:t>
             </a:r>
           </a:p>
         </p:txBody>
@@ -4187,16 +4087,84 @@
           </a:p>
         </p:txBody>
       </p:sp>
-      <p:sp>
-        <p:nvSpPr>
-          <p:cNvPr id="4" name="TextBox 3"/>
+      <p:pic>
+        <p:nvPicPr>
+          <p:cNvPr id="4" name="Picture 3" descr="ame_byage.png"/>
+          <p:cNvPicPr>
+            <a:picLocks noChangeAspect="1"/>
+          </p:cNvPicPr>
+          <p:nvPr/>
+        </p:nvPicPr>
+        <p:blipFill>
+          <a:blip r:embed="rId2"/>
+          <a:stretch>
+            <a:fillRect/>
+          </a:stretch>
+        </p:blipFill>
+        <p:spPr>
+          <a:xfrm>
+            <a:off x="2216766" y="1005840"/>
+            <a:ext cx="7727986" cy="4663440"/>
+          </a:xfrm>
+          <a:prstGeom prst="rect">
+            <a:avLst/>
+          </a:prstGeom>
+        </p:spPr>
+      </p:pic>
+      <p:sp>
+        <p:nvSpPr>
+          <p:cNvPr id="5" name="Rectangle 4"/>
+          <p:cNvSpPr/>
+          <p:nvPr/>
+        </p:nvSpPr>
+        <p:spPr>
+          <a:xfrm>
+            <a:off x="0" y="5769864"/>
+            <a:ext cx="12191695" cy="960120"/>
+          </a:xfrm>
+          <a:prstGeom prst="rect">
+            <a:avLst/>
+          </a:prstGeom>
+          <a:solidFill>
+            <a:srgbClr val="ECF2F9"/>
+          </a:solidFill>
+          <a:ln>
+            <a:noFill/>
+          </a:ln>
+          <a:effectLst/>
+        </p:spPr>
+        <p:style>
+          <a:lnRef idx="1">
+            <a:schemeClr val="accent1"/>
+          </a:lnRef>
+          <a:fillRef idx="3">
+            <a:schemeClr val="accent1"/>
+          </a:fillRef>
+          <a:effectRef idx="2">
+            <a:schemeClr val="accent1"/>
+          </a:effectRef>
+          <a:fontRef idx="minor">
+            <a:schemeClr val="lt1"/>
+          </a:fontRef>
+        </p:style>
+        <p:txBody>
+          <a:bodyPr rtlCol="0" anchor="ctr"/>
+          <a:lstStyle/>
+          <a:p>
+            <a:pPr algn="ctr"/>
+          </a:p>
+        </p:txBody>
+      </p:sp>
+      <p:sp>
+        <p:nvSpPr>
+          <p:cNvPr id="6" name="TextBox 5"/>
           <p:cNvSpPr txBox="1"/>
           <p:nvPr/>
         </p:nvSpPr>
         <p:spPr>
           <a:xfrm>
-            <a:off x="822960" y="1280160"/>
-            <a:ext cx="10789920" cy="457200"/>
+            <a:off x="822960" y="5897880"/>
+            <a:ext cx="10789920" cy="822960"/>
           </a:xfrm>
           <a:prstGeom prst="rect">
             <a:avLst/>
@@ -4211,257 +4179,29 @@
           <a:p>
             <a:pPr algn="l">
               <a:lnSpc>
-                <a:spcPts val="2816"/>
+                <a:spcPts val="1855"/>
               </a:lnSpc>
               <a:spcAft>
                 <a:spcPts val="0"/>
               </a:spcAft>
             </a:pPr>
             <a:r>
-              <a:rPr sz="2200" b="1" i="0">
-                <a:solidFill>
-                  <a:srgbClr val="2D6CB5"/>
-                </a:solidFill>
-                <a:latin typeface="Garamond"/>
-              </a:rPr>
-              <a:t>Switchers </a:t>
-            </a:r>
-            <a:r>
-              <a:rPr sz="1800" b="0" i="0">
-                <a:solidFill>
-                  <a:srgbClr val="6B7480"/>
-                </a:solidFill>
-                <a:latin typeface="Garamond"/>
-              </a:rPr>
-              <a:t>(employed in another job)</a:t>
-            </a:r>
-          </a:p>
-        </p:txBody>
-      </p:sp>
-      <p:sp>
-        <p:nvSpPr>
-          <p:cNvPr id="5" name="TextBox 4"/>
-          <p:cNvSpPr txBox="1"/>
-          <p:nvPr/>
-        </p:nvSpPr>
-        <p:spPr>
-          <a:xfrm>
-            <a:off x="822960" y="1783080"/>
-            <a:ext cx="10789920" cy="1005840"/>
-          </a:xfrm>
-          <a:prstGeom prst="rect">
-            <a:avLst/>
-          </a:prstGeom>
-          <a:noFill/>
-        </p:spPr>
-        <p:txBody>
-          <a:bodyPr wrap="square" lIns="0" rIns="0" tIns="0" bIns="0">
-            <a:spAutoFit/>
-          </a:bodyPr>
-          <a:lstStyle/>
-          <a:p>
-            <a:pPr algn="l">
-              <a:lnSpc>
-                <a:spcPts val="2432"/>
-              </a:lnSpc>
-              <a:spcAft>
-                <a:spcPts val="0"/>
-              </a:spcAft>
-            </a:pPr>
-            <a:r>
-              <a:rPr sz="1900" b="0" i="0">
+              <a:rPr sz="1450" b="1" i="0">
+                <a:solidFill>
+                  <a:srgbClr val="102D5E"/>
+                </a:solidFill>
+                <a:latin typeface="Garamond"/>
+              </a:rPr>
+              <a:t>Key message.  </a:t>
+            </a:r>
+            <a:r>
+              <a:rPr sz="1450" b="0" i="0">
                 <a:solidFill>
                   <a:srgbClr val="212529"/>
                 </a:solidFill>
                 <a:latin typeface="Garamond"/>
               </a:rPr>
-              <a:t>Two groups, two approaches. Some stay close to education: how can we bring their skills back to schools? Others move to jobs that do not need a degree: why do they go there?</a:t>
-            </a:r>
-          </a:p>
-        </p:txBody>
-      </p:sp>
-      <p:sp>
-        <p:nvSpPr>
-          <p:cNvPr id="6" name="TextBox 5"/>
-          <p:cNvSpPr txBox="1"/>
-          <p:nvPr/>
-        </p:nvSpPr>
-        <p:spPr>
-          <a:xfrm>
-            <a:off x="822960" y="2971800"/>
-            <a:ext cx="10789920" cy="457200"/>
-          </a:xfrm>
-          <a:prstGeom prst="rect">
-            <a:avLst/>
-          </a:prstGeom>
-          <a:noFill/>
-        </p:spPr>
-        <p:txBody>
-          <a:bodyPr wrap="square" lIns="0" rIns="0" tIns="0" bIns="0">
-            <a:spAutoFit/>
-          </a:bodyPr>
-          <a:lstStyle/>
-          <a:p>
-            <a:pPr algn="l">
-              <a:lnSpc>
-                <a:spcPts val="2816"/>
-              </a:lnSpc>
-              <a:spcAft>
-                <a:spcPts val="0"/>
-              </a:spcAft>
-            </a:pPr>
-            <a:r>
-              <a:rPr sz="2200" b="1" i="0">
-                <a:solidFill>
-                  <a:srgbClr val="2D6CB5"/>
-                </a:solidFill>
-                <a:latin typeface="Garamond"/>
-              </a:rPr>
-              <a:t>Early exits </a:t>
-            </a:r>
-            <a:r>
-              <a:rPr sz="1800" b="0" i="0">
-                <a:solidFill>
-                  <a:srgbClr val="6B7480"/>
-                </a:solidFill>
-                <a:latin typeface="Garamond"/>
-              </a:rPr>
-              <a:t>(out of the labor force, under 55)</a:t>
-            </a:r>
-          </a:p>
-        </p:txBody>
-      </p:sp>
-      <p:sp>
-        <p:nvSpPr>
-          <p:cNvPr id="7" name="TextBox 6"/>
-          <p:cNvSpPr txBox="1"/>
-          <p:nvPr/>
-        </p:nvSpPr>
-        <p:spPr>
-          <a:xfrm>
-            <a:off x="822960" y="3474720"/>
-            <a:ext cx="10789920" cy="1005840"/>
-          </a:xfrm>
-          <a:prstGeom prst="rect">
-            <a:avLst/>
-          </a:prstGeom>
-          <a:noFill/>
-        </p:spPr>
-        <p:txBody>
-          <a:bodyPr wrap="square" lIns="0" rIns="0" tIns="0" bIns="0">
-            <a:spAutoFit/>
-          </a:bodyPr>
-          <a:lstStyle/>
-          <a:p>
-            <a:pPr algn="l">
-              <a:lnSpc>
-                <a:spcPts val="2432"/>
-              </a:lnSpc>
-              <a:spcAft>
-                <a:spcPts val="0"/>
-              </a:spcAft>
-            </a:pPr>
-            <a:r>
-              <a:rPr sz="1900" b="0" i="0">
-                <a:solidFill>
-                  <a:srgbClr val="212529"/>
-                </a:solidFill>
-                <a:latin typeface="Garamond"/>
-              </a:rPr>
-              <a:t>Two groups, two approaches. Mostly mothers at home. Also young people without children who return to study.</a:t>
-            </a:r>
-          </a:p>
-        </p:txBody>
-      </p:sp>
-      <p:sp>
-        <p:nvSpPr>
-          <p:cNvPr id="8" name="TextBox 7"/>
-          <p:cNvSpPr txBox="1"/>
-          <p:nvPr/>
-        </p:nvSpPr>
-        <p:spPr>
-          <a:xfrm>
-            <a:off x="822960" y="4663440"/>
-            <a:ext cx="10789920" cy="457200"/>
-          </a:xfrm>
-          <a:prstGeom prst="rect">
-            <a:avLst/>
-          </a:prstGeom>
-          <a:noFill/>
-        </p:spPr>
-        <p:txBody>
-          <a:bodyPr wrap="square" lIns="0" rIns="0" tIns="0" bIns="0">
-            <a:spAutoFit/>
-          </a:bodyPr>
-          <a:lstStyle/>
-          <a:p>
-            <a:pPr algn="l">
-              <a:lnSpc>
-                <a:spcPts val="2816"/>
-              </a:lnSpc>
-              <a:spcAft>
-                <a:spcPts val="0"/>
-              </a:spcAft>
-            </a:pPr>
-            <a:r>
-              <a:rPr sz="2200" b="1" i="0">
-                <a:solidFill>
-                  <a:srgbClr val="2D6CB5"/>
-                </a:solidFill>
-                <a:latin typeface="Garamond"/>
-              </a:rPr>
-              <a:t>Retirees </a:t>
-            </a:r>
-            <a:r>
-              <a:rPr sz="1800" b="0" i="0">
-                <a:solidFill>
-                  <a:srgbClr val="6B7480"/>
-                </a:solidFill>
-                <a:latin typeface="Garamond"/>
-              </a:rPr>
-              <a:t>(out of the labor force, over 55)</a:t>
-            </a:r>
-          </a:p>
-        </p:txBody>
-      </p:sp>
-      <p:sp>
-        <p:nvSpPr>
-          <p:cNvPr id="9" name="TextBox 8"/>
-          <p:cNvSpPr txBox="1"/>
-          <p:nvPr/>
-        </p:nvSpPr>
-        <p:spPr>
-          <a:xfrm>
-            <a:off x="822960" y="5166360"/>
-            <a:ext cx="10789920" cy="731520"/>
-          </a:xfrm>
-          <a:prstGeom prst="rect">
-            <a:avLst/>
-          </a:prstGeom>
-          <a:noFill/>
-        </p:spPr>
-        <p:txBody>
-          <a:bodyPr wrap="square" lIns="0" rIns="0" tIns="0" bIns="0">
-            <a:spAutoFit/>
-          </a:bodyPr>
-          <a:lstStyle/>
-          <a:p>
-            <a:pPr algn="l">
-              <a:lnSpc>
-                <a:spcPts val="2432"/>
-              </a:lnSpc>
-              <a:spcAft>
-                <a:spcPts val="0"/>
-              </a:spcAft>
-            </a:pPr>
-            <a:r>
-              <a:rPr sz="1900" b="0" i="0">
-                <a:solidFill>
-                  <a:srgbClr val="212529"/>
-                </a:solidFill>
-                <a:latin typeface="Garamond"/>
-              </a:rPr>
-              <a:t>Experienced teachers at the end of their careers.</a:t>
+              <a:t>For teachers under 35, a public-school job retains three times more strongly than for the rest (−4.5 vs −1.6 points), and a pension plan also retains more. Security keeps the young in the classroom.</a:t>
             </a:r>
           </a:p>
         </p:txBody>
@@ -4486,20 +4226,111 @@
       <p:grpSpPr/>
       <p:sp>
         <p:nvSpPr>
-          <p:cNvPr id="2" name="Rectangle 1"/>
+          <p:cNvPr id="2" name="TextBox 1"/>
+          <p:cNvSpPr txBox="1"/>
+          <p:nvPr/>
+        </p:nvSpPr>
+        <p:spPr>
+          <a:xfrm>
+            <a:off x="502920" y="219456"/>
+            <a:ext cx="11247120" cy="566928"/>
+          </a:xfrm>
+          <a:prstGeom prst="rect">
+            <a:avLst/>
+          </a:prstGeom>
+          <a:noFill/>
+        </p:spPr>
+        <p:txBody>
+          <a:bodyPr wrap="square" lIns="0" rIns="0" tIns="0" bIns="0"/>
+          <a:lstStyle/>
+          <a:p>
+            <a:r>
+              <a:rPr sz="2800" b="1">
+                <a:solidFill>
+                  <a:srgbClr val="102D5E"/>
+                </a:solidFill>
+                <a:latin typeface="Garamond"/>
+              </a:rPr>
+              <a:t>Relative pay since 1997</a:t>
+            </a:r>
+          </a:p>
+        </p:txBody>
+      </p:sp>
+      <p:sp>
+        <p:nvSpPr>
+          <p:cNvPr id="3" name="TextBox 2"/>
+          <p:cNvSpPr txBox="1"/>
+          <p:nvPr/>
+        </p:nvSpPr>
+        <p:spPr>
+          <a:xfrm>
+            <a:off x="11384280" y="6446520"/>
+            <a:ext cx="640080" cy="292608"/>
+          </a:xfrm>
+          <a:prstGeom prst="rect">
+            <a:avLst/>
+          </a:prstGeom>
+          <a:noFill/>
+        </p:spPr>
+        <p:txBody>
+          <a:bodyPr wrap="none" lIns="0" rIns="0" tIns="0" bIns="0">
+            <a:spAutoFit/>
+          </a:bodyPr>
+          <a:lstStyle/>
+          <a:p>
+            <a:pPr algn="r"/>
+            <a:r>
+              <a:rPr sz="1100">
+                <a:solidFill>
+                  <a:srgbClr val="6B7480"/>
+                </a:solidFill>
+                <a:latin typeface="Garamond"/>
+              </a:rPr>
+              <a:t>15</a:t>
+            </a:r>
+          </a:p>
+        </p:txBody>
+      </p:sp>
+      <p:pic>
+        <p:nvPicPr>
+          <p:cNvPr id="4" name="Picture 3" descr="msgA3.png"/>
+          <p:cNvPicPr>
+            <a:picLocks noChangeAspect="1"/>
+          </p:cNvPicPr>
+          <p:nvPr/>
+        </p:nvPicPr>
+        <p:blipFill>
+          <a:blip r:embed="rId2"/>
+          <a:stretch>
+            <a:fillRect/>
+          </a:stretch>
+        </p:blipFill>
+        <p:spPr>
+          <a:xfrm>
+            <a:off x="702337" y="1097280"/>
+            <a:ext cx="10756845" cy="4434840"/>
+          </a:xfrm>
+          <a:prstGeom prst="rect">
+            <a:avLst/>
+          </a:prstGeom>
+        </p:spPr>
+      </p:pic>
+      <p:sp>
+        <p:nvSpPr>
+          <p:cNvPr id="5" name="Rectangle 4"/>
           <p:cNvSpPr/>
           <p:nvPr/>
         </p:nvSpPr>
         <p:spPr>
           <a:xfrm>
-            <a:off x="0" y="0"/>
-            <a:ext cx="12191695" cy="6858000"/>
+            <a:off x="0" y="5559552"/>
+            <a:ext cx="12191695" cy="960120"/>
           </a:xfrm>
           <a:prstGeom prst="rect">
             <a:avLst/>
           </a:prstGeom>
           <a:solidFill>
-            <a:srgbClr val="102D5E"/>
+            <a:srgbClr val="ECF2F9"/>
           </a:solidFill>
           <a:ln>
             <a:noFill/>
@@ -4530,14 +4361,14 @@
       </p:sp>
       <p:sp>
         <p:nvSpPr>
-          <p:cNvPr id="3" name="TextBox 2"/>
+          <p:cNvPr id="6" name="TextBox 5"/>
           <p:cNvSpPr txBox="1"/>
           <p:nvPr/>
         </p:nvSpPr>
         <p:spPr>
           <a:xfrm>
-            <a:off x="914400" y="2240280"/>
-            <a:ext cx="10360152" cy="1188720"/>
+            <a:off x="822960" y="5687568"/>
+            <a:ext cx="10789920" cy="822960"/>
           </a:xfrm>
           <a:prstGeom prst="rect">
             <a:avLst/>
@@ -4550,64 +4381,31 @@
           </a:bodyPr>
           <a:lstStyle/>
           <a:p>
-            <a:pPr algn="ctr">
+            <a:pPr algn="l">
               <a:lnSpc>
-                <a:spcPts val="7680"/>
+                <a:spcPts val="2048"/>
               </a:lnSpc>
               <a:spcAft>
                 <a:spcPts val="0"/>
               </a:spcAft>
             </a:pPr>
             <a:r>
-              <a:rPr sz="6000" b="1" i="0">
-                <a:solidFill>
-                  <a:srgbClr val="FFFFFF"/>
-                </a:solidFill>
-                <a:latin typeface="Garamond"/>
-              </a:rPr>
-              <a:t>3</a:t>
-            </a:r>
-          </a:p>
-        </p:txBody>
-      </p:sp>
-      <p:sp>
-        <p:nvSpPr>
-          <p:cNvPr id="4" name="TextBox 3"/>
-          <p:cNvSpPr txBox="1"/>
-          <p:nvPr/>
-        </p:nvSpPr>
-        <p:spPr>
-          <a:xfrm>
-            <a:off x="914400" y="3703320"/>
-            <a:ext cx="10360152" cy="731520"/>
-          </a:xfrm>
-          <a:prstGeom prst="rect">
-            <a:avLst/>
-          </a:prstGeom>
-          <a:noFill/>
-        </p:spPr>
-        <p:txBody>
-          <a:bodyPr wrap="square" lIns="0" rIns="0" tIns="0" bIns="0">
-            <a:spAutoFit/>
-          </a:bodyPr>
-          <a:lstStyle/>
-          <a:p>
-            <a:pPr algn="ctr">
-              <a:lnSpc>
-                <a:spcPts val="3584"/>
-              </a:lnSpc>
-              <a:spcAft>
-                <a:spcPts val="0"/>
-              </a:spcAft>
-            </a:pPr>
-            <a:r>
-              <a:rPr sz="2800" b="0" i="0">
-                <a:solidFill>
-                  <a:srgbClr val="D7E3F2"/>
-                </a:solidFill>
-                <a:latin typeface="Garamond"/>
-              </a:rPr>
-              <a:t>Correlations: why they leave?</a:t>
+              <a:rPr sz="1600" b="1" i="0">
+                <a:solidFill>
+                  <a:srgbClr val="102D5E"/>
+                </a:solidFill>
+                <a:latin typeface="Garamond"/>
+              </a:rPr>
+              <a:t>Key message.  </a:t>
+            </a:r>
+            <a:r>
+              <a:rPr sz="1600" b="0" i="0">
+                <a:solidFill>
+                  <a:srgbClr val="212529"/>
+                </a:solidFill>
+                <a:latin typeface="Garamond"/>
+              </a:rPr>
+              <a:t>Teacher pay has not grown in 25 years.</a:t>
             </a:r>
           </a:p>
         </p:txBody>
@@ -4657,7 +4455,7 @@
                 </a:solidFill>
                 <a:latin typeface="Garamond"/>
               </a:rPr>
-              <a:t>What correlates with leaving</a:t>
+              <a:t>Leaving, by position in the teacher pay distribution</a:t>
             </a:r>
           </a:p>
         </p:txBody>
@@ -4699,7 +4497,7 @@
       </p:sp>
       <p:pic>
         <p:nvPicPr>
-          <p:cNvPr id="4" name="Picture 3" descr="ame_ext.png"/>
+          <p:cNvPr id="4" name="Picture 3" descr="pay3_deciles_deck.png"/>
           <p:cNvPicPr>
             <a:picLocks noChangeAspect="1"/>
           </p:cNvPicPr>
@@ -4713,14 +4511,109 @@
         </p:blipFill>
         <p:spPr>
           <a:xfrm>
-            <a:off x="1587500" y="1024128"/>
-            <a:ext cx="8986520" cy="5577840"/>
+            <a:off x="1645920" y="1097280"/>
+            <a:ext cx="8869680" cy="4434840"/>
           </a:xfrm>
           <a:prstGeom prst="rect">
             <a:avLst/>
           </a:prstGeom>
         </p:spPr>
       </p:pic>
+      <p:sp>
+        <p:nvSpPr>
+          <p:cNvPr id="5" name="Rectangle 4"/>
+          <p:cNvSpPr/>
+          <p:nvPr/>
+        </p:nvSpPr>
+        <p:spPr>
+          <a:xfrm>
+            <a:off x="0" y="5559552"/>
+            <a:ext cx="12191695" cy="960120"/>
+          </a:xfrm>
+          <a:prstGeom prst="rect">
+            <a:avLst/>
+          </a:prstGeom>
+          <a:solidFill>
+            <a:srgbClr val="ECF2F9"/>
+          </a:solidFill>
+          <a:ln>
+            <a:noFill/>
+          </a:ln>
+          <a:effectLst/>
+        </p:spPr>
+        <p:style>
+          <a:lnRef idx="1">
+            <a:schemeClr val="accent1"/>
+          </a:lnRef>
+          <a:fillRef idx="3">
+            <a:schemeClr val="accent1"/>
+          </a:fillRef>
+          <a:effectRef idx="2">
+            <a:schemeClr val="accent1"/>
+          </a:effectRef>
+          <a:fontRef idx="minor">
+            <a:schemeClr val="lt1"/>
+          </a:fontRef>
+        </p:style>
+        <p:txBody>
+          <a:bodyPr rtlCol="0" anchor="ctr"/>
+          <a:lstStyle/>
+          <a:p>
+            <a:pPr algn="ctr"/>
+          </a:p>
+        </p:txBody>
+      </p:sp>
+      <p:sp>
+        <p:nvSpPr>
+          <p:cNvPr id="6" name="TextBox 5"/>
+          <p:cNvSpPr txBox="1"/>
+          <p:nvPr/>
+        </p:nvSpPr>
+        <p:spPr>
+          <a:xfrm>
+            <a:off x="822960" y="5687568"/>
+            <a:ext cx="10789920" cy="822960"/>
+          </a:xfrm>
+          <a:prstGeom prst="rect">
+            <a:avLst/>
+          </a:prstGeom>
+          <a:noFill/>
+        </p:spPr>
+        <p:txBody>
+          <a:bodyPr wrap="square" lIns="0" rIns="0" tIns="0" bIns="0">
+            <a:spAutoFit/>
+          </a:bodyPr>
+          <a:lstStyle/>
+          <a:p>
+            <a:pPr algn="l">
+              <a:lnSpc>
+                <a:spcPts val="2048"/>
+              </a:lnSpc>
+              <a:spcAft>
+                <a:spcPts val="0"/>
+              </a:spcAft>
+            </a:pPr>
+            <a:r>
+              <a:rPr sz="1600" b="1" i="0">
+                <a:solidFill>
+                  <a:srgbClr val="102D5E"/>
+                </a:solidFill>
+                <a:latin typeface="Garamond"/>
+              </a:rPr>
+              <a:t>Key message.  </a:t>
+            </a:r>
+            <a:r>
+              <a:rPr sz="1600" b="0" i="0">
+                <a:solidFill>
+                  <a:srgbClr val="212529"/>
+                </a:solidFill>
+                <a:latin typeface="Garamond"/>
+              </a:rPr>
+              <a:t>Leavers are concentrated in the bottom two deciles.</a:t>
+            </a:r>
+          </a:p>
+        </p:txBody>
+      </p:sp>
     </p:spTree>
   </p:cSld>
   <p:clrMapOvr>
@@ -4766,7 +4659,7 @@
                 </a:solidFill>
                 <a:latin typeface="Garamond"/>
               </a:rPr>
-              <a:t>Early-career teachers respond to different levers</a:t>
+              <a:t>Pension coverage and leaving, across states</a:t>
             </a:r>
           </a:p>
         </p:txBody>
@@ -4808,7 +4701,7 @@
       </p:sp>
       <p:pic>
         <p:nvPicPr>
-          <p:cNvPr id="4" name="Picture 3" descr="ame_byage.png"/>
+          <p:cNvPr id="4" name="Picture 3" descr="pension_scatter_deck.png"/>
           <p:cNvPicPr>
             <a:picLocks noChangeAspect="1"/>
           </p:cNvPicPr>
@@ -4822,8 +4715,8 @@
         </p:blipFill>
         <p:spPr>
           <a:xfrm>
-            <a:off x="2216766" y="1005840"/>
-            <a:ext cx="7727986" cy="4663440"/>
+            <a:off x="2289687" y="1097280"/>
+            <a:ext cx="7582145" cy="4434840"/>
           </a:xfrm>
           <a:prstGeom prst="rect">
             <a:avLst/>
@@ -4838,7 +4731,7 @@
         </p:nvSpPr>
         <p:spPr>
           <a:xfrm>
-            <a:off x="0" y="5769864"/>
+            <a:off x="0" y="5559552"/>
             <a:ext cx="12191695" cy="960120"/>
           </a:xfrm>
           <a:prstGeom prst="rect">
@@ -4882,7 +4775,7 @@
         </p:nvSpPr>
         <p:spPr>
           <a:xfrm>
-            <a:off x="822960" y="5897880"/>
+            <a:off x="822960" y="5687568"/>
             <a:ext cx="10789920" cy="822960"/>
           </a:xfrm>
           <a:prstGeom prst="rect">
@@ -4898,14 +4791,14 @@
           <a:p>
             <a:pPr algn="l">
               <a:lnSpc>
-                <a:spcPts val="1855"/>
+                <a:spcPts val="2048"/>
               </a:lnSpc>
               <a:spcAft>
                 <a:spcPts val="0"/>
               </a:spcAft>
             </a:pPr>
             <a:r>
-              <a:rPr sz="1450" b="1" i="0">
+              <a:rPr sz="1600" b="1" i="0">
                 <a:solidFill>
                   <a:srgbClr val="102D5E"/>
                 </a:solidFill>
@@ -4914,13 +4807,13 @@
               <a:t>Key message.  </a:t>
             </a:r>
             <a:r>
-              <a:rPr sz="1450" b="0" i="0">
+              <a:rPr sz="1600" b="0" i="0">
                 <a:solidFill>
                   <a:srgbClr val="212529"/>
                 </a:solidFill>
                 <a:latin typeface="Garamond"/>
               </a:rPr>
-              <a:t>For teachers under 35, a public-school job retains three times more strongly than for the rest (−4.5 vs −1.6 points), and a pension plan also retains more. Security keeps the young in the classroom.</a:t>
+              <a:t>States where more teachers have a pension plan have fewer early exits.</a:t>
             </a:r>
           </a:p>
         </p:txBody>
@@ -4945,111 +4838,20 @@
       <p:grpSpPr/>
       <p:sp>
         <p:nvSpPr>
-          <p:cNvPr id="2" name="TextBox 1"/>
-          <p:cNvSpPr txBox="1"/>
-          <p:nvPr/>
-        </p:nvSpPr>
-        <p:spPr>
-          <a:xfrm>
-            <a:off x="502920" y="219456"/>
-            <a:ext cx="11247120" cy="566928"/>
-          </a:xfrm>
-          <a:prstGeom prst="rect">
-            <a:avLst/>
-          </a:prstGeom>
-          <a:noFill/>
-        </p:spPr>
-        <p:txBody>
-          <a:bodyPr wrap="square" lIns="0" rIns="0" tIns="0" bIns="0"/>
-          <a:lstStyle/>
-          <a:p>
-            <a:r>
-              <a:rPr sz="2800" b="1">
-                <a:solidFill>
-                  <a:srgbClr val="102D5E"/>
-                </a:solidFill>
-                <a:latin typeface="Garamond"/>
-              </a:rPr>
-              <a:t>Leaving, over the life cycle</a:t>
-            </a:r>
-          </a:p>
-        </p:txBody>
-      </p:sp>
-      <p:sp>
-        <p:nvSpPr>
-          <p:cNvPr id="3" name="TextBox 2"/>
-          <p:cNvSpPr txBox="1"/>
-          <p:nvPr/>
-        </p:nvSpPr>
-        <p:spPr>
-          <a:xfrm>
-            <a:off x="11384280" y="6446520"/>
-            <a:ext cx="640080" cy="292608"/>
-          </a:xfrm>
-          <a:prstGeom prst="rect">
-            <a:avLst/>
-          </a:prstGeom>
-          <a:noFill/>
-        </p:spPr>
-        <p:txBody>
-          <a:bodyPr wrap="none" lIns="0" rIns="0" tIns="0" bIns="0">
-            <a:spAutoFit/>
-          </a:bodyPr>
-          <a:lstStyle/>
-          <a:p>
-            <a:pPr algn="r"/>
-            <a:r>
-              <a:rPr sz="1100">
-                <a:solidFill>
-                  <a:srgbClr val="6B7480"/>
-                </a:solidFill>
-                <a:latin typeface="Garamond"/>
-              </a:rPr>
-              <a:t>18</a:t>
-            </a:r>
-          </a:p>
-        </p:txBody>
-      </p:sp>
-      <p:pic>
-        <p:nvPicPr>
-          <p:cNvPr id="4" name="Picture 3" descr="u_routes_deck.png"/>
-          <p:cNvPicPr>
-            <a:picLocks noChangeAspect="1"/>
-          </p:cNvPicPr>
-          <p:nvPr/>
-        </p:nvPicPr>
-        <p:blipFill>
-          <a:blip r:embed="rId2"/>
-          <a:stretch>
-            <a:fillRect/>
-          </a:stretch>
-        </p:blipFill>
-        <p:spPr>
-          <a:xfrm>
-            <a:off x="640080" y="1501140"/>
-            <a:ext cx="10881360" cy="3627120"/>
-          </a:xfrm>
-          <a:prstGeom prst="rect">
-            <a:avLst/>
-          </a:prstGeom>
-        </p:spPr>
-      </p:pic>
-      <p:sp>
-        <p:nvSpPr>
-          <p:cNvPr id="5" name="Rectangle 4"/>
+          <p:cNvPr id="2" name="Rectangle 1"/>
           <p:cNvSpPr/>
           <p:nvPr/>
         </p:nvSpPr>
         <p:spPr>
           <a:xfrm>
-            <a:off x="0" y="5559552"/>
-            <a:ext cx="12191695" cy="960120"/>
+            <a:off x="0" y="0"/>
+            <a:ext cx="12191695" cy="6858000"/>
           </a:xfrm>
           <a:prstGeom prst="rect">
             <a:avLst/>
           </a:prstGeom>
           <a:solidFill>
-            <a:srgbClr val="ECF2F9"/>
+            <a:srgbClr val="102D5E"/>
           </a:solidFill>
           <a:ln>
             <a:noFill/>
@@ -5080,14 +4882,14 @@
       </p:sp>
       <p:sp>
         <p:nvSpPr>
-          <p:cNvPr id="6" name="TextBox 5"/>
+          <p:cNvPr id="3" name="TextBox 2"/>
           <p:cNvSpPr txBox="1"/>
           <p:nvPr/>
         </p:nvSpPr>
         <p:spPr>
           <a:xfrm>
-            <a:off x="822960" y="5687568"/>
-            <a:ext cx="10789920" cy="822960"/>
+            <a:off x="914400" y="2240280"/>
+            <a:ext cx="10360152" cy="1188720"/>
           </a:xfrm>
           <a:prstGeom prst="rect">
             <a:avLst/>
@@ -5100,31 +4902,64 @@
           </a:bodyPr>
           <a:lstStyle/>
           <a:p>
-            <a:pPr algn="l">
+            <a:pPr algn="ctr">
               <a:lnSpc>
-                <a:spcPts val="2048"/>
+                <a:spcPts val="7680"/>
               </a:lnSpc>
               <a:spcAft>
                 <a:spcPts val="0"/>
               </a:spcAft>
             </a:pPr>
             <a:r>
-              <a:rPr sz="1600" b="1" i="0">
-                <a:solidFill>
-                  <a:srgbClr val="102D5E"/>
-                </a:solidFill>
-                <a:latin typeface="Garamond"/>
-              </a:rPr>
-              <a:t>Key message.  </a:t>
-            </a:r>
-            <a:r>
-              <a:rPr sz="1600" b="0" i="0">
-                <a:solidFill>
-                  <a:srgbClr val="212529"/>
-                </a:solidFill>
-                <a:latin typeface="Garamond"/>
-              </a:rPr>
-              <a:t>The risk of leaving is highest at the two ends of the career. Early exits go to other jobs; late exits leave the labor force.</a:t>
+              <a:rPr sz="6000" b="1" i="0">
+                <a:solidFill>
+                  <a:srgbClr val="FFFFFF"/>
+                </a:solidFill>
+                <a:latin typeface="Garamond"/>
+              </a:rPr>
+              <a:t>4</a:t>
+            </a:r>
+          </a:p>
+        </p:txBody>
+      </p:sp>
+      <p:sp>
+        <p:nvSpPr>
+          <p:cNvPr id="4" name="TextBox 3"/>
+          <p:cNvSpPr txBox="1"/>
+          <p:nvPr/>
+        </p:nvSpPr>
+        <p:spPr>
+          <a:xfrm>
+            <a:off x="914400" y="3703320"/>
+            <a:ext cx="10360152" cy="731520"/>
+          </a:xfrm>
+          <a:prstGeom prst="rect">
+            <a:avLst/>
+          </a:prstGeom>
+          <a:noFill/>
+        </p:spPr>
+        <p:txBody>
+          <a:bodyPr wrap="square" lIns="0" rIns="0" tIns="0" bIns="0">
+            <a:spAutoFit/>
+          </a:bodyPr>
+          <a:lstStyle/>
+          <a:p>
+            <a:pPr algn="ctr">
+              <a:lnSpc>
+                <a:spcPts val="3584"/>
+              </a:lnSpc>
+              <a:spcAft>
+                <a:spcPts val="0"/>
+              </a:spcAft>
+            </a:pPr>
+            <a:r>
+              <a:rPr sz="2800" b="0" i="0">
+                <a:solidFill>
+                  <a:srgbClr val="D7E3F2"/>
+                </a:solidFill>
+                <a:latin typeface="Garamond"/>
+              </a:rPr>
+              <a:t>What it means for policy</a:t>
             </a:r>
           </a:p>
         </p:txBody>
@@ -5174,7 +5009,7 @@
                 </a:solidFill>
                 <a:latin typeface="Garamond"/>
               </a:rPr>
-              <a:t>Relative pay since 1997</a:t>
+              <a:t>Policy options for re-attraction</a:t>
             </a:r>
           </a:p>
         </p:txBody>
@@ -5214,84 +5049,16 @@
           </a:p>
         </p:txBody>
       </p:sp>
-      <p:pic>
-        <p:nvPicPr>
-          <p:cNvPr id="4" name="Picture 3" descr="msgA3.png"/>
-          <p:cNvPicPr>
-            <a:picLocks noChangeAspect="1"/>
-          </p:cNvPicPr>
-          <p:nvPr/>
-        </p:nvPicPr>
-        <p:blipFill>
-          <a:blip r:embed="rId2"/>
-          <a:stretch>
-            <a:fillRect/>
-          </a:stretch>
-        </p:blipFill>
-        <p:spPr>
-          <a:xfrm>
-            <a:off x="702337" y="1097280"/>
-            <a:ext cx="10756845" cy="4434840"/>
-          </a:xfrm>
-          <a:prstGeom prst="rect">
-            <a:avLst/>
-          </a:prstGeom>
-        </p:spPr>
-      </p:pic>
-      <p:sp>
-        <p:nvSpPr>
-          <p:cNvPr id="5" name="Rectangle 4"/>
-          <p:cNvSpPr/>
-          <p:nvPr/>
-        </p:nvSpPr>
-        <p:spPr>
-          <a:xfrm>
-            <a:off x="0" y="5559552"/>
-            <a:ext cx="12191695" cy="960120"/>
-          </a:xfrm>
-          <a:prstGeom prst="rect">
-            <a:avLst/>
-          </a:prstGeom>
-          <a:solidFill>
-            <a:srgbClr val="ECF2F9"/>
-          </a:solidFill>
-          <a:ln>
-            <a:noFill/>
-          </a:ln>
-          <a:effectLst/>
-        </p:spPr>
-        <p:style>
-          <a:lnRef idx="1">
-            <a:schemeClr val="accent1"/>
-          </a:lnRef>
-          <a:fillRef idx="3">
-            <a:schemeClr val="accent1"/>
-          </a:fillRef>
-          <a:effectRef idx="2">
-            <a:schemeClr val="accent1"/>
-          </a:effectRef>
-          <a:fontRef idx="minor">
-            <a:schemeClr val="lt1"/>
-          </a:fontRef>
-        </p:style>
-        <p:txBody>
-          <a:bodyPr rtlCol="0" anchor="ctr"/>
-          <a:lstStyle/>
-          <a:p>
-            <a:pPr algn="ctr"/>
-          </a:p>
-        </p:txBody>
-      </p:sp>
-      <p:sp>
-        <p:nvSpPr>
-          <p:cNvPr id="6" name="TextBox 5"/>
+      <p:sp>
+        <p:nvSpPr>
+          <p:cNvPr id="4" name="TextBox 3"/>
           <p:cNvSpPr txBox="1"/>
           <p:nvPr/>
         </p:nvSpPr>
         <p:spPr>
           <a:xfrm>
-            <a:off x="822960" y="5687568"/>
-            <a:ext cx="10789920" cy="822960"/>
+            <a:off x="822960" y="1325880"/>
+            <a:ext cx="5120640" cy="457200"/>
           </a:xfrm>
           <a:prstGeom prst="rect">
             <a:avLst/>
@@ -5306,29 +5073,391 @@
           <a:p>
             <a:pPr algn="l">
               <a:lnSpc>
-                <a:spcPts val="2048"/>
+                <a:spcPts val="2688"/>
               </a:lnSpc>
               <a:spcAft>
                 <a:spcPts val="0"/>
               </a:spcAft>
             </a:pPr>
             <a:r>
-              <a:rPr sz="1600" b="1" i="0">
+              <a:rPr sz="2100" b="1" i="0">
+                <a:solidFill>
+                  <a:srgbClr val="2D6CB5"/>
+                </a:solidFill>
+                <a:latin typeface="Garamond"/>
+              </a:rPr>
+              <a:t>Short term and retirees</a:t>
+            </a:r>
+          </a:p>
+        </p:txBody>
+      </p:sp>
+      <p:sp>
+        <p:nvSpPr>
+          <p:cNvPr id="5" name="TextBox 4"/>
+          <p:cNvSpPr txBox="1"/>
+          <p:nvPr/>
+        </p:nvSpPr>
+        <p:spPr>
+          <a:xfrm>
+            <a:off x="822960" y="1828800"/>
+            <a:ext cx="5120640" cy="1554480"/>
+          </a:xfrm>
+          <a:prstGeom prst="rect">
+            <a:avLst/>
+          </a:prstGeom>
+          <a:noFill/>
+        </p:spPr>
+        <p:txBody>
+          <a:bodyPr wrap="square" lIns="0" rIns="0" tIns="0" bIns="0">
+            <a:spAutoFit/>
+          </a:bodyPr>
+          <a:lstStyle/>
+          <a:p>
+            <a:pPr algn="l">
+              <a:lnSpc>
+                <a:spcPts val="2176"/>
+              </a:lnSpc>
+              <a:spcAft>
+                <a:spcPts val="0"/>
+              </a:spcAft>
+            </a:pPr>
+            <a:r>
+              <a:rPr sz="1700" b="0" i="0">
+                <a:solidFill>
+                  <a:srgbClr val="212529"/>
+                </a:solidFill>
+                <a:latin typeface="Garamond"/>
+              </a:rPr>
+              <a:t>A reserve for local shortages. They bring experience and can mentor new teachers. Make it easy to return, for example part-time or “double-dipping”.</a:t>
+            </a:r>
+          </a:p>
+        </p:txBody>
+      </p:sp>
+      <p:sp>
+        <p:nvSpPr>
+          <p:cNvPr id="6" name="TextBox 5"/>
+          <p:cNvSpPr txBox="1"/>
+          <p:nvPr/>
+        </p:nvSpPr>
+        <p:spPr>
+          <a:xfrm>
+            <a:off x="6355080" y="1325880"/>
+            <a:ext cx="5120640" cy="457200"/>
+          </a:xfrm>
+          <a:prstGeom prst="rect">
+            <a:avLst/>
+          </a:prstGeom>
+          <a:noFill/>
+        </p:spPr>
+        <p:txBody>
+          <a:bodyPr wrap="square" lIns="0" rIns="0" tIns="0" bIns="0">
+            <a:spAutoFit/>
+          </a:bodyPr>
+          <a:lstStyle/>
+          <a:p>
+            <a:pPr algn="l">
+              <a:lnSpc>
+                <a:spcPts val="2688"/>
+              </a:lnSpc>
+              <a:spcAft>
+                <a:spcPts val="0"/>
+              </a:spcAft>
+            </a:pPr>
+            <a:r>
+              <a:rPr sz="2100" b="1" i="0">
+                <a:solidFill>
+                  <a:srgbClr val="2D6CB5"/>
+                </a:solidFill>
+                <a:latin typeface="Garamond"/>
+              </a:rPr>
+              <a:t>Medium term and switchers</a:t>
+            </a:r>
+          </a:p>
+        </p:txBody>
+      </p:sp>
+      <p:sp>
+        <p:nvSpPr>
+          <p:cNvPr id="7" name="TextBox 6"/>
+          <p:cNvSpPr txBox="1"/>
+          <p:nvPr/>
+        </p:nvSpPr>
+        <p:spPr>
+          <a:xfrm>
+            <a:off x="6355080" y="1828800"/>
+            <a:ext cx="5120640" cy="1554480"/>
+          </a:xfrm>
+          <a:prstGeom prst="rect">
+            <a:avLst/>
+          </a:prstGeom>
+          <a:noFill/>
+        </p:spPr>
+        <p:txBody>
+          <a:bodyPr wrap="square" lIns="0" rIns="0" tIns="0" bIns="0">
+            <a:spAutoFit/>
+          </a:bodyPr>
+          <a:lstStyle/>
+          <a:p>
+            <a:pPr algn="l">
+              <a:lnSpc>
+                <a:spcPts val="2176"/>
+              </a:lnSpc>
+              <a:spcAft>
+                <a:spcPts val="0"/>
+              </a:spcAft>
+            </a:pPr>
+            <a:r>
+              <a:rPr sz="1700" b="0" i="0">
+                <a:solidFill>
+                  <a:srgbClr val="212529"/>
+                </a:solidFill>
+                <a:latin typeface="Garamond"/>
+              </a:rPr>
+              <a:t>Early-career conditions (secure contracts, fair pay at the bottom) and support (mentoring). Learn why some move to jobs that do not require a degree.</a:t>
+            </a:r>
+          </a:p>
+        </p:txBody>
+      </p:sp>
+      <p:sp>
+        <p:nvSpPr>
+          <p:cNvPr id="8" name="TextBox 7"/>
+          <p:cNvSpPr txBox="1"/>
+          <p:nvPr/>
+        </p:nvSpPr>
+        <p:spPr>
+          <a:xfrm>
+            <a:off x="822960" y="3566160"/>
+            <a:ext cx="5120640" cy="457200"/>
+          </a:xfrm>
+          <a:prstGeom prst="rect">
+            <a:avLst/>
+          </a:prstGeom>
+          <a:noFill/>
+        </p:spPr>
+        <p:txBody>
+          <a:bodyPr wrap="square" lIns="0" rIns="0" tIns="0" bIns="0">
+            <a:spAutoFit/>
+          </a:bodyPr>
+          <a:lstStyle/>
+          <a:p>
+            <a:pPr algn="l">
+              <a:lnSpc>
+                <a:spcPts val="2688"/>
+              </a:lnSpc>
+              <a:spcAft>
+                <a:spcPts val="0"/>
+              </a:spcAft>
+            </a:pPr>
+            <a:r>
+              <a:rPr sz="2100" b="1" i="0">
+                <a:solidFill>
+                  <a:srgbClr val="2D6CB5"/>
+                </a:solidFill>
+                <a:latin typeface="Garamond"/>
+              </a:rPr>
+              <a:t>Long term and early exits</a:t>
+            </a:r>
+          </a:p>
+        </p:txBody>
+      </p:sp>
+      <p:sp>
+        <p:nvSpPr>
+          <p:cNvPr id="9" name="TextBox 8"/>
+          <p:cNvSpPr txBox="1"/>
+          <p:nvPr/>
+        </p:nvSpPr>
+        <p:spPr>
+          <a:xfrm>
+            <a:off x="822960" y="4069080"/>
+            <a:ext cx="5120640" cy="1554480"/>
+          </a:xfrm>
+          <a:prstGeom prst="rect">
+            <a:avLst/>
+          </a:prstGeom>
+          <a:noFill/>
+        </p:spPr>
+        <p:txBody>
+          <a:bodyPr wrap="square" lIns="0" rIns="0" tIns="0" bIns="0">
+            <a:spAutoFit/>
+          </a:bodyPr>
+          <a:lstStyle/>
+          <a:p>
+            <a:pPr algn="l">
+              <a:lnSpc>
+                <a:spcPts val="2176"/>
+              </a:lnSpc>
+              <a:spcAft>
+                <a:spcPts val="0"/>
+              </a:spcAft>
+            </a:pPr>
+            <a:r>
+              <a:rPr sz="1700" b="0" i="0">
+                <a:solidFill>
+                  <a:srgbClr val="212529"/>
+                </a:solidFill>
+                <a:latin typeface="Garamond"/>
+              </a:rPr>
+              <a:t>Flexibility, so those who want to return can do so in favoring conditions, and clear paths to return.</a:t>
+            </a:r>
+          </a:p>
+        </p:txBody>
+      </p:sp>
+      <p:sp>
+        <p:nvSpPr>
+          <p:cNvPr id="10" name="TextBox 9"/>
+          <p:cNvSpPr txBox="1"/>
+          <p:nvPr/>
+        </p:nvSpPr>
+        <p:spPr>
+          <a:xfrm>
+            <a:off x="6355080" y="3566160"/>
+            <a:ext cx="5120640" cy="457200"/>
+          </a:xfrm>
+          <a:prstGeom prst="rect">
+            <a:avLst/>
+          </a:prstGeom>
+          <a:noFill/>
+        </p:spPr>
+        <p:txBody>
+          <a:bodyPr wrap="square" lIns="0" rIns="0" tIns="0" bIns="0">
+            <a:spAutoFit/>
+          </a:bodyPr>
+          <a:lstStyle/>
+          <a:p>
+            <a:pPr algn="l">
+              <a:lnSpc>
+                <a:spcPts val="2688"/>
+              </a:lnSpc>
+              <a:spcAft>
+                <a:spcPts val="0"/>
+              </a:spcAft>
+            </a:pPr>
+            <a:r>
+              <a:rPr sz="2100" b="1" i="0">
+                <a:solidFill>
+                  <a:srgbClr val="2D6CB5"/>
+                </a:solidFill>
+                <a:latin typeface="Garamond"/>
+              </a:rPr>
+              <a:t>Research agenda</a:t>
+            </a:r>
+          </a:p>
+        </p:txBody>
+      </p:sp>
+      <p:sp>
+        <p:nvSpPr>
+          <p:cNvPr id="11" name="TextBox 10"/>
+          <p:cNvSpPr txBox="1"/>
+          <p:nvPr/>
+        </p:nvSpPr>
+        <p:spPr>
+          <a:xfrm>
+            <a:off x="6355080" y="4069080"/>
+            <a:ext cx="5120640" cy="1554480"/>
+          </a:xfrm>
+          <a:prstGeom prst="rect">
+            <a:avLst/>
+          </a:prstGeom>
+          <a:noFill/>
+        </p:spPr>
+        <p:txBody>
+          <a:bodyPr wrap="square" lIns="0" rIns="0" tIns="0" bIns="0">
+            <a:spAutoFit/>
+          </a:bodyPr>
+          <a:lstStyle/>
+          <a:p>
+            <a:pPr algn="l">
+              <a:lnSpc>
+                <a:spcPts val="2176"/>
+              </a:lnSpc>
+              <a:spcAft>
+                <a:spcPts val="0"/>
+              </a:spcAft>
+            </a:pPr>
+            <a:r>
+              <a:rPr sz="1700" b="0" i="0">
+                <a:solidFill>
+                  <a:srgbClr val="212529"/>
+                </a:solidFill>
+                <a:latin typeface="Garamond"/>
+              </a:rPr>
+              <a:t>Working conditions inside schools. Do these patterns hold in other countries?</a:t>
+            </a:r>
+          </a:p>
+        </p:txBody>
+      </p:sp>
+      <p:cxnSp>
+        <p:nvCxnSpPr>
+          <p:cNvPr id="12" name="Connector 11"/>
+          <p:cNvCxnSpPr/>
+          <p:nvPr/>
+        </p:nvCxnSpPr>
+        <p:spPr>
+          <a:xfrm>
+            <a:off x="822960" y="5806440"/>
+            <a:ext cx="10543032" cy="0"/>
+          </a:xfrm>
+          <a:prstGeom prst="line">
+            <a:avLst/>
+          </a:prstGeom>
+          <a:ln w="12700">
+            <a:solidFill>
+              <a:srgbClr val="102D5E"/>
+            </a:solidFill>
+          </a:ln>
+        </p:spPr>
+        <p:style>
+          <a:lnRef idx="2">
+            <a:schemeClr val="accent1"/>
+          </a:lnRef>
+          <a:fillRef idx="0">
+            <a:schemeClr val="accent1"/>
+          </a:fillRef>
+          <a:effectRef idx="1">
+            <a:schemeClr val="accent1"/>
+          </a:effectRef>
+          <a:fontRef idx="minor">
+            <a:schemeClr val="tx1"/>
+          </a:fontRef>
+        </p:style>
+      </p:cxnSp>
+      <p:sp>
+        <p:nvSpPr>
+          <p:cNvPr id="13" name="TextBox 12"/>
+          <p:cNvSpPr txBox="1"/>
+          <p:nvPr/>
+        </p:nvSpPr>
+        <p:spPr>
+          <a:xfrm>
+            <a:off x="822960" y="5989320"/>
+            <a:ext cx="10789920" cy="457200"/>
+          </a:xfrm>
+          <a:prstGeom prst="rect">
+            <a:avLst/>
+          </a:prstGeom>
+          <a:noFill/>
+        </p:spPr>
+        <p:txBody>
+          <a:bodyPr wrap="square" lIns="0" rIns="0" tIns="0" bIns="0">
+            <a:spAutoFit/>
+          </a:bodyPr>
+          <a:lstStyle/>
+          <a:p>
+            <a:pPr algn="ctr">
+              <a:lnSpc>
+                <a:spcPts val="2560"/>
+              </a:lnSpc>
+              <a:spcAft>
+                <a:spcPts val="0"/>
+              </a:spcAft>
+            </a:pPr>
+            <a:r>
+              <a:rPr sz="2000" b="1" i="0">
                 <a:solidFill>
                   <a:srgbClr val="102D5E"/>
                 </a:solidFill>
                 <a:latin typeface="Garamond"/>
               </a:rPr>
-              <a:t>Key message.  </a:t>
-            </a:r>
-            <a:r>
-              <a:rPr sz="1600" b="0" i="0">
-                <a:solidFill>
-                  <a:srgbClr val="212529"/>
-                </a:solidFill>
-                <a:latin typeface="Garamond"/>
-              </a:rPr>
-              <a:t>Teacher pay has not grown in 25 years.</a:t>
+              <a:t>Across all three: economic security.</a:t>
             </a:r>
           </a:p>
         </p:txBody>
@@ -5705,7 +5834,7 @@
                 </a:solidFill>
                 <a:latin typeface="Garamond"/>
               </a:rPr>
-              <a:t>Leaving, by position in the teacher pay distribution</a:t>
+              <a:t>Open questions</a:t>
             </a:r>
           </a:p>
         </p:txBody>
@@ -5741,1268 +5870,6 @@
                 <a:latin typeface="Garamond"/>
               </a:rPr>
               <a:t>20</a:t>
-            </a:r>
-          </a:p>
-        </p:txBody>
-      </p:sp>
-      <p:pic>
-        <p:nvPicPr>
-          <p:cNvPr id="4" name="Picture 3" descr="pay3_deciles_deck.png"/>
-          <p:cNvPicPr>
-            <a:picLocks noChangeAspect="1"/>
-          </p:cNvPicPr>
-          <p:nvPr/>
-        </p:nvPicPr>
-        <p:blipFill>
-          <a:blip r:embed="rId2"/>
-          <a:stretch>
-            <a:fillRect/>
-          </a:stretch>
-        </p:blipFill>
-        <p:spPr>
-          <a:xfrm>
-            <a:off x="1645920" y="1097280"/>
-            <a:ext cx="8869680" cy="4434840"/>
-          </a:xfrm>
-          <a:prstGeom prst="rect">
-            <a:avLst/>
-          </a:prstGeom>
-        </p:spPr>
-      </p:pic>
-      <p:sp>
-        <p:nvSpPr>
-          <p:cNvPr id="5" name="Rectangle 4"/>
-          <p:cNvSpPr/>
-          <p:nvPr/>
-        </p:nvSpPr>
-        <p:spPr>
-          <a:xfrm>
-            <a:off x="0" y="5559552"/>
-            <a:ext cx="12191695" cy="960120"/>
-          </a:xfrm>
-          <a:prstGeom prst="rect">
-            <a:avLst/>
-          </a:prstGeom>
-          <a:solidFill>
-            <a:srgbClr val="ECF2F9"/>
-          </a:solidFill>
-          <a:ln>
-            <a:noFill/>
-          </a:ln>
-          <a:effectLst/>
-        </p:spPr>
-        <p:style>
-          <a:lnRef idx="1">
-            <a:schemeClr val="accent1"/>
-          </a:lnRef>
-          <a:fillRef idx="3">
-            <a:schemeClr val="accent1"/>
-          </a:fillRef>
-          <a:effectRef idx="2">
-            <a:schemeClr val="accent1"/>
-          </a:effectRef>
-          <a:fontRef idx="minor">
-            <a:schemeClr val="lt1"/>
-          </a:fontRef>
-        </p:style>
-        <p:txBody>
-          <a:bodyPr rtlCol="0" anchor="ctr"/>
-          <a:lstStyle/>
-          <a:p>
-            <a:pPr algn="ctr"/>
-          </a:p>
-        </p:txBody>
-      </p:sp>
-      <p:sp>
-        <p:nvSpPr>
-          <p:cNvPr id="6" name="TextBox 5"/>
-          <p:cNvSpPr txBox="1"/>
-          <p:nvPr/>
-        </p:nvSpPr>
-        <p:spPr>
-          <a:xfrm>
-            <a:off x="822960" y="5687568"/>
-            <a:ext cx="10789920" cy="822960"/>
-          </a:xfrm>
-          <a:prstGeom prst="rect">
-            <a:avLst/>
-          </a:prstGeom>
-          <a:noFill/>
-        </p:spPr>
-        <p:txBody>
-          <a:bodyPr wrap="square" lIns="0" rIns="0" tIns="0" bIns="0">
-            <a:spAutoFit/>
-          </a:bodyPr>
-          <a:lstStyle/>
-          <a:p>
-            <a:pPr algn="l">
-              <a:lnSpc>
-                <a:spcPts val="2048"/>
-              </a:lnSpc>
-              <a:spcAft>
-                <a:spcPts val="0"/>
-              </a:spcAft>
-            </a:pPr>
-            <a:r>
-              <a:rPr sz="1600" b="1" i="0">
-                <a:solidFill>
-                  <a:srgbClr val="102D5E"/>
-                </a:solidFill>
-                <a:latin typeface="Garamond"/>
-              </a:rPr>
-              <a:t>Key message.  </a:t>
-            </a:r>
-            <a:r>
-              <a:rPr sz="1600" b="0" i="0">
-                <a:solidFill>
-                  <a:srgbClr val="212529"/>
-                </a:solidFill>
-                <a:latin typeface="Garamond"/>
-              </a:rPr>
-              <a:t>Leavers are concentrated in the bottom two deciles.</a:t>
-            </a:r>
-          </a:p>
-        </p:txBody>
-      </p:sp>
-    </p:spTree>
-  </p:cSld>
-  <p:clrMapOvr>
-    <a:masterClrMapping/>
-  </p:clrMapOvr>
-</p:sld>
-</file>
-
-<file path=ppt/slides/slide21.xml><?xml version="1.0" encoding="utf-8"?>
-<p:sld xmlns:a="http://schemas.openxmlformats.org/drawingml/2006/main" xmlns:p="http://schemas.openxmlformats.org/presentationml/2006/main" xmlns:r="http://schemas.openxmlformats.org/officeDocument/2006/relationships">
-  <p:cSld>
-    <p:spTree>
-      <p:nvGrpSpPr>
-        <p:cNvPr id="1" name=""/>
-        <p:cNvGrpSpPr/>
-        <p:nvPr/>
-      </p:nvGrpSpPr>
-      <p:grpSpPr/>
-      <p:sp>
-        <p:nvSpPr>
-          <p:cNvPr id="2" name="TextBox 1"/>
-          <p:cNvSpPr txBox="1"/>
-          <p:nvPr/>
-        </p:nvSpPr>
-        <p:spPr>
-          <a:xfrm>
-            <a:off x="502920" y="219456"/>
-            <a:ext cx="11247120" cy="566928"/>
-          </a:xfrm>
-          <a:prstGeom prst="rect">
-            <a:avLst/>
-          </a:prstGeom>
-          <a:noFill/>
-        </p:spPr>
-        <p:txBody>
-          <a:bodyPr wrap="square" lIns="0" rIns="0" tIns="0" bIns="0"/>
-          <a:lstStyle/>
-          <a:p>
-            <a:r>
-              <a:rPr sz="2800" b="1">
-                <a:solidFill>
-                  <a:srgbClr val="102D5E"/>
-                </a:solidFill>
-                <a:latin typeface="Garamond"/>
-              </a:rPr>
-              <a:t>Pension coverage and leaving, across states</a:t>
-            </a:r>
-          </a:p>
-        </p:txBody>
-      </p:sp>
-      <p:sp>
-        <p:nvSpPr>
-          <p:cNvPr id="3" name="TextBox 2"/>
-          <p:cNvSpPr txBox="1"/>
-          <p:nvPr/>
-        </p:nvSpPr>
-        <p:spPr>
-          <a:xfrm>
-            <a:off x="11384280" y="6446520"/>
-            <a:ext cx="640080" cy="292608"/>
-          </a:xfrm>
-          <a:prstGeom prst="rect">
-            <a:avLst/>
-          </a:prstGeom>
-          <a:noFill/>
-        </p:spPr>
-        <p:txBody>
-          <a:bodyPr wrap="none" lIns="0" rIns="0" tIns="0" bIns="0">
-            <a:spAutoFit/>
-          </a:bodyPr>
-          <a:lstStyle/>
-          <a:p>
-            <a:pPr algn="r"/>
-            <a:r>
-              <a:rPr sz="1100">
-                <a:solidFill>
-                  <a:srgbClr val="6B7480"/>
-                </a:solidFill>
-                <a:latin typeface="Garamond"/>
-              </a:rPr>
-              <a:t>21</a:t>
-            </a:r>
-          </a:p>
-        </p:txBody>
-      </p:sp>
-      <p:pic>
-        <p:nvPicPr>
-          <p:cNvPr id="4" name="Picture 3" descr="pension_scatter_deck.png"/>
-          <p:cNvPicPr>
-            <a:picLocks noChangeAspect="1"/>
-          </p:cNvPicPr>
-          <p:nvPr/>
-        </p:nvPicPr>
-        <p:blipFill>
-          <a:blip r:embed="rId2"/>
-          <a:stretch>
-            <a:fillRect/>
-          </a:stretch>
-        </p:blipFill>
-        <p:spPr>
-          <a:xfrm>
-            <a:off x="2289687" y="1097280"/>
-            <a:ext cx="7582145" cy="4434840"/>
-          </a:xfrm>
-          <a:prstGeom prst="rect">
-            <a:avLst/>
-          </a:prstGeom>
-        </p:spPr>
-      </p:pic>
-      <p:sp>
-        <p:nvSpPr>
-          <p:cNvPr id="5" name="Rectangle 4"/>
-          <p:cNvSpPr/>
-          <p:nvPr/>
-        </p:nvSpPr>
-        <p:spPr>
-          <a:xfrm>
-            <a:off x="0" y="5559552"/>
-            <a:ext cx="12191695" cy="960120"/>
-          </a:xfrm>
-          <a:prstGeom prst="rect">
-            <a:avLst/>
-          </a:prstGeom>
-          <a:solidFill>
-            <a:srgbClr val="ECF2F9"/>
-          </a:solidFill>
-          <a:ln>
-            <a:noFill/>
-          </a:ln>
-          <a:effectLst/>
-        </p:spPr>
-        <p:style>
-          <a:lnRef idx="1">
-            <a:schemeClr val="accent1"/>
-          </a:lnRef>
-          <a:fillRef idx="3">
-            <a:schemeClr val="accent1"/>
-          </a:fillRef>
-          <a:effectRef idx="2">
-            <a:schemeClr val="accent1"/>
-          </a:effectRef>
-          <a:fontRef idx="minor">
-            <a:schemeClr val="lt1"/>
-          </a:fontRef>
-        </p:style>
-        <p:txBody>
-          <a:bodyPr rtlCol="0" anchor="ctr"/>
-          <a:lstStyle/>
-          <a:p>
-            <a:pPr algn="ctr"/>
-          </a:p>
-        </p:txBody>
-      </p:sp>
-      <p:sp>
-        <p:nvSpPr>
-          <p:cNvPr id="6" name="TextBox 5"/>
-          <p:cNvSpPr txBox="1"/>
-          <p:nvPr/>
-        </p:nvSpPr>
-        <p:spPr>
-          <a:xfrm>
-            <a:off x="822960" y="5687568"/>
-            <a:ext cx="10789920" cy="822960"/>
-          </a:xfrm>
-          <a:prstGeom prst="rect">
-            <a:avLst/>
-          </a:prstGeom>
-          <a:noFill/>
-        </p:spPr>
-        <p:txBody>
-          <a:bodyPr wrap="square" lIns="0" rIns="0" tIns="0" bIns="0">
-            <a:spAutoFit/>
-          </a:bodyPr>
-          <a:lstStyle/>
-          <a:p>
-            <a:pPr algn="l">
-              <a:lnSpc>
-                <a:spcPts val="2048"/>
-              </a:lnSpc>
-              <a:spcAft>
-                <a:spcPts val="0"/>
-              </a:spcAft>
-            </a:pPr>
-            <a:r>
-              <a:rPr sz="1600" b="1" i="0">
-                <a:solidFill>
-                  <a:srgbClr val="102D5E"/>
-                </a:solidFill>
-                <a:latin typeface="Garamond"/>
-              </a:rPr>
-              <a:t>Key message.  </a:t>
-            </a:r>
-            <a:r>
-              <a:rPr sz="1600" b="0" i="0">
-                <a:solidFill>
-                  <a:srgbClr val="212529"/>
-                </a:solidFill>
-                <a:latin typeface="Garamond"/>
-              </a:rPr>
-              <a:t>States where more teachers have a pension plan have fewer early exits.</a:t>
-            </a:r>
-          </a:p>
-        </p:txBody>
-      </p:sp>
-    </p:spTree>
-  </p:cSld>
-  <p:clrMapOvr>
-    <a:masterClrMapping/>
-  </p:clrMapOvr>
-</p:sld>
-</file>
-
-<file path=ppt/slides/slide22.xml><?xml version="1.0" encoding="utf-8"?>
-<p:sld xmlns:a="http://schemas.openxmlformats.org/drawingml/2006/main" xmlns:p="http://schemas.openxmlformats.org/presentationml/2006/main" xmlns:r="http://schemas.openxmlformats.org/officeDocument/2006/relationships">
-  <p:cSld>
-    <p:spTree>
-      <p:nvGrpSpPr>
-        <p:cNvPr id="1" name=""/>
-        <p:cNvGrpSpPr/>
-        <p:nvPr/>
-      </p:nvGrpSpPr>
-      <p:grpSpPr/>
-      <p:sp>
-        <p:nvSpPr>
-          <p:cNvPr id="2" name="Rectangle 1"/>
-          <p:cNvSpPr/>
-          <p:nvPr/>
-        </p:nvSpPr>
-        <p:spPr>
-          <a:xfrm>
-            <a:off x="0" y="0"/>
-            <a:ext cx="12191695" cy="6858000"/>
-          </a:xfrm>
-          <a:prstGeom prst="rect">
-            <a:avLst/>
-          </a:prstGeom>
-          <a:solidFill>
-            <a:srgbClr val="102D5E"/>
-          </a:solidFill>
-          <a:ln>
-            <a:noFill/>
-          </a:ln>
-          <a:effectLst/>
-        </p:spPr>
-        <p:style>
-          <a:lnRef idx="1">
-            <a:schemeClr val="accent1"/>
-          </a:lnRef>
-          <a:fillRef idx="3">
-            <a:schemeClr val="accent1"/>
-          </a:fillRef>
-          <a:effectRef idx="2">
-            <a:schemeClr val="accent1"/>
-          </a:effectRef>
-          <a:fontRef idx="minor">
-            <a:schemeClr val="lt1"/>
-          </a:fontRef>
-        </p:style>
-        <p:txBody>
-          <a:bodyPr rtlCol="0" anchor="ctr"/>
-          <a:lstStyle/>
-          <a:p>
-            <a:pPr algn="ctr"/>
-          </a:p>
-        </p:txBody>
-      </p:sp>
-      <p:sp>
-        <p:nvSpPr>
-          <p:cNvPr id="3" name="TextBox 2"/>
-          <p:cNvSpPr txBox="1"/>
-          <p:nvPr/>
-        </p:nvSpPr>
-        <p:spPr>
-          <a:xfrm>
-            <a:off x="914400" y="2240280"/>
-            <a:ext cx="10360152" cy="1188720"/>
-          </a:xfrm>
-          <a:prstGeom prst="rect">
-            <a:avLst/>
-          </a:prstGeom>
-          <a:noFill/>
-        </p:spPr>
-        <p:txBody>
-          <a:bodyPr wrap="square" lIns="0" rIns="0" tIns="0" bIns="0">
-            <a:spAutoFit/>
-          </a:bodyPr>
-          <a:lstStyle/>
-          <a:p>
-            <a:pPr algn="ctr">
-              <a:lnSpc>
-                <a:spcPts val="7680"/>
-              </a:lnSpc>
-              <a:spcAft>
-                <a:spcPts val="0"/>
-              </a:spcAft>
-            </a:pPr>
-            <a:r>
-              <a:rPr sz="6000" b="1" i="0">
-                <a:solidFill>
-                  <a:srgbClr val="FFFFFF"/>
-                </a:solidFill>
-                <a:latin typeface="Garamond"/>
-              </a:rPr>
-              <a:t>4</a:t>
-            </a:r>
-          </a:p>
-        </p:txBody>
-      </p:sp>
-      <p:sp>
-        <p:nvSpPr>
-          <p:cNvPr id="4" name="TextBox 3"/>
-          <p:cNvSpPr txBox="1"/>
-          <p:nvPr/>
-        </p:nvSpPr>
-        <p:spPr>
-          <a:xfrm>
-            <a:off x="914400" y="3703320"/>
-            <a:ext cx="10360152" cy="731520"/>
-          </a:xfrm>
-          <a:prstGeom prst="rect">
-            <a:avLst/>
-          </a:prstGeom>
-          <a:noFill/>
-        </p:spPr>
-        <p:txBody>
-          <a:bodyPr wrap="square" lIns="0" rIns="0" tIns="0" bIns="0">
-            <a:spAutoFit/>
-          </a:bodyPr>
-          <a:lstStyle/>
-          <a:p>
-            <a:pPr algn="ctr">
-              <a:lnSpc>
-                <a:spcPts val="3584"/>
-              </a:lnSpc>
-              <a:spcAft>
-                <a:spcPts val="0"/>
-              </a:spcAft>
-            </a:pPr>
-            <a:r>
-              <a:rPr sz="2800" b="0" i="0">
-                <a:solidFill>
-                  <a:srgbClr val="D7E3F2"/>
-                </a:solidFill>
-                <a:latin typeface="Garamond"/>
-              </a:rPr>
-              <a:t>What it means for policy</a:t>
-            </a:r>
-          </a:p>
-        </p:txBody>
-      </p:sp>
-    </p:spTree>
-  </p:cSld>
-  <p:clrMapOvr>
-    <a:masterClrMapping/>
-  </p:clrMapOvr>
-</p:sld>
-</file>
-
-<file path=ppt/slides/slide23.xml><?xml version="1.0" encoding="utf-8"?>
-<p:sld xmlns:a="http://schemas.openxmlformats.org/drawingml/2006/main" xmlns:p="http://schemas.openxmlformats.org/presentationml/2006/main" xmlns:r="http://schemas.openxmlformats.org/officeDocument/2006/relationships">
-  <p:cSld>
-    <p:spTree>
-      <p:nvGrpSpPr>
-        <p:cNvPr id="1" name=""/>
-        <p:cNvGrpSpPr/>
-        <p:nvPr/>
-      </p:nvGrpSpPr>
-      <p:grpSpPr/>
-      <p:sp>
-        <p:nvSpPr>
-          <p:cNvPr id="2" name="TextBox 1"/>
-          <p:cNvSpPr txBox="1"/>
-          <p:nvPr/>
-        </p:nvSpPr>
-        <p:spPr>
-          <a:xfrm>
-            <a:off x="502920" y="219456"/>
-            <a:ext cx="11247120" cy="566928"/>
-          </a:xfrm>
-          <a:prstGeom prst="rect">
-            <a:avLst/>
-          </a:prstGeom>
-          <a:noFill/>
-        </p:spPr>
-        <p:txBody>
-          <a:bodyPr wrap="square" lIns="0" rIns="0" tIns="0" bIns="0"/>
-          <a:lstStyle/>
-          <a:p>
-            <a:r>
-              <a:rPr sz="2800" b="1">
-                <a:solidFill>
-                  <a:srgbClr val="102D5E"/>
-                </a:solidFill>
-                <a:latin typeface="Garamond"/>
-              </a:rPr>
-              <a:t>Data recap</a:t>
-            </a:r>
-          </a:p>
-        </p:txBody>
-      </p:sp>
-      <p:sp>
-        <p:nvSpPr>
-          <p:cNvPr id="3" name="TextBox 2"/>
-          <p:cNvSpPr txBox="1"/>
-          <p:nvPr/>
-        </p:nvSpPr>
-        <p:spPr>
-          <a:xfrm>
-            <a:off x="11384280" y="6446520"/>
-            <a:ext cx="640080" cy="292608"/>
-          </a:xfrm>
-          <a:prstGeom prst="rect">
-            <a:avLst/>
-          </a:prstGeom>
-          <a:noFill/>
-        </p:spPr>
-        <p:txBody>
-          <a:bodyPr wrap="none" lIns="0" rIns="0" tIns="0" bIns="0">
-            <a:spAutoFit/>
-          </a:bodyPr>
-          <a:lstStyle/>
-          <a:p>
-            <a:pPr algn="r"/>
-            <a:r>
-              <a:rPr sz="1100">
-                <a:solidFill>
-                  <a:srgbClr val="6B7480"/>
-                </a:solidFill>
-                <a:latin typeface="Garamond"/>
-              </a:rPr>
-              <a:t>23</a:t>
-            </a:r>
-          </a:p>
-        </p:txBody>
-      </p:sp>
-      <p:sp>
-        <p:nvSpPr>
-          <p:cNvPr id="4" name="TextBox 3"/>
-          <p:cNvSpPr txBox="1"/>
-          <p:nvPr/>
-        </p:nvSpPr>
-        <p:spPr>
-          <a:xfrm>
-            <a:off x="822960" y="1645920"/>
-            <a:ext cx="10789920" cy="5120640"/>
-          </a:xfrm>
-          <a:prstGeom prst="rect">
-            <a:avLst/>
-          </a:prstGeom>
-          <a:noFill/>
-        </p:spPr>
-        <p:txBody>
-          <a:bodyPr wrap="square" lIns="0" rIns="0" tIns="0" bIns="0">
-            <a:spAutoFit/>
-          </a:bodyPr>
-          <a:lstStyle/>
-          <a:p>
-            <a:pPr algn="l">
-              <a:lnSpc>
-                <a:spcPts val="2688"/>
-              </a:lnSpc>
-              <a:spcAft>
-                <a:spcPts val="2800"/>
-              </a:spcAft>
-            </a:pPr>
-            <a:r>
-              <a:rPr sz="2100" b="1" i="0">
-                <a:solidFill>
-                  <a:srgbClr val="2D6CB5"/>
-                </a:solidFill>
-                <a:latin typeface="Garamond"/>
-              </a:rPr>
-              <a:t>▪  </a:t>
-            </a:r>
-            <a:r>
-              <a:rPr sz="2100" b="1" i="0">
-                <a:solidFill>
-                  <a:srgbClr val="102D5E"/>
-                </a:solidFill>
-                <a:latin typeface="Garamond"/>
-              </a:rPr>
-              <a:t>Contract.  </a:t>
-            </a:r>
-            <a:r>
-              <a:rPr sz="2100" b="0" i="0">
-                <a:solidFill>
-                  <a:srgbClr val="212529"/>
-                </a:solidFill>
-                <a:latin typeface="Garamond"/>
-              </a:rPr>
-              <a:t>A full-year contract goes with far fewer exits, a part-time contract with more.</a:t>
-            </a:r>
-          </a:p>
-          <a:p>
-            <a:pPr algn="l">
-              <a:lnSpc>
-                <a:spcPts val="2688"/>
-              </a:lnSpc>
-              <a:spcAft>
-                <a:spcPts val="2800"/>
-              </a:spcAft>
-            </a:pPr>
-            <a:r>
-              <a:rPr sz="2100" b="1" i="0">
-                <a:solidFill>
-                  <a:srgbClr val="2D6CB5"/>
-                </a:solidFill>
-                <a:latin typeface="Garamond"/>
-              </a:rPr>
-              <a:t>▪  </a:t>
-            </a:r>
-            <a:r>
-              <a:rPr sz="2100" b="1" i="0">
-                <a:solidFill>
-                  <a:srgbClr val="102D5E"/>
-                </a:solidFill>
-                <a:latin typeface="Garamond"/>
-              </a:rPr>
-              <a:t>Age.  </a:t>
-            </a:r>
-            <a:r>
-              <a:rPr sz="2100" b="0" i="0">
-                <a:solidFill>
-                  <a:srgbClr val="212529"/>
-                </a:solidFill>
-                <a:latin typeface="Garamond"/>
-              </a:rPr>
-              <a:t>Highest at both ends of the career. Young teachers leave for other jobs, older teachers leave the labor force.</a:t>
-            </a:r>
-          </a:p>
-          <a:p>
-            <a:pPr algn="l">
-              <a:lnSpc>
-                <a:spcPts val="2688"/>
-              </a:lnSpc>
-              <a:spcAft>
-                <a:spcPts val="2800"/>
-              </a:spcAft>
-            </a:pPr>
-            <a:r>
-              <a:rPr sz="2100" b="1" i="0">
-                <a:solidFill>
-                  <a:srgbClr val="2D6CB5"/>
-                </a:solidFill>
-                <a:latin typeface="Garamond"/>
-              </a:rPr>
-              <a:t>▪  </a:t>
-            </a:r>
-            <a:r>
-              <a:rPr sz="2100" b="1" i="0">
-                <a:solidFill>
-                  <a:srgbClr val="102D5E"/>
-                </a:solidFill>
-                <a:latin typeface="Garamond"/>
-              </a:rPr>
-              <a:t>Pay.  </a:t>
-            </a:r>
-            <a:r>
-              <a:rPr sz="2100" b="0" i="0">
-                <a:solidFill>
-                  <a:srgbClr val="212529"/>
-                </a:solidFill>
-                <a:latin typeface="Garamond"/>
-              </a:rPr>
-              <a:t>Exits are concentrated at the bottom of the pay distribution.</a:t>
-            </a:r>
-          </a:p>
-          <a:p>
-            <a:pPr algn="l">
-              <a:lnSpc>
-                <a:spcPts val="2688"/>
-              </a:lnSpc>
-              <a:spcAft>
-                <a:spcPts val="2800"/>
-              </a:spcAft>
-            </a:pPr>
-            <a:r>
-              <a:rPr sz="2100" b="1" i="0">
-                <a:solidFill>
-                  <a:srgbClr val="2D6CB5"/>
-                </a:solidFill>
-                <a:latin typeface="Garamond"/>
-              </a:rPr>
-              <a:t>▪  </a:t>
-            </a:r>
-            <a:r>
-              <a:rPr sz="2100" b="1" i="0">
-                <a:solidFill>
-                  <a:srgbClr val="102D5E"/>
-                </a:solidFill>
-                <a:latin typeface="Garamond"/>
-              </a:rPr>
-              <a:t>Security.  </a:t>
-            </a:r>
-            <a:r>
-              <a:rPr sz="2100" b="0" i="0">
-                <a:solidFill>
-                  <a:srgbClr val="212529"/>
-                </a:solidFill>
-                <a:latin typeface="Garamond"/>
-              </a:rPr>
-              <a:t>A pension plan and a public-sector job go with fewer exits.</a:t>
-            </a:r>
-          </a:p>
-          <a:p>
-            <a:pPr algn="l">
-              <a:lnSpc>
-                <a:spcPts val="2688"/>
-              </a:lnSpc>
-              <a:spcAft>
-                <a:spcPts val="0"/>
-              </a:spcAft>
-            </a:pPr>
-            <a:r>
-              <a:rPr sz="2100" b="1" i="0">
-                <a:solidFill>
-                  <a:srgbClr val="2D6CB5"/>
-                </a:solidFill>
-                <a:latin typeface="Garamond"/>
-              </a:rPr>
-              <a:t>▪  </a:t>
-            </a:r>
-            <a:r>
-              <a:rPr sz="2100" b="1" i="0">
-                <a:solidFill>
-                  <a:srgbClr val="102D5E"/>
-                </a:solidFill>
-                <a:latin typeface="Garamond"/>
-              </a:rPr>
-              <a:t>Life events.  </a:t>
-            </a:r>
-            <a:r>
-              <a:rPr sz="2100" b="0" i="0">
-                <a:solidFill>
-                  <a:srgbClr val="212529"/>
-                </a:solidFill>
-                <a:latin typeface="Garamond"/>
-              </a:rPr>
-              <a:t>A new baby during the year, or a disability, go with more exits.</a:t>
-            </a:r>
-          </a:p>
-        </p:txBody>
-      </p:sp>
-    </p:spTree>
-  </p:cSld>
-  <p:clrMapOvr>
-    <a:masterClrMapping/>
-  </p:clrMapOvr>
-</p:sld>
-</file>
-
-<file path=ppt/slides/slide24.xml><?xml version="1.0" encoding="utf-8"?>
-<p:sld xmlns:a="http://schemas.openxmlformats.org/drawingml/2006/main" xmlns:p="http://schemas.openxmlformats.org/presentationml/2006/main" xmlns:r="http://schemas.openxmlformats.org/officeDocument/2006/relationships">
-  <p:cSld>
-    <p:spTree>
-      <p:nvGrpSpPr>
-        <p:cNvPr id="1" name=""/>
-        <p:cNvGrpSpPr/>
-        <p:nvPr/>
-      </p:nvGrpSpPr>
-      <p:grpSpPr/>
-      <p:sp>
-        <p:nvSpPr>
-          <p:cNvPr id="2" name="TextBox 1"/>
-          <p:cNvSpPr txBox="1"/>
-          <p:nvPr/>
-        </p:nvSpPr>
-        <p:spPr>
-          <a:xfrm>
-            <a:off x="502920" y="219456"/>
-            <a:ext cx="11247120" cy="566928"/>
-          </a:xfrm>
-          <a:prstGeom prst="rect">
-            <a:avLst/>
-          </a:prstGeom>
-          <a:noFill/>
-        </p:spPr>
-        <p:txBody>
-          <a:bodyPr wrap="square" lIns="0" rIns="0" tIns="0" bIns="0"/>
-          <a:lstStyle/>
-          <a:p>
-            <a:r>
-              <a:rPr sz="2800" b="1">
-                <a:solidFill>
-                  <a:srgbClr val="102D5E"/>
-                </a:solidFill>
-                <a:latin typeface="Garamond"/>
-              </a:rPr>
-              <a:t>Policy options for re-attraction</a:t>
-            </a:r>
-          </a:p>
-        </p:txBody>
-      </p:sp>
-      <p:sp>
-        <p:nvSpPr>
-          <p:cNvPr id="3" name="TextBox 2"/>
-          <p:cNvSpPr txBox="1"/>
-          <p:nvPr/>
-        </p:nvSpPr>
-        <p:spPr>
-          <a:xfrm>
-            <a:off x="11384280" y="6446520"/>
-            <a:ext cx="640080" cy="292608"/>
-          </a:xfrm>
-          <a:prstGeom prst="rect">
-            <a:avLst/>
-          </a:prstGeom>
-          <a:noFill/>
-        </p:spPr>
-        <p:txBody>
-          <a:bodyPr wrap="none" lIns="0" rIns="0" tIns="0" bIns="0">
-            <a:spAutoFit/>
-          </a:bodyPr>
-          <a:lstStyle/>
-          <a:p>
-            <a:pPr algn="r"/>
-            <a:r>
-              <a:rPr sz="1100">
-                <a:solidFill>
-                  <a:srgbClr val="6B7480"/>
-                </a:solidFill>
-                <a:latin typeface="Garamond"/>
-              </a:rPr>
-              <a:t>24</a:t>
-            </a:r>
-          </a:p>
-        </p:txBody>
-      </p:sp>
-      <p:sp>
-        <p:nvSpPr>
-          <p:cNvPr id="4" name="Rounded Rectangle 3"/>
-          <p:cNvSpPr/>
-          <p:nvPr/>
-        </p:nvSpPr>
-        <p:spPr>
-          <a:xfrm>
-            <a:off x="667512" y="1298448"/>
-            <a:ext cx="5349240" cy="1993392"/>
-          </a:xfrm>
-          <a:prstGeom prst="roundRect">
-            <a:avLst/>
-          </a:prstGeom>
-          <a:solidFill>
-            <a:srgbClr val="ECF2F9"/>
-          </a:solidFill>
-          <a:ln>
-            <a:noFill/>
-          </a:ln>
-          <a:effectLst/>
-        </p:spPr>
-        <p:style>
-          <a:lnRef idx="1">
-            <a:schemeClr val="accent1"/>
-          </a:lnRef>
-          <a:fillRef idx="3">
-            <a:schemeClr val="accent1"/>
-          </a:fillRef>
-          <a:effectRef idx="2">
-            <a:schemeClr val="accent1"/>
-          </a:effectRef>
-          <a:fontRef idx="minor">
-            <a:schemeClr val="lt1"/>
-          </a:fontRef>
-        </p:style>
-        <p:txBody>
-          <a:bodyPr rtlCol="0" anchor="ctr" wrap="square" lIns="201168" rIns="201168" tIns="146304" bIns="109728"/>
-          <a:lstStyle/>
-          <a:p>
-            <a:pPr algn="ctr"/>
-            <a:r>
-              <a:rPr sz="1900" b="1">
-                <a:solidFill>
-                  <a:srgbClr val="102D5E"/>
-                </a:solidFill>
-                <a:latin typeface="Garamond"/>
-              </a:rPr>
-              <a:t>Short term and retirees</a:t>
-            </a:r>
-          </a:p>
-          <a:p>
-            <a:pPr>
-              <a:lnSpc>
-                <a:spcPts val="1891"/>
-              </a:lnSpc>
-              <a:spcBef>
-                <a:spcPts val="600"/>
-              </a:spcBef>
-            </a:pPr>
-            <a:r>
-              <a:rPr sz="1550">
-                <a:solidFill>
-                  <a:srgbClr val="212529"/>
-                </a:solidFill>
-                <a:latin typeface="Garamond"/>
-              </a:rPr>
-              <a:t>A reserve for local shortages. They bring experience and can mentor new teachers. Make it easy to return, for example part-time or “double-dipping”.</a:t>
-            </a:r>
-          </a:p>
-        </p:txBody>
-      </p:sp>
-      <p:sp>
-        <p:nvSpPr>
-          <p:cNvPr id="5" name="Rounded Rectangle 4"/>
-          <p:cNvSpPr/>
-          <p:nvPr/>
-        </p:nvSpPr>
-        <p:spPr>
-          <a:xfrm>
-            <a:off x="6291071" y="1298448"/>
-            <a:ext cx="5349240" cy="1993392"/>
-          </a:xfrm>
-          <a:prstGeom prst="roundRect">
-            <a:avLst/>
-          </a:prstGeom>
-          <a:solidFill>
-            <a:srgbClr val="ECF2F9"/>
-          </a:solidFill>
-          <a:ln>
-            <a:noFill/>
-          </a:ln>
-          <a:effectLst/>
-        </p:spPr>
-        <p:style>
-          <a:lnRef idx="1">
-            <a:schemeClr val="accent1"/>
-          </a:lnRef>
-          <a:fillRef idx="3">
-            <a:schemeClr val="accent1"/>
-          </a:fillRef>
-          <a:effectRef idx="2">
-            <a:schemeClr val="accent1"/>
-          </a:effectRef>
-          <a:fontRef idx="minor">
-            <a:schemeClr val="lt1"/>
-          </a:fontRef>
-        </p:style>
-        <p:txBody>
-          <a:bodyPr rtlCol="0" anchor="ctr" wrap="square" lIns="201168" rIns="201168" tIns="146304" bIns="109728"/>
-          <a:lstStyle/>
-          <a:p>
-            <a:pPr algn="ctr"/>
-            <a:r>
-              <a:rPr sz="1900" b="1">
-                <a:solidFill>
-                  <a:srgbClr val="102D5E"/>
-                </a:solidFill>
-                <a:latin typeface="Garamond"/>
-              </a:rPr>
-              <a:t>Medium term and switchers</a:t>
-            </a:r>
-          </a:p>
-          <a:p>
-            <a:pPr>
-              <a:lnSpc>
-                <a:spcPts val="1891"/>
-              </a:lnSpc>
-              <a:spcBef>
-                <a:spcPts val="600"/>
-              </a:spcBef>
-            </a:pPr>
-            <a:r>
-              <a:rPr sz="1550">
-                <a:solidFill>
-                  <a:srgbClr val="212529"/>
-                </a:solidFill>
-                <a:latin typeface="Garamond"/>
-              </a:rPr>
-              <a:t>Early-career conditions (secure contracts, fair pay at the bottom) and support (mentoring). Learn why some move to jobs that do not require a degree.</a:t>
-            </a:r>
-          </a:p>
-        </p:txBody>
-      </p:sp>
-      <p:sp>
-        <p:nvSpPr>
-          <p:cNvPr id="6" name="Rounded Rectangle 5"/>
-          <p:cNvSpPr/>
-          <p:nvPr/>
-        </p:nvSpPr>
-        <p:spPr>
-          <a:xfrm>
-            <a:off x="667512" y="3547872"/>
-            <a:ext cx="5349240" cy="1993392"/>
-          </a:xfrm>
-          <a:prstGeom prst="roundRect">
-            <a:avLst/>
-          </a:prstGeom>
-          <a:solidFill>
-            <a:srgbClr val="ECF2F9"/>
-          </a:solidFill>
-          <a:ln>
-            <a:noFill/>
-          </a:ln>
-          <a:effectLst/>
-        </p:spPr>
-        <p:style>
-          <a:lnRef idx="1">
-            <a:schemeClr val="accent1"/>
-          </a:lnRef>
-          <a:fillRef idx="3">
-            <a:schemeClr val="accent1"/>
-          </a:fillRef>
-          <a:effectRef idx="2">
-            <a:schemeClr val="accent1"/>
-          </a:effectRef>
-          <a:fontRef idx="minor">
-            <a:schemeClr val="lt1"/>
-          </a:fontRef>
-        </p:style>
-        <p:txBody>
-          <a:bodyPr rtlCol="0" anchor="ctr" wrap="square" lIns="201168" rIns="201168" tIns="146304" bIns="109728"/>
-          <a:lstStyle/>
-          <a:p>
-            <a:pPr algn="ctr"/>
-            <a:r>
-              <a:rPr sz="1900" b="1">
-                <a:solidFill>
-                  <a:srgbClr val="102D5E"/>
-                </a:solidFill>
-                <a:latin typeface="Garamond"/>
-              </a:rPr>
-              <a:t>Long term and early exits</a:t>
-            </a:r>
-          </a:p>
-          <a:p>
-            <a:pPr>
-              <a:lnSpc>
-                <a:spcPts val="1891"/>
-              </a:lnSpc>
-              <a:spcBef>
-                <a:spcPts val="600"/>
-              </a:spcBef>
-            </a:pPr>
-            <a:r>
-              <a:rPr sz="1550">
-                <a:solidFill>
-                  <a:srgbClr val="212529"/>
-                </a:solidFill>
-                <a:latin typeface="Garamond"/>
-              </a:rPr>
-              <a:t>Flexibility, so those who want to return can do so in favoring conditions, and clear paths to return.</a:t>
-            </a:r>
-          </a:p>
-        </p:txBody>
-      </p:sp>
-      <p:sp>
-        <p:nvSpPr>
-          <p:cNvPr id="7" name="Rounded Rectangle 6"/>
-          <p:cNvSpPr/>
-          <p:nvPr/>
-        </p:nvSpPr>
-        <p:spPr>
-          <a:xfrm>
-            <a:off x="6291071" y="3547872"/>
-            <a:ext cx="5349240" cy="1993392"/>
-          </a:xfrm>
-          <a:prstGeom prst="roundRect">
-            <a:avLst/>
-          </a:prstGeom>
-          <a:solidFill>
-            <a:srgbClr val="ECF2F9"/>
-          </a:solidFill>
-          <a:ln>
-            <a:noFill/>
-          </a:ln>
-          <a:effectLst/>
-        </p:spPr>
-        <p:style>
-          <a:lnRef idx="1">
-            <a:schemeClr val="accent1"/>
-          </a:lnRef>
-          <a:fillRef idx="3">
-            <a:schemeClr val="accent1"/>
-          </a:fillRef>
-          <a:effectRef idx="2">
-            <a:schemeClr val="accent1"/>
-          </a:effectRef>
-          <a:fontRef idx="minor">
-            <a:schemeClr val="lt1"/>
-          </a:fontRef>
-        </p:style>
-        <p:txBody>
-          <a:bodyPr rtlCol="0" anchor="ctr" wrap="square" lIns="201168" rIns="201168" tIns="146304" bIns="109728"/>
-          <a:lstStyle/>
-          <a:p>
-            <a:pPr algn="ctr"/>
-            <a:r>
-              <a:rPr sz="1900" b="1">
-                <a:solidFill>
-                  <a:srgbClr val="102D5E"/>
-                </a:solidFill>
-                <a:latin typeface="Garamond"/>
-              </a:rPr>
-              <a:t>Research agenda</a:t>
-            </a:r>
-          </a:p>
-          <a:p>
-            <a:pPr>
-              <a:lnSpc>
-                <a:spcPts val="1891"/>
-              </a:lnSpc>
-              <a:spcBef>
-                <a:spcPts val="600"/>
-              </a:spcBef>
-            </a:pPr>
-            <a:r>
-              <a:rPr sz="1550">
-                <a:solidFill>
-                  <a:srgbClr val="212529"/>
-                </a:solidFill>
-                <a:latin typeface="Garamond"/>
-              </a:rPr>
-              <a:t>Working conditions inside schools. Do these patterns hold in other countries?</a:t>
-            </a:r>
-          </a:p>
-        </p:txBody>
-      </p:sp>
-      <p:sp>
-        <p:nvSpPr>
-          <p:cNvPr id="8" name="TextBox 7"/>
-          <p:cNvSpPr txBox="1"/>
-          <p:nvPr/>
-        </p:nvSpPr>
-        <p:spPr>
-          <a:xfrm>
-            <a:off x="822960" y="5989320"/>
-            <a:ext cx="10789920" cy="457200"/>
-          </a:xfrm>
-          <a:prstGeom prst="rect">
-            <a:avLst/>
-          </a:prstGeom>
-          <a:noFill/>
-        </p:spPr>
-        <p:txBody>
-          <a:bodyPr wrap="square" lIns="0" rIns="0" tIns="0" bIns="0">
-            <a:spAutoFit/>
-          </a:bodyPr>
-          <a:lstStyle/>
-          <a:p>
-            <a:pPr algn="ctr">
-              <a:lnSpc>
-                <a:spcPts val="2560"/>
-              </a:lnSpc>
-              <a:spcAft>
-                <a:spcPts val="0"/>
-              </a:spcAft>
-            </a:pPr>
-            <a:r>
-              <a:rPr sz="2000" b="1" i="0">
-                <a:solidFill>
-                  <a:srgbClr val="102D5E"/>
-                </a:solidFill>
-                <a:latin typeface="Garamond"/>
-              </a:rPr>
-              <a:t>Across all three: economic security.</a:t>
-            </a:r>
-          </a:p>
-        </p:txBody>
-      </p:sp>
-    </p:spTree>
-  </p:cSld>
-  <p:clrMapOvr>
-    <a:masterClrMapping/>
-  </p:clrMapOvr>
-</p:sld>
-</file>
-
-<file path=ppt/slides/slide25.xml><?xml version="1.0" encoding="utf-8"?>
-<p:sld xmlns:a="http://schemas.openxmlformats.org/drawingml/2006/main" xmlns:p="http://schemas.openxmlformats.org/presentationml/2006/main" xmlns:r="http://schemas.openxmlformats.org/officeDocument/2006/relationships">
-  <p:cSld>
-    <p:spTree>
-      <p:nvGrpSpPr>
-        <p:cNvPr id="1" name=""/>
-        <p:cNvGrpSpPr/>
-        <p:nvPr/>
-      </p:nvGrpSpPr>
-      <p:grpSpPr/>
-      <p:sp>
-        <p:nvSpPr>
-          <p:cNvPr id="2" name="TextBox 1"/>
-          <p:cNvSpPr txBox="1"/>
-          <p:nvPr/>
-        </p:nvSpPr>
-        <p:spPr>
-          <a:xfrm>
-            <a:off x="502920" y="219456"/>
-            <a:ext cx="11247120" cy="566928"/>
-          </a:xfrm>
-          <a:prstGeom prst="rect">
-            <a:avLst/>
-          </a:prstGeom>
-          <a:noFill/>
-        </p:spPr>
-        <p:txBody>
-          <a:bodyPr wrap="square" lIns="0" rIns="0" tIns="0" bIns="0"/>
-          <a:lstStyle/>
-          <a:p>
-            <a:r>
-              <a:rPr sz="2800" b="1">
-                <a:solidFill>
-                  <a:srgbClr val="102D5E"/>
-                </a:solidFill>
-                <a:latin typeface="Garamond"/>
-              </a:rPr>
-              <a:t>Open questions</a:t>
-            </a:r>
-          </a:p>
-        </p:txBody>
-      </p:sp>
-      <p:sp>
-        <p:nvSpPr>
-          <p:cNvPr id="3" name="TextBox 2"/>
-          <p:cNvSpPr txBox="1"/>
-          <p:nvPr/>
-        </p:nvSpPr>
-        <p:spPr>
-          <a:xfrm>
-            <a:off x="11384280" y="6446520"/>
-            <a:ext cx="640080" cy="292608"/>
-          </a:xfrm>
-          <a:prstGeom prst="rect">
-            <a:avLst/>
-          </a:prstGeom>
-          <a:noFill/>
-        </p:spPr>
-        <p:txBody>
-          <a:bodyPr wrap="none" lIns="0" rIns="0" tIns="0" bIns="0">
-            <a:spAutoFit/>
-          </a:bodyPr>
-          <a:lstStyle/>
-          <a:p>
-            <a:pPr algn="r"/>
-            <a:r>
-              <a:rPr sz="1100">
-                <a:solidFill>
-                  <a:srgbClr val="6B7480"/>
-                </a:solidFill>
-                <a:latin typeface="Garamond"/>
-              </a:rPr>
-              <a:t>25</a:t>
             </a:r>
           </a:p>
         </p:txBody>
@@ -7302,7 +6169,7 @@
       </p:sp>
       <p:sp>
         <p:nvSpPr>
-          <p:cNvPr id="4" name="Rounded Rectangle 3"/>
+          <p:cNvPr id="4" name="Rectangle 3"/>
           <p:cNvSpPr/>
           <p:nvPr/>
         </p:nvSpPr>
@@ -7311,7 +6178,7 @@
             <a:off x="667512" y="1554480"/>
             <a:ext cx="2670048" cy="2148840"/>
           </a:xfrm>
-          <a:prstGeom prst="roundRect">
+          <a:prstGeom prst="rect">
             <a:avLst/>
           </a:prstGeom>
           <a:solidFill>
@@ -7387,7 +6254,51 @@
       </p:sp>
       <p:sp>
         <p:nvSpPr>
-          <p:cNvPr id="5" name="Rounded Rectangle 4"/>
+          <p:cNvPr id="5" name="Rectangle 4"/>
+          <p:cNvSpPr/>
+          <p:nvPr/>
+        </p:nvSpPr>
+        <p:spPr>
+          <a:xfrm>
+            <a:off x="667512" y="1554480"/>
+            <a:ext cx="2670048" cy="64008"/>
+          </a:xfrm>
+          <a:prstGeom prst="rect">
+            <a:avLst/>
+          </a:prstGeom>
+          <a:solidFill>
+            <a:srgbClr val="102D5E"/>
+          </a:solidFill>
+          <a:ln>
+            <a:noFill/>
+          </a:ln>
+          <a:effectLst/>
+        </p:spPr>
+        <p:style>
+          <a:lnRef idx="1">
+            <a:schemeClr val="accent1"/>
+          </a:lnRef>
+          <a:fillRef idx="3">
+            <a:schemeClr val="accent1"/>
+          </a:fillRef>
+          <a:effectRef idx="2">
+            <a:schemeClr val="accent1"/>
+          </a:effectRef>
+          <a:fontRef idx="minor">
+            <a:schemeClr val="lt1"/>
+          </a:fontRef>
+        </p:style>
+        <p:txBody>
+          <a:bodyPr rtlCol="0" anchor="ctr"/>
+          <a:lstStyle/>
+          <a:p>
+            <a:pPr algn="ctr"/>
+          </a:p>
+        </p:txBody>
+      </p:sp>
+      <p:sp>
+        <p:nvSpPr>
+          <p:cNvPr id="6" name="Rectangle 5"/>
           <p:cNvSpPr/>
           <p:nvPr/>
         </p:nvSpPr>
@@ -7396,7 +6307,7 @@
             <a:off x="3465576" y="1554480"/>
             <a:ext cx="2670048" cy="2148840"/>
           </a:xfrm>
-          <a:prstGeom prst="roundRect">
+          <a:prstGeom prst="rect">
             <a:avLst/>
           </a:prstGeom>
           <a:solidFill>
@@ -7433,7 +6344,7 @@
                 </a:solidFill>
                 <a:latin typeface="Garamond"/>
               </a:rPr>
-              <a:t>100,000+</a:t>
+              <a:t>5 million</a:t>
             </a:r>
           </a:p>
           <a:p>
@@ -7449,7 +6360,7 @@
                 </a:solidFill>
                 <a:latin typeface="Garamond"/>
               </a:rPr>
-              <a:t>adults interviewed</a:t>
+              <a:t>people interviewed</a:t>
             </a:r>
           </a:p>
           <a:p>
@@ -7465,14 +6376,58 @@
                 </a:solidFill>
                 <a:latin typeface="Garamond"/>
               </a:rPr>
-              <a:t>every March</a:t>
-            </a:r>
-          </a:p>
-        </p:txBody>
-      </p:sp>
-      <p:sp>
-        <p:nvSpPr>
-          <p:cNvPr id="6" name="Rounded Rectangle 5"/>
+              <a:t>in the March surveys</a:t>
+            </a:r>
+          </a:p>
+        </p:txBody>
+      </p:sp>
+      <p:sp>
+        <p:nvSpPr>
+          <p:cNvPr id="7" name="Rectangle 6"/>
+          <p:cNvSpPr/>
+          <p:nvPr/>
+        </p:nvSpPr>
+        <p:spPr>
+          <a:xfrm>
+            <a:off x="3465576" y="1554480"/>
+            <a:ext cx="2670048" cy="64008"/>
+          </a:xfrm>
+          <a:prstGeom prst="rect">
+            <a:avLst/>
+          </a:prstGeom>
+          <a:solidFill>
+            <a:srgbClr val="102D5E"/>
+          </a:solidFill>
+          <a:ln>
+            <a:noFill/>
+          </a:ln>
+          <a:effectLst/>
+        </p:spPr>
+        <p:style>
+          <a:lnRef idx="1">
+            <a:schemeClr val="accent1"/>
+          </a:lnRef>
+          <a:fillRef idx="3">
+            <a:schemeClr val="accent1"/>
+          </a:fillRef>
+          <a:effectRef idx="2">
+            <a:schemeClr val="accent1"/>
+          </a:effectRef>
+          <a:fontRef idx="minor">
+            <a:schemeClr val="lt1"/>
+          </a:fontRef>
+        </p:style>
+        <p:txBody>
+          <a:bodyPr rtlCol="0" anchor="ctr"/>
+          <a:lstStyle/>
+          <a:p>
+            <a:pPr algn="ctr"/>
+          </a:p>
+        </p:txBody>
+      </p:sp>
+      <p:sp>
+        <p:nvSpPr>
+          <p:cNvPr id="8" name="Rectangle 7"/>
           <p:cNvSpPr/>
           <p:nvPr/>
         </p:nvSpPr>
@@ -7481,7 +6436,7 @@
             <a:off x="6263640" y="1554480"/>
             <a:ext cx="2670048" cy="2148840"/>
           </a:xfrm>
-          <a:prstGeom prst="roundRect">
+          <a:prstGeom prst="rect">
             <a:avLst/>
           </a:prstGeom>
           <a:solidFill>
@@ -7518,7 +6473,7 @@
                 </a:solidFill>
                 <a:latin typeface="Garamond"/>
               </a:rPr>
-              <a:t>104,545</a:t>
+              <a:t>103,820</a:t>
             </a:r>
           </a:p>
           <a:p>
@@ -7557,7 +6512,51 @@
       </p:sp>
       <p:sp>
         <p:nvSpPr>
-          <p:cNvPr id="7" name="Rounded Rectangle 6"/>
+          <p:cNvPr id="9" name="Rectangle 8"/>
+          <p:cNvSpPr/>
+          <p:nvPr/>
+        </p:nvSpPr>
+        <p:spPr>
+          <a:xfrm>
+            <a:off x="6263640" y="1554480"/>
+            <a:ext cx="2670048" cy="64008"/>
+          </a:xfrm>
+          <a:prstGeom prst="rect">
+            <a:avLst/>
+          </a:prstGeom>
+          <a:solidFill>
+            <a:srgbClr val="102D5E"/>
+          </a:solidFill>
+          <a:ln>
+            <a:noFill/>
+          </a:ln>
+          <a:effectLst/>
+        </p:spPr>
+        <p:style>
+          <a:lnRef idx="1">
+            <a:schemeClr val="accent1"/>
+          </a:lnRef>
+          <a:fillRef idx="3">
+            <a:schemeClr val="accent1"/>
+          </a:fillRef>
+          <a:effectRef idx="2">
+            <a:schemeClr val="accent1"/>
+          </a:effectRef>
+          <a:fontRef idx="minor">
+            <a:schemeClr val="lt1"/>
+          </a:fontRef>
+        </p:style>
+        <p:txBody>
+          <a:bodyPr rtlCol="0" anchor="ctr"/>
+          <a:lstStyle/>
+          <a:p>
+            <a:pPr algn="ctr"/>
+          </a:p>
+        </p:txBody>
+      </p:sp>
+      <p:sp>
+        <p:nvSpPr>
+          <p:cNvPr id="10" name="Rectangle 9"/>
           <p:cNvSpPr/>
           <p:nvPr/>
         </p:nvSpPr>
@@ -7566,7 +6565,7 @@
             <a:off x="9061704" y="1554480"/>
             <a:ext cx="2670048" cy="2148840"/>
           </a:xfrm>
-          <a:prstGeom prst="roundRect">
+          <a:prstGeom prst="rect">
             <a:avLst/>
           </a:prstGeom>
           <a:solidFill>
@@ -7642,7 +6641,51 @@
       </p:sp>
       <p:sp>
         <p:nvSpPr>
-          <p:cNvPr id="8" name="TextBox 7"/>
+          <p:cNvPr id="11" name="Rectangle 10"/>
+          <p:cNvSpPr/>
+          <p:nvPr/>
+        </p:nvSpPr>
+        <p:spPr>
+          <a:xfrm>
+            <a:off x="9061704" y="1554480"/>
+            <a:ext cx="2670048" cy="64008"/>
+          </a:xfrm>
+          <a:prstGeom prst="rect">
+            <a:avLst/>
+          </a:prstGeom>
+          <a:solidFill>
+            <a:srgbClr val="102D5E"/>
+          </a:solidFill>
+          <a:ln>
+            <a:noFill/>
+          </a:ln>
+          <a:effectLst/>
+        </p:spPr>
+        <p:style>
+          <a:lnRef idx="1">
+            <a:schemeClr val="accent1"/>
+          </a:lnRef>
+          <a:fillRef idx="3">
+            <a:schemeClr val="accent1"/>
+          </a:fillRef>
+          <a:effectRef idx="2">
+            <a:schemeClr val="accent1"/>
+          </a:effectRef>
+          <a:fontRef idx="minor">
+            <a:schemeClr val="lt1"/>
+          </a:fontRef>
+        </p:style>
+        <p:txBody>
+          <a:bodyPr rtlCol="0" anchor="ctr"/>
+          <a:lstStyle/>
+          <a:p>
+            <a:pPr algn="ctr"/>
+          </a:p>
+        </p:txBody>
+      </p:sp>
+      <p:sp>
+        <p:nvSpPr>
+          <p:cNvPr id="12" name="TextBox 11"/>
           <p:cNvSpPr txBox="1"/>
           <p:nvPr/>
         </p:nvSpPr>
@@ -9541,111 +8584,20 @@
       <p:grpSpPr/>
       <p:sp>
         <p:nvSpPr>
-          <p:cNvPr id="2" name="TextBox 1"/>
-          <p:cNvSpPr txBox="1"/>
-          <p:nvPr/>
-        </p:nvSpPr>
-        <p:spPr>
-          <a:xfrm>
-            <a:off x="502920" y="219456"/>
-            <a:ext cx="11247120" cy="566928"/>
-          </a:xfrm>
-          <a:prstGeom prst="rect">
-            <a:avLst/>
-          </a:prstGeom>
-          <a:noFill/>
-        </p:spPr>
-        <p:txBody>
-          <a:bodyPr wrap="square" lIns="0" rIns="0" tIns="0" bIns="0"/>
-          <a:lstStyle/>
-          <a:p>
-            <a:r>
-              <a:rPr sz="2800" b="1">
-                <a:solidFill>
-                  <a:srgbClr val="102D5E"/>
-                </a:solidFill>
-                <a:latin typeface="Garamond"/>
-              </a:rPr>
-              <a:t>Leaving and the economic cycle</a:t>
-            </a:r>
-          </a:p>
-        </p:txBody>
-      </p:sp>
-      <p:sp>
-        <p:nvSpPr>
-          <p:cNvPr id="3" name="TextBox 2"/>
-          <p:cNvSpPr txBox="1"/>
-          <p:nvPr/>
-        </p:nvSpPr>
-        <p:spPr>
-          <a:xfrm>
-            <a:off x="11384280" y="6446520"/>
-            <a:ext cx="640080" cy="292608"/>
-          </a:xfrm>
-          <a:prstGeom prst="rect">
-            <a:avLst/>
-          </a:prstGeom>
-          <a:noFill/>
-        </p:spPr>
-        <p:txBody>
-          <a:bodyPr wrap="none" lIns="0" rIns="0" tIns="0" bIns="0">
-            <a:spAutoFit/>
-          </a:bodyPr>
-          <a:lstStyle/>
-          <a:p>
-            <a:pPr algn="r"/>
-            <a:r>
-              <a:rPr sz="1100">
-                <a:solidFill>
-                  <a:srgbClr val="6B7480"/>
-                </a:solidFill>
-                <a:latin typeface="Garamond"/>
-              </a:rPr>
-              <a:t>9</a:t>
-            </a:r>
-          </a:p>
-        </p:txBody>
-      </p:sp>
-      <p:pic>
-        <p:nvPicPr>
-          <p:cNvPr id="4" name="Picture 3" descr="cycle1.png"/>
-          <p:cNvPicPr>
-            <a:picLocks noChangeAspect="1"/>
-          </p:cNvPicPr>
-          <p:nvPr/>
-        </p:nvPicPr>
-        <p:blipFill>
-          <a:blip r:embed="rId2"/>
-          <a:stretch>
-            <a:fillRect/>
-          </a:stretch>
-        </p:blipFill>
-        <p:spPr>
-          <a:xfrm>
-            <a:off x="1329145" y="1097280"/>
-            <a:ext cx="9503228" cy="4434840"/>
-          </a:xfrm>
-          <a:prstGeom prst="rect">
-            <a:avLst/>
-          </a:prstGeom>
-        </p:spPr>
-      </p:pic>
-      <p:sp>
-        <p:nvSpPr>
-          <p:cNvPr id="5" name="Rectangle 4"/>
+          <p:cNvPr id="2" name="Rectangle 1"/>
           <p:cNvSpPr/>
           <p:nvPr/>
         </p:nvSpPr>
         <p:spPr>
           <a:xfrm>
-            <a:off x="0" y="5559552"/>
-            <a:ext cx="12191695" cy="960120"/>
+            <a:off x="0" y="0"/>
+            <a:ext cx="12191695" cy="6858000"/>
           </a:xfrm>
           <a:prstGeom prst="rect">
             <a:avLst/>
           </a:prstGeom>
           <a:solidFill>
-            <a:srgbClr val="ECF2F9"/>
+            <a:srgbClr val="102D5E"/>
           </a:solidFill>
           <a:ln>
             <a:noFill/>
@@ -9676,14 +8628,14 @@
       </p:sp>
       <p:sp>
         <p:nvSpPr>
-          <p:cNvPr id="6" name="TextBox 5"/>
+          <p:cNvPr id="3" name="TextBox 2"/>
           <p:cNvSpPr txBox="1"/>
           <p:nvPr/>
         </p:nvSpPr>
         <p:spPr>
           <a:xfrm>
-            <a:off x="822960" y="5687568"/>
-            <a:ext cx="10789920" cy="822960"/>
+            <a:off x="914400" y="2240280"/>
+            <a:ext cx="10360152" cy="1188720"/>
           </a:xfrm>
           <a:prstGeom prst="rect">
             <a:avLst/>
@@ -9696,31 +8648,64 @@
           </a:bodyPr>
           <a:lstStyle/>
           <a:p>
-            <a:pPr algn="l">
+            <a:pPr algn="ctr">
               <a:lnSpc>
-                <a:spcPts val="2048"/>
+                <a:spcPts val="7680"/>
               </a:lnSpc>
               <a:spcAft>
                 <a:spcPts val="0"/>
               </a:spcAft>
             </a:pPr>
             <a:r>
-              <a:rPr sz="1600" b="1" i="0">
-                <a:solidFill>
-                  <a:srgbClr val="102D5E"/>
-                </a:solidFill>
-                <a:latin typeface="Garamond"/>
-              </a:rPr>
-              <a:t>Key message.  </a:t>
-            </a:r>
-            <a:r>
-              <a:rPr sz="1600" b="0" i="0">
-                <a:solidFill>
-                  <a:srgbClr val="212529"/>
-                </a:solidFill>
-                <a:latin typeface="Garamond"/>
-              </a:rPr>
-              <a:t>Attrition slightly moves with the business cycle; recessions don’t solve shortages and booms not necessarily cause them.</a:t>
+              <a:rPr sz="6000" b="1" i="0">
+                <a:solidFill>
+                  <a:srgbClr val="FFFFFF"/>
+                </a:solidFill>
+                <a:latin typeface="Garamond"/>
+              </a:rPr>
+              <a:t>2</a:t>
+            </a:r>
+          </a:p>
+        </p:txBody>
+      </p:sp>
+      <p:sp>
+        <p:nvSpPr>
+          <p:cNvPr id="4" name="TextBox 3"/>
+          <p:cNvSpPr txBox="1"/>
+          <p:nvPr/>
+        </p:nvSpPr>
+        <p:spPr>
+          <a:xfrm>
+            <a:off x="914400" y="3703320"/>
+            <a:ext cx="10360152" cy="731520"/>
+          </a:xfrm>
+          <a:prstGeom prst="rect">
+            <a:avLst/>
+          </a:prstGeom>
+          <a:noFill/>
+        </p:spPr>
+        <p:txBody>
+          <a:bodyPr wrap="square" lIns="0" rIns="0" tIns="0" bIns="0">
+            <a:spAutoFit/>
+          </a:bodyPr>
+          <a:lstStyle/>
+          <a:p>
+            <a:pPr algn="ctr">
+              <a:lnSpc>
+                <a:spcPts val="3584"/>
+              </a:lnSpc>
+              <a:spcAft>
+                <a:spcPts val="0"/>
+              </a:spcAft>
+            </a:pPr>
+            <a:r>
+              <a:rPr sz="2800" b="0" i="0">
+                <a:solidFill>
+                  <a:srgbClr val="D7E3F2"/>
+                </a:solidFill>
+                <a:latin typeface="Garamond"/>
+              </a:rPr>
+              <a:t>Composition: where they go?</a:t>
             </a:r>
           </a:p>
         </p:txBody>

</xml_diff>

<commit_message>
Policy deck: drop the regression slides, thirteen content slides
Removes the coefficient plot and the early-career heterogeneity slide
so the policy deck is all charts; the drivers section is now relative
pay, pay deciles and pensions.

Co-Authored-By: Claude Opus 5.5 <noreply@anthropic.com>
Claude-Session: https://claude.ai/code/session_01DNzQPDcr3zfLTraMHUHqUn
</commit_message>
<xml_diff>
--- a/report/data_cluster/Proyect_US_policy.pptx
+++ b/report/data_cluster/Proyect_US_policy.pptx
@@ -23,8 +23,6 @@
     <p:sldId id="271" r:id="rId22"/>
     <p:sldId id="272" r:id="rId23"/>
     <p:sldId id="273" r:id="rId24"/>
-    <p:sldId id="274" r:id="rId25"/>
-    <p:sldId id="275" r:id="rId26"/>
   </p:sldIdLst>
   <p:sldSz cx="12191695" cy="6858000" type="screen4x3"/>
   <p:notesSz cx="6858000" cy="9144000"/>
@@ -3938,7 +3936,7 @@
                 </a:solidFill>
                 <a:latin typeface="Garamond"/>
               </a:rPr>
-              <a:t>What correlates with leaving</a:t>
+              <a:t>Relative pay since 1997</a:t>
             </a:r>
           </a:p>
         </p:txBody>
@@ -3980,7 +3978,7 @@
       </p:sp>
       <p:pic>
         <p:nvPicPr>
-          <p:cNvPr id="4" name="Picture 3" descr="ame_ext.png"/>
+          <p:cNvPr id="4" name="Picture 3" descr="msgA3.png"/>
           <p:cNvPicPr>
             <a:picLocks noChangeAspect="1"/>
           </p:cNvPicPr>
@@ -3994,14 +3992,109 @@
         </p:blipFill>
         <p:spPr>
           <a:xfrm>
-            <a:off x="1587500" y="1024128"/>
-            <a:ext cx="8986520" cy="5577840"/>
+            <a:off x="702337" y="1097280"/>
+            <a:ext cx="10756845" cy="4434840"/>
           </a:xfrm>
           <a:prstGeom prst="rect">
             <a:avLst/>
           </a:prstGeom>
         </p:spPr>
       </p:pic>
+      <p:sp>
+        <p:nvSpPr>
+          <p:cNvPr id="5" name="Rectangle 4"/>
+          <p:cNvSpPr/>
+          <p:nvPr/>
+        </p:nvSpPr>
+        <p:spPr>
+          <a:xfrm>
+            <a:off x="0" y="5559552"/>
+            <a:ext cx="12191695" cy="960120"/>
+          </a:xfrm>
+          <a:prstGeom prst="rect">
+            <a:avLst/>
+          </a:prstGeom>
+          <a:solidFill>
+            <a:srgbClr val="ECF2F9"/>
+          </a:solidFill>
+          <a:ln>
+            <a:noFill/>
+          </a:ln>
+          <a:effectLst/>
+        </p:spPr>
+        <p:style>
+          <a:lnRef idx="1">
+            <a:schemeClr val="accent1"/>
+          </a:lnRef>
+          <a:fillRef idx="3">
+            <a:schemeClr val="accent1"/>
+          </a:fillRef>
+          <a:effectRef idx="2">
+            <a:schemeClr val="accent1"/>
+          </a:effectRef>
+          <a:fontRef idx="minor">
+            <a:schemeClr val="lt1"/>
+          </a:fontRef>
+        </p:style>
+        <p:txBody>
+          <a:bodyPr rtlCol="0" anchor="ctr"/>
+          <a:lstStyle/>
+          <a:p>
+            <a:pPr algn="ctr"/>
+          </a:p>
+        </p:txBody>
+      </p:sp>
+      <p:sp>
+        <p:nvSpPr>
+          <p:cNvPr id="6" name="TextBox 5"/>
+          <p:cNvSpPr txBox="1"/>
+          <p:nvPr/>
+        </p:nvSpPr>
+        <p:spPr>
+          <a:xfrm>
+            <a:off x="822960" y="5687568"/>
+            <a:ext cx="10789920" cy="822960"/>
+          </a:xfrm>
+          <a:prstGeom prst="rect">
+            <a:avLst/>
+          </a:prstGeom>
+          <a:noFill/>
+        </p:spPr>
+        <p:txBody>
+          <a:bodyPr wrap="square" lIns="0" rIns="0" tIns="0" bIns="0">
+            <a:spAutoFit/>
+          </a:bodyPr>
+          <a:lstStyle/>
+          <a:p>
+            <a:pPr algn="l">
+              <a:lnSpc>
+                <a:spcPts val="2048"/>
+              </a:lnSpc>
+              <a:spcAft>
+                <a:spcPts val="0"/>
+              </a:spcAft>
+            </a:pPr>
+            <a:r>
+              <a:rPr sz="1600" b="1" i="0">
+                <a:solidFill>
+                  <a:srgbClr val="102D5E"/>
+                </a:solidFill>
+                <a:latin typeface="Garamond"/>
+              </a:rPr>
+              <a:t>Key message.  </a:t>
+            </a:r>
+            <a:r>
+              <a:rPr sz="1600" b="0" i="0">
+                <a:solidFill>
+                  <a:srgbClr val="212529"/>
+                </a:solidFill>
+                <a:latin typeface="Garamond"/>
+              </a:rPr>
+              <a:t>Teacher pay has not grown in 25 years.</a:t>
+            </a:r>
+          </a:p>
+        </p:txBody>
+      </p:sp>
     </p:spTree>
   </p:cSld>
   <p:clrMapOvr>
@@ -4047,7 +4140,7 @@
                 </a:solidFill>
                 <a:latin typeface="Garamond"/>
               </a:rPr>
-              <a:t>Early-career teachers respond to different levers</a:t>
+              <a:t>Leaving, by position in the teacher pay distribution</a:t>
             </a:r>
           </a:p>
         </p:txBody>
@@ -4089,7 +4182,7 @@
       </p:sp>
       <p:pic>
         <p:nvPicPr>
-          <p:cNvPr id="4" name="Picture 3" descr="ame_byage.png"/>
+          <p:cNvPr id="4" name="Picture 3" descr="pay3_deciles_deck.png"/>
           <p:cNvPicPr>
             <a:picLocks noChangeAspect="1"/>
           </p:cNvPicPr>
@@ -4103,8 +4196,8 @@
         </p:blipFill>
         <p:spPr>
           <a:xfrm>
-            <a:off x="2216766" y="1005840"/>
-            <a:ext cx="7727986" cy="4663440"/>
+            <a:off x="1645920" y="1097280"/>
+            <a:ext cx="8869680" cy="4434840"/>
           </a:xfrm>
           <a:prstGeom prst="rect">
             <a:avLst/>
@@ -4119,7 +4212,7 @@
         </p:nvSpPr>
         <p:spPr>
           <a:xfrm>
-            <a:off x="0" y="5769864"/>
+            <a:off x="0" y="5559552"/>
             <a:ext cx="12191695" cy="960120"/>
           </a:xfrm>
           <a:prstGeom prst="rect">
@@ -4163,7 +4256,7 @@
         </p:nvSpPr>
         <p:spPr>
           <a:xfrm>
-            <a:off x="822960" y="5897880"/>
+            <a:off x="822960" y="5687568"/>
             <a:ext cx="10789920" cy="822960"/>
           </a:xfrm>
           <a:prstGeom prst="rect">
@@ -4179,14 +4272,14 @@
           <a:p>
             <a:pPr algn="l">
               <a:lnSpc>
-                <a:spcPts val="1855"/>
+                <a:spcPts val="2048"/>
               </a:lnSpc>
               <a:spcAft>
                 <a:spcPts val="0"/>
               </a:spcAft>
             </a:pPr>
             <a:r>
-              <a:rPr sz="1450" b="1" i="0">
+              <a:rPr sz="1600" b="1" i="0">
                 <a:solidFill>
                   <a:srgbClr val="102D5E"/>
                 </a:solidFill>
@@ -4195,13 +4288,13 @@
               <a:t>Key message.  </a:t>
             </a:r>
             <a:r>
-              <a:rPr sz="1450" b="0" i="0">
+              <a:rPr sz="1600" b="0" i="0">
                 <a:solidFill>
                   <a:srgbClr val="212529"/>
                 </a:solidFill>
                 <a:latin typeface="Garamond"/>
               </a:rPr>
-              <a:t>For teachers under 35, a public-school job retains three times more strongly than for the rest (−4.5 vs −1.6 points), and a pension plan also retains more. Security keeps the young in the classroom.</a:t>
+              <a:t>Leavers are concentrated in the bottom two deciles.</a:t>
             </a:r>
           </a:p>
         </p:txBody>
@@ -4251,7 +4344,7 @@
                 </a:solidFill>
                 <a:latin typeface="Garamond"/>
               </a:rPr>
-              <a:t>Relative pay since 1997</a:t>
+              <a:t>Pension coverage and leaving, across states</a:t>
             </a:r>
           </a:p>
         </p:txBody>
@@ -4293,7 +4386,7 @@
       </p:sp>
       <p:pic>
         <p:nvPicPr>
-          <p:cNvPr id="4" name="Picture 3" descr="msgA3.png"/>
+          <p:cNvPr id="4" name="Picture 3" descr="pension_scatter_deck.png"/>
           <p:cNvPicPr>
             <a:picLocks noChangeAspect="1"/>
           </p:cNvPicPr>
@@ -4307,8 +4400,8 @@
         </p:blipFill>
         <p:spPr>
           <a:xfrm>
-            <a:off x="702337" y="1097280"/>
-            <a:ext cx="10756845" cy="4434840"/>
+            <a:off x="2289687" y="1097280"/>
+            <a:ext cx="7582145" cy="4434840"/>
           </a:xfrm>
           <a:prstGeom prst="rect">
             <a:avLst/>
@@ -4405,7 +4498,7 @@
                 </a:solidFill>
                 <a:latin typeface="Garamond"/>
               </a:rPr>
-              <a:t>Teacher pay has not grown in 25 years.</a:t>
+              <a:t>States where more teachers have a pension plan have fewer early exits.</a:t>
             </a:r>
           </a:p>
         </p:txBody>
@@ -4430,111 +4523,20 @@
       <p:grpSpPr/>
       <p:sp>
         <p:nvSpPr>
-          <p:cNvPr id="2" name="TextBox 1"/>
-          <p:cNvSpPr txBox="1"/>
-          <p:nvPr/>
-        </p:nvSpPr>
-        <p:spPr>
-          <a:xfrm>
-            <a:off x="502920" y="219456"/>
-            <a:ext cx="11247120" cy="566928"/>
-          </a:xfrm>
-          <a:prstGeom prst="rect">
-            <a:avLst/>
-          </a:prstGeom>
-          <a:noFill/>
-        </p:spPr>
-        <p:txBody>
-          <a:bodyPr wrap="square" lIns="0" rIns="0" tIns="0" bIns="0"/>
-          <a:lstStyle/>
-          <a:p>
-            <a:r>
-              <a:rPr sz="2800" b="1">
-                <a:solidFill>
-                  <a:srgbClr val="102D5E"/>
-                </a:solidFill>
-                <a:latin typeface="Garamond"/>
-              </a:rPr>
-              <a:t>Leaving, by position in the teacher pay distribution</a:t>
-            </a:r>
-          </a:p>
-        </p:txBody>
-      </p:sp>
-      <p:sp>
-        <p:nvSpPr>
-          <p:cNvPr id="3" name="TextBox 2"/>
-          <p:cNvSpPr txBox="1"/>
-          <p:nvPr/>
-        </p:nvSpPr>
-        <p:spPr>
-          <a:xfrm>
-            <a:off x="11384280" y="6446520"/>
-            <a:ext cx="640080" cy="292608"/>
-          </a:xfrm>
-          <a:prstGeom prst="rect">
-            <a:avLst/>
-          </a:prstGeom>
-          <a:noFill/>
-        </p:spPr>
-        <p:txBody>
-          <a:bodyPr wrap="none" lIns="0" rIns="0" tIns="0" bIns="0">
-            <a:spAutoFit/>
-          </a:bodyPr>
-          <a:lstStyle/>
-          <a:p>
-            <a:pPr algn="r"/>
-            <a:r>
-              <a:rPr sz="1100">
-                <a:solidFill>
-                  <a:srgbClr val="6B7480"/>
-                </a:solidFill>
-                <a:latin typeface="Garamond"/>
-              </a:rPr>
-              <a:t>16</a:t>
-            </a:r>
-          </a:p>
-        </p:txBody>
-      </p:sp>
-      <p:pic>
-        <p:nvPicPr>
-          <p:cNvPr id="4" name="Picture 3" descr="pay3_deciles_deck.png"/>
-          <p:cNvPicPr>
-            <a:picLocks noChangeAspect="1"/>
-          </p:cNvPicPr>
-          <p:nvPr/>
-        </p:nvPicPr>
-        <p:blipFill>
-          <a:blip r:embed="rId2"/>
-          <a:stretch>
-            <a:fillRect/>
-          </a:stretch>
-        </p:blipFill>
-        <p:spPr>
-          <a:xfrm>
-            <a:off x="1645920" y="1097280"/>
-            <a:ext cx="8869680" cy="4434840"/>
-          </a:xfrm>
-          <a:prstGeom prst="rect">
-            <a:avLst/>
-          </a:prstGeom>
-        </p:spPr>
-      </p:pic>
-      <p:sp>
-        <p:nvSpPr>
-          <p:cNvPr id="5" name="Rectangle 4"/>
+          <p:cNvPr id="2" name="Rectangle 1"/>
           <p:cNvSpPr/>
           <p:nvPr/>
         </p:nvSpPr>
         <p:spPr>
           <a:xfrm>
-            <a:off x="0" y="5559552"/>
-            <a:ext cx="12191695" cy="960120"/>
+            <a:off x="0" y="0"/>
+            <a:ext cx="12191695" cy="6858000"/>
           </a:xfrm>
           <a:prstGeom prst="rect">
             <a:avLst/>
           </a:prstGeom>
           <a:solidFill>
-            <a:srgbClr val="ECF2F9"/>
+            <a:srgbClr val="102D5E"/>
           </a:solidFill>
           <a:ln>
             <a:noFill/>
@@ -4565,14 +4567,14 @@
       </p:sp>
       <p:sp>
         <p:nvSpPr>
-          <p:cNvPr id="6" name="TextBox 5"/>
+          <p:cNvPr id="3" name="TextBox 2"/>
           <p:cNvSpPr txBox="1"/>
           <p:nvPr/>
         </p:nvSpPr>
         <p:spPr>
           <a:xfrm>
-            <a:off x="822960" y="5687568"/>
-            <a:ext cx="10789920" cy="822960"/>
+            <a:off x="914400" y="2240280"/>
+            <a:ext cx="10360152" cy="1188720"/>
           </a:xfrm>
           <a:prstGeom prst="rect">
             <a:avLst/>
@@ -4585,31 +4587,64 @@
           </a:bodyPr>
           <a:lstStyle/>
           <a:p>
-            <a:pPr algn="l">
+            <a:pPr algn="ctr">
               <a:lnSpc>
-                <a:spcPts val="2048"/>
+                <a:spcPts val="7680"/>
               </a:lnSpc>
               <a:spcAft>
                 <a:spcPts val="0"/>
               </a:spcAft>
             </a:pPr>
             <a:r>
-              <a:rPr sz="1600" b="1" i="0">
-                <a:solidFill>
-                  <a:srgbClr val="102D5E"/>
-                </a:solidFill>
-                <a:latin typeface="Garamond"/>
-              </a:rPr>
-              <a:t>Key message.  </a:t>
-            </a:r>
-            <a:r>
-              <a:rPr sz="1600" b="0" i="0">
-                <a:solidFill>
-                  <a:srgbClr val="212529"/>
-                </a:solidFill>
-                <a:latin typeface="Garamond"/>
-              </a:rPr>
-              <a:t>Leavers are concentrated in the bottom two deciles.</a:t>
+              <a:rPr sz="6000" b="1" i="0">
+                <a:solidFill>
+                  <a:srgbClr val="FFFFFF"/>
+                </a:solidFill>
+                <a:latin typeface="Garamond"/>
+              </a:rPr>
+              <a:t>4</a:t>
+            </a:r>
+          </a:p>
+        </p:txBody>
+      </p:sp>
+      <p:sp>
+        <p:nvSpPr>
+          <p:cNvPr id="4" name="TextBox 3"/>
+          <p:cNvSpPr txBox="1"/>
+          <p:nvPr/>
+        </p:nvSpPr>
+        <p:spPr>
+          <a:xfrm>
+            <a:off x="914400" y="3703320"/>
+            <a:ext cx="10360152" cy="731520"/>
+          </a:xfrm>
+          <a:prstGeom prst="rect">
+            <a:avLst/>
+          </a:prstGeom>
+          <a:noFill/>
+        </p:spPr>
+        <p:txBody>
+          <a:bodyPr wrap="square" lIns="0" rIns="0" tIns="0" bIns="0">
+            <a:spAutoFit/>
+          </a:bodyPr>
+          <a:lstStyle/>
+          <a:p>
+            <a:pPr algn="ctr">
+              <a:lnSpc>
+                <a:spcPts val="3584"/>
+              </a:lnSpc>
+              <a:spcAft>
+                <a:spcPts val="0"/>
+              </a:spcAft>
+            </a:pPr>
+            <a:r>
+              <a:rPr sz="2800" b="0" i="0">
+                <a:solidFill>
+                  <a:srgbClr val="D7E3F2"/>
+                </a:solidFill>
+                <a:latin typeface="Garamond"/>
+              </a:rPr>
+              <a:t>What it means for policy</a:t>
             </a:r>
           </a:p>
         </p:txBody>
@@ -4659,7 +4694,7 @@
                 </a:solidFill>
                 <a:latin typeface="Garamond"/>
               </a:rPr>
-              <a:t>Pension coverage and leaving, across states</a:t>
+              <a:t>Policy options for re-attraction</a:t>
             </a:r>
           </a:p>
         </p:txBody>
@@ -4699,84 +4734,16 @@
           </a:p>
         </p:txBody>
       </p:sp>
-      <p:pic>
-        <p:nvPicPr>
-          <p:cNvPr id="4" name="Picture 3" descr="pension_scatter_deck.png"/>
-          <p:cNvPicPr>
-            <a:picLocks noChangeAspect="1"/>
-          </p:cNvPicPr>
-          <p:nvPr/>
-        </p:nvPicPr>
-        <p:blipFill>
-          <a:blip r:embed="rId2"/>
-          <a:stretch>
-            <a:fillRect/>
-          </a:stretch>
-        </p:blipFill>
-        <p:spPr>
-          <a:xfrm>
-            <a:off x="2289687" y="1097280"/>
-            <a:ext cx="7582145" cy="4434840"/>
-          </a:xfrm>
-          <a:prstGeom prst="rect">
-            <a:avLst/>
-          </a:prstGeom>
-        </p:spPr>
-      </p:pic>
-      <p:sp>
-        <p:nvSpPr>
-          <p:cNvPr id="5" name="Rectangle 4"/>
-          <p:cNvSpPr/>
-          <p:nvPr/>
-        </p:nvSpPr>
-        <p:spPr>
-          <a:xfrm>
-            <a:off x="0" y="5559552"/>
-            <a:ext cx="12191695" cy="960120"/>
-          </a:xfrm>
-          <a:prstGeom prst="rect">
-            <a:avLst/>
-          </a:prstGeom>
-          <a:solidFill>
-            <a:srgbClr val="ECF2F9"/>
-          </a:solidFill>
-          <a:ln>
-            <a:noFill/>
-          </a:ln>
-          <a:effectLst/>
-        </p:spPr>
-        <p:style>
-          <a:lnRef idx="1">
-            <a:schemeClr val="accent1"/>
-          </a:lnRef>
-          <a:fillRef idx="3">
-            <a:schemeClr val="accent1"/>
-          </a:fillRef>
-          <a:effectRef idx="2">
-            <a:schemeClr val="accent1"/>
-          </a:effectRef>
-          <a:fontRef idx="minor">
-            <a:schemeClr val="lt1"/>
-          </a:fontRef>
-        </p:style>
-        <p:txBody>
-          <a:bodyPr rtlCol="0" anchor="ctr"/>
-          <a:lstStyle/>
-          <a:p>
-            <a:pPr algn="ctr"/>
-          </a:p>
-        </p:txBody>
-      </p:sp>
-      <p:sp>
-        <p:nvSpPr>
-          <p:cNvPr id="6" name="TextBox 5"/>
+      <p:sp>
+        <p:nvSpPr>
+          <p:cNvPr id="4" name="TextBox 3"/>
           <p:cNvSpPr txBox="1"/>
           <p:nvPr/>
         </p:nvSpPr>
         <p:spPr>
           <a:xfrm>
-            <a:off x="822960" y="5687568"/>
-            <a:ext cx="10789920" cy="822960"/>
+            <a:off x="822960" y="1325880"/>
+            <a:ext cx="5120640" cy="457200"/>
           </a:xfrm>
           <a:prstGeom prst="rect">
             <a:avLst/>
@@ -4791,29 +4758,391 @@
           <a:p>
             <a:pPr algn="l">
               <a:lnSpc>
-                <a:spcPts val="2048"/>
+                <a:spcPts val="2688"/>
               </a:lnSpc>
               <a:spcAft>
                 <a:spcPts val="0"/>
               </a:spcAft>
             </a:pPr>
             <a:r>
-              <a:rPr sz="1600" b="1" i="0">
+              <a:rPr sz="2100" b="1" i="0">
+                <a:solidFill>
+                  <a:srgbClr val="2D6CB5"/>
+                </a:solidFill>
+                <a:latin typeface="Garamond"/>
+              </a:rPr>
+              <a:t>Short term and retirees</a:t>
+            </a:r>
+          </a:p>
+        </p:txBody>
+      </p:sp>
+      <p:sp>
+        <p:nvSpPr>
+          <p:cNvPr id="5" name="TextBox 4"/>
+          <p:cNvSpPr txBox="1"/>
+          <p:nvPr/>
+        </p:nvSpPr>
+        <p:spPr>
+          <a:xfrm>
+            <a:off x="822960" y="1828800"/>
+            <a:ext cx="5120640" cy="1554480"/>
+          </a:xfrm>
+          <a:prstGeom prst="rect">
+            <a:avLst/>
+          </a:prstGeom>
+          <a:noFill/>
+        </p:spPr>
+        <p:txBody>
+          <a:bodyPr wrap="square" lIns="0" rIns="0" tIns="0" bIns="0">
+            <a:spAutoFit/>
+          </a:bodyPr>
+          <a:lstStyle/>
+          <a:p>
+            <a:pPr algn="l">
+              <a:lnSpc>
+                <a:spcPts val="2176"/>
+              </a:lnSpc>
+              <a:spcAft>
+                <a:spcPts val="0"/>
+              </a:spcAft>
+            </a:pPr>
+            <a:r>
+              <a:rPr sz="1700" b="0" i="0">
+                <a:solidFill>
+                  <a:srgbClr val="212529"/>
+                </a:solidFill>
+                <a:latin typeface="Garamond"/>
+              </a:rPr>
+              <a:t>A reserve for local shortages. They bring experience and can mentor new teachers. Make it easy to return, for example part-time or “double-dipping”.</a:t>
+            </a:r>
+          </a:p>
+        </p:txBody>
+      </p:sp>
+      <p:sp>
+        <p:nvSpPr>
+          <p:cNvPr id="6" name="TextBox 5"/>
+          <p:cNvSpPr txBox="1"/>
+          <p:nvPr/>
+        </p:nvSpPr>
+        <p:spPr>
+          <a:xfrm>
+            <a:off x="6355080" y="1325880"/>
+            <a:ext cx="5120640" cy="457200"/>
+          </a:xfrm>
+          <a:prstGeom prst="rect">
+            <a:avLst/>
+          </a:prstGeom>
+          <a:noFill/>
+        </p:spPr>
+        <p:txBody>
+          <a:bodyPr wrap="square" lIns="0" rIns="0" tIns="0" bIns="0">
+            <a:spAutoFit/>
+          </a:bodyPr>
+          <a:lstStyle/>
+          <a:p>
+            <a:pPr algn="l">
+              <a:lnSpc>
+                <a:spcPts val="2688"/>
+              </a:lnSpc>
+              <a:spcAft>
+                <a:spcPts val="0"/>
+              </a:spcAft>
+            </a:pPr>
+            <a:r>
+              <a:rPr sz="2100" b="1" i="0">
+                <a:solidFill>
+                  <a:srgbClr val="2D6CB5"/>
+                </a:solidFill>
+                <a:latin typeface="Garamond"/>
+              </a:rPr>
+              <a:t>Medium term and switchers</a:t>
+            </a:r>
+          </a:p>
+        </p:txBody>
+      </p:sp>
+      <p:sp>
+        <p:nvSpPr>
+          <p:cNvPr id="7" name="TextBox 6"/>
+          <p:cNvSpPr txBox="1"/>
+          <p:nvPr/>
+        </p:nvSpPr>
+        <p:spPr>
+          <a:xfrm>
+            <a:off x="6355080" y="1828800"/>
+            <a:ext cx="5120640" cy="1554480"/>
+          </a:xfrm>
+          <a:prstGeom prst="rect">
+            <a:avLst/>
+          </a:prstGeom>
+          <a:noFill/>
+        </p:spPr>
+        <p:txBody>
+          <a:bodyPr wrap="square" lIns="0" rIns="0" tIns="0" bIns="0">
+            <a:spAutoFit/>
+          </a:bodyPr>
+          <a:lstStyle/>
+          <a:p>
+            <a:pPr algn="l">
+              <a:lnSpc>
+                <a:spcPts val="2176"/>
+              </a:lnSpc>
+              <a:spcAft>
+                <a:spcPts val="0"/>
+              </a:spcAft>
+            </a:pPr>
+            <a:r>
+              <a:rPr sz="1700" b="0" i="0">
+                <a:solidFill>
+                  <a:srgbClr val="212529"/>
+                </a:solidFill>
+                <a:latin typeface="Garamond"/>
+              </a:rPr>
+              <a:t>Early-career conditions (secure contracts, fair pay at the bottom) and support (mentoring). Learn why some move to jobs that do not require a degree.</a:t>
+            </a:r>
+          </a:p>
+        </p:txBody>
+      </p:sp>
+      <p:sp>
+        <p:nvSpPr>
+          <p:cNvPr id="8" name="TextBox 7"/>
+          <p:cNvSpPr txBox="1"/>
+          <p:nvPr/>
+        </p:nvSpPr>
+        <p:spPr>
+          <a:xfrm>
+            <a:off x="822960" y="3566160"/>
+            <a:ext cx="5120640" cy="457200"/>
+          </a:xfrm>
+          <a:prstGeom prst="rect">
+            <a:avLst/>
+          </a:prstGeom>
+          <a:noFill/>
+        </p:spPr>
+        <p:txBody>
+          <a:bodyPr wrap="square" lIns="0" rIns="0" tIns="0" bIns="0">
+            <a:spAutoFit/>
+          </a:bodyPr>
+          <a:lstStyle/>
+          <a:p>
+            <a:pPr algn="l">
+              <a:lnSpc>
+                <a:spcPts val="2688"/>
+              </a:lnSpc>
+              <a:spcAft>
+                <a:spcPts val="0"/>
+              </a:spcAft>
+            </a:pPr>
+            <a:r>
+              <a:rPr sz="2100" b="1" i="0">
+                <a:solidFill>
+                  <a:srgbClr val="2D6CB5"/>
+                </a:solidFill>
+                <a:latin typeface="Garamond"/>
+              </a:rPr>
+              <a:t>Long term and early exits</a:t>
+            </a:r>
+          </a:p>
+        </p:txBody>
+      </p:sp>
+      <p:sp>
+        <p:nvSpPr>
+          <p:cNvPr id="9" name="TextBox 8"/>
+          <p:cNvSpPr txBox="1"/>
+          <p:nvPr/>
+        </p:nvSpPr>
+        <p:spPr>
+          <a:xfrm>
+            <a:off x="822960" y="4069080"/>
+            <a:ext cx="5120640" cy="1554480"/>
+          </a:xfrm>
+          <a:prstGeom prst="rect">
+            <a:avLst/>
+          </a:prstGeom>
+          <a:noFill/>
+        </p:spPr>
+        <p:txBody>
+          <a:bodyPr wrap="square" lIns="0" rIns="0" tIns="0" bIns="0">
+            <a:spAutoFit/>
+          </a:bodyPr>
+          <a:lstStyle/>
+          <a:p>
+            <a:pPr algn="l">
+              <a:lnSpc>
+                <a:spcPts val="2176"/>
+              </a:lnSpc>
+              <a:spcAft>
+                <a:spcPts val="0"/>
+              </a:spcAft>
+            </a:pPr>
+            <a:r>
+              <a:rPr sz="1700" b="0" i="0">
+                <a:solidFill>
+                  <a:srgbClr val="212529"/>
+                </a:solidFill>
+                <a:latin typeface="Garamond"/>
+              </a:rPr>
+              <a:t>Flexibility, so those who want to return can do so in favoring conditions, and clear paths to return.</a:t>
+            </a:r>
+          </a:p>
+        </p:txBody>
+      </p:sp>
+      <p:sp>
+        <p:nvSpPr>
+          <p:cNvPr id="10" name="TextBox 9"/>
+          <p:cNvSpPr txBox="1"/>
+          <p:nvPr/>
+        </p:nvSpPr>
+        <p:spPr>
+          <a:xfrm>
+            <a:off x="6355080" y="3566160"/>
+            <a:ext cx="5120640" cy="457200"/>
+          </a:xfrm>
+          <a:prstGeom prst="rect">
+            <a:avLst/>
+          </a:prstGeom>
+          <a:noFill/>
+        </p:spPr>
+        <p:txBody>
+          <a:bodyPr wrap="square" lIns="0" rIns="0" tIns="0" bIns="0">
+            <a:spAutoFit/>
+          </a:bodyPr>
+          <a:lstStyle/>
+          <a:p>
+            <a:pPr algn="l">
+              <a:lnSpc>
+                <a:spcPts val="2688"/>
+              </a:lnSpc>
+              <a:spcAft>
+                <a:spcPts val="0"/>
+              </a:spcAft>
+            </a:pPr>
+            <a:r>
+              <a:rPr sz="2100" b="1" i="0">
+                <a:solidFill>
+                  <a:srgbClr val="2D6CB5"/>
+                </a:solidFill>
+                <a:latin typeface="Garamond"/>
+              </a:rPr>
+              <a:t>Research agenda</a:t>
+            </a:r>
+          </a:p>
+        </p:txBody>
+      </p:sp>
+      <p:sp>
+        <p:nvSpPr>
+          <p:cNvPr id="11" name="TextBox 10"/>
+          <p:cNvSpPr txBox="1"/>
+          <p:nvPr/>
+        </p:nvSpPr>
+        <p:spPr>
+          <a:xfrm>
+            <a:off x="6355080" y="4069080"/>
+            <a:ext cx="5120640" cy="1554480"/>
+          </a:xfrm>
+          <a:prstGeom prst="rect">
+            <a:avLst/>
+          </a:prstGeom>
+          <a:noFill/>
+        </p:spPr>
+        <p:txBody>
+          <a:bodyPr wrap="square" lIns="0" rIns="0" tIns="0" bIns="0">
+            <a:spAutoFit/>
+          </a:bodyPr>
+          <a:lstStyle/>
+          <a:p>
+            <a:pPr algn="l">
+              <a:lnSpc>
+                <a:spcPts val="2176"/>
+              </a:lnSpc>
+              <a:spcAft>
+                <a:spcPts val="0"/>
+              </a:spcAft>
+            </a:pPr>
+            <a:r>
+              <a:rPr sz="1700" b="0" i="0">
+                <a:solidFill>
+                  <a:srgbClr val="212529"/>
+                </a:solidFill>
+                <a:latin typeface="Garamond"/>
+              </a:rPr>
+              <a:t>Working conditions inside schools. Do these patterns hold in other countries?</a:t>
+            </a:r>
+          </a:p>
+        </p:txBody>
+      </p:sp>
+      <p:cxnSp>
+        <p:nvCxnSpPr>
+          <p:cNvPr id="12" name="Connector 11"/>
+          <p:cNvCxnSpPr/>
+          <p:nvPr/>
+        </p:nvCxnSpPr>
+        <p:spPr>
+          <a:xfrm>
+            <a:off x="822960" y="5806440"/>
+            <a:ext cx="10543032" cy="0"/>
+          </a:xfrm>
+          <a:prstGeom prst="line">
+            <a:avLst/>
+          </a:prstGeom>
+          <a:ln w="12700">
+            <a:solidFill>
+              <a:srgbClr val="102D5E"/>
+            </a:solidFill>
+          </a:ln>
+        </p:spPr>
+        <p:style>
+          <a:lnRef idx="2">
+            <a:schemeClr val="accent1"/>
+          </a:lnRef>
+          <a:fillRef idx="0">
+            <a:schemeClr val="accent1"/>
+          </a:fillRef>
+          <a:effectRef idx="1">
+            <a:schemeClr val="accent1"/>
+          </a:effectRef>
+          <a:fontRef idx="minor">
+            <a:schemeClr val="tx1"/>
+          </a:fontRef>
+        </p:style>
+      </p:cxnSp>
+      <p:sp>
+        <p:nvSpPr>
+          <p:cNvPr id="13" name="TextBox 12"/>
+          <p:cNvSpPr txBox="1"/>
+          <p:nvPr/>
+        </p:nvSpPr>
+        <p:spPr>
+          <a:xfrm>
+            <a:off x="822960" y="5989320"/>
+            <a:ext cx="10789920" cy="457200"/>
+          </a:xfrm>
+          <a:prstGeom prst="rect">
+            <a:avLst/>
+          </a:prstGeom>
+          <a:noFill/>
+        </p:spPr>
+        <p:txBody>
+          <a:bodyPr wrap="square" lIns="0" rIns="0" tIns="0" bIns="0">
+            <a:spAutoFit/>
+          </a:bodyPr>
+          <a:lstStyle/>
+          <a:p>
+            <a:pPr algn="ctr">
+              <a:lnSpc>
+                <a:spcPts val="2560"/>
+              </a:lnSpc>
+              <a:spcAft>
+                <a:spcPts val="0"/>
+              </a:spcAft>
+            </a:pPr>
+            <a:r>
+              <a:rPr sz="2000" b="1" i="0">
                 <a:solidFill>
                   <a:srgbClr val="102D5E"/>
                 </a:solidFill>
                 <a:latin typeface="Garamond"/>
               </a:rPr>
-              <a:t>Key message.  </a:t>
-            </a:r>
-            <a:r>
-              <a:rPr sz="1600" b="0" i="0">
-                <a:solidFill>
-                  <a:srgbClr val="212529"/>
-                </a:solidFill>
-                <a:latin typeface="Garamond"/>
-              </a:rPr>
-              <a:t>States where more teachers have a pension plan have fewer early exits.</a:t>
+              <a:t>Across all three: economic security.</a:t>
             </a:r>
           </a:p>
         </p:txBody>
@@ -4838,45 +5167,33 @@
       <p:grpSpPr/>
       <p:sp>
         <p:nvSpPr>
-          <p:cNvPr id="2" name="Rectangle 1"/>
-          <p:cNvSpPr/>
-          <p:nvPr/>
-        </p:nvSpPr>
-        <p:spPr>
-          <a:xfrm>
-            <a:off x="0" y="0"/>
-            <a:ext cx="12191695" cy="6858000"/>
-          </a:xfrm>
-          <a:prstGeom prst="rect">
-            <a:avLst/>
-          </a:prstGeom>
-          <a:solidFill>
-            <a:srgbClr val="102D5E"/>
-          </a:solidFill>
-          <a:ln>
-            <a:noFill/>
-          </a:ln>
-          <a:effectLst/>
-        </p:spPr>
-        <p:style>
-          <a:lnRef idx="1">
-            <a:schemeClr val="accent1"/>
-          </a:lnRef>
-          <a:fillRef idx="3">
-            <a:schemeClr val="accent1"/>
-          </a:fillRef>
-          <a:effectRef idx="2">
-            <a:schemeClr val="accent1"/>
-          </a:effectRef>
-          <a:fontRef idx="minor">
-            <a:schemeClr val="lt1"/>
-          </a:fontRef>
-        </p:style>
-        <p:txBody>
-          <a:bodyPr rtlCol="0" anchor="ctr"/>
-          <a:lstStyle/>
-          <a:p>
-            <a:pPr algn="ctr"/>
+          <p:cNvPr id="2" name="TextBox 1"/>
+          <p:cNvSpPr txBox="1"/>
+          <p:nvPr/>
+        </p:nvSpPr>
+        <p:spPr>
+          <a:xfrm>
+            <a:off x="502920" y="219456"/>
+            <a:ext cx="11247120" cy="566928"/>
+          </a:xfrm>
+          <a:prstGeom prst="rect">
+            <a:avLst/>
+          </a:prstGeom>
+          <a:noFill/>
+        </p:spPr>
+        <p:txBody>
+          <a:bodyPr wrap="square" lIns="0" rIns="0" tIns="0" bIns="0"/>
+          <a:lstStyle/>
+          <a:p>
+            <a:r>
+              <a:rPr sz="2800" b="1">
+                <a:solidFill>
+                  <a:srgbClr val="102D5E"/>
+                </a:solidFill>
+                <a:latin typeface="Garamond"/>
+              </a:rPr>
+              <a:t>Open questions</a:t>
+            </a:r>
           </a:p>
         </p:txBody>
       </p:sp>
@@ -4888,8 +5205,43 @@
         </p:nvSpPr>
         <p:spPr>
           <a:xfrm>
-            <a:off x="914400" y="2240280"/>
-            <a:ext cx="10360152" cy="1188720"/>
+            <a:off x="11384280" y="6446520"/>
+            <a:ext cx="640080" cy="292608"/>
+          </a:xfrm>
+          <a:prstGeom prst="rect">
+            <a:avLst/>
+          </a:prstGeom>
+          <a:noFill/>
+        </p:spPr>
+        <p:txBody>
+          <a:bodyPr wrap="none" lIns="0" rIns="0" tIns="0" bIns="0">
+            <a:spAutoFit/>
+          </a:bodyPr>
+          <a:lstStyle/>
+          <a:p>
+            <a:pPr algn="r"/>
+            <a:r>
+              <a:rPr sz="1100">
+                <a:solidFill>
+                  <a:srgbClr val="6B7480"/>
+                </a:solidFill>
+                <a:latin typeface="Garamond"/>
+              </a:rPr>
+              <a:t>18</a:t>
+            </a:r>
+          </a:p>
+        </p:txBody>
+      </p:sp>
+      <p:sp>
+        <p:nvSpPr>
+          <p:cNvPr id="4" name="TextBox 3"/>
+          <p:cNvSpPr txBox="1"/>
+          <p:nvPr/>
+        </p:nvSpPr>
+        <p:spPr>
+          <a:xfrm>
+            <a:off x="822960" y="1554480"/>
+            <a:ext cx="10789920" cy="5120640"/>
           </a:xfrm>
           <a:prstGeom prst="rect">
             <a:avLst/>
@@ -4902,547 +5254,155 @@
           </a:bodyPr>
           <a:lstStyle/>
           <a:p>
-            <a:pPr algn="ctr">
+            <a:pPr algn="l">
               <a:lnSpc>
-                <a:spcPts val="7680"/>
+                <a:spcPts val="2560"/>
               </a:lnSpc>
               <a:spcAft>
-                <a:spcPts val="0"/>
+                <a:spcPts val="2600"/>
               </a:spcAft>
             </a:pPr>
             <a:r>
-              <a:rPr sz="6000" b="1" i="0">
-                <a:solidFill>
-                  <a:srgbClr val="FFFFFF"/>
-                </a:solidFill>
-                <a:latin typeface="Garamond"/>
-              </a:rPr>
-              <a:t>4</a:t>
-            </a:r>
-          </a:p>
-        </p:txBody>
-      </p:sp>
-      <p:sp>
-        <p:nvSpPr>
-          <p:cNvPr id="4" name="TextBox 3"/>
-          <p:cNvSpPr txBox="1"/>
-          <p:nvPr/>
-        </p:nvSpPr>
-        <p:spPr>
-          <a:xfrm>
-            <a:off x="914400" y="3703320"/>
-            <a:ext cx="10360152" cy="731520"/>
-          </a:xfrm>
-          <a:prstGeom prst="rect">
-            <a:avLst/>
-          </a:prstGeom>
-          <a:noFill/>
-        </p:spPr>
-        <p:txBody>
-          <a:bodyPr wrap="square" lIns="0" rIns="0" tIns="0" bIns="0">
-            <a:spAutoFit/>
-          </a:bodyPr>
-          <a:lstStyle/>
-          <a:p>
-            <a:pPr algn="ctr">
+              <a:rPr sz="2000" b="1" i="0">
+                <a:solidFill>
+                  <a:srgbClr val="2D6CB5"/>
+                </a:solidFill>
+                <a:latin typeface="Garamond"/>
+              </a:rPr>
+              <a:t>▪  </a:t>
+            </a:r>
+            <a:r>
+              <a:rPr sz="2000" b="1" i="0">
+                <a:solidFill>
+                  <a:srgbClr val="102D5E"/>
+                </a:solidFill>
+                <a:latin typeface="Garamond"/>
+              </a:rPr>
+              <a:t>Pay floors.  </a:t>
+            </a:r>
+            <a:r>
+              <a:rPr sz="2000" b="0" i="0">
+                <a:solidFill>
+                  <a:srgbClr val="212529"/>
+                </a:solidFill>
+                <a:latin typeface="Garamond"/>
+              </a:rPr>
+              <a:t>Leaving concentrates in the bottom two pay deciles. Would raising the floor retain more teachers than raising the average?</a:t>
+            </a:r>
+          </a:p>
+          <a:p>
+            <a:pPr algn="l">
               <a:lnSpc>
-                <a:spcPts val="3584"/>
+                <a:spcPts val="2560"/>
               </a:lnSpc>
               <a:spcAft>
-                <a:spcPts val="0"/>
+                <a:spcPts val="2600"/>
               </a:spcAft>
             </a:pPr>
             <a:r>
-              <a:rPr sz="2800" b="0" i="0">
-                <a:solidFill>
-                  <a:srgbClr val="D7E3F2"/>
-                </a:solidFill>
-                <a:latin typeface="Garamond"/>
-              </a:rPr>
-              <a:t>What it means for policy</a:t>
-            </a:r>
-          </a:p>
-        </p:txBody>
-      </p:sp>
-    </p:spTree>
-  </p:cSld>
-  <p:clrMapOvr>
-    <a:masterClrMapping/>
-  </p:clrMapOvr>
-</p:sld>
-</file>
-
-<file path=ppt/slides/slide19.xml><?xml version="1.0" encoding="utf-8"?>
-<p:sld xmlns:a="http://schemas.openxmlformats.org/drawingml/2006/main" xmlns:p="http://schemas.openxmlformats.org/presentationml/2006/main" xmlns:r="http://schemas.openxmlformats.org/officeDocument/2006/relationships">
-  <p:cSld>
-    <p:spTree>
-      <p:nvGrpSpPr>
-        <p:cNvPr id="1" name=""/>
-        <p:cNvGrpSpPr/>
-        <p:nvPr/>
-      </p:nvGrpSpPr>
-      <p:grpSpPr/>
-      <p:sp>
-        <p:nvSpPr>
-          <p:cNvPr id="2" name="TextBox 1"/>
-          <p:cNvSpPr txBox="1"/>
-          <p:nvPr/>
-        </p:nvSpPr>
-        <p:spPr>
-          <a:xfrm>
-            <a:off x="502920" y="219456"/>
-            <a:ext cx="11247120" cy="566928"/>
-          </a:xfrm>
-          <a:prstGeom prst="rect">
-            <a:avLst/>
-          </a:prstGeom>
-          <a:noFill/>
-        </p:spPr>
-        <p:txBody>
-          <a:bodyPr wrap="square" lIns="0" rIns="0" tIns="0" bIns="0"/>
-          <a:lstStyle/>
-          <a:p>
-            <a:r>
-              <a:rPr sz="2800" b="1">
+              <a:rPr sz="2000" b="1" i="0">
+                <a:solidFill>
+                  <a:srgbClr val="2D6CB5"/>
+                </a:solidFill>
+                <a:latin typeface="Garamond"/>
+              </a:rPr>
+              <a:t>▪  </a:t>
+            </a:r>
+            <a:r>
+              <a:rPr sz="2000" b="1" i="0">
                 <a:solidFill>
                   <a:srgbClr val="102D5E"/>
                 </a:solidFill>
                 <a:latin typeface="Garamond"/>
               </a:rPr>
-              <a:t>Policy options for re-attraction</a:t>
-            </a:r>
-          </a:p>
-        </p:txBody>
-      </p:sp>
-      <p:sp>
-        <p:nvSpPr>
-          <p:cNvPr id="3" name="TextBox 2"/>
-          <p:cNvSpPr txBox="1"/>
-          <p:nvPr/>
-        </p:nvSpPr>
-        <p:spPr>
-          <a:xfrm>
-            <a:off x="11384280" y="6446520"/>
-            <a:ext cx="640080" cy="292608"/>
-          </a:xfrm>
-          <a:prstGeom prst="rect">
-            <a:avLst/>
-          </a:prstGeom>
-          <a:noFill/>
-        </p:spPr>
-        <p:txBody>
-          <a:bodyPr wrap="none" lIns="0" rIns="0" tIns="0" bIns="0">
-            <a:spAutoFit/>
-          </a:bodyPr>
-          <a:lstStyle/>
-          <a:p>
-            <a:pPr algn="r"/>
-            <a:r>
-              <a:rPr sz="1100">
-                <a:solidFill>
-                  <a:srgbClr val="6B7480"/>
-                </a:solidFill>
-                <a:latin typeface="Garamond"/>
-              </a:rPr>
-              <a:t>19</a:t>
-            </a:r>
-          </a:p>
-        </p:txBody>
-      </p:sp>
-      <p:sp>
-        <p:nvSpPr>
-          <p:cNvPr id="4" name="TextBox 3"/>
-          <p:cNvSpPr txBox="1"/>
-          <p:nvPr/>
-        </p:nvSpPr>
-        <p:spPr>
-          <a:xfrm>
-            <a:off x="822960" y="1325880"/>
-            <a:ext cx="5120640" cy="457200"/>
-          </a:xfrm>
-          <a:prstGeom prst="rect">
-            <a:avLst/>
-          </a:prstGeom>
-          <a:noFill/>
-        </p:spPr>
-        <p:txBody>
-          <a:bodyPr wrap="square" lIns="0" rIns="0" tIns="0" bIns="0">
-            <a:spAutoFit/>
-          </a:bodyPr>
-          <a:lstStyle/>
+              <a:t>Early careers.  </a:t>
+            </a:r>
+            <a:r>
+              <a:rPr sz="2000" b="0" i="0">
+                <a:solidFill>
+                  <a:srgbClr val="212529"/>
+                </a:solidFill>
+                <a:latin typeface="Garamond"/>
+              </a:rPr>
+              <a:t>Exits peak in the first years of the career. Which policies move this margin — mentoring, stable placements, or pay?</a:t>
+            </a:r>
+          </a:p>
           <a:p>
             <a:pPr algn="l">
               <a:lnSpc>
-                <a:spcPts val="2688"/>
+                <a:spcPts val="2560"/>
               </a:lnSpc>
               <a:spcAft>
-                <a:spcPts val="0"/>
+                <a:spcPts val="2600"/>
               </a:spcAft>
             </a:pPr>
             <a:r>
-              <a:rPr sz="2100" b="1" i="0">
+              <a:rPr sz="2000" b="1" i="0">
                 <a:solidFill>
                   <a:srgbClr val="2D6CB5"/>
                 </a:solidFill>
                 <a:latin typeface="Garamond"/>
               </a:rPr>
-              <a:t>Short term and retirees</a:t>
-            </a:r>
-          </a:p>
-        </p:txBody>
-      </p:sp>
-      <p:sp>
-        <p:nvSpPr>
-          <p:cNvPr id="5" name="TextBox 4"/>
-          <p:cNvSpPr txBox="1"/>
-          <p:nvPr/>
-        </p:nvSpPr>
-        <p:spPr>
-          <a:xfrm>
-            <a:off x="822960" y="1828800"/>
-            <a:ext cx="5120640" cy="1554480"/>
-          </a:xfrm>
-          <a:prstGeom prst="rect">
-            <a:avLst/>
-          </a:prstGeom>
-          <a:noFill/>
-        </p:spPr>
-        <p:txBody>
-          <a:bodyPr wrap="square" lIns="0" rIns="0" tIns="0" bIns="0">
-            <a:spAutoFit/>
-          </a:bodyPr>
-          <a:lstStyle/>
+              <a:t>▪  </a:t>
+            </a:r>
+            <a:r>
+              <a:rPr sz="2000" b="1" i="0">
+                <a:solidFill>
+                  <a:srgbClr val="102D5E"/>
+                </a:solidFill>
+                <a:latin typeface="Garamond"/>
+              </a:rPr>
+              <a:t>Family exits.  </a:t>
+            </a:r>
+            <a:r>
+              <a:rPr sz="2000" b="0" i="0">
+                <a:solidFill>
+                  <a:srgbClr val="212529"/>
+                </a:solidFill>
+                <a:latin typeface="Garamond"/>
+              </a:rPr>
+              <a:t>Half of the early labor-force exits are mothers with a child at home. Is this an education policy problem or a child-care one?</a:t>
+            </a:r>
+          </a:p>
           <a:p>
             <a:pPr algn="l">
               <a:lnSpc>
-                <a:spcPts val="2176"/>
+                <a:spcPts val="2560"/>
               </a:lnSpc>
               <a:spcAft>
-                <a:spcPts val="0"/>
+                <a:spcPts val="2600"/>
               </a:spcAft>
             </a:pPr>
             <a:r>
-              <a:rPr sz="1700" b="0" i="0">
+              <a:rPr sz="2000" b="1" i="0">
+                <a:solidFill>
+                  <a:srgbClr val="2D6CB5"/>
+                </a:solidFill>
+                <a:latin typeface="Garamond"/>
+              </a:rPr>
+              <a:t>▪  </a:t>
+            </a:r>
+            <a:r>
+              <a:rPr sz="2000" b="1" i="0">
+                <a:solidFill>
+                  <a:srgbClr val="102D5E"/>
+                </a:solidFill>
+                <a:latin typeface="Garamond"/>
+              </a:rPr>
+              <a:t>Re-entry.  </a:t>
+            </a:r>
+            <a:r>
+              <a:rPr sz="2000" b="0" i="0">
                 <a:solidFill>
                   <a:srgbClr val="212529"/>
                 </a:solidFill>
                 <a:latin typeface="Garamond"/>
               </a:rPr>
-              <a:t>A reserve for local shortages. They bring experience and can mentor new teachers. Make it easy to return, for example part-time or “double-dipping”.</a:t>
-            </a:r>
-          </a:p>
-        </p:txBody>
-      </p:sp>
-      <p:sp>
-        <p:nvSpPr>
-          <p:cNvPr id="6" name="TextBox 5"/>
-          <p:cNvSpPr txBox="1"/>
-          <p:nvPr/>
-        </p:nvSpPr>
-        <p:spPr>
-          <a:xfrm>
-            <a:off x="6355080" y="1325880"/>
-            <a:ext cx="5120640" cy="457200"/>
-          </a:xfrm>
-          <a:prstGeom prst="rect">
-            <a:avLst/>
-          </a:prstGeom>
-          <a:noFill/>
-        </p:spPr>
-        <p:txBody>
-          <a:bodyPr wrap="square" lIns="0" rIns="0" tIns="0" bIns="0">
-            <a:spAutoFit/>
-          </a:bodyPr>
-          <a:lstStyle/>
+              <a:t>The young leave to study and mothers leave to care. How many could come back, and what would bring them back?</a:t>
+            </a:r>
+          </a:p>
           <a:p>
             <a:pPr algn="l">
-              <a:lnSpc>
-                <a:spcPts val="2688"/>
-              </a:lnSpc>
-              <a:spcAft>
-                <a:spcPts val="0"/>
-              </a:spcAft>
-            </a:pPr>
-            <a:r>
-              <a:rPr sz="2100" b="1" i="0">
-                <a:solidFill>
-                  <a:srgbClr val="2D6CB5"/>
-                </a:solidFill>
-                <a:latin typeface="Garamond"/>
-              </a:rPr>
-              <a:t>Medium term and switchers</a:t>
-            </a:r>
-          </a:p>
-        </p:txBody>
-      </p:sp>
-      <p:sp>
-        <p:nvSpPr>
-          <p:cNvPr id="7" name="TextBox 6"/>
-          <p:cNvSpPr txBox="1"/>
-          <p:nvPr/>
-        </p:nvSpPr>
-        <p:spPr>
-          <a:xfrm>
-            <a:off x="6355080" y="1828800"/>
-            <a:ext cx="5120640" cy="1554480"/>
-          </a:xfrm>
-          <a:prstGeom prst="rect">
-            <a:avLst/>
-          </a:prstGeom>
-          <a:noFill/>
-        </p:spPr>
-        <p:txBody>
-          <a:bodyPr wrap="square" lIns="0" rIns="0" tIns="0" bIns="0">
-            <a:spAutoFit/>
-          </a:bodyPr>
-          <a:lstStyle/>
-          <a:p>
-            <a:pPr algn="l">
-              <a:lnSpc>
-                <a:spcPts val="2176"/>
-              </a:lnSpc>
-              <a:spcAft>
-                <a:spcPts val="0"/>
-              </a:spcAft>
-            </a:pPr>
-            <a:r>
-              <a:rPr sz="1700" b="0" i="0">
-                <a:solidFill>
-                  <a:srgbClr val="212529"/>
-                </a:solidFill>
-                <a:latin typeface="Garamond"/>
-              </a:rPr>
-              <a:t>Early-career conditions (secure contracts, fair pay at the bottom) and support (mentoring). Learn why some move to jobs that do not require a degree.</a:t>
-            </a:r>
-          </a:p>
-        </p:txBody>
-      </p:sp>
-      <p:sp>
-        <p:nvSpPr>
-          <p:cNvPr id="8" name="TextBox 7"/>
-          <p:cNvSpPr txBox="1"/>
-          <p:nvPr/>
-        </p:nvSpPr>
-        <p:spPr>
-          <a:xfrm>
-            <a:off x="822960" y="3566160"/>
-            <a:ext cx="5120640" cy="457200"/>
-          </a:xfrm>
-          <a:prstGeom prst="rect">
-            <a:avLst/>
-          </a:prstGeom>
-          <a:noFill/>
-        </p:spPr>
-        <p:txBody>
-          <a:bodyPr wrap="square" lIns="0" rIns="0" tIns="0" bIns="0">
-            <a:spAutoFit/>
-          </a:bodyPr>
-          <a:lstStyle/>
-          <a:p>
-            <a:pPr algn="l">
-              <a:lnSpc>
-                <a:spcPts val="2688"/>
-              </a:lnSpc>
-              <a:spcAft>
-                <a:spcPts val="0"/>
-              </a:spcAft>
-            </a:pPr>
-            <a:r>
-              <a:rPr sz="2100" b="1" i="0">
-                <a:solidFill>
-                  <a:srgbClr val="2D6CB5"/>
-                </a:solidFill>
-                <a:latin typeface="Garamond"/>
-              </a:rPr>
-              <a:t>Long term and early exits</a:t>
-            </a:r>
-          </a:p>
-        </p:txBody>
-      </p:sp>
-      <p:sp>
-        <p:nvSpPr>
-          <p:cNvPr id="9" name="TextBox 8"/>
-          <p:cNvSpPr txBox="1"/>
-          <p:nvPr/>
-        </p:nvSpPr>
-        <p:spPr>
-          <a:xfrm>
-            <a:off x="822960" y="4069080"/>
-            <a:ext cx="5120640" cy="1554480"/>
-          </a:xfrm>
-          <a:prstGeom prst="rect">
-            <a:avLst/>
-          </a:prstGeom>
-          <a:noFill/>
-        </p:spPr>
-        <p:txBody>
-          <a:bodyPr wrap="square" lIns="0" rIns="0" tIns="0" bIns="0">
-            <a:spAutoFit/>
-          </a:bodyPr>
-          <a:lstStyle/>
-          <a:p>
-            <a:pPr algn="l">
-              <a:lnSpc>
-                <a:spcPts val="2176"/>
-              </a:lnSpc>
-              <a:spcAft>
-                <a:spcPts val="0"/>
-              </a:spcAft>
-            </a:pPr>
-            <a:r>
-              <a:rPr sz="1700" b="0" i="0">
-                <a:solidFill>
-                  <a:srgbClr val="212529"/>
-                </a:solidFill>
-                <a:latin typeface="Garamond"/>
-              </a:rPr>
-              <a:t>Flexibility, so those who want to return can do so in favoring conditions, and clear paths to return.</a:t>
-            </a:r>
-          </a:p>
-        </p:txBody>
-      </p:sp>
-      <p:sp>
-        <p:nvSpPr>
-          <p:cNvPr id="10" name="TextBox 9"/>
-          <p:cNvSpPr txBox="1"/>
-          <p:nvPr/>
-        </p:nvSpPr>
-        <p:spPr>
-          <a:xfrm>
-            <a:off x="6355080" y="3566160"/>
-            <a:ext cx="5120640" cy="457200"/>
-          </a:xfrm>
-          <a:prstGeom prst="rect">
-            <a:avLst/>
-          </a:prstGeom>
-          <a:noFill/>
-        </p:spPr>
-        <p:txBody>
-          <a:bodyPr wrap="square" lIns="0" rIns="0" tIns="0" bIns="0">
-            <a:spAutoFit/>
-          </a:bodyPr>
-          <a:lstStyle/>
-          <a:p>
-            <a:pPr algn="l">
-              <a:lnSpc>
-                <a:spcPts val="2688"/>
-              </a:lnSpc>
-              <a:spcAft>
-                <a:spcPts val="0"/>
-              </a:spcAft>
-            </a:pPr>
-            <a:r>
-              <a:rPr sz="2100" b="1" i="0">
-                <a:solidFill>
-                  <a:srgbClr val="2D6CB5"/>
-                </a:solidFill>
-                <a:latin typeface="Garamond"/>
-              </a:rPr>
-              <a:t>Research agenda</a:t>
-            </a:r>
-          </a:p>
-        </p:txBody>
-      </p:sp>
-      <p:sp>
-        <p:nvSpPr>
-          <p:cNvPr id="11" name="TextBox 10"/>
-          <p:cNvSpPr txBox="1"/>
-          <p:nvPr/>
-        </p:nvSpPr>
-        <p:spPr>
-          <a:xfrm>
-            <a:off x="6355080" y="4069080"/>
-            <a:ext cx="5120640" cy="1554480"/>
-          </a:xfrm>
-          <a:prstGeom prst="rect">
-            <a:avLst/>
-          </a:prstGeom>
-          <a:noFill/>
-        </p:spPr>
-        <p:txBody>
-          <a:bodyPr wrap="square" lIns="0" rIns="0" tIns="0" bIns="0">
-            <a:spAutoFit/>
-          </a:bodyPr>
-          <a:lstStyle/>
-          <a:p>
-            <a:pPr algn="l">
-              <a:lnSpc>
-                <a:spcPts val="2176"/>
-              </a:lnSpc>
-              <a:spcAft>
-                <a:spcPts val="0"/>
-              </a:spcAft>
-            </a:pPr>
-            <a:r>
-              <a:rPr sz="1700" b="0" i="0">
-                <a:solidFill>
-                  <a:srgbClr val="212529"/>
-                </a:solidFill>
-                <a:latin typeface="Garamond"/>
-              </a:rPr>
-              <a:t>Working conditions inside schools. Do these patterns hold in other countries?</a:t>
-            </a:r>
-          </a:p>
-        </p:txBody>
-      </p:sp>
-      <p:cxnSp>
-        <p:nvCxnSpPr>
-          <p:cNvPr id="12" name="Connector 11"/>
-          <p:cNvCxnSpPr/>
-          <p:nvPr/>
-        </p:nvCxnSpPr>
-        <p:spPr>
-          <a:xfrm>
-            <a:off x="822960" y="5806440"/>
-            <a:ext cx="10543032" cy="0"/>
-          </a:xfrm>
-          <a:prstGeom prst="line">
-            <a:avLst/>
-          </a:prstGeom>
-          <a:ln w="12700">
-            <a:solidFill>
-              <a:srgbClr val="102D5E"/>
-            </a:solidFill>
-          </a:ln>
-        </p:spPr>
-        <p:style>
-          <a:lnRef idx="2">
-            <a:schemeClr val="accent1"/>
-          </a:lnRef>
-          <a:fillRef idx="0">
-            <a:schemeClr val="accent1"/>
-          </a:fillRef>
-          <a:effectRef idx="1">
-            <a:schemeClr val="accent1"/>
-          </a:effectRef>
-          <a:fontRef idx="minor">
-            <a:schemeClr val="tx1"/>
-          </a:fontRef>
-        </p:style>
-      </p:cxnSp>
-      <p:sp>
-        <p:nvSpPr>
-          <p:cNvPr id="13" name="TextBox 12"/>
-          <p:cNvSpPr txBox="1"/>
-          <p:nvPr/>
-        </p:nvSpPr>
-        <p:spPr>
-          <a:xfrm>
-            <a:off x="822960" y="5989320"/>
-            <a:ext cx="10789920" cy="457200"/>
-          </a:xfrm>
-          <a:prstGeom prst="rect">
-            <a:avLst/>
-          </a:prstGeom>
-          <a:noFill/>
-        </p:spPr>
-        <p:txBody>
-          <a:bodyPr wrap="square" lIns="0" rIns="0" tIns="0" bIns="0">
-            <a:spAutoFit/>
-          </a:bodyPr>
-          <a:lstStyle/>
-          <a:p>
-            <a:pPr algn="ctr">
               <a:lnSpc>
                 <a:spcPts val="2560"/>
               </a:lnSpc>
@@ -5453,11 +5413,29 @@
             <a:r>
               <a:rPr sz="2000" b="1" i="0">
                 <a:solidFill>
+                  <a:srgbClr val="2D6CB5"/>
+                </a:solidFill>
+                <a:latin typeface="Garamond"/>
+              </a:rPr>
+              <a:t>▪  </a:t>
+            </a:r>
+            <a:r>
+              <a:rPr sz="2000" b="1" i="0">
+                <a:solidFill>
                   <a:srgbClr val="102D5E"/>
                 </a:solidFill>
                 <a:latin typeface="Garamond"/>
               </a:rPr>
-              <a:t>Across all three: economic security.</a:t>
+              <a:t>What we cannot see.  </a:t>
+            </a:r>
+            <a:r>
+              <a:rPr sz="2000" b="0" i="0">
+                <a:solidFill>
+                  <a:srgbClr val="212529"/>
+                </a:solidFill>
+                <a:latin typeface="Garamond"/>
+              </a:rPr>
+              <a:t>Working conditions and school climate are invisible in household data. What would it take to measure them every year?</a:t>
             </a:r>
           </a:p>
         </p:txBody>
@@ -5785,299 +5763,6 @@
                 <a:latin typeface="Garamond"/>
               </a:rPr>
               <a:t>The US official rate (NCES Teacher Follow-up Survey) appears only every 4–9 years, not annually.</a:t>
-            </a:r>
-          </a:p>
-        </p:txBody>
-      </p:sp>
-    </p:spTree>
-  </p:cSld>
-  <p:clrMapOvr>
-    <a:masterClrMapping/>
-  </p:clrMapOvr>
-</p:sld>
-</file>
-
-<file path=ppt/slides/slide20.xml><?xml version="1.0" encoding="utf-8"?>
-<p:sld xmlns:a="http://schemas.openxmlformats.org/drawingml/2006/main" xmlns:p="http://schemas.openxmlformats.org/presentationml/2006/main" xmlns:r="http://schemas.openxmlformats.org/officeDocument/2006/relationships">
-  <p:cSld>
-    <p:spTree>
-      <p:nvGrpSpPr>
-        <p:cNvPr id="1" name=""/>
-        <p:cNvGrpSpPr/>
-        <p:nvPr/>
-      </p:nvGrpSpPr>
-      <p:grpSpPr/>
-      <p:sp>
-        <p:nvSpPr>
-          <p:cNvPr id="2" name="TextBox 1"/>
-          <p:cNvSpPr txBox="1"/>
-          <p:nvPr/>
-        </p:nvSpPr>
-        <p:spPr>
-          <a:xfrm>
-            <a:off x="502920" y="219456"/>
-            <a:ext cx="11247120" cy="566928"/>
-          </a:xfrm>
-          <a:prstGeom prst="rect">
-            <a:avLst/>
-          </a:prstGeom>
-          <a:noFill/>
-        </p:spPr>
-        <p:txBody>
-          <a:bodyPr wrap="square" lIns="0" rIns="0" tIns="0" bIns="0"/>
-          <a:lstStyle/>
-          <a:p>
-            <a:r>
-              <a:rPr sz="2800" b="1">
-                <a:solidFill>
-                  <a:srgbClr val="102D5E"/>
-                </a:solidFill>
-                <a:latin typeface="Garamond"/>
-              </a:rPr>
-              <a:t>Open questions</a:t>
-            </a:r>
-          </a:p>
-        </p:txBody>
-      </p:sp>
-      <p:sp>
-        <p:nvSpPr>
-          <p:cNvPr id="3" name="TextBox 2"/>
-          <p:cNvSpPr txBox="1"/>
-          <p:nvPr/>
-        </p:nvSpPr>
-        <p:spPr>
-          <a:xfrm>
-            <a:off x="11384280" y="6446520"/>
-            <a:ext cx="640080" cy="292608"/>
-          </a:xfrm>
-          <a:prstGeom prst="rect">
-            <a:avLst/>
-          </a:prstGeom>
-          <a:noFill/>
-        </p:spPr>
-        <p:txBody>
-          <a:bodyPr wrap="none" lIns="0" rIns="0" tIns="0" bIns="0">
-            <a:spAutoFit/>
-          </a:bodyPr>
-          <a:lstStyle/>
-          <a:p>
-            <a:pPr algn="r"/>
-            <a:r>
-              <a:rPr sz="1100">
-                <a:solidFill>
-                  <a:srgbClr val="6B7480"/>
-                </a:solidFill>
-                <a:latin typeface="Garamond"/>
-              </a:rPr>
-              <a:t>20</a:t>
-            </a:r>
-          </a:p>
-        </p:txBody>
-      </p:sp>
-      <p:sp>
-        <p:nvSpPr>
-          <p:cNvPr id="4" name="TextBox 3"/>
-          <p:cNvSpPr txBox="1"/>
-          <p:nvPr/>
-        </p:nvSpPr>
-        <p:spPr>
-          <a:xfrm>
-            <a:off x="822960" y="1554480"/>
-            <a:ext cx="10789920" cy="5120640"/>
-          </a:xfrm>
-          <a:prstGeom prst="rect">
-            <a:avLst/>
-          </a:prstGeom>
-          <a:noFill/>
-        </p:spPr>
-        <p:txBody>
-          <a:bodyPr wrap="square" lIns="0" rIns="0" tIns="0" bIns="0">
-            <a:spAutoFit/>
-          </a:bodyPr>
-          <a:lstStyle/>
-          <a:p>
-            <a:pPr algn="l">
-              <a:lnSpc>
-                <a:spcPts val="2560"/>
-              </a:lnSpc>
-              <a:spcAft>
-                <a:spcPts val="2600"/>
-              </a:spcAft>
-            </a:pPr>
-            <a:r>
-              <a:rPr sz="2000" b="1" i="0">
-                <a:solidFill>
-                  <a:srgbClr val="2D6CB5"/>
-                </a:solidFill>
-                <a:latin typeface="Garamond"/>
-              </a:rPr>
-              <a:t>▪  </a:t>
-            </a:r>
-            <a:r>
-              <a:rPr sz="2000" b="1" i="0">
-                <a:solidFill>
-                  <a:srgbClr val="102D5E"/>
-                </a:solidFill>
-                <a:latin typeface="Garamond"/>
-              </a:rPr>
-              <a:t>Pay floors.  </a:t>
-            </a:r>
-            <a:r>
-              <a:rPr sz="2000" b="0" i="0">
-                <a:solidFill>
-                  <a:srgbClr val="212529"/>
-                </a:solidFill>
-                <a:latin typeface="Garamond"/>
-              </a:rPr>
-              <a:t>Leaving concentrates in the bottom two pay deciles. Would raising the floor retain more teachers than raising the average?</a:t>
-            </a:r>
-          </a:p>
-          <a:p>
-            <a:pPr algn="l">
-              <a:lnSpc>
-                <a:spcPts val="2560"/>
-              </a:lnSpc>
-              <a:spcAft>
-                <a:spcPts val="2600"/>
-              </a:spcAft>
-            </a:pPr>
-            <a:r>
-              <a:rPr sz="2000" b="1" i="0">
-                <a:solidFill>
-                  <a:srgbClr val="2D6CB5"/>
-                </a:solidFill>
-                <a:latin typeface="Garamond"/>
-              </a:rPr>
-              <a:t>▪  </a:t>
-            </a:r>
-            <a:r>
-              <a:rPr sz="2000" b="1" i="0">
-                <a:solidFill>
-                  <a:srgbClr val="102D5E"/>
-                </a:solidFill>
-                <a:latin typeface="Garamond"/>
-              </a:rPr>
-              <a:t>Early careers.  </a:t>
-            </a:r>
-            <a:r>
-              <a:rPr sz="2000" b="0" i="0">
-                <a:solidFill>
-                  <a:srgbClr val="212529"/>
-                </a:solidFill>
-                <a:latin typeface="Garamond"/>
-              </a:rPr>
-              <a:t>Exits peak in the first years of the career. Which policies move this margin — mentoring, stable placements, or pay?</a:t>
-            </a:r>
-          </a:p>
-          <a:p>
-            <a:pPr algn="l">
-              <a:lnSpc>
-                <a:spcPts val="2560"/>
-              </a:lnSpc>
-              <a:spcAft>
-                <a:spcPts val="2600"/>
-              </a:spcAft>
-            </a:pPr>
-            <a:r>
-              <a:rPr sz="2000" b="1" i="0">
-                <a:solidFill>
-                  <a:srgbClr val="2D6CB5"/>
-                </a:solidFill>
-                <a:latin typeface="Garamond"/>
-              </a:rPr>
-              <a:t>▪  </a:t>
-            </a:r>
-            <a:r>
-              <a:rPr sz="2000" b="1" i="0">
-                <a:solidFill>
-                  <a:srgbClr val="102D5E"/>
-                </a:solidFill>
-                <a:latin typeface="Garamond"/>
-              </a:rPr>
-              <a:t>Family exits.  </a:t>
-            </a:r>
-            <a:r>
-              <a:rPr sz="2000" b="0" i="0">
-                <a:solidFill>
-                  <a:srgbClr val="212529"/>
-                </a:solidFill>
-                <a:latin typeface="Garamond"/>
-              </a:rPr>
-              <a:t>Half of the early labor-force exits are mothers with a child at home. Is this an education policy problem or a child-care one?</a:t>
-            </a:r>
-          </a:p>
-          <a:p>
-            <a:pPr algn="l">
-              <a:lnSpc>
-                <a:spcPts val="2560"/>
-              </a:lnSpc>
-              <a:spcAft>
-                <a:spcPts val="2600"/>
-              </a:spcAft>
-            </a:pPr>
-            <a:r>
-              <a:rPr sz="2000" b="1" i="0">
-                <a:solidFill>
-                  <a:srgbClr val="2D6CB5"/>
-                </a:solidFill>
-                <a:latin typeface="Garamond"/>
-              </a:rPr>
-              <a:t>▪  </a:t>
-            </a:r>
-            <a:r>
-              <a:rPr sz="2000" b="1" i="0">
-                <a:solidFill>
-                  <a:srgbClr val="102D5E"/>
-                </a:solidFill>
-                <a:latin typeface="Garamond"/>
-              </a:rPr>
-              <a:t>Re-entry.  </a:t>
-            </a:r>
-            <a:r>
-              <a:rPr sz="2000" b="0" i="0">
-                <a:solidFill>
-                  <a:srgbClr val="212529"/>
-                </a:solidFill>
-                <a:latin typeface="Garamond"/>
-              </a:rPr>
-              <a:t>The young leave to study and mothers leave to care. How many could come back, and what would bring them back?</a:t>
-            </a:r>
-          </a:p>
-          <a:p>
-            <a:pPr algn="l">
-              <a:lnSpc>
-                <a:spcPts val="2560"/>
-              </a:lnSpc>
-              <a:spcAft>
-                <a:spcPts val="0"/>
-              </a:spcAft>
-            </a:pPr>
-            <a:r>
-              <a:rPr sz="2000" b="1" i="0">
-                <a:solidFill>
-                  <a:srgbClr val="2D6CB5"/>
-                </a:solidFill>
-                <a:latin typeface="Garamond"/>
-              </a:rPr>
-              <a:t>▪  </a:t>
-            </a:r>
-            <a:r>
-              <a:rPr sz="2000" b="1" i="0">
-                <a:solidFill>
-                  <a:srgbClr val="102D5E"/>
-                </a:solidFill>
-                <a:latin typeface="Garamond"/>
-              </a:rPr>
-              <a:t>What we cannot see.  </a:t>
-            </a:r>
-            <a:r>
-              <a:rPr sz="2000" b="0" i="0">
-                <a:solidFill>
-                  <a:srgbClr val="212529"/>
-                </a:solidFill>
-                <a:latin typeface="Garamond"/>
-              </a:rPr>
-              <a:t>Working conditions and school climate are invisible in household data. What would it take to measure them every year?</a:t>
             </a:r>
           </a:p>
         </p:txBody>

</xml_diff>

<commit_message>
Policy deck: discussion prompts, why-teachers-leave slide, booktabs numbers
Section dividers each carry a question for the funding governments
(how their system measures leaving, where teachers go, which levers
they can move, what would bring teachers back). Adds a visual slide on
the reasons in the literature, split into those beyond household data
and those we explore, with a discussion prompt, just before the
drivers. The CPS numbers slide keeps the author's labels in a booktabs
layout (thick top rule, thin column rules and bottom rule), and key
messages get a navy accent stripe and larger navy text.

Co-Authored-By: Claude Opus 5.5 <noreply@anthropic.com>
Claude-Session: https://claude.ai/code/session_01DNzQPDcr3zfLTraMHUHqUn
</commit_message>
<xml_diff>
--- a/report/data_cluster/Proyect_US_policy.pptx
+++ b/report/data_cluster/Proyect_US_policy.pptx
@@ -23,6 +23,7 @@
     <p:sldId id="271" r:id="rId22"/>
     <p:sldId id="272" r:id="rId23"/>
     <p:sldId id="273" r:id="rId24"/>
+    <p:sldId id="274" r:id="rId25"/>
   </p:sldIdLst>
   <p:sldSz cx="12191695" cy="6858000" type="screen4x3"/>
   <p:notesSz cx="6858000" cy="9144000"/>
@@ -3492,7 +3493,51 @@
       </p:sp>
       <p:sp>
         <p:nvSpPr>
-          <p:cNvPr id="6" name="TextBox 5"/>
+          <p:cNvPr id="6" name="Rectangle 5"/>
+          <p:cNvSpPr/>
+          <p:nvPr/>
+        </p:nvSpPr>
+        <p:spPr>
+          <a:xfrm>
+            <a:off x="502920" y="5669280"/>
+            <a:ext cx="73152" cy="713232"/>
+          </a:xfrm>
+          <a:prstGeom prst="rect">
+            <a:avLst/>
+          </a:prstGeom>
+          <a:solidFill>
+            <a:srgbClr val="102D5E"/>
+          </a:solidFill>
+          <a:ln>
+            <a:noFill/>
+          </a:ln>
+          <a:effectLst/>
+        </p:spPr>
+        <p:style>
+          <a:lnRef idx="1">
+            <a:schemeClr val="accent1"/>
+          </a:lnRef>
+          <a:fillRef idx="3">
+            <a:schemeClr val="accent1"/>
+          </a:fillRef>
+          <a:effectRef idx="2">
+            <a:schemeClr val="accent1"/>
+          </a:effectRef>
+          <a:fontRef idx="minor">
+            <a:schemeClr val="lt1"/>
+          </a:fontRef>
+        </p:style>
+        <p:txBody>
+          <a:bodyPr rtlCol="0" anchor="ctr"/>
+          <a:lstStyle/>
+          <a:p>
+            <a:pPr algn="ctr"/>
+          </a:p>
+        </p:txBody>
+      </p:sp>
+      <p:sp>
+        <p:nvSpPr>
+          <p:cNvPr id="7" name="TextBox 6"/>
           <p:cNvSpPr txBox="1"/>
           <p:nvPr/>
         </p:nvSpPr>
@@ -3514,14 +3559,14 @@
           <a:p>
             <a:pPr algn="l">
               <a:lnSpc>
-                <a:spcPts val="2048"/>
+                <a:spcPts val="2176"/>
               </a:lnSpc>
               <a:spcAft>
                 <a:spcPts val="0"/>
               </a:spcAft>
             </a:pPr>
             <a:r>
-              <a:rPr sz="1600" b="1" i="0">
+              <a:rPr sz="1700" b="1" i="0">
                 <a:solidFill>
                   <a:srgbClr val="102D5E"/>
                 </a:solidFill>
@@ -3530,9 +3575,9 @@
               <a:t>Key messages.  </a:t>
             </a:r>
             <a:r>
-              <a:rPr sz="1600" b="0" i="0">
-                <a:solidFill>
-                  <a:srgbClr val="212529"/>
+              <a:rPr sz="1700" b="0" i="0">
+                <a:solidFill>
+                  <a:srgbClr val="102D5E"/>
                 </a:solidFill>
                 <a:latin typeface="Garamond"/>
               </a:rPr>
@@ -3696,7 +3741,51 @@
       </p:sp>
       <p:sp>
         <p:nvSpPr>
-          <p:cNvPr id="6" name="TextBox 5"/>
+          <p:cNvPr id="6" name="Rectangle 5"/>
+          <p:cNvSpPr/>
+          <p:nvPr/>
+        </p:nvSpPr>
+        <p:spPr>
+          <a:xfrm>
+            <a:off x="502920" y="5669280"/>
+            <a:ext cx="73152" cy="713232"/>
+          </a:xfrm>
+          <a:prstGeom prst="rect">
+            <a:avLst/>
+          </a:prstGeom>
+          <a:solidFill>
+            <a:srgbClr val="102D5E"/>
+          </a:solidFill>
+          <a:ln>
+            <a:noFill/>
+          </a:ln>
+          <a:effectLst/>
+        </p:spPr>
+        <p:style>
+          <a:lnRef idx="1">
+            <a:schemeClr val="accent1"/>
+          </a:lnRef>
+          <a:fillRef idx="3">
+            <a:schemeClr val="accent1"/>
+          </a:fillRef>
+          <a:effectRef idx="2">
+            <a:schemeClr val="accent1"/>
+          </a:effectRef>
+          <a:fontRef idx="minor">
+            <a:schemeClr val="lt1"/>
+          </a:fontRef>
+        </p:style>
+        <p:txBody>
+          <a:bodyPr rtlCol="0" anchor="ctr"/>
+          <a:lstStyle/>
+          <a:p>
+            <a:pPr algn="ctr"/>
+          </a:p>
+        </p:txBody>
+      </p:sp>
+      <p:sp>
+        <p:nvSpPr>
+          <p:cNvPr id="7" name="TextBox 6"/>
           <p:cNvSpPr txBox="1"/>
           <p:nvPr/>
         </p:nvSpPr>
@@ -3718,14 +3807,14 @@
           <a:p>
             <a:pPr algn="l">
               <a:lnSpc>
-                <a:spcPts val="2048"/>
+                <a:spcPts val="2176"/>
               </a:lnSpc>
               <a:spcAft>
                 <a:spcPts val="0"/>
               </a:spcAft>
             </a:pPr>
             <a:r>
-              <a:rPr sz="1600" b="1" i="0">
+              <a:rPr sz="1700" b="1" i="0">
                 <a:solidFill>
                   <a:srgbClr val="102D5E"/>
                 </a:solidFill>
@@ -3734,9 +3823,9 @@
               <a:t>Key message.  </a:t>
             </a:r>
             <a:r>
-              <a:rPr sz="1600" b="0" i="0">
-                <a:solidFill>
-                  <a:srgbClr val="212529"/>
+              <a:rPr sz="1700" b="0" i="0">
+                <a:solidFill>
+                  <a:srgbClr val="102D5E"/>
                 </a:solidFill>
                 <a:latin typeface="Garamond"/>
               </a:rPr>
@@ -3891,6 +3980,48 @@
           </a:p>
         </p:txBody>
       </p:sp>
+      <p:sp>
+        <p:nvSpPr>
+          <p:cNvPr id="5" name="TextBox 4"/>
+          <p:cNvSpPr txBox="1"/>
+          <p:nvPr/>
+        </p:nvSpPr>
+        <p:spPr>
+          <a:xfrm>
+            <a:off x="1371600" y="4892040"/>
+            <a:ext cx="9445752" cy="731520"/>
+          </a:xfrm>
+          <a:prstGeom prst="rect">
+            <a:avLst/>
+          </a:prstGeom>
+          <a:noFill/>
+        </p:spPr>
+        <p:txBody>
+          <a:bodyPr wrap="square" lIns="0" rIns="0" tIns="0" bIns="0">
+            <a:spAutoFit/>
+          </a:bodyPr>
+          <a:lstStyle/>
+          <a:p>
+            <a:pPr algn="ctr">
+              <a:lnSpc>
+                <a:spcPts val="2304"/>
+              </a:lnSpc>
+              <a:spcAft>
+                <a:spcPts val="0"/>
+              </a:spcAft>
+            </a:pPr>
+            <a:r>
+              <a:rPr sz="1800" b="0" i="1">
+                <a:solidFill>
+                  <a:srgbClr val="BED3EE"/>
+                </a:solidFill>
+                <a:latin typeface="Garamond"/>
+              </a:rPr>
+              <a:t>For discussion: which of these levers can your system move?</a:t>
+            </a:r>
+          </a:p>
+        </p:txBody>
+      </p:sp>
     </p:spTree>
   </p:cSld>
   <p:clrMapOvr>
@@ -3936,7 +4067,7 @@
                 </a:solidFill>
                 <a:latin typeface="Garamond"/>
               </a:rPr>
-              <a:t>Relative pay since 1997</a:t>
+              <a:t>Why do teachers leave?</a:t>
             </a:r>
           </a:p>
         </p:txBody>
@@ -3976,84 +4107,16 @@
           </a:p>
         </p:txBody>
       </p:sp>
-      <p:pic>
-        <p:nvPicPr>
-          <p:cNvPr id="4" name="Picture 3" descr="msgA3.png"/>
-          <p:cNvPicPr>
-            <a:picLocks noChangeAspect="1"/>
-          </p:cNvPicPr>
-          <p:nvPr/>
-        </p:nvPicPr>
-        <p:blipFill>
-          <a:blip r:embed="rId2"/>
-          <a:stretch>
-            <a:fillRect/>
-          </a:stretch>
-        </p:blipFill>
-        <p:spPr>
-          <a:xfrm>
-            <a:off x="702337" y="1097280"/>
-            <a:ext cx="10756845" cy="4434840"/>
-          </a:xfrm>
-          <a:prstGeom prst="rect">
-            <a:avLst/>
-          </a:prstGeom>
-        </p:spPr>
-      </p:pic>
-      <p:sp>
-        <p:nvSpPr>
-          <p:cNvPr id="5" name="Rectangle 4"/>
-          <p:cNvSpPr/>
-          <p:nvPr/>
-        </p:nvSpPr>
-        <p:spPr>
-          <a:xfrm>
-            <a:off x="0" y="5559552"/>
-            <a:ext cx="12191695" cy="960120"/>
-          </a:xfrm>
-          <a:prstGeom prst="rect">
-            <a:avLst/>
-          </a:prstGeom>
-          <a:solidFill>
-            <a:srgbClr val="ECF2F9"/>
-          </a:solidFill>
-          <a:ln>
-            <a:noFill/>
-          </a:ln>
-          <a:effectLst/>
-        </p:spPr>
-        <p:style>
-          <a:lnRef idx="1">
-            <a:schemeClr val="accent1"/>
-          </a:lnRef>
-          <a:fillRef idx="3">
-            <a:schemeClr val="accent1"/>
-          </a:fillRef>
-          <a:effectRef idx="2">
-            <a:schemeClr val="accent1"/>
-          </a:effectRef>
-          <a:fontRef idx="minor">
-            <a:schemeClr val="lt1"/>
-          </a:fontRef>
-        </p:style>
-        <p:txBody>
-          <a:bodyPr rtlCol="0" anchor="ctr"/>
-          <a:lstStyle/>
-          <a:p>
-            <a:pPr algn="ctr"/>
-          </a:p>
-        </p:txBody>
-      </p:sp>
-      <p:sp>
-        <p:nvSpPr>
-          <p:cNvPr id="6" name="TextBox 5"/>
+      <p:sp>
+        <p:nvSpPr>
+          <p:cNvPr id="4" name="TextBox 3"/>
           <p:cNvSpPr txBox="1"/>
           <p:nvPr/>
         </p:nvSpPr>
         <p:spPr>
           <a:xfrm>
-            <a:off x="822960" y="5687568"/>
-            <a:ext cx="10789920" cy="822960"/>
+            <a:off x="822960" y="1188720"/>
+            <a:ext cx="10789920" cy="457200"/>
           </a:xfrm>
           <a:prstGeom prst="rect">
             <a:avLst/>
@@ -4075,22 +4138,484 @@
               </a:spcAft>
             </a:pPr>
             <a:r>
-              <a:rPr sz="1600" b="1" i="0">
+              <a:rPr sz="1600" b="0" i="1">
+                <a:solidFill>
+                  <a:srgbClr val="6B7480"/>
+                </a:solidFill>
+                <a:latin typeface="Garamond"/>
+              </a:rPr>
+              <a:t>Reasons identified in the literature</a:t>
+            </a:r>
+          </a:p>
+        </p:txBody>
+      </p:sp>
+      <p:sp>
+        <p:nvSpPr>
+          <p:cNvPr id="5" name="Rectangle 4"/>
+          <p:cNvSpPr/>
+          <p:nvPr/>
+        </p:nvSpPr>
+        <p:spPr>
+          <a:xfrm>
+            <a:off x="822960" y="1783080"/>
+            <a:ext cx="5056632" cy="3063240"/>
+          </a:xfrm>
+          <a:prstGeom prst="rect">
+            <a:avLst/>
+          </a:prstGeom>
+          <a:solidFill>
+            <a:srgbClr val="F2F2F2"/>
+          </a:solidFill>
+          <a:ln>
+            <a:noFill/>
+          </a:ln>
+          <a:effectLst/>
+        </p:spPr>
+        <p:style>
+          <a:lnRef idx="1">
+            <a:schemeClr val="accent1"/>
+          </a:lnRef>
+          <a:fillRef idx="3">
+            <a:schemeClr val="accent1"/>
+          </a:fillRef>
+          <a:effectRef idx="2">
+            <a:schemeClr val="accent1"/>
+          </a:effectRef>
+          <a:fontRef idx="minor">
+            <a:schemeClr val="lt1"/>
+          </a:fontRef>
+        </p:style>
+        <p:txBody>
+          <a:bodyPr rtlCol="0" anchor="ctr"/>
+          <a:lstStyle/>
+          <a:p>
+            <a:pPr algn="ctr"/>
+          </a:p>
+        </p:txBody>
+      </p:sp>
+      <p:sp>
+        <p:nvSpPr>
+          <p:cNvPr id="6" name="TextBox 5"/>
+          <p:cNvSpPr txBox="1"/>
+          <p:nvPr/>
+        </p:nvSpPr>
+        <p:spPr>
+          <a:xfrm>
+            <a:off x="1143000" y="1965960"/>
+            <a:ext cx="4480560" cy="457200"/>
+          </a:xfrm>
+          <a:prstGeom prst="rect">
+            <a:avLst/>
+          </a:prstGeom>
+          <a:noFill/>
+        </p:spPr>
+        <p:txBody>
+          <a:bodyPr wrap="square" lIns="0" rIns="0" tIns="0" bIns="0">
+            <a:spAutoFit/>
+          </a:bodyPr>
+          <a:lstStyle/>
+          <a:p>
+            <a:pPr algn="l">
+              <a:lnSpc>
+                <a:spcPts val="2560"/>
+              </a:lnSpc>
+              <a:spcAft>
+                <a:spcPts val="0"/>
+              </a:spcAft>
+            </a:pPr>
+            <a:r>
+              <a:rPr sz="2000" b="1" i="0">
                 <a:solidFill>
                   <a:srgbClr val="102D5E"/>
                 </a:solidFill>
                 <a:latin typeface="Garamond"/>
               </a:rPr>
-              <a:t>Key message.  </a:t>
-            </a:r>
-            <a:r>
-              <a:rPr sz="1600" b="0" i="0">
+              <a:t>Beyond household data</a:t>
+            </a:r>
+          </a:p>
+        </p:txBody>
+      </p:sp>
+      <p:sp>
+        <p:nvSpPr>
+          <p:cNvPr id="7" name="TextBox 6"/>
+          <p:cNvSpPr txBox="1"/>
+          <p:nvPr/>
+        </p:nvSpPr>
+        <p:spPr>
+          <a:xfrm>
+            <a:off x="1143000" y="2606040"/>
+            <a:ext cx="4480560" cy="2103120"/>
+          </a:xfrm>
+          <a:prstGeom prst="rect">
+            <a:avLst/>
+          </a:prstGeom>
+          <a:noFill/>
+        </p:spPr>
+        <p:txBody>
+          <a:bodyPr wrap="square" lIns="0" rIns="0" tIns="0" bIns="0">
+            <a:spAutoFit/>
+          </a:bodyPr>
+          <a:lstStyle/>
+          <a:p>
+            <a:pPr algn="l">
+              <a:lnSpc>
+                <a:spcPts val="2816"/>
+              </a:lnSpc>
+              <a:spcAft>
+                <a:spcPts val="1400"/>
+              </a:spcAft>
+            </a:pPr>
+            <a:r>
+              <a:rPr sz="2200" b="0" i="0">
                 <a:solidFill>
                   <a:srgbClr val="212529"/>
                 </a:solidFill>
                 <a:latin typeface="Garamond"/>
               </a:rPr>
-              <a:t>Teacher pay has not grown in 25 years.</a:t>
+              <a:t>Working conditions</a:t>
+            </a:r>
+          </a:p>
+          <a:p>
+            <a:pPr algn="l">
+              <a:lnSpc>
+                <a:spcPts val="2816"/>
+              </a:lnSpc>
+              <a:spcAft>
+                <a:spcPts val="1400"/>
+              </a:spcAft>
+            </a:pPr>
+            <a:r>
+              <a:rPr sz="2200" b="0" i="0">
+                <a:solidFill>
+                  <a:srgbClr val="212529"/>
+                </a:solidFill>
+                <a:latin typeface="Garamond"/>
+              </a:rPr>
+              <a:t>Organizational support</a:t>
+            </a:r>
+          </a:p>
+          <a:p>
+            <a:pPr algn="l">
+              <a:lnSpc>
+                <a:spcPts val="2816"/>
+              </a:lnSpc>
+              <a:spcAft>
+                <a:spcPts val="1400"/>
+              </a:spcAft>
+            </a:pPr>
+            <a:r>
+              <a:rPr sz="2200" b="0" i="0">
+                <a:solidFill>
+                  <a:srgbClr val="212529"/>
+                </a:solidFill>
+                <a:latin typeface="Garamond"/>
+              </a:rPr>
+              <a:t>Autonomy and intrinsic motives</a:t>
+            </a:r>
+          </a:p>
+        </p:txBody>
+      </p:sp>
+      <p:sp>
+        <p:nvSpPr>
+          <p:cNvPr id="8" name="Rectangle 7"/>
+          <p:cNvSpPr/>
+          <p:nvPr/>
+        </p:nvSpPr>
+        <p:spPr>
+          <a:xfrm>
+            <a:off x="6309360" y="1783080"/>
+            <a:ext cx="5056632" cy="3063240"/>
+          </a:xfrm>
+          <a:prstGeom prst="rect">
+            <a:avLst/>
+          </a:prstGeom>
+          <a:solidFill>
+            <a:srgbClr val="102D5E"/>
+          </a:solidFill>
+          <a:ln>
+            <a:noFill/>
+          </a:ln>
+          <a:effectLst/>
+        </p:spPr>
+        <p:style>
+          <a:lnRef idx="1">
+            <a:schemeClr val="accent1"/>
+          </a:lnRef>
+          <a:fillRef idx="3">
+            <a:schemeClr val="accent1"/>
+          </a:fillRef>
+          <a:effectRef idx="2">
+            <a:schemeClr val="accent1"/>
+          </a:effectRef>
+          <a:fontRef idx="minor">
+            <a:schemeClr val="lt1"/>
+          </a:fontRef>
+        </p:style>
+        <p:txBody>
+          <a:bodyPr rtlCol="0" anchor="ctr"/>
+          <a:lstStyle/>
+          <a:p>
+            <a:pPr algn="ctr"/>
+          </a:p>
+        </p:txBody>
+      </p:sp>
+      <p:sp>
+        <p:nvSpPr>
+          <p:cNvPr id="9" name="TextBox 8"/>
+          <p:cNvSpPr txBox="1"/>
+          <p:nvPr/>
+        </p:nvSpPr>
+        <p:spPr>
+          <a:xfrm>
+            <a:off x="6629400" y="1965960"/>
+            <a:ext cx="4480560" cy="457200"/>
+          </a:xfrm>
+          <a:prstGeom prst="rect">
+            <a:avLst/>
+          </a:prstGeom>
+          <a:noFill/>
+        </p:spPr>
+        <p:txBody>
+          <a:bodyPr wrap="square" lIns="0" rIns="0" tIns="0" bIns="0">
+            <a:spAutoFit/>
+          </a:bodyPr>
+          <a:lstStyle/>
+          <a:p>
+            <a:pPr algn="l">
+              <a:lnSpc>
+                <a:spcPts val="2560"/>
+              </a:lnSpc>
+              <a:spcAft>
+                <a:spcPts val="0"/>
+              </a:spcAft>
+            </a:pPr>
+            <a:r>
+              <a:rPr sz="2000" b="1" i="0">
+                <a:solidFill>
+                  <a:srgbClr val="FFFFFF"/>
+                </a:solidFill>
+                <a:latin typeface="Garamond"/>
+              </a:rPr>
+              <a:t>What we explore</a:t>
+            </a:r>
+          </a:p>
+        </p:txBody>
+      </p:sp>
+      <p:sp>
+        <p:nvSpPr>
+          <p:cNvPr id="10" name="TextBox 9"/>
+          <p:cNvSpPr txBox="1"/>
+          <p:nvPr/>
+        </p:nvSpPr>
+        <p:spPr>
+          <a:xfrm>
+            <a:off x="6629400" y="2606040"/>
+            <a:ext cx="4480560" cy="2103120"/>
+          </a:xfrm>
+          <a:prstGeom prst="rect">
+            <a:avLst/>
+          </a:prstGeom>
+          <a:noFill/>
+        </p:spPr>
+        <p:txBody>
+          <a:bodyPr wrap="square" lIns="0" rIns="0" tIns="0" bIns="0">
+            <a:spAutoFit/>
+          </a:bodyPr>
+          <a:lstStyle/>
+          <a:p>
+            <a:pPr algn="l">
+              <a:lnSpc>
+                <a:spcPts val="2816"/>
+              </a:lnSpc>
+              <a:spcAft>
+                <a:spcPts val="1400"/>
+              </a:spcAft>
+            </a:pPr>
+            <a:r>
+              <a:rPr sz="2200" b="0" i="0">
+                <a:solidFill>
+                  <a:srgbClr val="FFFFFF"/>
+                </a:solidFill>
+                <a:latin typeface="Garamond"/>
+              </a:rPr>
+              <a:t>Financial factors</a:t>
+            </a:r>
+          </a:p>
+          <a:p>
+            <a:pPr algn="l">
+              <a:lnSpc>
+                <a:spcPts val="2816"/>
+              </a:lnSpc>
+              <a:spcAft>
+                <a:spcPts val="1400"/>
+              </a:spcAft>
+            </a:pPr>
+            <a:r>
+              <a:rPr sz="2200" b="0" i="0">
+                <a:solidFill>
+                  <a:srgbClr val="FFFFFF"/>
+                </a:solidFill>
+                <a:latin typeface="Garamond"/>
+              </a:rPr>
+              <a:t>Personal life-cycle motives</a:t>
+            </a:r>
+          </a:p>
+          <a:p>
+            <a:pPr algn="l">
+              <a:lnSpc>
+                <a:spcPts val="2816"/>
+              </a:lnSpc>
+              <a:spcAft>
+                <a:spcPts val="1400"/>
+              </a:spcAft>
+            </a:pPr>
+            <a:r>
+              <a:rPr sz="2200" b="0" i="0">
+                <a:solidFill>
+                  <a:srgbClr val="FFFFFF"/>
+                </a:solidFill>
+                <a:latin typeface="Garamond"/>
+              </a:rPr>
+              <a:t>Sociodemographics</a:t>
+            </a:r>
+          </a:p>
+        </p:txBody>
+      </p:sp>
+      <p:sp>
+        <p:nvSpPr>
+          <p:cNvPr id="11" name="Rectangle 10"/>
+          <p:cNvSpPr/>
+          <p:nvPr/>
+        </p:nvSpPr>
+        <p:spPr>
+          <a:xfrm>
+            <a:off x="0" y="5312664"/>
+            <a:ext cx="12191695" cy="960120"/>
+          </a:xfrm>
+          <a:prstGeom prst="rect">
+            <a:avLst/>
+          </a:prstGeom>
+          <a:solidFill>
+            <a:srgbClr val="ECF2F9"/>
+          </a:solidFill>
+          <a:ln>
+            <a:noFill/>
+          </a:ln>
+          <a:effectLst/>
+        </p:spPr>
+        <p:style>
+          <a:lnRef idx="1">
+            <a:schemeClr val="accent1"/>
+          </a:lnRef>
+          <a:fillRef idx="3">
+            <a:schemeClr val="accent1"/>
+          </a:fillRef>
+          <a:effectRef idx="2">
+            <a:schemeClr val="accent1"/>
+          </a:effectRef>
+          <a:fontRef idx="minor">
+            <a:schemeClr val="lt1"/>
+          </a:fontRef>
+        </p:style>
+        <p:txBody>
+          <a:bodyPr rtlCol="0" anchor="ctr"/>
+          <a:lstStyle/>
+          <a:p>
+            <a:pPr algn="ctr"/>
+          </a:p>
+        </p:txBody>
+      </p:sp>
+      <p:sp>
+        <p:nvSpPr>
+          <p:cNvPr id="12" name="Rectangle 11"/>
+          <p:cNvSpPr/>
+          <p:nvPr/>
+        </p:nvSpPr>
+        <p:spPr>
+          <a:xfrm>
+            <a:off x="502920" y="5422392"/>
+            <a:ext cx="73152" cy="713232"/>
+          </a:xfrm>
+          <a:prstGeom prst="rect">
+            <a:avLst/>
+          </a:prstGeom>
+          <a:solidFill>
+            <a:srgbClr val="102D5E"/>
+          </a:solidFill>
+          <a:ln>
+            <a:noFill/>
+          </a:ln>
+          <a:effectLst/>
+        </p:spPr>
+        <p:style>
+          <a:lnRef idx="1">
+            <a:schemeClr val="accent1"/>
+          </a:lnRef>
+          <a:fillRef idx="3">
+            <a:schemeClr val="accent1"/>
+          </a:fillRef>
+          <a:effectRef idx="2">
+            <a:schemeClr val="accent1"/>
+          </a:effectRef>
+          <a:fontRef idx="minor">
+            <a:schemeClr val="lt1"/>
+          </a:fontRef>
+        </p:style>
+        <p:txBody>
+          <a:bodyPr rtlCol="0" anchor="ctr"/>
+          <a:lstStyle/>
+          <a:p>
+            <a:pPr algn="ctr"/>
+          </a:p>
+        </p:txBody>
+      </p:sp>
+      <p:sp>
+        <p:nvSpPr>
+          <p:cNvPr id="13" name="TextBox 12"/>
+          <p:cNvSpPr txBox="1"/>
+          <p:nvPr/>
+        </p:nvSpPr>
+        <p:spPr>
+          <a:xfrm>
+            <a:off x="822960" y="5440680"/>
+            <a:ext cx="10789920" cy="822960"/>
+          </a:xfrm>
+          <a:prstGeom prst="rect">
+            <a:avLst/>
+          </a:prstGeom>
+          <a:noFill/>
+        </p:spPr>
+        <p:txBody>
+          <a:bodyPr wrap="square" lIns="0" rIns="0" tIns="0" bIns="0">
+            <a:spAutoFit/>
+          </a:bodyPr>
+          <a:lstStyle/>
+          <a:p>
+            <a:pPr algn="l">
+              <a:lnSpc>
+                <a:spcPts val="2176"/>
+              </a:lnSpc>
+              <a:spcAft>
+                <a:spcPts val="0"/>
+              </a:spcAft>
+            </a:pPr>
+            <a:r>
+              <a:rPr sz="1700" b="1" i="0">
+                <a:solidFill>
+                  <a:srgbClr val="102D5E"/>
+                </a:solidFill>
+                <a:latin typeface="Garamond"/>
+              </a:rPr>
+              <a:t>For discussion.  </a:t>
+            </a:r>
+            <a:r>
+              <a:rPr sz="1700" b="0" i="0">
+                <a:solidFill>
+                  <a:srgbClr val="102D5E"/>
+                </a:solidFill>
+                <a:latin typeface="Garamond"/>
+              </a:rPr>
+              <a:t>Are there more? Which ones matter most in your country?</a:t>
             </a:r>
           </a:p>
         </p:txBody>
@@ -4140,7 +4665,7 @@
                 </a:solidFill>
                 <a:latin typeface="Garamond"/>
               </a:rPr>
-              <a:t>Leaving, by position in the teacher pay distribution</a:t>
+              <a:t>Relative pay since 1997</a:t>
             </a:r>
           </a:p>
         </p:txBody>
@@ -4182,7 +4707,7 @@
       </p:sp>
       <p:pic>
         <p:nvPicPr>
-          <p:cNvPr id="4" name="Picture 3" descr="pay3_deciles_deck.png"/>
+          <p:cNvPr id="4" name="Picture 3" descr="msgA3.png"/>
           <p:cNvPicPr>
             <a:picLocks noChangeAspect="1"/>
           </p:cNvPicPr>
@@ -4196,8 +4721,8 @@
         </p:blipFill>
         <p:spPr>
           <a:xfrm>
-            <a:off x="1645920" y="1097280"/>
-            <a:ext cx="8869680" cy="4434840"/>
+            <a:off x="702337" y="1097280"/>
+            <a:ext cx="10756845" cy="4434840"/>
           </a:xfrm>
           <a:prstGeom prst="rect">
             <a:avLst/>
@@ -4250,7 +4775,51 @@
       </p:sp>
       <p:sp>
         <p:nvSpPr>
-          <p:cNvPr id="6" name="TextBox 5"/>
+          <p:cNvPr id="6" name="Rectangle 5"/>
+          <p:cNvSpPr/>
+          <p:nvPr/>
+        </p:nvSpPr>
+        <p:spPr>
+          <a:xfrm>
+            <a:off x="502920" y="5669280"/>
+            <a:ext cx="73152" cy="713232"/>
+          </a:xfrm>
+          <a:prstGeom prst="rect">
+            <a:avLst/>
+          </a:prstGeom>
+          <a:solidFill>
+            <a:srgbClr val="102D5E"/>
+          </a:solidFill>
+          <a:ln>
+            <a:noFill/>
+          </a:ln>
+          <a:effectLst/>
+        </p:spPr>
+        <p:style>
+          <a:lnRef idx="1">
+            <a:schemeClr val="accent1"/>
+          </a:lnRef>
+          <a:fillRef idx="3">
+            <a:schemeClr val="accent1"/>
+          </a:fillRef>
+          <a:effectRef idx="2">
+            <a:schemeClr val="accent1"/>
+          </a:effectRef>
+          <a:fontRef idx="minor">
+            <a:schemeClr val="lt1"/>
+          </a:fontRef>
+        </p:style>
+        <p:txBody>
+          <a:bodyPr rtlCol="0" anchor="ctr"/>
+          <a:lstStyle/>
+          <a:p>
+            <a:pPr algn="ctr"/>
+          </a:p>
+        </p:txBody>
+      </p:sp>
+      <p:sp>
+        <p:nvSpPr>
+          <p:cNvPr id="7" name="TextBox 6"/>
           <p:cNvSpPr txBox="1"/>
           <p:nvPr/>
         </p:nvSpPr>
@@ -4272,14 +4841,14 @@
           <a:p>
             <a:pPr algn="l">
               <a:lnSpc>
-                <a:spcPts val="2048"/>
+                <a:spcPts val="2176"/>
               </a:lnSpc>
               <a:spcAft>
                 <a:spcPts val="0"/>
               </a:spcAft>
             </a:pPr>
             <a:r>
-              <a:rPr sz="1600" b="1" i="0">
+              <a:rPr sz="1700" b="1" i="0">
                 <a:solidFill>
                   <a:srgbClr val="102D5E"/>
                 </a:solidFill>
@@ -4288,13 +4857,13 @@
               <a:t>Key message.  </a:t>
             </a:r>
             <a:r>
-              <a:rPr sz="1600" b="0" i="0">
-                <a:solidFill>
-                  <a:srgbClr val="212529"/>
-                </a:solidFill>
-                <a:latin typeface="Garamond"/>
-              </a:rPr>
-              <a:t>Leavers are concentrated in the bottom two deciles.</a:t>
+              <a:rPr sz="1700" b="0" i="0">
+                <a:solidFill>
+                  <a:srgbClr val="102D5E"/>
+                </a:solidFill>
+                <a:latin typeface="Garamond"/>
+              </a:rPr>
+              <a:t>Teacher pay has not grown in 25 years.</a:t>
             </a:r>
           </a:p>
         </p:txBody>
@@ -4344,7 +4913,7 @@
                 </a:solidFill>
                 <a:latin typeface="Garamond"/>
               </a:rPr>
-              <a:t>Pension coverage and leaving, across states</a:t>
+              <a:t>Leaving, by position in the teacher pay distribution</a:t>
             </a:r>
           </a:p>
         </p:txBody>
@@ -4386,7 +4955,7 @@
       </p:sp>
       <p:pic>
         <p:nvPicPr>
-          <p:cNvPr id="4" name="Picture 3" descr="pension_scatter_deck.png"/>
+          <p:cNvPr id="4" name="Picture 3" descr="pay3_deciles_deck.png"/>
           <p:cNvPicPr>
             <a:picLocks noChangeAspect="1"/>
           </p:cNvPicPr>
@@ -4400,8 +4969,8 @@
         </p:blipFill>
         <p:spPr>
           <a:xfrm>
-            <a:off x="2289687" y="1097280"/>
-            <a:ext cx="7582145" cy="4434840"/>
+            <a:off x="1645920" y="1097280"/>
+            <a:ext cx="8869680" cy="4434840"/>
           </a:xfrm>
           <a:prstGeom prst="rect">
             <a:avLst/>
@@ -4454,7 +5023,51 @@
       </p:sp>
       <p:sp>
         <p:nvSpPr>
-          <p:cNvPr id="6" name="TextBox 5"/>
+          <p:cNvPr id="6" name="Rectangle 5"/>
+          <p:cNvSpPr/>
+          <p:nvPr/>
+        </p:nvSpPr>
+        <p:spPr>
+          <a:xfrm>
+            <a:off x="502920" y="5669280"/>
+            <a:ext cx="73152" cy="713232"/>
+          </a:xfrm>
+          <a:prstGeom prst="rect">
+            <a:avLst/>
+          </a:prstGeom>
+          <a:solidFill>
+            <a:srgbClr val="102D5E"/>
+          </a:solidFill>
+          <a:ln>
+            <a:noFill/>
+          </a:ln>
+          <a:effectLst/>
+        </p:spPr>
+        <p:style>
+          <a:lnRef idx="1">
+            <a:schemeClr val="accent1"/>
+          </a:lnRef>
+          <a:fillRef idx="3">
+            <a:schemeClr val="accent1"/>
+          </a:fillRef>
+          <a:effectRef idx="2">
+            <a:schemeClr val="accent1"/>
+          </a:effectRef>
+          <a:fontRef idx="minor">
+            <a:schemeClr val="lt1"/>
+          </a:fontRef>
+        </p:style>
+        <p:txBody>
+          <a:bodyPr rtlCol="0" anchor="ctr"/>
+          <a:lstStyle/>
+          <a:p>
+            <a:pPr algn="ctr"/>
+          </a:p>
+        </p:txBody>
+      </p:sp>
+      <p:sp>
+        <p:nvSpPr>
+          <p:cNvPr id="7" name="TextBox 6"/>
           <p:cNvSpPr txBox="1"/>
           <p:nvPr/>
         </p:nvSpPr>
@@ -4476,14 +5089,14 @@
           <a:p>
             <a:pPr algn="l">
               <a:lnSpc>
-                <a:spcPts val="2048"/>
+                <a:spcPts val="2176"/>
               </a:lnSpc>
               <a:spcAft>
                 <a:spcPts val="0"/>
               </a:spcAft>
             </a:pPr>
             <a:r>
-              <a:rPr sz="1600" b="1" i="0">
+              <a:rPr sz="1700" b="1" i="0">
                 <a:solidFill>
                   <a:srgbClr val="102D5E"/>
                 </a:solidFill>
@@ -4492,13 +5105,13 @@
               <a:t>Key message.  </a:t>
             </a:r>
             <a:r>
-              <a:rPr sz="1600" b="0" i="0">
-                <a:solidFill>
-                  <a:srgbClr val="212529"/>
-                </a:solidFill>
-                <a:latin typeface="Garamond"/>
-              </a:rPr>
-              <a:t>States where more teachers have a pension plan have fewer early exits.</a:t>
+              <a:rPr sz="1700" b="0" i="0">
+                <a:solidFill>
+                  <a:srgbClr val="102D5E"/>
+                </a:solidFill>
+                <a:latin typeface="Garamond"/>
+              </a:rPr>
+              <a:t>Leavers are concentrated in the bottom two deciles.</a:t>
             </a:r>
           </a:p>
         </p:txBody>
@@ -4523,14 +5136,149 @@
       <p:grpSpPr/>
       <p:sp>
         <p:nvSpPr>
-          <p:cNvPr id="2" name="Rectangle 1"/>
+          <p:cNvPr id="2" name="TextBox 1"/>
+          <p:cNvSpPr txBox="1"/>
+          <p:nvPr/>
+        </p:nvSpPr>
+        <p:spPr>
+          <a:xfrm>
+            <a:off x="502920" y="219456"/>
+            <a:ext cx="11247120" cy="566928"/>
+          </a:xfrm>
+          <a:prstGeom prst="rect">
+            <a:avLst/>
+          </a:prstGeom>
+          <a:noFill/>
+        </p:spPr>
+        <p:txBody>
+          <a:bodyPr wrap="square" lIns="0" rIns="0" tIns="0" bIns="0"/>
+          <a:lstStyle/>
+          <a:p>
+            <a:r>
+              <a:rPr sz="2800" b="1">
+                <a:solidFill>
+                  <a:srgbClr val="102D5E"/>
+                </a:solidFill>
+                <a:latin typeface="Garamond"/>
+              </a:rPr>
+              <a:t>Pension coverage and leaving, across states</a:t>
+            </a:r>
+          </a:p>
+        </p:txBody>
+      </p:sp>
+      <p:sp>
+        <p:nvSpPr>
+          <p:cNvPr id="3" name="TextBox 2"/>
+          <p:cNvSpPr txBox="1"/>
+          <p:nvPr/>
+        </p:nvSpPr>
+        <p:spPr>
+          <a:xfrm>
+            <a:off x="11384280" y="6446520"/>
+            <a:ext cx="640080" cy="292608"/>
+          </a:xfrm>
+          <a:prstGeom prst="rect">
+            <a:avLst/>
+          </a:prstGeom>
+          <a:noFill/>
+        </p:spPr>
+        <p:txBody>
+          <a:bodyPr wrap="none" lIns="0" rIns="0" tIns="0" bIns="0">
+            <a:spAutoFit/>
+          </a:bodyPr>
+          <a:lstStyle/>
+          <a:p>
+            <a:pPr algn="r"/>
+            <a:r>
+              <a:rPr sz="1100">
+                <a:solidFill>
+                  <a:srgbClr val="6B7480"/>
+                </a:solidFill>
+                <a:latin typeface="Garamond"/>
+              </a:rPr>
+              <a:t>16</a:t>
+            </a:r>
+          </a:p>
+        </p:txBody>
+      </p:sp>
+      <p:pic>
+        <p:nvPicPr>
+          <p:cNvPr id="4" name="Picture 3" descr="pension_scatter_deck.png"/>
+          <p:cNvPicPr>
+            <a:picLocks noChangeAspect="1"/>
+          </p:cNvPicPr>
+          <p:nvPr/>
+        </p:nvPicPr>
+        <p:blipFill>
+          <a:blip r:embed="rId2"/>
+          <a:stretch>
+            <a:fillRect/>
+          </a:stretch>
+        </p:blipFill>
+        <p:spPr>
+          <a:xfrm>
+            <a:off x="2289687" y="1097280"/>
+            <a:ext cx="7582145" cy="4434840"/>
+          </a:xfrm>
+          <a:prstGeom prst="rect">
+            <a:avLst/>
+          </a:prstGeom>
+        </p:spPr>
+      </p:pic>
+      <p:sp>
+        <p:nvSpPr>
+          <p:cNvPr id="5" name="Rectangle 4"/>
           <p:cNvSpPr/>
           <p:nvPr/>
         </p:nvSpPr>
         <p:spPr>
           <a:xfrm>
-            <a:off x="0" y="0"/>
-            <a:ext cx="12191695" cy="6858000"/>
+            <a:off x="0" y="5559552"/>
+            <a:ext cx="12191695" cy="960120"/>
+          </a:xfrm>
+          <a:prstGeom prst="rect">
+            <a:avLst/>
+          </a:prstGeom>
+          <a:solidFill>
+            <a:srgbClr val="ECF2F9"/>
+          </a:solidFill>
+          <a:ln>
+            <a:noFill/>
+          </a:ln>
+          <a:effectLst/>
+        </p:spPr>
+        <p:style>
+          <a:lnRef idx="1">
+            <a:schemeClr val="accent1"/>
+          </a:lnRef>
+          <a:fillRef idx="3">
+            <a:schemeClr val="accent1"/>
+          </a:fillRef>
+          <a:effectRef idx="2">
+            <a:schemeClr val="accent1"/>
+          </a:effectRef>
+          <a:fontRef idx="minor">
+            <a:schemeClr val="lt1"/>
+          </a:fontRef>
+        </p:style>
+        <p:txBody>
+          <a:bodyPr rtlCol="0" anchor="ctr"/>
+          <a:lstStyle/>
+          <a:p>
+            <a:pPr algn="ctr"/>
+          </a:p>
+        </p:txBody>
+      </p:sp>
+      <p:sp>
+        <p:nvSpPr>
+          <p:cNvPr id="6" name="Rectangle 5"/>
+          <p:cNvSpPr/>
+          <p:nvPr/>
+        </p:nvSpPr>
+        <p:spPr>
+          <a:xfrm>
+            <a:off x="502920" y="5669280"/>
+            <a:ext cx="73152" cy="713232"/>
           </a:xfrm>
           <a:prstGeom prst="rect">
             <a:avLst/>
@@ -4567,14 +5315,14 @@
       </p:sp>
       <p:sp>
         <p:nvSpPr>
-          <p:cNvPr id="3" name="TextBox 2"/>
+          <p:cNvPr id="7" name="TextBox 6"/>
           <p:cNvSpPr txBox="1"/>
           <p:nvPr/>
         </p:nvSpPr>
         <p:spPr>
           <a:xfrm>
-            <a:off x="914400" y="2240280"/>
-            <a:ext cx="10360152" cy="1188720"/>
+            <a:off x="822960" y="5687568"/>
+            <a:ext cx="10789920" cy="822960"/>
           </a:xfrm>
           <a:prstGeom prst="rect">
             <a:avLst/>
@@ -4587,64 +5335,31 @@
           </a:bodyPr>
           <a:lstStyle/>
           <a:p>
-            <a:pPr algn="ctr">
+            <a:pPr algn="l">
               <a:lnSpc>
-                <a:spcPts val="7680"/>
+                <a:spcPts val="2176"/>
               </a:lnSpc>
               <a:spcAft>
                 <a:spcPts val="0"/>
               </a:spcAft>
             </a:pPr>
             <a:r>
-              <a:rPr sz="6000" b="1" i="0">
-                <a:solidFill>
-                  <a:srgbClr val="FFFFFF"/>
-                </a:solidFill>
-                <a:latin typeface="Garamond"/>
-              </a:rPr>
-              <a:t>4</a:t>
-            </a:r>
-          </a:p>
-        </p:txBody>
-      </p:sp>
-      <p:sp>
-        <p:nvSpPr>
-          <p:cNvPr id="4" name="TextBox 3"/>
-          <p:cNvSpPr txBox="1"/>
-          <p:nvPr/>
-        </p:nvSpPr>
-        <p:spPr>
-          <a:xfrm>
-            <a:off x="914400" y="3703320"/>
-            <a:ext cx="10360152" cy="731520"/>
-          </a:xfrm>
-          <a:prstGeom prst="rect">
-            <a:avLst/>
-          </a:prstGeom>
-          <a:noFill/>
-        </p:spPr>
-        <p:txBody>
-          <a:bodyPr wrap="square" lIns="0" rIns="0" tIns="0" bIns="0">
-            <a:spAutoFit/>
-          </a:bodyPr>
-          <a:lstStyle/>
-          <a:p>
-            <a:pPr algn="ctr">
-              <a:lnSpc>
-                <a:spcPts val="3584"/>
-              </a:lnSpc>
-              <a:spcAft>
-                <a:spcPts val="0"/>
-              </a:spcAft>
-            </a:pPr>
-            <a:r>
-              <a:rPr sz="2800" b="0" i="0">
-                <a:solidFill>
-                  <a:srgbClr val="D7E3F2"/>
-                </a:solidFill>
-                <a:latin typeface="Garamond"/>
-              </a:rPr>
-              <a:t>What it means for policy</a:t>
+              <a:rPr sz="1700" b="1" i="0">
+                <a:solidFill>
+                  <a:srgbClr val="102D5E"/>
+                </a:solidFill>
+                <a:latin typeface="Garamond"/>
+              </a:rPr>
+              <a:t>Key message.  </a:t>
+            </a:r>
+            <a:r>
+              <a:rPr sz="1700" b="0" i="0">
+                <a:solidFill>
+                  <a:srgbClr val="102D5E"/>
+                </a:solidFill>
+                <a:latin typeface="Garamond"/>
+              </a:rPr>
+              <a:t>States where more teachers have a pension plan have fewer early exits.</a:t>
             </a:r>
           </a:p>
         </p:txBody>
@@ -4669,33 +5384,45 @@
       <p:grpSpPr/>
       <p:sp>
         <p:nvSpPr>
-          <p:cNvPr id="2" name="TextBox 1"/>
-          <p:cNvSpPr txBox="1"/>
-          <p:nvPr/>
-        </p:nvSpPr>
-        <p:spPr>
-          <a:xfrm>
-            <a:off x="502920" y="219456"/>
-            <a:ext cx="11247120" cy="566928"/>
-          </a:xfrm>
-          <a:prstGeom prst="rect">
-            <a:avLst/>
-          </a:prstGeom>
-          <a:noFill/>
-        </p:spPr>
-        <p:txBody>
-          <a:bodyPr wrap="square" lIns="0" rIns="0" tIns="0" bIns="0"/>
-          <a:lstStyle/>
-          <a:p>
-            <a:r>
-              <a:rPr sz="2800" b="1">
-                <a:solidFill>
-                  <a:srgbClr val="102D5E"/>
-                </a:solidFill>
-                <a:latin typeface="Garamond"/>
-              </a:rPr>
-              <a:t>Policy options for re-attraction</a:t>
-            </a:r>
+          <p:cNvPr id="2" name="Rectangle 1"/>
+          <p:cNvSpPr/>
+          <p:nvPr/>
+        </p:nvSpPr>
+        <p:spPr>
+          <a:xfrm>
+            <a:off x="0" y="0"/>
+            <a:ext cx="12191695" cy="6858000"/>
+          </a:xfrm>
+          <a:prstGeom prst="rect">
+            <a:avLst/>
+          </a:prstGeom>
+          <a:solidFill>
+            <a:srgbClr val="102D5E"/>
+          </a:solidFill>
+          <a:ln>
+            <a:noFill/>
+          </a:ln>
+          <a:effectLst/>
+        </p:spPr>
+        <p:style>
+          <a:lnRef idx="1">
+            <a:schemeClr val="accent1"/>
+          </a:lnRef>
+          <a:fillRef idx="3">
+            <a:schemeClr val="accent1"/>
+          </a:fillRef>
+          <a:effectRef idx="2">
+            <a:schemeClr val="accent1"/>
+          </a:effectRef>
+          <a:fontRef idx="minor">
+            <a:schemeClr val="lt1"/>
+          </a:fontRef>
+        </p:style>
+        <p:txBody>
+          <a:bodyPr rtlCol="0" anchor="ctr"/>
+          <a:lstStyle/>
+          <a:p>
+            <a:pPr algn="ctr"/>
           </a:p>
         </p:txBody>
       </p:sp>
@@ -4707,43 +5434,8 @@
         </p:nvSpPr>
         <p:spPr>
           <a:xfrm>
-            <a:off x="11384280" y="6446520"/>
-            <a:ext cx="640080" cy="292608"/>
-          </a:xfrm>
-          <a:prstGeom prst="rect">
-            <a:avLst/>
-          </a:prstGeom>
-          <a:noFill/>
-        </p:spPr>
-        <p:txBody>
-          <a:bodyPr wrap="none" lIns="0" rIns="0" tIns="0" bIns="0">
-            <a:spAutoFit/>
-          </a:bodyPr>
-          <a:lstStyle/>
-          <a:p>
-            <a:pPr algn="r"/>
-            <a:r>
-              <a:rPr sz="1100">
-                <a:solidFill>
-                  <a:srgbClr val="6B7480"/>
-                </a:solidFill>
-                <a:latin typeface="Garamond"/>
-              </a:rPr>
-              <a:t>17</a:t>
-            </a:r>
-          </a:p>
-        </p:txBody>
-      </p:sp>
-      <p:sp>
-        <p:nvSpPr>
-          <p:cNvPr id="4" name="TextBox 3"/>
-          <p:cNvSpPr txBox="1"/>
-          <p:nvPr/>
-        </p:nvSpPr>
-        <p:spPr>
-          <a:xfrm>
-            <a:off x="822960" y="1325880"/>
-            <a:ext cx="5120640" cy="457200"/>
+            <a:off x="914400" y="2240280"/>
+            <a:ext cx="10360152" cy="1188720"/>
           </a:xfrm>
           <a:prstGeom prst="rect">
             <a:avLst/>
@@ -4756,36 +5448,36 @@
           </a:bodyPr>
           <a:lstStyle/>
           <a:p>
-            <a:pPr algn="l">
+            <a:pPr algn="ctr">
               <a:lnSpc>
-                <a:spcPts val="2688"/>
+                <a:spcPts val="7680"/>
               </a:lnSpc>
               <a:spcAft>
                 <a:spcPts val="0"/>
               </a:spcAft>
             </a:pPr>
             <a:r>
-              <a:rPr sz="2100" b="1" i="0">
-                <a:solidFill>
-                  <a:srgbClr val="2D6CB5"/>
-                </a:solidFill>
-                <a:latin typeface="Garamond"/>
-              </a:rPr>
-              <a:t>Short term and retirees</a:t>
-            </a:r>
-          </a:p>
-        </p:txBody>
-      </p:sp>
-      <p:sp>
-        <p:nvSpPr>
-          <p:cNvPr id="5" name="TextBox 4"/>
+              <a:rPr sz="6000" b="1" i="0">
+                <a:solidFill>
+                  <a:srgbClr val="FFFFFF"/>
+                </a:solidFill>
+                <a:latin typeface="Garamond"/>
+              </a:rPr>
+              <a:t>4</a:t>
+            </a:r>
+          </a:p>
+        </p:txBody>
+      </p:sp>
+      <p:sp>
+        <p:nvSpPr>
+          <p:cNvPr id="4" name="TextBox 3"/>
           <p:cNvSpPr txBox="1"/>
           <p:nvPr/>
         </p:nvSpPr>
         <p:spPr>
           <a:xfrm>
-            <a:off x="822960" y="1828800"/>
-            <a:ext cx="5120640" cy="1554480"/>
+            <a:off x="914400" y="3703320"/>
+            <a:ext cx="10360152" cy="731520"/>
           </a:xfrm>
           <a:prstGeom prst="rect">
             <a:avLst/>
@@ -4798,36 +5490,36 @@
           </a:bodyPr>
           <a:lstStyle/>
           <a:p>
-            <a:pPr algn="l">
+            <a:pPr algn="ctr">
               <a:lnSpc>
-                <a:spcPts val="2176"/>
+                <a:spcPts val="3584"/>
               </a:lnSpc>
               <a:spcAft>
                 <a:spcPts val="0"/>
               </a:spcAft>
             </a:pPr>
             <a:r>
-              <a:rPr sz="1700" b="0" i="0">
-                <a:solidFill>
-                  <a:srgbClr val="212529"/>
-                </a:solidFill>
-                <a:latin typeface="Garamond"/>
-              </a:rPr>
-              <a:t>A reserve for local shortages. They bring experience and can mentor new teachers. Make it easy to return, for example part-time or “double-dipping”.</a:t>
-            </a:r>
-          </a:p>
-        </p:txBody>
-      </p:sp>
-      <p:sp>
-        <p:nvSpPr>
-          <p:cNvPr id="6" name="TextBox 5"/>
+              <a:rPr sz="2800" b="0" i="0">
+                <a:solidFill>
+                  <a:srgbClr val="D7E3F2"/>
+                </a:solidFill>
+                <a:latin typeface="Garamond"/>
+              </a:rPr>
+              <a:t>What it means for policy</a:t>
+            </a:r>
+          </a:p>
+        </p:txBody>
+      </p:sp>
+      <p:sp>
+        <p:nvSpPr>
+          <p:cNvPr id="5" name="TextBox 4"/>
           <p:cNvSpPr txBox="1"/>
           <p:nvPr/>
         </p:nvSpPr>
         <p:spPr>
           <a:xfrm>
-            <a:off x="6355080" y="1325880"/>
-            <a:ext cx="5120640" cy="457200"/>
+            <a:off x="1371600" y="4892040"/>
+            <a:ext cx="9445752" cy="731520"/>
           </a:xfrm>
           <a:prstGeom prst="rect">
             <a:avLst/>
@@ -4840,309 +5532,22 @@
           </a:bodyPr>
           <a:lstStyle/>
           <a:p>
-            <a:pPr algn="l">
+            <a:pPr algn="ctr">
               <a:lnSpc>
-                <a:spcPts val="2688"/>
+                <a:spcPts val="2304"/>
               </a:lnSpc>
               <a:spcAft>
                 <a:spcPts val="0"/>
               </a:spcAft>
             </a:pPr>
             <a:r>
-              <a:rPr sz="2100" b="1" i="0">
-                <a:solidFill>
-                  <a:srgbClr val="2D6CB5"/>
-                </a:solidFill>
-                <a:latin typeface="Garamond"/>
-              </a:rPr>
-              <a:t>Medium term and switchers</a:t>
-            </a:r>
-          </a:p>
-        </p:txBody>
-      </p:sp>
-      <p:sp>
-        <p:nvSpPr>
-          <p:cNvPr id="7" name="TextBox 6"/>
-          <p:cNvSpPr txBox="1"/>
-          <p:nvPr/>
-        </p:nvSpPr>
-        <p:spPr>
-          <a:xfrm>
-            <a:off x="6355080" y="1828800"/>
-            <a:ext cx="5120640" cy="1554480"/>
-          </a:xfrm>
-          <a:prstGeom prst="rect">
-            <a:avLst/>
-          </a:prstGeom>
-          <a:noFill/>
-        </p:spPr>
-        <p:txBody>
-          <a:bodyPr wrap="square" lIns="0" rIns="0" tIns="0" bIns="0">
-            <a:spAutoFit/>
-          </a:bodyPr>
-          <a:lstStyle/>
-          <a:p>
-            <a:pPr algn="l">
-              <a:lnSpc>
-                <a:spcPts val="2176"/>
-              </a:lnSpc>
-              <a:spcAft>
-                <a:spcPts val="0"/>
-              </a:spcAft>
-            </a:pPr>
-            <a:r>
-              <a:rPr sz="1700" b="0" i="0">
-                <a:solidFill>
-                  <a:srgbClr val="212529"/>
-                </a:solidFill>
-                <a:latin typeface="Garamond"/>
-              </a:rPr>
-              <a:t>Early-career conditions (secure contracts, fair pay at the bottom) and support (mentoring). Learn why some move to jobs that do not require a degree.</a:t>
-            </a:r>
-          </a:p>
-        </p:txBody>
-      </p:sp>
-      <p:sp>
-        <p:nvSpPr>
-          <p:cNvPr id="8" name="TextBox 7"/>
-          <p:cNvSpPr txBox="1"/>
-          <p:nvPr/>
-        </p:nvSpPr>
-        <p:spPr>
-          <a:xfrm>
-            <a:off x="822960" y="3566160"/>
-            <a:ext cx="5120640" cy="457200"/>
-          </a:xfrm>
-          <a:prstGeom prst="rect">
-            <a:avLst/>
-          </a:prstGeom>
-          <a:noFill/>
-        </p:spPr>
-        <p:txBody>
-          <a:bodyPr wrap="square" lIns="0" rIns="0" tIns="0" bIns="0">
-            <a:spAutoFit/>
-          </a:bodyPr>
-          <a:lstStyle/>
-          <a:p>
-            <a:pPr algn="l">
-              <a:lnSpc>
-                <a:spcPts val="2688"/>
-              </a:lnSpc>
-              <a:spcAft>
-                <a:spcPts val="0"/>
-              </a:spcAft>
-            </a:pPr>
-            <a:r>
-              <a:rPr sz="2100" b="1" i="0">
-                <a:solidFill>
-                  <a:srgbClr val="2D6CB5"/>
-                </a:solidFill>
-                <a:latin typeface="Garamond"/>
-              </a:rPr>
-              <a:t>Long term and early exits</a:t>
-            </a:r>
-          </a:p>
-        </p:txBody>
-      </p:sp>
-      <p:sp>
-        <p:nvSpPr>
-          <p:cNvPr id="9" name="TextBox 8"/>
-          <p:cNvSpPr txBox="1"/>
-          <p:nvPr/>
-        </p:nvSpPr>
-        <p:spPr>
-          <a:xfrm>
-            <a:off x="822960" y="4069080"/>
-            <a:ext cx="5120640" cy="1554480"/>
-          </a:xfrm>
-          <a:prstGeom prst="rect">
-            <a:avLst/>
-          </a:prstGeom>
-          <a:noFill/>
-        </p:spPr>
-        <p:txBody>
-          <a:bodyPr wrap="square" lIns="0" rIns="0" tIns="0" bIns="0">
-            <a:spAutoFit/>
-          </a:bodyPr>
-          <a:lstStyle/>
-          <a:p>
-            <a:pPr algn="l">
-              <a:lnSpc>
-                <a:spcPts val="2176"/>
-              </a:lnSpc>
-              <a:spcAft>
-                <a:spcPts val="0"/>
-              </a:spcAft>
-            </a:pPr>
-            <a:r>
-              <a:rPr sz="1700" b="0" i="0">
-                <a:solidFill>
-                  <a:srgbClr val="212529"/>
-                </a:solidFill>
-                <a:latin typeface="Garamond"/>
-              </a:rPr>
-              <a:t>Flexibility, so those who want to return can do so in favoring conditions, and clear paths to return.</a:t>
-            </a:r>
-          </a:p>
-        </p:txBody>
-      </p:sp>
-      <p:sp>
-        <p:nvSpPr>
-          <p:cNvPr id="10" name="TextBox 9"/>
-          <p:cNvSpPr txBox="1"/>
-          <p:nvPr/>
-        </p:nvSpPr>
-        <p:spPr>
-          <a:xfrm>
-            <a:off x="6355080" y="3566160"/>
-            <a:ext cx="5120640" cy="457200"/>
-          </a:xfrm>
-          <a:prstGeom prst="rect">
-            <a:avLst/>
-          </a:prstGeom>
-          <a:noFill/>
-        </p:spPr>
-        <p:txBody>
-          <a:bodyPr wrap="square" lIns="0" rIns="0" tIns="0" bIns="0">
-            <a:spAutoFit/>
-          </a:bodyPr>
-          <a:lstStyle/>
-          <a:p>
-            <a:pPr algn="l">
-              <a:lnSpc>
-                <a:spcPts val="2688"/>
-              </a:lnSpc>
-              <a:spcAft>
-                <a:spcPts val="0"/>
-              </a:spcAft>
-            </a:pPr>
-            <a:r>
-              <a:rPr sz="2100" b="1" i="0">
-                <a:solidFill>
-                  <a:srgbClr val="2D6CB5"/>
-                </a:solidFill>
-                <a:latin typeface="Garamond"/>
-              </a:rPr>
-              <a:t>Research agenda</a:t>
-            </a:r>
-          </a:p>
-        </p:txBody>
-      </p:sp>
-      <p:sp>
-        <p:nvSpPr>
-          <p:cNvPr id="11" name="TextBox 10"/>
-          <p:cNvSpPr txBox="1"/>
-          <p:nvPr/>
-        </p:nvSpPr>
-        <p:spPr>
-          <a:xfrm>
-            <a:off x="6355080" y="4069080"/>
-            <a:ext cx="5120640" cy="1554480"/>
-          </a:xfrm>
-          <a:prstGeom prst="rect">
-            <a:avLst/>
-          </a:prstGeom>
-          <a:noFill/>
-        </p:spPr>
-        <p:txBody>
-          <a:bodyPr wrap="square" lIns="0" rIns="0" tIns="0" bIns="0">
-            <a:spAutoFit/>
-          </a:bodyPr>
-          <a:lstStyle/>
-          <a:p>
-            <a:pPr algn="l">
-              <a:lnSpc>
-                <a:spcPts val="2176"/>
-              </a:lnSpc>
-              <a:spcAft>
-                <a:spcPts val="0"/>
-              </a:spcAft>
-            </a:pPr>
-            <a:r>
-              <a:rPr sz="1700" b="0" i="0">
-                <a:solidFill>
-                  <a:srgbClr val="212529"/>
-                </a:solidFill>
-                <a:latin typeface="Garamond"/>
-              </a:rPr>
-              <a:t>Working conditions inside schools. Do these patterns hold in other countries?</a:t>
-            </a:r>
-          </a:p>
-        </p:txBody>
-      </p:sp>
-      <p:cxnSp>
-        <p:nvCxnSpPr>
-          <p:cNvPr id="12" name="Connector 11"/>
-          <p:cNvCxnSpPr/>
-          <p:nvPr/>
-        </p:nvCxnSpPr>
-        <p:spPr>
-          <a:xfrm>
-            <a:off x="822960" y="5806440"/>
-            <a:ext cx="10543032" cy="0"/>
-          </a:xfrm>
-          <a:prstGeom prst="line">
-            <a:avLst/>
-          </a:prstGeom>
-          <a:ln w="12700">
-            <a:solidFill>
-              <a:srgbClr val="102D5E"/>
-            </a:solidFill>
-          </a:ln>
-        </p:spPr>
-        <p:style>
-          <a:lnRef idx="2">
-            <a:schemeClr val="accent1"/>
-          </a:lnRef>
-          <a:fillRef idx="0">
-            <a:schemeClr val="accent1"/>
-          </a:fillRef>
-          <a:effectRef idx="1">
-            <a:schemeClr val="accent1"/>
-          </a:effectRef>
-          <a:fontRef idx="minor">
-            <a:schemeClr val="tx1"/>
-          </a:fontRef>
-        </p:style>
-      </p:cxnSp>
-      <p:sp>
-        <p:nvSpPr>
-          <p:cNvPr id="13" name="TextBox 12"/>
-          <p:cNvSpPr txBox="1"/>
-          <p:nvPr/>
-        </p:nvSpPr>
-        <p:spPr>
-          <a:xfrm>
-            <a:off x="822960" y="5989320"/>
-            <a:ext cx="10789920" cy="457200"/>
-          </a:xfrm>
-          <a:prstGeom prst="rect">
-            <a:avLst/>
-          </a:prstGeom>
-          <a:noFill/>
-        </p:spPr>
-        <p:txBody>
-          <a:bodyPr wrap="square" lIns="0" rIns="0" tIns="0" bIns="0">
-            <a:spAutoFit/>
-          </a:bodyPr>
-          <a:lstStyle/>
-          <a:p>
-            <a:pPr algn="ctr">
-              <a:lnSpc>
-                <a:spcPts val="2560"/>
-              </a:lnSpc>
-              <a:spcAft>
-                <a:spcPts val="0"/>
-              </a:spcAft>
-            </a:pPr>
-            <a:r>
-              <a:rPr sz="2000" b="1" i="0">
-                <a:solidFill>
-                  <a:srgbClr val="102D5E"/>
-                </a:solidFill>
-                <a:latin typeface="Garamond"/>
-              </a:rPr>
-              <a:t>Across all three: economic security.</a:t>
+              <a:rPr sz="1800" b="0" i="1">
+                <a:solidFill>
+                  <a:srgbClr val="BED3EE"/>
+                </a:solidFill>
+                <a:latin typeface="Garamond"/>
+              </a:rPr>
+              <a:t>For discussion: what would bring teachers back in your country?</a:t>
             </a:r>
           </a:p>
         </p:txBody>
@@ -5192,7 +5597,7 @@
                 </a:solidFill>
                 <a:latin typeface="Garamond"/>
               </a:rPr>
-              <a:t>Open questions</a:t>
+              <a:t>Policy options for re-attraction</a:t>
             </a:r>
           </a:p>
         </p:txBody>
@@ -5228,6 +5633,504 @@
                 <a:latin typeface="Garamond"/>
               </a:rPr>
               <a:t>18</a:t>
+            </a:r>
+          </a:p>
+        </p:txBody>
+      </p:sp>
+      <p:sp>
+        <p:nvSpPr>
+          <p:cNvPr id="4" name="TextBox 3"/>
+          <p:cNvSpPr txBox="1"/>
+          <p:nvPr/>
+        </p:nvSpPr>
+        <p:spPr>
+          <a:xfrm>
+            <a:off x="822960" y="1325880"/>
+            <a:ext cx="5120640" cy="457200"/>
+          </a:xfrm>
+          <a:prstGeom prst="rect">
+            <a:avLst/>
+          </a:prstGeom>
+          <a:noFill/>
+        </p:spPr>
+        <p:txBody>
+          <a:bodyPr wrap="square" lIns="0" rIns="0" tIns="0" bIns="0">
+            <a:spAutoFit/>
+          </a:bodyPr>
+          <a:lstStyle/>
+          <a:p>
+            <a:pPr algn="l">
+              <a:lnSpc>
+                <a:spcPts val="2688"/>
+              </a:lnSpc>
+              <a:spcAft>
+                <a:spcPts val="0"/>
+              </a:spcAft>
+            </a:pPr>
+            <a:r>
+              <a:rPr sz="2100" b="1" i="0">
+                <a:solidFill>
+                  <a:srgbClr val="2D6CB5"/>
+                </a:solidFill>
+                <a:latin typeface="Garamond"/>
+              </a:rPr>
+              <a:t>Short term and retirees</a:t>
+            </a:r>
+          </a:p>
+        </p:txBody>
+      </p:sp>
+      <p:sp>
+        <p:nvSpPr>
+          <p:cNvPr id="5" name="TextBox 4"/>
+          <p:cNvSpPr txBox="1"/>
+          <p:nvPr/>
+        </p:nvSpPr>
+        <p:spPr>
+          <a:xfrm>
+            <a:off x="822960" y="1828800"/>
+            <a:ext cx="5120640" cy="1554480"/>
+          </a:xfrm>
+          <a:prstGeom prst="rect">
+            <a:avLst/>
+          </a:prstGeom>
+          <a:noFill/>
+        </p:spPr>
+        <p:txBody>
+          <a:bodyPr wrap="square" lIns="0" rIns="0" tIns="0" bIns="0">
+            <a:spAutoFit/>
+          </a:bodyPr>
+          <a:lstStyle/>
+          <a:p>
+            <a:pPr algn="l">
+              <a:lnSpc>
+                <a:spcPts val="2176"/>
+              </a:lnSpc>
+              <a:spcAft>
+                <a:spcPts val="0"/>
+              </a:spcAft>
+            </a:pPr>
+            <a:r>
+              <a:rPr sz="1700" b="0" i="0">
+                <a:solidFill>
+                  <a:srgbClr val="212529"/>
+                </a:solidFill>
+                <a:latin typeface="Garamond"/>
+              </a:rPr>
+              <a:t>A reserve for local shortages. They bring experience and can mentor new teachers. Make it easy to return, for example part-time or “double-dipping”.</a:t>
+            </a:r>
+          </a:p>
+        </p:txBody>
+      </p:sp>
+      <p:sp>
+        <p:nvSpPr>
+          <p:cNvPr id="6" name="TextBox 5"/>
+          <p:cNvSpPr txBox="1"/>
+          <p:nvPr/>
+        </p:nvSpPr>
+        <p:spPr>
+          <a:xfrm>
+            <a:off x="6355080" y="1325880"/>
+            <a:ext cx="5120640" cy="457200"/>
+          </a:xfrm>
+          <a:prstGeom prst="rect">
+            <a:avLst/>
+          </a:prstGeom>
+          <a:noFill/>
+        </p:spPr>
+        <p:txBody>
+          <a:bodyPr wrap="square" lIns="0" rIns="0" tIns="0" bIns="0">
+            <a:spAutoFit/>
+          </a:bodyPr>
+          <a:lstStyle/>
+          <a:p>
+            <a:pPr algn="l">
+              <a:lnSpc>
+                <a:spcPts val="2688"/>
+              </a:lnSpc>
+              <a:spcAft>
+                <a:spcPts val="0"/>
+              </a:spcAft>
+            </a:pPr>
+            <a:r>
+              <a:rPr sz="2100" b="1" i="0">
+                <a:solidFill>
+                  <a:srgbClr val="2D6CB5"/>
+                </a:solidFill>
+                <a:latin typeface="Garamond"/>
+              </a:rPr>
+              <a:t>Medium term and switchers</a:t>
+            </a:r>
+          </a:p>
+        </p:txBody>
+      </p:sp>
+      <p:sp>
+        <p:nvSpPr>
+          <p:cNvPr id="7" name="TextBox 6"/>
+          <p:cNvSpPr txBox="1"/>
+          <p:nvPr/>
+        </p:nvSpPr>
+        <p:spPr>
+          <a:xfrm>
+            <a:off x="6355080" y="1828800"/>
+            <a:ext cx="5120640" cy="1554480"/>
+          </a:xfrm>
+          <a:prstGeom prst="rect">
+            <a:avLst/>
+          </a:prstGeom>
+          <a:noFill/>
+        </p:spPr>
+        <p:txBody>
+          <a:bodyPr wrap="square" lIns="0" rIns="0" tIns="0" bIns="0">
+            <a:spAutoFit/>
+          </a:bodyPr>
+          <a:lstStyle/>
+          <a:p>
+            <a:pPr algn="l">
+              <a:lnSpc>
+                <a:spcPts val="2176"/>
+              </a:lnSpc>
+              <a:spcAft>
+                <a:spcPts val="0"/>
+              </a:spcAft>
+            </a:pPr>
+            <a:r>
+              <a:rPr sz="1700" b="0" i="0">
+                <a:solidFill>
+                  <a:srgbClr val="212529"/>
+                </a:solidFill>
+                <a:latin typeface="Garamond"/>
+              </a:rPr>
+              <a:t>Early-career conditions (secure contracts, fair pay at the bottom) and support (mentoring). Learn why some move to jobs that do not require a degree.</a:t>
+            </a:r>
+          </a:p>
+        </p:txBody>
+      </p:sp>
+      <p:sp>
+        <p:nvSpPr>
+          <p:cNvPr id="8" name="TextBox 7"/>
+          <p:cNvSpPr txBox="1"/>
+          <p:nvPr/>
+        </p:nvSpPr>
+        <p:spPr>
+          <a:xfrm>
+            <a:off x="822960" y="3566160"/>
+            <a:ext cx="5120640" cy="457200"/>
+          </a:xfrm>
+          <a:prstGeom prst="rect">
+            <a:avLst/>
+          </a:prstGeom>
+          <a:noFill/>
+        </p:spPr>
+        <p:txBody>
+          <a:bodyPr wrap="square" lIns="0" rIns="0" tIns="0" bIns="0">
+            <a:spAutoFit/>
+          </a:bodyPr>
+          <a:lstStyle/>
+          <a:p>
+            <a:pPr algn="l">
+              <a:lnSpc>
+                <a:spcPts val="2688"/>
+              </a:lnSpc>
+              <a:spcAft>
+                <a:spcPts val="0"/>
+              </a:spcAft>
+            </a:pPr>
+            <a:r>
+              <a:rPr sz="2100" b="1" i="0">
+                <a:solidFill>
+                  <a:srgbClr val="2D6CB5"/>
+                </a:solidFill>
+                <a:latin typeface="Garamond"/>
+              </a:rPr>
+              <a:t>Long term and early exits</a:t>
+            </a:r>
+          </a:p>
+        </p:txBody>
+      </p:sp>
+      <p:sp>
+        <p:nvSpPr>
+          <p:cNvPr id="9" name="TextBox 8"/>
+          <p:cNvSpPr txBox="1"/>
+          <p:nvPr/>
+        </p:nvSpPr>
+        <p:spPr>
+          <a:xfrm>
+            <a:off x="822960" y="4069080"/>
+            <a:ext cx="5120640" cy="1554480"/>
+          </a:xfrm>
+          <a:prstGeom prst="rect">
+            <a:avLst/>
+          </a:prstGeom>
+          <a:noFill/>
+        </p:spPr>
+        <p:txBody>
+          <a:bodyPr wrap="square" lIns="0" rIns="0" tIns="0" bIns="0">
+            <a:spAutoFit/>
+          </a:bodyPr>
+          <a:lstStyle/>
+          <a:p>
+            <a:pPr algn="l">
+              <a:lnSpc>
+                <a:spcPts val="2176"/>
+              </a:lnSpc>
+              <a:spcAft>
+                <a:spcPts val="0"/>
+              </a:spcAft>
+            </a:pPr>
+            <a:r>
+              <a:rPr sz="1700" b="0" i="0">
+                <a:solidFill>
+                  <a:srgbClr val="212529"/>
+                </a:solidFill>
+                <a:latin typeface="Garamond"/>
+              </a:rPr>
+              <a:t>Flexibility, so those who want to return can do so in favoring conditions, and clear paths to return.</a:t>
+            </a:r>
+          </a:p>
+        </p:txBody>
+      </p:sp>
+      <p:sp>
+        <p:nvSpPr>
+          <p:cNvPr id="10" name="TextBox 9"/>
+          <p:cNvSpPr txBox="1"/>
+          <p:nvPr/>
+        </p:nvSpPr>
+        <p:spPr>
+          <a:xfrm>
+            <a:off x="6355080" y="3566160"/>
+            <a:ext cx="5120640" cy="457200"/>
+          </a:xfrm>
+          <a:prstGeom prst="rect">
+            <a:avLst/>
+          </a:prstGeom>
+          <a:noFill/>
+        </p:spPr>
+        <p:txBody>
+          <a:bodyPr wrap="square" lIns="0" rIns="0" tIns="0" bIns="0">
+            <a:spAutoFit/>
+          </a:bodyPr>
+          <a:lstStyle/>
+          <a:p>
+            <a:pPr algn="l">
+              <a:lnSpc>
+                <a:spcPts val="2688"/>
+              </a:lnSpc>
+              <a:spcAft>
+                <a:spcPts val="0"/>
+              </a:spcAft>
+            </a:pPr>
+            <a:r>
+              <a:rPr sz="2100" b="1" i="0">
+                <a:solidFill>
+                  <a:srgbClr val="2D6CB5"/>
+                </a:solidFill>
+                <a:latin typeface="Garamond"/>
+              </a:rPr>
+              <a:t>Research agenda</a:t>
+            </a:r>
+          </a:p>
+        </p:txBody>
+      </p:sp>
+      <p:sp>
+        <p:nvSpPr>
+          <p:cNvPr id="11" name="TextBox 10"/>
+          <p:cNvSpPr txBox="1"/>
+          <p:nvPr/>
+        </p:nvSpPr>
+        <p:spPr>
+          <a:xfrm>
+            <a:off x="6355080" y="4069080"/>
+            <a:ext cx="5120640" cy="1554480"/>
+          </a:xfrm>
+          <a:prstGeom prst="rect">
+            <a:avLst/>
+          </a:prstGeom>
+          <a:noFill/>
+        </p:spPr>
+        <p:txBody>
+          <a:bodyPr wrap="square" lIns="0" rIns="0" tIns="0" bIns="0">
+            <a:spAutoFit/>
+          </a:bodyPr>
+          <a:lstStyle/>
+          <a:p>
+            <a:pPr algn="l">
+              <a:lnSpc>
+                <a:spcPts val="2176"/>
+              </a:lnSpc>
+              <a:spcAft>
+                <a:spcPts val="0"/>
+              </a:spcAft>
+            </a:pPr>
+            <a:r>
+              <a:rPr sz="1700" b="0" i="0">
+                <a:solidFill>
+                  <a:srgbClr val="212529"/>
+                </a:solidFill>
+                <a:latin typeface="Garamond"/>
+              </a:rPr>
+              <a:t>Working conditions inside schools. Do these patterns hold in other countries?</a:t>
+            </a:r>
+          </a:p>
+        </p:txBody>
+      </p:sp>
+      <p:cxnSp>
+        <p:nvCxnSpPr>
+          <p:cNvPr id="12" name="Connector 11"/>
+          <p:cNvCxnSpPr/>
+          <p:nvPr/>
+        </p:nvCxnSpPr>
+        <p:spPr>
+          <a:xfrm>
+            <a:off x="822960" y="5806440"/>
+            <a:ext cx="10543032" cy="0"/>
+          </a:xfrm>
+          <a:prstGeom prst="line">
+            <a:avLst/>
+          </a:prstGeom>
+          <a:ln w="12700">
+            <a:solidFill>
+              <a:srgbClr val="102D5E"/>
+            </a:solidFill>
+          </a:ln>
+        </p:spPr>
+        <p:style>
+          <a:lnRef idx="2">
+            <a:schemeClr val="accent1"/>
+          </a:lnRef>
+          <a:fillRef idx="0">
+            <a:schemeClr val="accent1"/>
+          </a:fillRef>
+          <a:effectRef idx="1">
+            <a:schemeClr val="accent1"/>
+          </a:effectRef>
+          <a:fontRef idx="minor">
+            <a:schemeClr val="tx1"/>
+          </a:fontRef>
+        </p:style>
+      </p:cxnSp>
+      <p:sp>
+        <p:nvSpPr>
+          <p:cNvPr id="13" name="TextBox 12"/>
+          <p:cNvSpPr txBox="1"/>
+          <p:nvPr/>
+        </p:nvSpPr>
+        <p:spPr>
+          <a:xfrm>
+            <a:off x="822960" y="5989320"/>
+            <a:ext cx="10789920" cy="457200"/>
+          </a:xfrm>
+          <a:prstGeom prst="rect">
+            <a:avLst/>
+          </a:prstGeom>
+          <a:noFill/>
+        </p:spPr>
+        <p:txBody>
+          <a:bodyPr wrap="square" lIns="0" rIns="0" tIns="0" bIns="0">
+            <a:spAutoFit/>
+          </a:bodyPr>
+          <a:lstStyle/>
+          <a:p>
+            <a:pPr algn="ctr">
+              <a:lnSpc>
+                <a:spcPts val="2560"/>
+              </a:lnSpc>
+              <a:spcAft>
+                <a:spcPts val="0"/>
+              </a:spcAft>
+            </a:pPr>
+            <a:r>
+              <a:rPr sz="2000" b="1" i="0">
+                <a:solidFill>
+                  <a:srgbClr val="102D5E"/>
+                </a:solidFill>
+                <a:latin typeface="Garamond"/>
+              </a:rPr>
+              <a:t>Across all three: economic security.</a:t>
+            </a:r>
+          </a:p>
+        </p:txBody>
+      </p:sp>
+    </p:spTree>
+  </p:cSld>
+  <p:clrMapOvr>
+    <a:masterClrMapping/>
+  </p:clrMapOvr>
+</p:sld>
+</file>
+
+<file path=ppt/slides/slide19.xml><?xml version="1.0" encoding="utf-8"?>
+<p:sld xmlns:a="http://schemas.openxmlformats.org/drawingml/2006/main" xmlns:p="http://schemas.openxmlformats.org/presentationml/2006/main" xmlns:r="http://schemas.openxmlformats.org/officeDocument/2006/relationships">
+  <p:cSld>
+    <p:spTree>
+      <p:nvGrpSpPr>
+        <p:cNvPr id="1" name=""/>
+        <p:cNvGrpSpPr/>
+        <p:nvPr/>
+      </p:nvGrpSpPr>
+      <p:grpSpPr/>
+      <p:sp>
+        <p:nvSpPr>
+          <p:cNvPr id="2" name="TextBox 1"/>
+          <p:cNvSpPr txBox="1"/>
+          <p:nvPr/>
+        </p:nvSpPr>
+        <p:spPr>
+          <a:xfrm>
+            <a:off x="502920" y="219456"/>
+            <a:ext cx="11247120" cy="566928"/>
+          </a:xfrm>
+          <a:prstGeom prst="rect">
+            <a:avLst/>
+          </a:prstGeom>
+          <a:noFill/>
+        </p:spPr>
+        <p:txBody>
+          <a:bodyPr wrap="square" lIns="0" rIns="0" tIns="0" bIns="0"/>
+          <a:lstStyle/>
+          <a:p>
+            <a:r>
+              <a:rPr sz="2800" b="1">
+                <a:solidFill>
+                  <a:srgbClr val="102D5E"/>
+                </a:solidFill>
+                <a:latin typeface="Garamond"/>
+              </a:rPr>
+              <a:t>Open questions</a:t>
+            </a:r>
+          </a:p>
+        </p:txBody>
+      </p:sp>
+      <p:sp>
+        <p:nvSpPr>
+          <p:cNvPr id="3" name="TextBox 2"/>
+          <p:cNvSpPr txBox="1"/>
+          <p:nvPr/>
+        </p:nvSpPr>
+        <p:spPr>
+          <a:xfrm>
+            <a:off x="11384280" y="6446520"/>
+            <a:ext cx="640080" cy="292608"/>
+          </a:xfrm>
+          <a:prstGeom prst="rect">
+            <a:avLst/>
+          </a:prstGeom>
+          <a:noFill/>
+        </p:spPr>
+        <p:txBody>
+          <a:bodyPr wrap="none" lIns="0" rIns="0" tIns="0" bIns="0">
+            <a:spAutoFit/>
+          </a:bodyPr>
+          <a:lstStyle/>
+          <a:p>
+            <a:pPr algn="r"/>
+            <a:r>
+              <a:rPr sz="1100">
+                <a:solidFill>
+                  <a:srgbClr val="6B7480"/>
+                </a:solidFill>
+                <a:latin typeface="Garamond"/>
+              </a:rPr>
+              <a:t>19</a:t>
             </a:r>
           </a:p>
         </p:txBody>
@@ -5852,49 +6755,73 @@
           </a:p>
         </p:txBody>
       </p:sp>
-      <p:sp>
-        <p:nvSpPr>
-          <p:cNvPr id="4" name="Rectangle 3"/>
-          <p:cNvSpPr/>
-          <p:nvPr/>
-        </p:nvSpPr>
-        <p:spPr>
-          <a:xfrm>
-            <a:off x="667512" y="1554480"/>
-            <a:ext cx="2670048" cy="2148840"/>
-          </a:xfrm>
-          <a:prstGeom prst="rect">
-            <a:avLst/>
-          </a:prstGeom>
-          <a:solidFill>
-            <a:srgbClr val="ECF2F9"/>
-          </a:solidFill>
-          <a:ln>
-            <a:noFill/>
+      <p:cxnSp>
+        <p:nvCxnSpPr>
+          <p:cNvPr id="4" name="Connector 3"/>
+          <p:cNvCxnSpPr/>
+          <p:nvPr/>
+        </p:nvCxnSpPr>
+        <p:spPr>
+          <a:xfrm>
+            <a:off x="822960" y="1600200"/>
+            <a:ext cx="10543032" cy="0"/>
+          </a:xfrm>
+          <a:prstGeom prst="line">
+            <a:avLst/>
+          </a:prstGeom>
+          <a:ln w="20320">
+            <a:solidFill>
+              <a:srgbClr val="212529"/>
+            </a:solidFill>
           </a:ln>
-          <a:effectLst/>
         </p:spPr>
         <p:style>
-          <a:lnRef idx="1">
+          <a:lnRef idx="2">
             <a:schemeClr val="accent1"/>
           </a:lnRef>
-          <a:fillRef idx="3">
+          <a:fillRef idx="0">
             <a:schemeClr val="accent1"/>
           </a:fillRef>
-          <a:effectRef idx="2">
+          <a:effectRef idx="1">
             <a:schemeClr val="accent1"/>
           </a:effectRef>
           <a:fontRef idx="minor">
-            <a:schemeClr val="lt1"/>
+            <a:schemeClr val="tx1"/>
           </a:fontRef>
         </p:style>
-        <p:txBody>
-          <a:bodyPr rtlCol="0" anchor="ctr" wrap="square" lIns="73152" rIns="73152" tIns="274320" bIns="0"/>
-          <a:lstStyle/>
-          <a:p>
-            <a:pPr algn="ctr"/>
-            <a:r>
-              <a:rPr sz="4400" b="1">
+      </p:cxnSp>
+      <p:sp>
+        <p:nvSpPr>
+          <p:cNvPr id="5" name="TextBox 4"/>
+          <p:cNvSpPr txBox="1"/>
+          <p:nvPr/>
+        </p:nvSpPr>
+        <p:spPr>
+          <a:xfrm>
+            <a:off x="822960" y="1984248"/>
+            <a:ext cx="2635758" cy="914400"/>
+          </a:xfrm>
+          <a:prstGeom prst="rect">
+            <a:avLst/>
+          </a:prstGeom>
+          <a:noFill/>
+        </p:spPr>
+        <p:txBody>
+          <a:bodyPr wrap="square" lIns="0" rIns="0" tIns="0" bIns="0">
+            <a:spAutoFit/>
+          </a:bodyPr>
+          <a:lstStyle/>
+          <a:p>
+            <a:pPr algn="ctr">
+              <a:lnSpc>
+                <a:spcPts val="3600"/>
+              </a:lnSpc>
+              <a:spcAft>
+                <a:spcPts val="0"/>
+              </a:spcAft>
+            </a:pPr>
+            <a:r>
+              <a:rPr sz="3600" b="1" i="0">
                 <a:solidFill>
                   <a:srgbClr val="102D5E"/>
                 </a:solidFill>
@@ -5903,474 +6830,445 @@
               <a:t>28</a:t>
             </a:r>
           </a:p>
+        </p:txBody>
+      </p:sp>
+      <p:sp>
+        <p:nvSpPr>
+          <p:cNvPr id="6" name="TextBox 5"/>
+          <p:cNvSpPr txBox="1"/>
+          <p:nvPr/>
+        </p:nvSpPr>
+        <p:spPr>
+          <a:xfrm>
+            <a:off x="960120" y="2971800"/>
+            <a:ext cx="2361438" cy="640080"/>
+          </a:xfrm>
+          <a:prstGeom prst="rect">
+            <a:avLst/>
+          </a:prstGeom>
+          <a:noFill/>
+        </p:spPr>
+        <p:txBody>
+          <a:bodyPr wrap="square" lIns="0" rIns="0" tIns="0" bIns="0">
+            <a:spAutoFit/>
+          </a:bodyPr>
+          <a:lstStyle/>
           <a:p>
             <a:pPr algn="ctr">
-              <a:spcBef>
-                <a:spcPts val="1000"/>
-              </a:spcBef>
+              <a:lnSpc>
+                <a:spcPts val="1725"/>
+              </a:lnSpc>
+              <a:spcAft>
+                <a:spcPts val="0"/>
+              </a:spcAft>
             </a:pPr>
             <a:r>
-              <a:rPr sz="1450">
-                <a:solidFill>
-                  <a:srgbClr val="212529"/>
-                </a:solidFill>
-                <a:latin typeface="Garamond"/>
-              </a:rPr>
-              <a:t>consecutive years</a:t>
-            </a:r>
-          </a:p>
+              <a:rPr sz="1500" b="0" i="1">
+                <a:solidFill>
+                  <a:srgbClr val="6B7480"/>
+                </a:solidFill>
+                <a:latin typeface="Garamond"/>
+              </a:rPr>
+              <a:t>Years (1998–2025)</a:t>
+            </a:r>
+          </a:p>
+        </p:txBody>
+      </p:sp>
+      <p:sp>
+        <p:nvSpPr>
+          <p:cNvPr id="7" name="TextBox 6"/>
+          <p:cNvSpPr txBox="1"/>
+          <p:nvPr/>
+        </p:nvSpPr>
+        <p:spPr>
+          <a:xfrm>
+            <a:off x="3458718" y="1984248"/>
+            <a:ext cx="2635758" cy="914400"/>
+          </a:xfrm>
+          <a:prstGeom prst="rect">
+            <a:avLst/>
+          </a:prstGeom>
+          <a:noFill/>
+        </p:spPr>
+        <p:txBody>
+          <a:bodyPr wrap="square" lIns="0" rIns="0" tIns="0" bIns="0">
+            <a:spAutoFit/>
+          </a:bodyPr>
+          <a:lstStyle/>
           <a:p>
             <a:pPr algn="ctr">
-              <a:spcBef>
+              <a:lnSpc>
+                <a:spcPts val="3600"/>
+              </a:lnSpc>
+              <a:spcAft>
                 <a:spcPts val="0"/>
-              </a:spcBef>
+              </a:spcAft>
             </a:pPr>
             <a:r>
-              <a:rPr sz="1450">
-                <a:solidFill>
-                  <a:srgbClr val="212529"/>
-                </a:solidFill>
-                <a:latin typeface="Garamond"/>
-              </a:rPr>
-              <a:t>(1998–2025)</a:t>
-            </a:r>
-          </a:p>
-        </p:txBody>
-      </p:sp>
-      <p:sp>
-        <p:nvSpPr>
-          <p:cNvPr id="5" name="Rectangle 4"/>
-          <p:cNvSpPr/>
-          <p:nvPr/>
-        </p:nvSpPr>
-        <p:spPr>
-          <a:xfrm>
-            <a:off x="667512" y="1554480"/>
-            <a:ext cx="2670048" cy="64008"/>
-          </a:xfrm>
-          <a:prstGeom prst="rect">
-            <a:avLst/>
-          </a:prstGeom>
-          <a:solidFill>
-            <a:srgbClr val="102D5E"/>
-          </a:solidFill>
-          <a:ln>
-            <a:noFill/>
+              <a:rPr sz="3600" b="1" i="0">
+                <a:solidFill>
+                  <a:srgbClr val="102D5E"/>
+                </a:solidFill>
+                <a:latin typeface="Garamond"/>
+              </a:rPr>
+              <a:t>5 million</a:t>
+            </a:r>
+          </a:p>
+        </p:txBody>
+      </p:sp>
+      <p:sp>
+        <p:nvSpPr>
+          <p:cNvPr id="8" name="TextBox 7"/>
+          <p:cNvSpPr txBox="1"/>
+          <p:nvPr/>
+        </p:nvSpPr>
+        <p:spPr>
+          <a:xfrm>
+            <a:off x="3595877" y="2971800"/>
+            <a:ext cx="2361438" cy="640080"/>
+          </a:xfrm>
+          <a:prstGeom prst="rect">
+            <a:avLst/>
+          </a:prstGeom>
+          <a:noFill/>
+        </p:spPr>
+        <p:txBody>
+          <a:bodyPr wrap="square" lIns="0" rIns="0" tIns="0" bIns="0">
+            <a:spAutoFit/>
+          </a:bodyPr>
+          <a:lstStyle/>
+          <a:p>
+            <a:pPr algn="ctr">
+              <a:lnSpc>
+                <a:spcPts val="1725"/>
+              </a:lnSpc>
+              <a:spcAft>
+                <a:spcPts val="0"/>
+              </a:spcAft>
+            </a:pPr>
+            <a:r>
+              <a:rPr sz="1500" b="0" i="1">
+                <a:solidFill>
+                  <a:srgbClr val="6B7480"/>
+                </a:solidFill>
+                <a:latin typeface="Garamond"/>
+              </a:rPr>
+              <a:t>Individual observations</a:t>
+            </a:r>
+          </a:p>
+        </p:txBody>
+      </p:sp>
+      <p:cxnSp>
+        <p:nvCxnSpPr>
+          <p:cNvPr id="9" name="Connector 8"/>
+          <p:cNvCxnSpPr/>
+          <p:nvPr/>
+        </p:nvCxnSpPr>
+        <p:spPr>
+          <a:xfrm>
+            <a:off x="3458718" y="1965960"/>
+            <a:ext cx="0" cy="1508760"/>
+          </a:xfrm>
+          <a:prstGeom prst="line">
+            <a:avLst/>
+          </a:prstGeom>
+          <a:ln w="9525">
+            <a:solidFill>
+              <a:srgbClr val="C9CFD6"/>
+            </a:solidFill>
           </a:ln>
-          <a:effectLst/>
         </p:spPr>
         <p:style>
-          <a:lnRef idx="1">
+          <a:lnRef idx="2">
             <a:schemeClr val="accent1"/>
           </a:lnRef>
-          <a:fillRef idx="3">
+          <a:fillRef idx="0">
             <a:schemeClr val="accent1"/>
           </a:fillRef>
-          <a:effectRef idx="2">
+          <a:effectRef idx="1">
             <a:schemeClr val="accent1"/>
           </a:effectRef>
           <a:fontRef idx="minor">
-            <a:schemeClr val="lt1"/>
+            <a:schemeClr val="tx1"/>
           </a:fontRef>
         </p:style>
-        <p:txBody>
-          <a:bodyPr rtlCol="0" anchor="ctr"/>
-          <a:lstStyle/>
-          <a:p>
-            <a:pPr algn="ctr"/>
-          </a:p>
-        </p:txBody>
-      </p:sp>
-      <p:sp>
-        <p:nvSpPr>
-          <p:cNvPr id="6" name="Rectangle 5"/>
-          <p:cNvSpPr/>
-          <p:nvPr/>
-        </p:nvSpPr>
-        <p:spPr>
-          <a:xfrm>
-            <a:off x="3465576" y="1554480"/>
-            <a:ext cx="2670048" cy="2148840"/>
-          </a:xfrm>
-          <a:prstGeom prst="rect">
-            <a:avLst/>
-          </a:prstGeom>
-          <a:solidFill>
-            <a:srgbClr val="ECF2F9"/>
-          </a:solidFill>
-          <a:ln>
-            <a:noFill/>
+      </p:cxnSp>
+      <p:sp>
+        <p:nvSpPr>
+          <p:cNvPr id="10" name="TextBox 9"/>
+          <p:cNvSpPr txBox="1"/>
+          <p:nvPr/>
+        </p:nvSpPr>
+        <p:spPr>
+          <a:xfrm>
+            <a:off x="6094476" y="1984248"/>
+            <a:ext cx="2635758" cy="914400"/>
+          </a:xfrm>
+          <a:prstGeom prst="rect">
+            <a:avLst/>
+          </a:prstGeom>
+          <a:noFill/>
+        </p:spPr>
+        <p:txBody>
+          <a:bodyPr wrap="square" lIns="0" rIns="0" tIns="0" bIns="0">
+            <a:spAutoFit/>
+          </a:bodyPr>
+          <a:lstStyle/>
+          <a:p>
+            <a:pPr algn="ctr">
+              <a:lnSpc>
+                <a:spcPts val="3600"/>
+              </a:lnSpc>
+              <a:spcAft>
+                <a:spcPts val="0"/>
+              </a:spcAft>
+            </a:pPr>
+            <a:r>
+              <a:rPr sz="3600" b="1" i="0">
+                <a:solidFill>
+                  <a:srgbClr val="102D5E"/>
+                </a:solidFill>
+                <a:latin typeface="Garamond"/>
+              </a:rPr>
+              <a:t>103,820</a:t>
+            </a:r>
+          </a:p>
+        </p:txBody>
+      </p:sp>
+      <p:sp>
+        <p:nvSpPr>
+          <p:cNvPr id="11" name="TextBox 10"/>
+          <p:cNvSpPr txBox="1"/>
+          <p:nvPr/>
+        </p:nvSpPr>
+        <p:spPr>
+          <a:xfrm>
+            <a:off x="6231636" y="2971800"/>
+            <a:ext cx="2361438" cy="640080"/>
+          </a:xfrm>
+          <a:prstGeom prst="rect">
+            <a:avLst/>
+          </a:prstGeom>
+          <a:noFill/>
+        </p:spPr>
+        <p:txBody>
+          <a:bodyPr wrap="square" lIns="0" rIns="0" tIns="0" bIns="0">
+            <a:spAutoFit/>
+          </a:bodyPr>
+          <a:lstStyle/>
+          <a:p>
+            <a:pPr algn="ctr">
+              <a:lnSpc>
+                <a:spcPts val="1725"/>
+              </a:lnSpc>
+              <a:spcAft>
+                <a:spcPts val="0"/>
+              </a:spcAft>
+            </a:pPr>
+            <a:r>
+              <a:rPr sz="1500" b="0" i="1">
+                <a:solidFill>
+                  <a:srgbClr val="6B7480"/>
+                </a:solidFill>
+                <a:latin typeface="Garamond"/>
+              </a:rPr>
+              <a:t>Teachers in our database</a:t>
+            </a:r>
+          </a:p>
+        </p:txBody>
+      </p:sp>
+      <p:cxnSp>
+        <p:nvCxnSpPr>
+          <p:cNvPr id="12" name="Connector 11"/>
+          <p:cNvCxnSpPr/>
+          <p:nvPr/>
+        </p:nvCxnSpPr>
+        <p:spPr>
+          <a:xfrm>
+            <a:off x="6094476" y="1965960"/>
+            <a:ext cx="0" cy="1508760"/>
+          </a:xfrm>
+          <a:prstGeom prst="line">
+            <a:avLst/>
+          </a:prstGeom>
+          <a:ln w="9525">
+            <a:solidFill>
+              <a:srgbClr val="C9CFD6"/>
+            </a:solidFill>
           </a:ln>
-          <a:effectLst/>
         </p:spPr>
         <p:style>
-          <a:lnRef idx="1">
+          <a:lnRef idx="2">
             <a:schemeClr val="accent1"/>
           </a:lnRef>
-          <a:fillRef idx="3">
+          <a:fillRef idx="0">
             <a:schemeClr val="accent1"/>
           </a:fillRef>
-          <a:effectRef idx="2">
+          <a:effectRef idx="1">
             <a:schemeClr val="accent1"/>
           </a:effectRef>
           <a:fontRef idx="minor">
-            <a:schemeClr val="lt1"/>
+            <a:schemeClr val="tx1"/>
           </a:fontRef>
         </p:style>
-        <p:txBody>
-          <a:bodyPr rtlCol="0" anchor="ctr" wrap="square" lIns="73152" rIns="73152" tIns="384048" bIns="0"/>
-          <a:lstStyle/>
-          <a:p>
-            <a:pPr algn="ctr"/>
-            <a:r>
-              <a:rPr sz="3000" b="1">
+      </p:cxnSp>
+      <p:sp>
+        <p:nvSpPr>
+          <p:cNvPr id="13" name="TextBox 12"/>
+          <p:cNvSpPr txBox="1"/>
+          <p:nvPr/>
+        </p:nvSpPr>
+        <p:spPr>
+          <a:xfrm>
+            <a:off x="8730234" y="1984248"/>
+            <a:ext cx="2635758" cy="914400"/>
+          </a:xfrm>
+          <a:prstGeom prst="rect">
+            <a:avLst/>
+          </a:prstGeom>
+          <a:noFill/>
+        </p:spPr>
+        <p:txBody>
+          <a:bodyPr wrap="square" lIns="0" rIns="0" tIns="0" bIns="0">
+            <a:spAutoFit/>
+          </a:bodyPr>
+          <a:lstStyle/>
+          <a:p>
+            <a:pPr algn="ctr">
+              <a:lnSpc>
+                <a:spcPts val="3600"/>
+              </a:lnSpc>
+              <a:spcAft>
+                <a:spcPts val="0"/>
+              </a:spcAft>
+            </a:pPr>
+            <a:r>
+              <a:rPr sz="3600" b="1" i="0">
                 <a:solidFill>
                   <a:srgbClr val="102D5E"/>
                 </a:solidFill>
                 <a:latin typeface="Garamond"/>
               </a:rPr>
-              <a:t>5 million</a:t>
-            </a:r>
-          </a:p>
+              <a:t>51</a:t>
+            </a:r>
+          </a:p>
+        </p:txBody>
+      </p:sp>
+      <p:sp>
+        <p:nvSpPr>
+          <p:cNvPr id="14" name="TextBox 13"/>
+          <p:cNvSpPr txBox="1"/>
+          <p:nvPr/>
+        </p:nvSpPr>
+        <p:spPr>
+          <a:xfrm>
+            <a:off x="8867394" y="2971800"/>
+            <a:ext cx="2361438" cy="640080"/>
+          </a:xfrm>
+          <a:prstGeom prst="rect">
+            <a:avLst/>
+          </a:prstGeom>
+          <a:noFill/>
+        </p:spPr>
+        <p:txBody>
+          <a:bodyPr wrap="square" lIns="0" rIns="0" tIns="0" bIns="0">
+            <a:spAutoFit/>
+          </a:bodyPr>
+          <a:lstStyle/>
           <a:p>
             <a:pPr algn="ctr">
-              <a:spcBef>
-                <a:spcPts val="1000"/>
-              </a:spcBef>
+              <a:lnSpc>
+                <a:spcPts val="1725"/>
+              </a:lnSpc>
+              <a:spcAft>
+                <a:spcPts val="0"/>
+              </a:spcAft>
             </a:pPr>
             <a:r>
-              <a:rPr sz="1450">
-                <a:solidFill>
-                  <a:srgbClr val="212529"/>
-                </a:solidFill>
-                <a:latin typeface="Garamond"/>
-              </a:rPr>
-              <a:t>people interviewed</a:t>
-            </a:r>
-          </a:p>
-          <a:p>
-            <a:pPr algn="ctr">
-              <a:spcBef>
-                <a:spcPts val="0"/>
-              </a:spcBef>
-            </a:pPr>
-            <a:r>
-              <a:rPr sz="1450">
-                <a:solidFill>
-                  <a:srgbClr val="212529"/>
-                </a:solidFill>
-                <a:latin typeface="Garamond"/>
-              </a:rPr>
-              <a:t>in the March surveys</a:t>
-            </a:r>
-          </a:p>
-        </p:txBody>
-      </p:sp>
-      <p:sp>
-        <p:nvSpPr>
-          <p:cNvPr id="7" name="Rectangle 6"/>
-          <p:cNvSpPr/>
-          <p:nvPr/>
-        </p:nvSpPr>
-        <p:spPr>
-          <a:xfrm>
-            <a:off x="3465576" y="1554480"/>
-            <a:ext cx="2670048" cy="64008"/>
-          </a:xfrm>
-          <a:prstGeom prst="rect">
-            <a:avLst/>
-          </a:prstGeom>
-          <a:solidFill>
-            <a:srgbClr val="102D5E"/>
-          </a:solidFill>
-          <a:ln>
-            <a:noFill/>
+              <a:rPr sz="1500" b="0" i="1">
+                <a:solidFill>
+                  <a:srgbClr val="6B7480"/>
+                </a:solidFill>
+                <a:latin typeface="Garamond"/>
+              </a:rPr>
+              <a:t>States, including the District of Columbia</a:t>
+            </a:r>
+          </a:p>
+        </p:txBody>
+      </p:sp>
+      <p:cxnSp>
+        <p:nvCxnSpPr>
+          <p:cNvPr id="15" name="Connector 14"/>
+          <p:cNvCxnSpPr/>
+          <p:nvPr/>
+        </p:nvCxnSpPr>
+        <p:spPr>
+          <a:xfrm>
+            <a:off x="8730234" y="1965960"/>
+            <a:ext cx="0" cy="1508760"/>
+          </a:xfrm>
+          <a:prstGeom prst="line">
+            <a:avLst/>
+          </a:prstGeom>
+          <a:ln w="9525">
+            <a:solidFill>
+              <a:srgbClr val="C9CFD6"/>
+            </a:solidFill>
           </a:ln>
-          <a:effectLst/>
         </p:spPr>
         <p:style>
-          <a:lnRef idx="1">
+          <a:lnRef idx="2">
             <a:schemeClr val="accent1"/>
           </a:lnRef>
-          <a:fillRef idx="3">
+          <a:fillRef idx="0">
             <a:schemeClr val="accent1"/>
           </a:fillRef>
-          <a:effectRef idx="2">
+          <a:effectRef idx="1">
             <a:schemeClr val="accent1"/>
           </a:effectRef>
           <a:fontRef idx="minor">
-            <a:schemeClr val="lt1"/>
+            <a:schemeClr val="tx1"/>
           </a:fontRef>
         </p:style>
-        <p:txBody>
-          <a:bodyPr rtlCol="0" anchor="ctr"/>
-          <a:lstStyle/>
-          <a:p>
-            <a:pPr algn="ctr"/>
-          </a:p>
-        </p:txBody>
-      </p:sp>
-      <p:sp>
-        <p:nvSpPr>
-          <p:cNvPr id="8" name="Rectangle 7"/>
-          <p:cNvSpPr/>
-          <p:nvPr/>
-        </p:nvSpPr>
-        <p:spPr>
-          <a:xfrm>
-            <a:off x="6263640" y="1554480"/>
-            <a:ext cx="2670048" cy="2148840"/>
-          </a:xfrm>
-          <a:prstGeom prst="rect">
-            <a:avLst/>
-          </a:prstGeom>
-          <a:solidFill>
-            <a:srgbClr val="ECF2F9"/>
-          </a:solidFill>
-          <a:ln>
-            <a:noFill/>
+      </p:cxnSp>
+      <p:cxnSp>
+        <p:nvCxnSpPr>
+          <p:cNvPr id="16" name="Connector 15"/>
+          <p:cNvCxnSpPr/>
+          <p:nvPr/>
+        </p:nvCxnSpPr>
+        <p:spPr>
+          <a:xfrm>
+            <a:off x="822960" y="3840480"/>
+            <a:ext cx="10543032" cy="0"/>
+          </a:xfrm>
+          <a:prstGeom prst="line">
+            <a:avLst/>
+          </a:prstGeom>
+          <a:ln w="7620">
+            <a:solidFill>
+              <a:srgbClr val="212529"/>
+            </a:solidFill>
           </a:ln>
-          <a:effectLst/>
         </p:spPr>
         <p:style>
-          <a:lnRef idx="1">
+          <a:lnRef idx="2">
             <a:schemeClr val="accent1"/>
           </a:lnRef>
-          <a:fillRef idx="3">
+          <a:fillRef idx="0">
             <a:schemeClr val="accent1"/>
           </a:fillRef>
-          <a:effectRef idx="2">
+          <a:effectRef idx="1">
             <a:schemeClr val="accent1"/>
           </a:effectRef>
           <a:fontRef idx="minor">
-            <a:schemeClr val="lt1"/>
+            <a:schemeClr val="tx1"/>
           </a:fontRef>
         </p:style>
-        <p:txBody>
-          <a:bodyPr rtlCol="0" anchor="ctr" wrap="square" lIns="73152" rIns="73152" tIns="384048" bIns="0"/>
-          <a:lstStyle/>
-          <a:p>
-            <a:pPr algn="ctr"/>
-            <a:r>
-              <a:rPr sz="3000" b="1">
-                <a:solidFill>
-                  <a:srgbClr val="102D5E"/>
-                </a:solidFill>
-                <a:latin typeface="Garamond"/>
-              </a:rPr>
-              <a:t>103,820</a:t>
-            </a:r>
-          </a:p>
-          <a:p>
-            <a:pPr algn="ctr">
-              <a:spcBef>
-                <a:spcPts val="1000"/>
-              </a:spcBef>
-            </a:pPr>
-            <a:r>
-              <a:rPr sz="1450">
-                <a:solidFill>
-                  <a:srgbClr val="212529"/>
-                </a:solidFill>
-                <a:latin typeface="Garamond"/>
-              </a:rPr>
-              <a:t>teachers observed</a:t>
-            </a:r>
-          </a:p>
-          <a:p>
-            <a:pPr algn="ctr">
-              <a:spcBef>
-                <a:spcPts val="0"/>
-              </a:spcBef>
-            </a:pPr>
-            <a:r>
-              <a:rPr sz="1450">
-                <a:solidFill>
-                  <a:srgbClr val="212529"/>
-                </a:solidFill>
-                <a:latin typeface="Garamond"/>
-              </a:rPr>
-              <a:t>over the period</a:t>
-            </a:r>
-          </a:p>
-        </p:txBody>
-      </p:sp>
-      <p:sp>
-        <p:nvSpPr>
-          <p:cNvPr id="9" name="Rectangle 8"/>
-          <p:cNvSpPr/>
-          <p:nvPr/>
-        </p:nvSpPr>
-        <p:spPr>
-          <a:xfrm>
-            <a:off x="6263640" y="1554480"/>
-            <a:ext cx="2670048" cy="64008"/>
-          </a:xfrm>
-          <a:prstGeom prst="rect">
-            <a:avLst/>
-          </a:prstGeom>
-          <a:solidFill>
-            <a:srgbClr val="102D5E"/>
-          </a:solidFill>
-          <a:ln>
-            <a:noFill/>
-          </a:ln>
-          <a:effectLst/>
-        </p:spPr>
-        <p:style>
-          <a:lnRef idx="1">
-            <a:schemeClr val="accent1"/>
-          </a:lnRef>
-          <a:fillRef idx="3">
-            <a:schemeClr val="accent1"/>
-          </a:fillRef>
-          <a:effectRef idx="2">
-            <a:schemeClr val="accent1"/>
-          </a:effectRef>
-          <a:fontRef idx="minor">
-            <a:schemeClr val="lt1"/>
-          </a:fontRef>
-        </p:style>
-        <p:txBody>
-          <a:bodyPr rtlCol="0" anchor="ctr"/>
-          <a:lstStyle/>
-          <a:p>
-            <a:pPr algn="ctr"/>
-          </a:p>
-        </p:txBody>
-      </p:sp>
-      <p:sp>
-        <p:nvSpPr>
-          <p:cNvPr id="10" name="Rectangle 9"/>
-          <p:cNvSpPr/>
-          <p:nvPr/>
-        </p:nvSpPr>
-        <p:spPr>
-          <a:xfrm>
-            <a:off x="9061704" y="1554480"/>
-            <a:ext cx="2670048" cy="2148840"/>
-          </a:xfrm>
-          <a:prstGeom prst="rect">
-            <a:avLst/>
-          </a:prstGeom>
-          <a:solidFill>
-            <a:srgbClr val="ECF2F9"/>
-          </a:solidFill>
-          <a:ln>
-            <a:noFill/>
-          </a:ln>
-          <a:effectLst/>
-        </p:spPr>
-        <p:style>
-          <a:lnRef idx="1">
-            <a:schemeClr val="accent1"/>
-          </a:lnRef>
-          <a:fillRef idx="3">
-            <a:schemeClr val="accent1"/>
-          </a:fillRef>
-          <a:effectRef idx="2">
-            <a:schemeClr val="accent1"/>
-          </a:effectRef>
-          <a:fontRef idx="minor">
-            <a:schemeClr val="lt1"/>
-          </a:fontRef>
-        </p:style>
-        <p:txBody>
-          <a:bodyPr rtlCol="0" anchor="ctr" wrap="square" lIns="73152" rIns="73152" tIns="274320" bIns="0"/>
-          <a:lstStyle/>
-          <a:p>
-            <a:pPr algn="ctr"/>
-            <a:r>
-              <a:rPr sz="4400" b="1">
-                <a:solidFill>
-                  <a:srgbClr val="102D5E"/>
-                </a:solidFill>
-                <a:latin typeface="Garamond"/>
-              </a:rPr>
-              <a:t>51</a:t>
-            </a:r>
-          </a:p>
-          <a:p>
-            <a:pPr algn="ctr">
-              <a:spcBef>
-                <a:spcPts val="1000"/>
-              </a:spcBef>
-            </a:pPr>
-            <a:r>
-              <a:rPr sz="1450">
-                <a:solidFill>
-                  <a:srgbClr val="212529"/>
-                </a:solidFill>
-                <a:latin typeface="Garamond"/>
-              </a:rPr>
-              <a:t>states, including the</a:t>
-            </a:r>
-          </a:p>
-          <a:p>
-            <a:pPr algn="ctr">
-              <a:spcBef>
-                <a:spcPts val="0"/>
-              </a:spcBef>
-            </a:pPr>
-            <a:r>
-              <a:rPr sz="1450">
-                <a:solidFill>
-                  <a:srgbClr val="212529"/>
-                </a:solidFill>
-                <a:latin typeface="Garamond"/>
-              </a:rPr>
-              <a:t>District of Columbia</a:t>
-            </a:r>
-          </a:p>
-        </p:txBody>
-      </p:sp>
-      <p:sp>
-        <p:nvSpPr>
-          <p:cNvPr id="11" name="Rectangle 10"/>
-          <p:cNvSpPr/>
-          <p:nvPr/>
-        </p:nvSpPr>
-        <p:spPr>
-          <a:xfrm>
-            <a:off x="9061704" y="1554480"/>
-            <a:ext cx="2670048" cy="64008"/>
-          </a:xfrm>
-          <a:prstGeom prst="rect">
-            <a:avLst/>
-          </a:prstGeom>
-          <a:solidFill>
-            <a:srgbClr val="102D5E"/>
-          </a:solidFill>
-          <a:ln>
-            <a:noFill/>
-          </a:ln>
-          <a:effectLst/>
-        </p:spPr>
-        <p:style>
-          <a:lnRef idx="1">
-            <a:schemeClr val="accent1"/>
-          </a:lnRef>
-          <a:fillRef idx="3">
-            <a:schemeClr val="accent1"/>
-          </a:fillRef>
-          <a:effectRef idx="2">
-            <a:schemeClr val="accent1"/>
-          </a:effectRef>
-          <a:fontRef idx="minor">
-            <a:schemeClr val="lt1"/>
-          </a:fontRef>
-        </p:style>
-        <p:txBody>
-          <a:bodyPr rtlCol="0" anchor="ctr"/>
-          <a:lstStyle/>
-          <a:p>
-            <a:pPr algn="ctr"/>
-          </a:p>
-        </p:txBody>
-      </p:sp>
-      <p:sp>
-        <p:nvSpPr>
-          <p:cNvPr id="12" name="TextBox 11"/>
+      </p:cxnSp>
+      <p:sp>
+        <p:nvSpPr>
+          <p:cNvPr id="17" name="TextBox 16"/>
           <p:cNvSpPr txBox="1"/>
           <p:nvPr/>
         </p:nvSpPr>
@@ -7637,6 +8535,48 @@
           </a:p>
         </p:txBody>
       </p:sp>
+      <p:sp>
+        <p:nvSpPr>
+          <p:cNvPr id="5" name="TextBox 4"/>
+          <p:cNvSpPr txBox="1"/>
+          <p:nvPr/>
+        </p:nvSpPr>
+        <p:spPr>
+          <a:xfrm>
+            <a:off x="1371600" y="4892040"/>
+            <a:ext cx="9445752" cy="731520"/>
+          </a:xfrm>
+          <a:prstGeom prst="rect">
+            <a:avLst/>
+          </a:prstGeom>
+          <a:noFill/>
+        </p:spPr>
+        <p:txBody>
+          <a:bodyPr wrap="square" lIns="0" rIns="0" tIns="0" bIns="0">
+            <a:spAutoFit/>
+          </a:bodyPr>
+          <a:lstStyle/>
+          <a:p>
+            <a:pPr algn="ctr">
+              <a:lnSpc>
+                <a:spcPts val="2304"/>
+              </a:lnSpc>
+              <a:spcAft>
+                <a:spcPts val="0"/>
+              </a:spcAft>
+            </a:pPr>
+            <a:r>
+              <a:rPr sz="1800" b="0" i="1">
+                <a:solidFill>
+                  <a:srgbClr val="BED3EE"/>
+                </a:solidFill>
+                <a:latin typeface="Garamond"/>
+              </a:rPr>
+              <a:t>For discussion: how often does your system measure who leaves?</a:t>
+            </a:r>
+          </a:p>
+        </p:txBody>
+      </p:sp>
     </p:spTree>
   </p:cSld>
   <p:clrMapOvr>
@@ -7792,7 +8732,51 @@
       </p:sp>
       <p:sp>
         <p:nvSpPr>
-          <p:cNvPr id="6" name="TextBox 5"/>
+          <p:cNvPr id="6" name="Rectangle 5"/>
+          <p:cNvSpPr/>
+          <p:nvPr/>
+        </p:nvSpPr>
+        <p:spPr>
+          <a:xfrm>
+            <a:off x="502920" y="5669280"/>
+            <a:ext cx="73152" cy="713232"/>
+          </a:xfrm>
+          <a:prstGeom prst="rect">
+            <a:avLst/>
+          </a:prstGeom>
+          <a:solidFill>
+            <a:srgbClr val="102D5E"/>
+          </a:solidFill>
+          <a:ln>
+            <a:noFill/>
+          </a:ln>
+          <a:effectLst/>
+        </p:spPr>
+        <p:style>
+          <a:lnRef idx="1">
+            <a:schemeClr val="accent1"/>
+          </a:lnRef>
+          <a:fillRef idx="3">
+            <a:schemeClr val="accent1"/>
+          </a:fillRef>
+          <a:effectRef idx="2">
+            <a:schemeClr val="accent1"/>
+          </a:effectRef>
+          <a:fontRef idx="minor">
+            <a:schemeClr val="lt1"/>
+          </a:fontRef>
+        </p:style>
+        <p:txBody>
+          <a:bodyPr rtlCol="0" anchor="ctr"/>
+          <a:lstStyle/>
+          <a:p>
+            <a:pPr algn="ctr"/>
+          </a:p>
+        </p:txBody>
+      </p:sp>
+      <p:sp>
+        <p:nvSpPr>
+          <p:cNvPr id="7" name="TextBox 6"/>
           <p:cNvSpPr txBox="1"/>
           <p:nvPr/>
         </p:nvSpPr>
@@ -7814,14 +8798,14 @@
           <a:p>
             <a:pPr algn="l">
               <a:lnSpc>
-                <a:spcPts val="1855"/>
+                <a:spcPts val="1984"/>
               </a:lnSpc>
               <a:spcAft>
                 <a:spcPts val="0"/>
               </a:spcAft>
             </a:pPr>
             <a:r>
-              <a:rPr sz="1450" b="1" i="0">
+              <a:rPr sz="1550" b="1" i="0">
                 <a:solidFill>
                   <a:srgbClr val="102D5E"/>
                 </a:solidFill>
@@ -7830,9 +8814,9 @@
               <a:t>Key message.  </a:t>
             </a:r>
             <a:r>
-              <a:rPr sz="1450" b="0" i="0">
-                <a:solidFill>
-                  <a:srgbClr val="212529"/>
+              <a:rPr sz="1550" b="0" i="0">
+                <a:solidFill>
+                  <a:srgbClr val="102D5E"/>
                 </a:solidFill>
                 <a:latin typeface="Garamond"/>
               </a:rPr>
@@ -7996,7 +8980,51 @@
       </p:sp>
       <p:sp>
         <p:nvSpPr>
-          <p:cNvPr id="6" name="TextBox 5"/>
+          <p:cNvPr id="6" name="Rectangle 5"/>
+          <p:cNvSpPr/>
+          <p:nvPr/>
+        </p:nvSpPr>
+        <p:spPr>
+          <a:xfrm>
+            <a:off x="502920" y="5669280"/>
+            <a:ext cx="73152" cy="713232"/>
+          </a:xfrm>
+          <a:prstGeom prst="rect">
+            <a:avLst/>
+          </a:prstGeom>
+          <a:solidFill>
+            <a:srgbClr val="102D5E"/>
+          </a:solidFill>
+          <a:ln>
+            <a:noFill/>
+          </a:ln>
+          <a:effectLst/>
+        </p:spPr>
+        <p:style>
+          <a:lnRef idx="1">
+            <a:schemeClr val="accent1"/>
+          </a:lnRef>
+          <a:fillRef idx="3">
+            <a:schemeClr val="accent1"/>
+          </a:fillRef>
+          <a:effectRef idx="2">
+            <a:schemeClr val="accent1"/>
+          </a:effectRef>
+          <a:fontRef idx="minor">
+            <a:schemeClr val="lt1"/>
+          </a:fontRef>
+        </p:style>
+        <p:txBody>
+          <a:bodyPr rtlCol="0" anchor="ctr"/>
+          <a:lstStyle/>
+          <a:p>
+            <a:pPr algn="ctr"/>
+          </a:p>
+        </p:txBody>
+      </p:sp>
+      <p:sp>
+        <p:nvSpPr>
+          <p:cNvPr id="7" name="TextBox 6"/>
           <p:cNvSpPr txBox="1"/>
           <p:nvPr/>
         </p:nvSpPr>
@@ -8018,14 +9046,14 @@
           <a:p>
             <a:pPr algn="l">
               <a:lnSpc>
-                <a:spcPts val="1855"/>
+                <a:spcPts val="1984"/>
               </a:lnSpc>
               <a:spcAft>
                 <a:spcPts val="0"/>
               </a:spcAft>
             </a:pPr>
             <a:r>
-              <a:rPr sz="1450" b="1" i="0">
+              <a:rPr sz="1550" b="1" i="0">
                 <a:solidFill>
                   <a:srgbClr val="102D5E"/>
                 </a:solidFill>
@@ -8034,9 +9062,9 @@
               <a:t>Key message.  </a:t>
             </a:r>
             <a:r>
-              <a:rPr sz="1450" b="0" i="0">
-                <a:solidFill>
-                  <a:srgbClr val="212529"/>
+              <a:rPr sz="1550" b="0" i="0">
+                <a:solidFill>
+                  <a:srgbClr val="102D5E"/>
                 </a:solidFill>
                 <a:latin typeface="Garamond"/>
               </a:rPr>
@@ -8200,7 +9228,51 @@
       </p:sp>
       <p:sp>
         <p:nvSpPr>
-          <p:cNvPr id="6" name="TextBox 5"/>
+          <p:cNvPr id="6" name="Rectangle 5"/>
+          <p:cNvSpPr/>
+          <p:nvPr/>
+        </p:nvSpPr>
+        <p:spPr>
+          <a:xfrm>
+            <a:off x="502920" y="5669280"/>
+            <a:ext cx="73152" cy="713232"/>
+          </a:xfrm>
+          <a:prstGeom prst="rect">
+            <a:avLst/>
+          </a:prstGeom>
+          <a:solidFill>
+            <a:srgbClr val="102D5E"/>
+          </a:solidFill>
+          <a:ln>
+            <a:noFill/>
+          </a:ln>
+          <a:effectLst/>
+        </p:spPr>
+        <p:style>
+          <a:lnRef idx="1">
+            <a:schemeClr val="accent1"/>
+          </a:lnRef>
+          <a:fillRef idx="3">
+            <a:schemeClr val="accent1"/>
+          </a:fillRef>
+          <a:effectRef idx="2">
+            <a:schemeClr val="accent1"/>
+          </a:effectRef>
+          <a:fontRef idx="minor">
+            <a:schemeClr val="lt1"/>
+          </a:fontRef>
+        </p:style>
+        <p:txBody>
+          <a:bodyPr rtlCol="0" anchor="ctr"/>
+          <a:lstStyle/>
+          <a:p>
+            <a:pPr algn="ctr"/>
+          </a:p>
+        </p:txBody>
+      </p:sp>
+      <p:sp>
+        <p:nvSpPr>
+          <p:cNvPr id="7" name="TextBox 6"/>
           <p:cNvSpPr txBox="1"/>
           <p:nvPr/>
         </p:nvSpPr>
@@ -8222,14 +9294,14 @@
           <a:p>
             <a:pPr algn="l">
               <a:lnSpc>
-                <a:spcPts val="2048"/>
+                <a:spcPts val="2176"/>
               </a:lnSpc>
               <a:spcAft>
                 <a:spcPts val="0"/>
               </a:spcAft>
             </a:pPr>
             <a:r>
-              <a:rPr sz="1600" b="1" i="0">
+              <a:rPr sz="1700" b="1" i="0">
                 <a:solidFill>
                   <a:srgbClr val="102D5E"/>
                 </a:solidFill>
@@ -8238,9 +9310,9 @@
               <a:t>Key message.  </a:t>
             </a:r>
             <a:r>
-              <a:rPr sz="1600" b="0" i="0">
-                <a:solidFill>
-                  <a:srgbClr val="212529"/>
+              <a:rPr sz="1700" b="0" i="0">
+                <a:solidFill>
+                  <a:srgbClr val="102D5E"/>
                 </a:solidFill>
                 <a:latin typeface="Garamond"/>
               </a:rPr>
@@ -8391,6 +9463,48 @@
                 <a:latin typeface="Garamond"/>
               </a:rPr>
               <a:t>Composition: where they go?</a:t>
+            </a:r>
+          </a:p>
+        </p:txBody>
+      </p:sp>
+      <p:sp>
+        <p:nvSpPr>
+          <p:cNvPr id="5" name="TextBox 4"/>
+          <p:cNvSpPr txBox="1"/>
+          <p:nvPr/>
+        </p:nvSpPr>
+        <p:spPr>
+          <a:xfrm>
+            <a:off x="1371600" y="4892040"/>
+            <a:ext cx="9445752" cy="731520"/>
+          </a:xfrm>
+          <a:prstGeom prst="rect">
+            <a:avLst/>
+          </a:prstGeom>
+          <a:noFill/>
+        </p:spPr>
+        <p:txBody>
+          <a:bodyPr wrap="square" lIns="0" rIns="0" tIns="0" bIns="0">
+            <a:spAutoFit/>
+          </a:bodyPr>
+          <a:lstStyle/>
+          <a:p>
+            <a:pPr algn="ctr">
+              <a:lnSpc>
+                <a:spcPts val="2304"/>
+              </a:lnSpc>
+              <a:spcAft>
+                <a:spcPts val="0"/>
+              </a:spcAft>
+            </a:pPr>
+            <a:r>
+              <a:rPr sz="1800" b="0" i="1">
+                <a:solidFill>
+                  <a:srgbClr val="BED3EE"/>
+                </a:solidFill>
+                <a:latin typeface="Garamond"/>
+              </a:rPr>
+              <a:t>For discussion: where do teachers go when they leave in your country?</a:t>
             </a:r>
           </a:p>
         </p:txBody>

</xml_diff>

<commit_message>
Coefficient plot with hourly pay; drivers slide with speaker notes
Adds build_ame_wage.py: the full 2018-2024 probit specification plus
the log of hourly pay (annual wage over weeks times usual hours,
trimmed at the 1st and 99th percentiles within year; N = 17,964),
shown per 10 percent higher hourly pay. The policy deck gains the
drivers slide with speaker notes giving the hierarchy (contracts, then
life events, then security; demographics far smaller; pay -0.1 points
per 10 percent) and a standalone drivers_pay_slide.pptx.

Co-Authored-By: Claude Opus 5.5 <noreply@anthropic.com>
Claude-Session: https://claude.ai/code/session_01DNzQPDcr3zfLTraMHUHqUn
</commit_message>
<xml_diff>
--- a/report/data_cluster/Proyect_US_policy.pptx
+++ b/report/data_cluster/Proyect_US_policy.pptx
@@ -19,11 +19,12 @@
     <p:sldId id="267" r:id="rId18"/>
     <p:sldId id="268" r:id="rId19"/>
     <p:sldId id="269" r:id="rId20"/>
-    <p:sldId id="270" r:id="rId21"/>
-    <p:sldId id="271" r:id="rId22"/>
-    <p:sldId id="272" r:id="rId23"/>
-    <p:sldId id="273" r:id="rId24"/>
-    <p:sldId id="274" r:id="rId25"/>
+    <p:sldId id="270" r:id="rId22"/>
+    <p:sldId id="271" r:id="rId23"/>
+    <p:sldId id="272" r:id="rId24"/>
+    <p:sldId id="273" r:id="rId25"/>
+    <p:sldId id="274" r:id="rId26"/>
+    <p:sldId id="275" r:id="rId27"/>
   </p:sldIdLst>
   <p:sldSz cx="12191695" cy="6858000" type="screen4x3"/>
   <p:notesSz cx="6858000" cy="9144000"/>
@@ -123,6 +124,426 @@
     </a:lvl9pPr>
   </p:defaultTextStyle>
 </p:presentation>
+</file>
+
+<file path=ppt/notesMasters/notesMaster1.xml><?xml version="1.0" encoding="utf-8"?>
+<p:notesMaster xmlns:a="http://schemas.openxmlformats.org/drawingml/2006/main" xmlns:p="http://schemas.openxmlformats.org/presentationml/2006/main" xmlns:r="http://schemas.openxmlformats.org/officeDocument/2006/relationships">
+  <p:cSld>
+    <p:bg>
+      <p:bgRef idx="1001">
+        <a:schemeClr val="bg1"/>
+      </p:bgRef>
+    </p:bg>
+    <p:spTree>
+      <p:nvGrpSpPr>
+        <p:cNvPr id="1" name=""/>
+        <p:cNvGrpSpPr/>
+        <p:nvPr/>
+      </p:nvGrpSpPr>
+      <p:grpSpPr>
+        <a:xfrm>
+          <a:off x="0" y="0"/>
+          <a:ext cx="0" cy="0"/>
+          <a:chOff x="0" y="0"/>
+          <a:chExt cx="0" cy="0"/>
+        </a:xfrm>
+      </p:grpSpPr>
+      <p:sp>
+        <p:nvSpPr>
+          <p:cNvPr id="2" name="Header Placeholder 1"/>
+          <p:cNvSpPr>
+            <a:spLocks noGrp="1"/>
+          </p:cNvSpPr>
+          <p:nvPr>
+            <p:ph type="hdr" sz="quarter"/>
+          </p:nvPr>
+        </p:nvSpPr>
+        <p:spPr>
+          <a:xfrm>
+            <a:off x="0" y="0"/>
+            <a:ext cx="2971800" cy="457200"/>
+          </a:xfrm>
+          <a:prstGeom prst="rect">
+            <a:avLst/>
+          </a:prstGeom>
+        </p:spPr>
+        <p:txBody>
+          <a:bodyPr vert="horz" lIns="91440" tIns="45720" rIns="91440" bIns="45720" rtlCol="0"/>
+          <a:lstStyle>
+            <a:lvl1pPr algn="l">
+              <a:defRPr sz="1200"/>
+            </a:lvl1pPr>
+          </a:lstStyle>
+          <a:p>
+            <a:endParaRPr lang="en-US"/>
+          </a:p>
+        </p:txBody>
+      </p:sp>
+      <p:sp>
+        <p:nvSpPr>
+          <p:cNvPr id="3" name="Date Placeholder 2"/>
+          <p:cNvSpPr>
+            <a:spLocks noGrp="1"/>
+          </p:cNvSpPr>
+          <p:nvPr>
+            <p:ph type="dt" idx="1"/>
+          </p:nvPr>
+        </p:nvSpPr>
+        <p:spPr>
+          <a:xfrm>
+            <a:off x="3884613" y="0"/>
+            <a:ext cx="2971800" cy="457200"/>
+          </a:xfrm>
+          <a:prstGeom prst="rect">
+            <a:avLst/>
+          </a:prstGeom>
+        </p:spPr>
+        <p:txBody>
+          <a:bodyPr vert="horz" lIns="91440" tIns="45720" rIns="91440" bIns="45720" rtlCol="0"/>
+          <a:lstStyle>
+            <a:lvl1pPr algn="r">
+              <a:defRPr sz="1200"/>
+            </a:lvl1pPr>
+          </a:lstStyle>
+          <a:p>
+            <a:fld id="{0F89C1C7-3DCD-1040-A9CF-14679D8B5DDD}" type="datetimeFigureOut">
+              <a:rPr lang="en-US" smtClean="0"/>
+              <a:t>10/17/16</a:t>
+            </a:fld>
+            <a:endParaRPr lang="en-US"/>
+          </a:p>
+        </p:txBody>
+      </p:sp>
+      <p:sp>
+        <p:nvSpPr>
+          <p:cNvPr id="4" name="Slide Image Placeholder 3"/>
+          <p:cNvSpPr>
+            <a:spLocks noGrp="1" noRot="1" noChangeAspect="1"/>
+          </p:cNvSpPr>
+          <p:nvPr>
+            <p:ph type="sldImg" idx="2"/>
+          </p:nvPr>
+        </p:nvSpPr>
+        <p:spPr>
+          <a:xfrm>
+            <a:off x="1143000" y="685800"/>
+            <a:ext cx="4572000" cy="3429000"/>
+          </a:xfrm>
+          <a:prstGeom prst="rect">
+            <a:avLst/>
+          </a:prstGeom>
+          <a:noFill/>
+          <a:ln w="12700">
+            <a:solidFill>
+              <a:prstClr val="black"/>
+            </a:solidFill>
+          </a:ln>
+        </p:spPr>
+        <p:txBody>
+          <a:bodyPr vert="horz" lIns="91440" tIns="45720" rIns="91440" bIns="45720" rtlCol="0" anchor="ctr"/>
+          <a:lstStyle/>
+          <a:p>
+            <a:endParaRPr lang="en-US"/>
+          </a:p>
+        </p:txBody>
+      </p:sp>
+      <p:sp>
+        <p:nvSpPr>
+          <p:cNvPr id="5" name="Notes Placeholder 4"/>
+          <p:cNvSpPr>
+            <a:spLocks noGrp="1"/>
+          </p:cNvSpPr>
+          <p:nvPr>
+            <p:ph type="body" sz="quarter" idx="3"/>
+          </p:nvPr>
+        </p:nvSpPr>
+        <p:spPr>
+          <a:xfrm>
+            <a:off x="685800" y="4343400"/>
+            <a:ext cx="5486400" cy="4114800"/>
+          </a:xfrm>
+          <a:prstGeom prst="rect">
+            <a:avLst/>
+          </a:prstGeom>
+        </p:spPr>
+        <p:txBody>
+          <a:bodyPr vert="horz" lIns="91440" tIns="45720" rIns="91440" bIns="45720" rtlCol="0"/>
+          <a:lstStyle/>
+          <a:p>
+            <a:pPr lvl="0"/>
+            <a:r>
+              <a:rPr lang="en-US" smtClean="0"/>
+              <a:t>Click to edit Master text styles</a:t>
+            </a:r>
+          </a:p>
+          <a:p>
+            <a:pPr lvl="1"/>
+            <a:r>
+              <a:rPr lang="en-US" smtClean="0"/>
+              <a:t>Second level</a:t>
+            </a:r>
+          </a:p>
+          <a:p>
+            <a:pPr lvl="2"/>
+            <a:r>
+              <a:rPr lang="en-US" smtClean="0"/>
+              <a:t>Third level</a:t>
+            </a:r>
+          </a:p>
+          <a:p>
+            <a:pPr lvl="3"/>
+            <a:r>
+              <a:rPr lang="en-US" smtClean="0"/>
+              <a:t>Fourth level</a:t>
+            </a:r>
+          </a:p>
+          <a:p>
+            <a:pPr lvl="4"/>
+            <a:r>
+              <a:rPr lang="en-US" smtClean="0"/>
+              <a:t>Fifth level</a:t>
+            </a:r>
+            <a:endParaRPr lang="en-US"/>
+          </a:p>
+        </p:txBody>
+      </p:sp>
+      <p:sp>
+        <p:nvSpPr>
+          <p:cNvPr id="6" name="Footer Placeholder 5"/>
+          <p:cNvSpPr>
+            <a:spLocks noGrp="1"/>
+          </p:cNvSpPr>
+          <p:nvPr>
+            <p:ph type="ftr" sz="quarter" idx="4"/>
+          </p:nvPr>
+        </p:nvSpPr>
+        <p:spPr>
+          <a:xfrm>
+            <a:off x="0" y="8685213"/>
+            <a:ext cx="2971800" cy="457200"/>
+          </a:xfrm>
+          <a:prstGeom prst="rect">
+            <a:avLst/>
+          </a:prstGeom>
+        </p:spPr>
+        <p:txBody>
+          <a:bodyPr vert="horz" lIns="91440" tIns="45720" rIns="91440" bIns="45720" rtlCol="0" anchor="b"/>
+          <a:lstStyle>
+            <a:lvl1pPr algn="l">
+              <a:defRPr sz="1200"/>
+            </a:lvl1pPr>
+          </a:lstStyle>
+          <a:p>
+            <a:endParaRPr lang="en-US"/>
+          </a:p>
+        </p:txBody>
+      </p:sp>
+      <p:sp>
+        <p:nvSpPr>
+          <p:cNvPr id="7" name="Slide Number Placeholder 6"/>
+          <p:cNvSpPr>
+            <a:spLocks noGrp="1"/>
+          </p:cNvSpPr>
+          <p:nvPr>
+            <p:ph type="sldNum" sz="quarter" idx="5"/>
+          </p:nvPr>
+        </p:nvSpPr>
+        <p:spPr>
+          <a:xfrm>
+            <a:off x="3884613" y="8685213"/>
+            <a:ext cx="2971800" cy="457200"/>
+          </a:xfrm>
+          <a:prstGeom prst="rect">
+            <a:avLst/>
+          </a:prstGeom>
+        </p:spPr>
+        <p:txBody>
+          <a:bodyPr vert="horz" lIns="91440" tIns="45720" rIns="91440" bIns="45720" rtlCol="0" anchor="b"/>
+          <a:lstStyle>
+            <a:lvl1pPr algn="r">
+              <a:defRPr sz="1200"/>
+            </a:lvl1pPr>
+          </a:lstStyle>
+          <a:p>
+            <a:fld id="{BB5E49A5-4136-284D-997B-48E1D791AD67}" type="slidenum">
+              <a:rPr lang="en-US" smtClean="0"/>
+              <a:t>‹#›</a:t>
+            </a:fld>
+            <a:endParaRPr lang="en-US"/>
+          </a:p>
+        </p:txBody>
+      </p:sp>
+    </p:spTree>
+    <p:extLst>
+      <p:ext uri="{BB962C8B-B14F-4D97-AF65-F5344CB8AC3E}">
+        <p14:creationId xmlns:p14="http://schemas.microsoft.com/office/powerpoint/2010/main" val="2623252185"/>
+      </p:ext>
+    </p:extLst>
+  </p:cSld>
+  <p:clrMap bg1="lt1" tx1="dk1" bg2="lt2" tx2="dk2" accent1="accent1" accent2="accent2" accent3="accent3" accent4="accent4" accent5="accent5" accent6="accent6" hlink="hlink" folHlink="folHlink"/>
+  <p:notesStyle>
+    <a:lvl1pPr marL="0" algn="l" defTabSz="457200" rtl="0" eaLnBrk="1" latinLnBrk="0" hangingPunct="1">
+      <a:defRPr sz="1200" kern="1200">
+        <a:solidFill>
+          <a:schemeClr val="tx1"/>
+        </a:solidFill>
+        <a:latin typeface="+mn-lt"/>
+        <a:ea typeface="+mn-ea"/>
+        <a:cs typeface="+mn-cs"/>
+      </a:defRPr>
+    </a:lvl1pPr>
+    <a:lvl2pPr marL="457200" algn="l" defTabSz="457200" rtl="0" eaLnBrk="1" latinLnBrk="0" hangingPunct="1">
+      <a:defRPr sz="1200" kern="1200">
+        <a:solidFill>
+          <a:schemeClr val="tx1"/>
+        </a:solidFill>
+        <a:latin typeface="+mn-lt"/>
+        <a:ea typeface="+mn-ea"/>
+        <a:cs typeface="+mn-cs"/>
+      </a:defRPr>
+    </a:lvl2pPr>
+    <a:lvl3pPr marL="914400" algn="l" defTabSz="457200" rtl="0" eaLnBrk="1" latinLnBrk="0" hangingPunct="1">
+      <a:defRPr sz="1200" kern="1200">
+        <a:solidFill>
+          <a:schemeClr val="tx1"/>
+        </a:solidFill>
+        <a:latin typeface="+mn-lt"/>
+        <a:ea typeface="+mn-ea"/>
+        <a:cs typeface="+mn-cs"/>
+      </a:defRPr>
+    </a:lvl3pPr>
+    <a:lvl4pPr marL="1371600" algn="l" defTabSz="457200" rtl="0" eaLnBrk="1" latinLnBrk="0" hangingPunct="1">
+      <a:defRPr sz="1200" kern="1200">
+        <a:solidFill>
+          <a:schemeClr val="tx1"/>
+        </a:solidFill>
+        <a:latin typeface="+mn-lt"/>
+        <a:ea typeface="+mn-ea"/>
+        <a:cs typeface="+mn-cs"/>
+      </a:defRPr>
+    </a:lvl4pPr>
+    <a:lvl5pPr marL="1828800" algn="l" defTabSz="457200" rtl="0" eaLnBrk="1" latinLnBrk="0" hangingPunct="1">
+      <a:defRPr sz="1200" kern="1200">
+        <a:solidFill>
+          <a:schemeClr val="tx1"/>
+        </a:solidFill>
+        <a:latin typeface="+mn-lt"/>
+        <a:ea typeface="+mn-ea"/>
+        <a:cs typeface="+mn-cs"/>
+      </a:defRPr>
+    </a:lvl5pPr>
+    <a:lvl6pPr marL="2286000" algn="l" defTabSz="457200" rtl="0" eaLnBrk="1" latinLnBrk="0" hangingPunct="1">
+      <a:defRPr sz="1200" kern="1200">
+        <a:solidFill>
+          <a:schemeClr val="tx1"/>
+        </a:solidFill>
+        <a:latin typeface="+mn-lt"/>
+        <a:ea typeface="+mn-ea"/>
+        <a:cs typeface="+mn-cs"/>
+      </a:defRPr>
+    </a:lvl6pPr>
+    <a:lvl7pPr marL="2743200" algn="l" defTabSz="457200" rtl="0" eaLnBrk="1" latinLnBrk="0" hangingPunct="1">
+      <a:defRPr sz="1200" kern="1200">
+        <a:solidFill>
+          <a:schemeClr val="tx1"/>
+        </a:solidFill>
+        <a:latin typeface="+mn-lt"/>
+        <a:ea typeface="+mn-ea"/>
+        <a:cs typeface="+mn-cs"/>
+      </a:defRPr>
+    </a:lvl7pPr>
+    <a:lvl8pPr marL="3200400" algn="l" defTabSz="457200" rtl="0" eaLnBrk="1" latinLnBrk="0" hangingPunct="1">
+      <a:defRPr sz="1200" kern="1200">
+        <a:solidFill>
+          <a:schemeClr val="tx1"/>
+        </a:solidFill>
+        <a:latin typeface="+mn-lt"/>
+        <a:ea typeface="+mn-ea"/>
+        <a:cs typeface="+mn-cs"/>
+      </a:defRPr>
+    </a:lvl8pPr>
+    <a:lvl9pPr marL="3657600" algn="l" defTabSz="457200" rtl="0" eaLnBrk="1" latinLnBrk="0" hangingPunct="1">
+      <a:defRPr sz="1200" kern="1200">
+        <a:solidFill>
+          <a:schemeClr val="tx1"/>
+        </a:solidFill>
+        <a:latin typeface="+mn-lt"/>
+        <a:ea typeface="+mn-ea"/>
+        <a:cs typeface="+mn-cs"/>
+      </a:defRPr>
+    </a:lvl9pPr>
+  </p:notesStyle>
+</p:notesMaster>
+</file>
+
+<file path=ppt/notesSlides/notesSlide1.xml><?xml version="1.0" encoding="utf-8"?>
+<p:notes xmlns:a="http://schemas.openxmlformats.org/drawingml/2006/main" xmlns:p="http://schemas.openxmlformats.org/presentationml/2006/main" xmlns:r="http://schemas.openxmlformats.org/officeDocument/2006/relationships">
+  <p:cSld>
+    <p:spTree>
+      <p:nvGrpSpPr>
+        <p:cNvPr id="1" name=""/>
+        <p:cNvGrpSpPr/>
+        <p:nvPr/>
+      </p:nvGrpSpPr>
+      <p:grpSpPr>
+        <a:xfrm>
+          <a:off x="0" y="0"/>
+          <a:ext cx="0" cy="0"/>
+          <a:chOff x="0" y="0"/>
+          <a:chExt cx="0" cy="0"/>
+        </a:xfrm>
+      </p:grpSpPr>
+      <p:sp>
+        <p:nvSpPr>
+          <p:cNvPr id="2" name="Slide Image Placeholder 1"/>
+          <p:cNvSpPr>
+            <a:spLocks noGrp="1"/>
+          </p:cNvSpPr>
+          <p:nvPr>
+            <p:ph type="sldImg" idx="2"/>
+          </p:nvPr>
+        </p:nvSpPr>
+        <p:spPr/>
+      </p:sp>
+      <p:sp>
+        <p:nvSpPr>
+          <p:cNvPr id="3" name="Notes Placeholder 2"/>
+          <p:cNvSpPr>
+            <a:spLocks noGrp="1"/>
+          </p:cNvSpPr>
+          <p:nvPr>
+            <p:ph type="body" idx="3" sz="quarter"/>
+          </p:nvPr>
+        </p:nvSpPr>
+        <p:spPr/>
+        <p:txBody>
+          <a:bodyPr/>
+          <a:lstStyle/>
+          <a:p>
+            <a:r>
+              <a:t>Read each dot as the change in the probability of leaving, in percentage points, against an average of about 7 in 100 teachers a year. The hierarchy is clear. First, the contract: a full-year contract goes with almost 8 points less leaving, and a part-time contract with 4 points more. These are the largest effects on the chart. Second, life events: a new baby or a disability each add about 4 points. Third, security: a pension plan and a public-school job each cut leaving by about 2 points. Surprisingly, demographics matter much less: being a woman, being Black or holding a master's degree moves the rate by 2 points at most once contracts and life events are accounted for. Pay is measured per hour, because weeks and hours are already in the model: a 10 percent higher hourly pay goes with 0.1 points less leaving, about 1.6 percent of the average rate. That does not make pay irrelevant. Low pay comes bundled with part-year and part-time contracts, which is where most of the action is, as the next charts show.</a:t>
+            </a:r>
+          </a:p>
+        </p:txBody>
+      </p:sp>
+      <p:sp>
+        <p:nvSpPr>
+          <p:cNvPr id="4" name="Slide Number Placeholder 3"/>
+          <p:cNvSpPr>
+            <a:spLocks noGrp="1"/>
+          </p:cNvSpPr>
+          <p:nvPr>
+            <p:ph type="sldNum" idx="5" sz="quarter"/>
+          </p:nvPr>
+        </p:nvSpPr>
+        <p:spPr/>
+      </p:sp>
+    </p:spTree>
+  </p:cSld>
+  <p:clrMapOvr>
+    <a:masterClrMapping/>
+  </p:clrMapOvr>
+</p:notes>
 </file>
 
 <file path=ppt/slideLayouts/slideLayout1.xml><?xml version="1.0" encoding="utf-8"?>
@@ -4665,7 +5086,7 @@
                 </a:solidFill>
                 <a:latin typeface="Garamond"/>
               </a:rPr>
-              <a:t>Relative pay since 1997</a:t>
+              <a:t>What correlates with leaving</a:t>
             </a:r>
           </a:p>
         </p:txBody>
@@ -4707,7 +5128,7 @@
       </p:sp>
       <p:pic>
         <p:nvPicPr>
-          <p:cNvPr id="4" name="Picture 3" descr="msgA3.png"/>
+          <p:cNvPr id="4" name="Picture 3" descr="ame_wage.png"/>
           <p:cNvPicPr>
             <a:picLocks noChangeAspect="1"/>
           </p:cNvPicPr>
@@ -4721,8 +5142,8 @@
         </p:blipFill>
         <p:spPr>
           <a:xfrm>
-            <a:off x="702337" y="1097280"/>
-            <a:ext cx="10756845" cy="4434840"/>
+            <a:off x="2389796" y="960120"/>
+            <a:ext cx="7381926" cy="4709160"/>
           </a:xfrm>
           <a:prstGeom prst="rect">
             <a:avLst/>
@@ -4737,7 +5158,7 @@
         </p:nvSpPr>
         <p:spPr>
           <a:xfrm>
-            <a:off x="0" y="5559552"/>
+            <a:off x="0" y="5724144"/>
             <a:ext cx="12191695" cy="960120"/>
           </a:xfrm>
           <a:prstGeom prst="rect">
@@ -4781,7 +5202,7 @@
         </p:nvSpPr>
         <p:spPr>
           <a:xfrm>
-            <a:off x="502920" y="5669280"/>
+            <a:off x="502920" y="5833872"/>
             <a:ext cx="73152" cy="713232"/>
           </a:xfrm>
           <a:prstGeom prst="rect">
@@ -4825,7 +5246,7 @@
         </p:nvSpPr>
         <p:spPr>
           <a:xfrm>
-            <a:off x="822960" y="5687568"/>
+            <a:off x="822960" y="5852160"/>
             <a:ext cx="10789920" cy="822960"/>
           </a:xfrm>
           <a:prstGeom prst="rect">
@@ -4841,14 +5262,14 @@
           <a:p>
             <a:pPr algn="l">
               <a:lnSpc>
-                <a:spcPts val="2176"/>
+                <a:spcPts val="1984"/>
               </a:lnSpc>
               <a:spcAft>
                 <a:spcPts val="0"/>
               </a:spcAft>
             </a:pPr>
             <a:r>
-              <a:rPr sz="1700" b="1" i="0">
+              <a:rPr sz="1550" b="1" i="0">
                 <a:solidFill>
                   <a:srgbClr val="102D5E"/>
                 </a:solidFill>
@@ -4857,13 +5278,13 @@
               <a:t>Key message.  </a:t>
             </a:r>
             <a:r>
-              <a:rPr sz="1700" b="0" i="0">
+              <a:rPr sz="1550" b="0" i="0">
                 <a:solidFill>
                   <a:srgbClr val="102D5E"/>
                 </a:solidFill>
                 <a:latin typeface="Garamond"/>
               </a:rPr>
-              <a:t>Teacher pay has not grown in 25 years.</a:t>
+              <a:t>Contracts matter most, then life events and economic security. Demographics matter far less, and pay works mostly through the contract.</a:t>
             </a:r>
           </a:p>
         </p:txBody>
@@ -4913,7 +5334,7 @@
                 </a:solidFill>
                 <a:latin typeface="Garamond"/>
               </a:rPr>
-              <a:t>Leaving, by position in the teacher pay distribution</a:t>
+              <a:t>Relative pay since 1997</a:t>
             </a:r>
           </a:p>
         </p:txBody>
@@ -4955,7 +5376,7 @@
       </p:sp>
       <p:pic>
         <p:nvPicPr>
-          <p:cNvPr id="4" name="Picture 3" descr="pay3_deciles_deck.png"/>
+          <p:cNvPr id="4" name="Picture 3" descr="msgA3.png"/>
           <p:cNvPicPr>
             <a:picLocks noChangeAspect="1"/>
           </p:cNvPicPr>
@@ -4969,8 +5390,8 @@
         </p:blipFill>
         <p:spPr>
           <a:xfrm>
-            <a:off x="1645920" y="1097280"/>
-            <a:ext cx="8869680" cy="4434840"/>
+            <a:off x="702337" y="1097280"/>
+            <a:ext cx="10756845" cy="4434840"/>
           </a:xfrm>
           <a:prstGeom prst="rect">
             <a:avLst/>
@@ -5111,7 +5532,7 @@
                 </a:solidFill>
                 <a:latin typeface="Garamond"/>
               </a:rPr>
-              <a:t>Leavers are concentrated in the bottom two deciles.</a:t>
+              <a:t>Teacher pay has not grown in 25 years.</a:t>
             </a:r>
           </a:p>
         </p:txBody>
@@ -5161,7 +5582,7 @@
                 </a:solidFill>
                 <a:latin typeface="Garamond"/>
               </a:rPr>
-              <a:t>Pension coverage and leaving, across states</a:t>
+              <a:t>Leaving, by position in the teacher pay distribution</a:t>
             </a:r>
           </a:p>
         </p:txBody>
@@ -5203,7 +5624,7 @@
       </p:sp>
       <p:pic>
         <p:nvPicPr>
-          <p:cNvPr id="4" name="Picture 3" descr="pension_scatter_deck.png"/>
+          <p:cNvPr id="4" name="Picture 3" descr="pay3_deciles_deck.png"/>
           <p:cNvPicPr>
             <a:picLocks noChangeAspect="1"/>
           </p:cNvPicPr>
@@ -5217,8 +5638,8 @@
         </p:blipFill>
         <p:spPr>
           <a:xfrm>
-            <a:off x="2289687" y="1097280"/>
-            <a:ext cx="7582145" cy="4434840"/>
+            <a:off x="1645920" y="1097280"/>
+            <a:ext cx="8869680" cy="4434840"/>
           </a:xfrm>
           <a:prstGeom prst="rect">
             <a:avLst/>
@@ -5359,7 +5780,7 @@
                 </a:solidFill>
                 <a:latin typeface="Garamond"/>
               </a:rPr>
-              <a:t>States where more teachers have a pension plan have fewer early exits.</a:t>
+              <a:t>Leavers are concentrated in the bottom two deciles.</a:t>
             </a:r>
           </a:p>
         </p:txBody>
@@ -5384,14 +5805,149 @@
       <p:grpSpPr/>
       <p:sp>
         <p:nvSpPr>
-          <p:cNvPr id="2" name="Rectangle 1"/>
+          <p:cNvPr id="2" name="TextBox 1"/>
+          <p:cNvSpPr txBox="1"/>
+          <p:nvPr/>
+        </p:nvSpPr>
+        <p:spPr>
+          <a:xfrm>
+            <a:off x="502920" y="219456"/>
+            <a:ext cx="11247120" cy="566928"/>
+          </a:xfrm>
+          <a:prstGeom prst="rect">
+            <a:avLst/>
+          </a:prstGeom>
+          <a:noFill/>
+        </p:spPr>
+        <p:txBody>
+          <a:bodyPr wrap="square" lIns="0" rIns="0" tIns="0" bIns="0"/>
+          <a:lstStyle/>
+          <a:p>
+            <a:r>
+              <a:rPr sz="2800" b="1">
+                <a:solidFill>
+                  <a:srgbClr val="102D5E"/>
+                </a:solidFill>
+                <a:latin typeface="Garamond"/>
+              </a:rPr>
+              <a:t>Pension coverage and leaving, across states</a:t>
+            </a:r>
+          </a:p>
+        </p:txBody>
+      </p:sp>
+      <p:sp>
+        <p:nvSpPr>
+          <p:cNvPr id="3" name="TextBox 2"/>
+          <p:cNvSpPr txBox="1"/>
+          <p:nvPr/>
+        </p:nvSpPr>
+        <p:spPr>
+          <a:xfrm>
+            <a:off x="11384280" y="6446520"/>
+            <a:ext cx="640080" cy="292608"/>
+          </a:xfrm>
+          <a:prstGeom prst="rect">
+            <a:avLst/>
+          </a:prstGeom>
+          <a:noFill/>
+        </p:spPr>
+        <p:txBody>
+          <a:bodyPr wrap="none" lIns="0" rIns="0" tIns="0" bIns="0">
+            <a:spAutoFit/>
+          </a:bodyPr>
+          <a:lstStyle/>
+          <a:p>
+            <a:pPr algn="r"/>
+            <a:r>
+              <a:rPr sz="1100">
+                <a:solidFill>
+                  <a:srgbClr val="6B7480"/>
+                </a:solidFill>
+                <a:latin typeface="Garamond"/>
+              </a:rPr>
+              <a:t>17</a:t>
+            </a:r>
+          </a:p>
+        </p:txBody>
+      </p:sp>
+      <p:pic>
+        <p:nvPicPr>
+          <p:cNvPr id="4" name="Picture 3" descr="pension_scatter_deck.png"/>
+          <p:cNvPicPr>
+            <a:picLocks noChangeAspect="1"/>
+          </p:cNvPicPr>
+          <p:nvPr/>
+        </p:nvPicPr>
+        <p:blipFill>
+          <a:blip r:embed="rId2"/>
+          <a:stretch>
+            <a:fillRect/>
+          </a:stretch>
+        </p:blipFill>
+        <p:spPr>
+          <a:xfrm>
+            <a:off x="2289687" y="1097280"/>
+            <a:ext cx="7582145" cy="4434840"/>
+          </a:xfrm>
+          <a:prstGeom prst="rect">
+            <a:avLst/>
+          </a:prstGeom>
+        </p:spPr>
+      </p:pic>
+      <p:sp>
+        <p:nvSpPr>
+          <p:cNvPr id="5" name="Rectangle 4"/>
           <p:cNvSpPr/>
           <p:nvPr/>
         </p:nvSpPr>
         <p:spPr>
           <a:xfrm>
-            <a:off x="0" y="0"/>
-            <a:ext cx="12191695" cy="6858000"/>
+            <a:off x="0" y="5559552"/>
+            <a:ext cx="12191695" cy="960120"/>
+          </a:xfrm>
+          <a:prstGeom prst="rect">
+            <a:avLst/>
+          </a:prstGeom>
+          <a:solidFill>
+            <a:srgbClr val="ECF2F9"/>
+          </a:solidFill>
+          <a:ln>
+            <a:noFill/>
+          </a:ln>
+          <a:effectLst/>
+        </p:spPr>
+        <p:style>
+          <a:lnRef idx="1">
+            <a:schemeClr val="accent1"/>
+          </a:lnRef>
+          <a:fillRef idx="3">
+            <a:schemeClr val="accent1"/>
+          </a:fillRef>
+          <a:effectRef idx="2">
+            <a:schemeClr val="accent1"/>
+          </a:effectRef>
+          <a:fontRef idx="minor">
+            <a:schemeClr val="lt1"/>
+          </a:fontRef>
+        </p:style>
+        <p:txBody>
+          <a:bodyPr rtlCol="0" anchor="ctr"/>
+          <a:lstStyle/>
+          <a:p>
+            <a:pPr algn="ctr"/>
+          </a:p>
+        </p:txBody>
+      </p:sp>
+      <p:sp>
+        <p:nvSpPr>
+          <p:cNvPr id="6" name="Rectangle 5"/>
+          <p:cNvSpPr/>
+          <p:nvPr/>
+        </p:nvSpPr>
+        <p:spPr>
+          <a:xfrm>
+            <a:off x="502920" y="5669280"/>
+            <a:ext cx="73152" cy="713232"/>
           </a:xfrm>
           <a:prstGeom prst="rect">
             <a:avLst/>
@@ -5428,14 +5984,14 @@
       </p:sp>
       <p:sp>
         <p:nvSpPr>
-          <p:cNvPr id="3" name="TextBox 2"/>
+          <p:cNvPr id="7" name="TextBox 6"/>
           <p:cNvSpPr txBox="1"/>
           <p:nvPr/>
         </p:nvSpPr>
         <p:spPr>
           <a:xfrm>
-            <a:off x="914400" y="2240280"/>
-            <a:ext cx="10360152" cy="1188720"/>
+            <a:off x="822960" y="5687568"/>
+            <a:ext cx="10789920" cy="822960"/>
           </a:xfrm>
           <a:prstGeom prst="rect">
             <a:avLst/>
@@ -5448,106 +6004,31 @@
           </a:bodyPr>
           <a:lstStyle/>
           <a:p>
-            <a:pPr algn="ctr">
+            <a:pPr algn="l">
               <a:lnSpc>
-                <a:spcPts val="7680"/>
+                <a:spcPts val="2176"/>
               </a:lnSpc>
               <a:spcAft>
                 <a:spcPts val="0"/>
               </a:spcAft>
             </a:pPr>
             <a:r>
-              <a:rPr sz="6000" b="1" i="0">
-                <a:solidFill>
-                  <a:srgbClr val="FFFFFF"/>
-                </a:solidFill>
-                <a:latin typeface="Garamond"/>
-              </a:rPr>
-              <a:t>4</a:t>
-            </a:r>
-          </a:p>
-        </p:txBody>
-      </p:sp>
-      <p:sp>
-        <p:nvSpPr>
-          <p:cNvPr id="4" name="TextBox 3"/>
-          <p:cNvSpPr txBox="1"/>
-          <p:nvPr/>
-        </p:nvSpPr>
-        <p:spPr>
-          <a:xfrm>
-            <a:off x="914400" y="3703320"/>
-            <a:ext cx="10360152" cy="731520"/>
-          </a:xfrm>
-          <a:prstGeom prst="rect">
-            <a:avLst/>
-          </a:prstGeom>
-          <a:noFill/>
-        </p:spPr>
-        <p:txBody>
-          <a:bodyPr wrap="square" lIns="0" rIns="0" tIns="0" bIns="0">
-            <a:spAutoFit/>
-          </a:bodyPr>
-          <a:lstStyle/>
-          <a:p>
-            <a:pPr algn="ctr">
-              <a:lnSpc>
-                <a:spcPts val="3584"/>
-              </a:lnSpc>
-              <a:spcAft>
-                <a:spcPts val="0"/>
-              </a:spcAft>
-            </a:pPr>
-            <a:r>
-              <a:rPr sz="2800" b="0" i="0">
-                <a:solidFill>
-                  <a:srgbClr val="D7E3F2"/>
-                </a:solidFill>
-                <a:latin typeface="Garamond"/>
-              </a:rPr>
-              <a:t>What it means for policy</a:t>
-            </a:r>
-          </a:p>
-        </p:txBody>
-      </p:sp>
-      <p:sp>
-        <p:nvSpPr>
-          <p:cNvPr id="5" name="TextBox 4"/>
-          <p:cNvSpPr txBox="1"/>
-          <p:nvPr/>
-        </p:nvSpPr>
-        <p:spPr>
-          <a:xfrm>
-            <a:off x="1371600" y="4892040"/>
-            <a:ext cx="9445752" cy="731520"/>
-          </a:xfrm>
-          <a:prstGeom prst="rect">
-            <a:avLst/>
-          </a:prstGeom>
-          <a:noFill/>
-        </p:spPr>
-        <p:txBody>
-          <a:bodyPr wrap="square" lIns="0" rIns="0" tIns="0" bIns="0">
-            <a:spAutoFit/>
-          </a:bodyPr>
-          <a:lstStyle/>
-          <a:p>
-            <a:pPr algn="ctr">
-              <a:lnSpc>
-                <a:spcPts val="2304"/>
-              </a:lnSpc>
-              <a:spcAft>
-                <a:spcPts val="0"/>
-              </a:spcAft>
-            </a:pPr>
-            <a:r>
-              <a:rPr sz="1800" b="0" i="1">
-                <a:solidFill>
-                  <a:srgbClr val="BED3EE"/>
-                </a:solidFill>
-                <a:latin typeface="Garamond"/>
-              </a:rPr>
-              <a:t>For discussion: what would bring teachers back in your country?</a:t>
+              <a:rPr sz="1700" b="1" i="0">
+                <a:solidFill>
+                  <a:srgbClr val="102D5E"/>
+                </a:solidFill>
+                <a:latin typeface="Garamond"/>
+              </a:rPr>
+              <a:t>Key message.  </a:t>
+            </a:r>
+            <a:r>
+              <a:rPr sz="1700" b="0" i="0">
+                <a:solidFill>
+                  <a:srgbClr val="102D5E"/>
+                </a:solidFill>
+                <a:latin typeface="Garamond"/>
+              </a:rPr>
+              <a:t>States where more teachers have a pension plan have fewer early exits.</a:t>
             </a:r>
           </a:p>
         </p:txBody>
@@ -5572,33 +6053,45 @@
       <p:grpSpPr/>
       <p:sp>
         <p:nvSpPr>
-          <p:cNvPr id="2" name="TextBox 1"/>
-          <p:cNvSpPr txBox="1"/>
-          <p:nvPr/>
-        </p:nvSpPr>
-        <p:spPr>
-          <a:xfrm>
-            <a:off x="502920" y="219456"/>
-            <a:ext cx="11247120" cy="566928"/>
-          </a:xfrm>
-          <a:prstGeom prst="rect">
-            <a:avLst/>
-          </a:prstGeom>
-          <a:noFill/>
-        </p:spPr>
-        <p:txBody>
-          <a:bodyPr wrap="square" lIns="0" rIns="0" tIns="0" bIns="0"/>
-          <a:lstStyle/>
-          <a:p>
-            <a:r>
-              <a:rPr sz="2800" b="1">
-                <a:solidFill>
-                  <a:srgbClr val="102D5E"/>
-                </a:solidFill>
-                <a:latin typeface="Garamond"/>
-              </a:rPr>
-              <a:t>Policy options for re-attraction</a:t>
-            </a:r>
+          <p:cNvPr id="2" name="Rectangle 1"/>
+          <p:cNvSpPr/>
+          <p:nvPr/>
+        </p:nvSpPr>
+        <p:spPr>
+          <a:xfrm>
+            <a:off x="0" y="0"/>
+            <a:ext cx="12191695" cy="6858000"/>
+          </a:xfrm>
+          <a:prstGeom prst="rect">
+            <a:avLst/>
+          </a:prstGeom>
+          <a:solidFill>
+            <a:srgbClr val="102D5E"/>
+          </a:solidFill>
+          <a:ln>
+            <a:noFill/>
+          </a:ln>
+          <a:effectLst/>
+        </p:spPr>
+        <p:style>
+          <a:lnRef idx="1">
+            <a:schemeClr val="accent1"/>
+          </a:lnRef>
+          <a:fillRef idx="3">
+            <a:schemeClr val="accent1"/>
+          </a:fillRef>
+          <a:effectRef idx="2">
+            <a:schemeClr val="accent1"/>
+          </a:effectRef>
+          <a:fontRef idx="minor">
+            <a:schemeClr val="lt1"/>
+          </a:fontRef>
+        </p:style>
+        <p:txBody>
+          <a:bodyPr rtlCol="0" anchor="ctr"/>
+          <a:lstStyle/>
+          <a:p>
+            <a:pPr algn="ctr"/>
           </a:p>
         </p:txBody>
       </p:sp>
@@ -5610,43 +6103,8 @@
         </p:nvSpPr>
         <p:spPr>
           <a:xfrm>
-            <a:off x="11384280" y="6446520"/>
-            <a:ext cx="640080" cy="292608"/>
-          </a:xfrm>
-          <a:prstGeom prst="rect">
-            <a:avLst/>
-          </a:prstGeom>
-          <a:noFill/>
-        </p:spPr>
-        <p:txBody>
-          <a:bodyPr wrap="none" lIns="0" rIns="0" tIns="0" bIns="0">
-            <a:spAutoFit/>
-          </a:bodyPr>
-          <a:lstStyle/>
-          <a:p>
-            <a:pPr algn="r"/>
-            <a:r>
-              <a:rPr sz="1100">
-                <a:solidFill>
-                  <a:srgbClr val="6B7480"/>
-                </a:solidFill>
-                <a:latin typeface="Garamond"/>
-              </a:rPr>
-              <a:t>18</a:t>
-            </a:r>
-          </a:p>
-        </p:txBody>
-      </p:sp>
-      <p:sp>
-        <p:nvSpPr>
-          <p:cNvPr id="4" name="TextBox 3"/>
-          <p:cNvSpPr txBox="1"/>
-          <p:nvPr/>
-        </p:nvSpPr>
-        <p:spPr>
-          <a:xfrm>
-            <a:off x="822960" y="1325880"/>
-            <a:ext cx="5120640" cy="457200"/>
+            <a:off x="914400" y="2240280"/>
+            <a:ext cx="10360152" cy="1188720"/>
           </a:xfrm>
           <a:prstGeom prst="rect">
             <a:avLst/>
@@ -5659,36 +6117,36 @@
           </a:bodyPr>
           <a:lstStyle/>
           <a:p>
-            <a:pPr algn="l">
+            <a:pPr algn="ctr">
               <a:lnSpc>
-                <a:spcPts val="2688"/>
+                <a:spcPts val="7680"/>
               </a:lnSpc>
               <a:spcAft>
                 <a:spcPts val="0"/>
               </a:spcAft>
             </a:pPr>
             <a:r>
-              <a:rPr sz="2100" b="1" i="0">
-                <a:solidFill>
-                  <a:srgbClr val="2D6CB5"/>
-                </a:solidFill>
-                <a:latin typeface="Garamond"/>
-              </a:rPr>
-              <a:t>Short term and retirees</a:t>
-            </a:r>
-          </a:p>
-        </p:txBody>
-      </p:sp>
-      <p:sp>
-        <p:nvSpPr>
-          <p:cNvPr id="5" name="TextBox 4"/>
+              <a:rPr sz="6000" b="1" i="0">
+                <a:solidFill>
+                  <a:srgbClr val="FFFFFF"/>
+                </a:solidFill>
+                <a:latin typeface="Garamond"/>
+              </a:rPr>
+              <a:t>4</a:t>
+            </a:r>
+          </a:p>
+        </p:txBody>
+      </p:sp>
+      <p:sp>
+        <p:nvSpPr>
+          <p:cNvPr id="4" name="TextBox 3"/>
           <p:cNvSpPr txBox="1"/>
           <p:nvPr/>
         </p:nvSpPr>
         <p:spPr>
           <a:xfrm>
-            <a:off x="822960" y="1828800"/>
-            <a:ext cx="5120640" cy="1554480"/>
+            <a:off x="914400" y="3703320"/>
+            <a:ext cx="10360152" cy="731520"/>
           </a:xfrm>
           <a:prstGeom prst="rect">
             <a:avLst/>
@@ -5701,36 +6159,36 @@
           </a:bodyPr>
           <a:lstStyle/>
           <a:p>
-            <a:pPr algn="l">
+            <a:pPr algn="ctr">
               <a:lnSpc>
-                <a:spcPts val="2176"/>
+                <a:spcPts val="3584"/>
               </a:lnSpc>
               <a:spcAft>
                 <a:spcPts val="0"/>
               </a:spcAft>
             </a:pPr>
             <a:r>
-              <a:rPr sz="1700" b="0" i="0">
-                <a:solidFill>
-                  <a:srgbClr val="212529"/>
-                </a:solidFill>
-                <a:latin typeface="Garamond"/>
-              </a:rPr>
-              <a:t>A reserve for local shortages. They bring experience and can mentor new teachers. Make it easy to return, for example part-time or “double-dipping”.</a:t>
-            </a:r>
-          </a:p>
-        </p:txBody>
-      </p:sp>
-      <p:sp>
-        <p:nvSpPr>
-          <p:cNvPr id="6" name="TextBox 5"/>
+              <a:rPr sz="2800" b="0" i="0">
+                <a:solidFill>
+                  <a:srgbClr val="D7E3F2"/>
+                </a:solidFill>
+                <a:latin typeface="Garamond"/>
+              </a:rPr>
+              <a:t>What it means for policy</a:t>
+            </a:r>
+          </a:p>
+        </p:txBody>
+      </p:sp>
+      <p:sp>
+        <p:nvSpPr>
+          <p:cNvPr id="5" name="TextBox 4"/>
           <p:cNvSpPr txBox="1"/>
           <p:nvPr/>
         </p:nvSpPr>
         <p:spPr>
           <a:xfrm>
-            <a:off x="6355080" y="1325880"/>
-            <a:ext cx="5120640" cy="457200"/>
+            <a:off x="1371600" y="4892040"/>
+            <a:ext cx="9445752" cy="731520"/>
           </a:xfrm>
           <a:prstGeom prst="rect">
             <a:avLst/>
@@ -5743,309 +6201,22 @@
           </a:bodyPr>
           <a:lstStyle/>
           <a:p>
-            <a:pPr algn="l">
+            <a:pPr algn="ctr">
               <a:lnSpc>
-                <a:spcPts val="2688"/>
+                <a:spcPts val="2304"/>
               </a:lnSpc>
               <a:spcAft>
                 <a:spcPts val="0"/>
               </a:spcAft>
             </a:pPr>
             <a:r>
-              <a:rPr sz="2100" b="1" i="0">
-                <a:solidFill>
-                  <a:srgbClr val="2D6CB5"/>
-                </a:solidFill>
-                <a:latin typeface="Garamond"/>
-              </a:rPr>
-              <a:t>Medium term and switchers</a:t>
-            </a:r>
-          </a:p>
-        </p:txBody>
-      </p:sp>
-      <p:sp>
-        <p:nvSpPr>
-          <p:cNvPr id="7" name="TextBox 6"/>
-          <p:cNvSpPr txBox="1"/>
-          <p:nvPr/>
-        </p:nvSpPr>
-        <p:spPr>
-          <a:xfrm>
-            <a:off x="6355080" y="1828800"/>
-            <a:ext cx="5120640" cy="1554480"/>
-          </a:xfrm>
-          <a:prstGeom prst="rect">
-            <a:avLst/>
-          </a:prstGeom>
-          <a:noFill/>
-        </p:spPr>
-        <p:txBody>
-          <a:bodyPr wrap="square" lIns="0" rIns="0" tIns="0" bIns="0">
-            <a:spAutoFit/>
-          </a:bodyPr>
-          <a:lstStyle/>
-          <a:p>
-            <a:pPr algn="l">
-              <a:lnSpc>
-                <a:spcPts val="2176"/>
-              </a:lnSpc>
-              <a:spcAft>
-                <a:spcPts val="0"/>
-              </a:spcAft>
-            </a:pPr>
-            <a:r>
-              <a:rPr sz="1700" b="0" i="0">
-                <a:solidFill>
-                  <a:srgbClr val="212529"/>
-                </a:solidFill>
-                <a:latin typeface="Garamond"/>
-              </a:rPr>
-              <a:t>Early-career conditions (secure contracts, fair pay at the bottom) and support (mentoring). Learn why some move to jobs that do not require a degree.</a:t>
-            </a:r>
-          </a:p>
-        </p:txBody>
-      </p:sp>
-      <p:sp>
-        <p:nvSpPr>
-          <p:cNvPr id="8" name="TextBox 7"/>
-          <p:cNvSpPr txBox="1"/>
-          <p:nvPr/>
-        </p:nvSpPr>
-        <p:spPr>
-          <a:xfrm>
-            <a:off x="822960" y="3566160"/>
-            <a:ext cx="5120640" cy="457200"/>
-          </a:xfrm>
-          <a:prstGeom prst="rect">
-            <a:avLst/>
-          </a:prstGeom>
-          <a:noFill/>
-        </p:spPr>
-        <p:txBody>
-          <a:bodyPr wrap="square" lIns="0" rIns="0" tIns="0" bIns="0">
-            <a:spAutoFit/>
-          </a:bodyPr>
-          <a:lstStyle/>
-          <a:p>
-            <a:pPr algn="l">
-              <a:lnSpc>
-                <a:spcPts val="2688"/>
-              </a:lnSpc>
-              <a:spcAft>
-                <a:spcPts val="0"/>
-              </a:spcAft>
-            </a:pPr>
-            <a:r>
-              <a:rPr sz="2100" b="1" i="0">
-                <a:solidFill>
-                  <a:srgbClr val="2D6CB5"/>
-                </a:solidFill>
-                <a:latin typeface="Garamond"/>
-              </a:rPr>
-              <a:t>Long term and early exits</a:t>
-            </a:r>
-          </a:p>
-        </p:txBody>
-      </p:sp>
-      <p:sp>
-        <p:nvSpPr>
-          <p:cNvPr id="9" name="TextBox 8"/>
-          <p:cNvSpPr txBox="1"/>
-          <p:nvPr/>
-        </p:nvSpPr>
-        <p:spPr>
-          <a:xfrm>
-            <a:off x="822960" y="4069080"/>
-            <a:ext cx="5120640" cy="1554480"/>
-          </a:xfrm>
-          <a:prstGeom prst="rect">
-            <a:avLst/>
-          </a:prstGeom>
-          <a:noFill/>
-        </p:spPr>
-        <p:txBody>
-          <a:bodyPr wrap="square" lIns="0" rIns="0" tIns="0" bIns="0">
-            <a:spAutoFit/>
-          </a:bodyPr>
-          <a:lstStyle/>
-          <a:p>
-            <a:pPr algn="l">
-              <a:lnSpc>
-                <a:spcPts val="2176"/>
-              </a:lnSpc>
-              <a:spcAft>
-                <a:spcPts val="0"/>
-              </a:spcAft>
-            </a:pPr>
-            <a:r>
-              <a:rPr sz="1700" b="0" i="0">
-                <a:solidFill>
-                  <a:srgbClr val="212529"/>
-                </a:solidFill>
-                <a:latin typeface="Garamond"/>
-              </a:rPr>
-              <a:t>Flexibility, so those who want to return can do so in favoring conditions, and clear paths to return.</a:t>
-            </a:r>
-          </a:p>
-        </p:txBody>
-      </p:sp>
-      <p:sp>
-        <p:nvSpPr>
-          <p:cNvPr id="10" name="TextBox 9"/>
-          <p:cNvSpPr txBox="1"/>
-          <p:nvPr/>
-        </p:nvSpPr>
-        <p:spPr>
-          <a:xfrm>
-            <a:off x="6355080" y="3566160"/>
-            <a:ext cx="5120640" cy="457200"/>
-          </a:xfrm>
-          <a:prstGeom prst="rect">
-            <a:avLst/>
-          </a:prstGeom>
-          <a:noFill/>
-        </p:spPr>
-        <p:txBody>
-          <a:bodyPr wrap="square" lIns="0" rIns="0" tIns="0" bIns="0">
-            <a:spAutoFit/>
-          </a:bodyPr>
-          <a:lstStyle/>
-          <a:p>
-            <a:pPr algn="l">
-              <a:lnSpc>
-                <a:spcPts val="2688"/>
-              </a:lnSpc>
-              <a:spcAft>
-                <a:spcPts val="0"/>
-              </a:spcAft>
-            </a:pPr>
-            <a:r>
-              <a:rPr sz="2100" b="1" i="0">
-                <a:solidFill>
-                  <a:srgbClr val="2D6CB5"/>
-                </a:solidFill>
-                <a:latin typeface="Garamond"/>
-              </a:rPr>
-              <a:t>Research agenda</a:t>
-            </a:r>
-          </a:p>
-        </p:txBody>
-      </p:sp>
-      <p:sp>
-        <p:nvSpPr>
-          <p:cNvPr id="11" name="TextBox 10"/>
-          <p:cNvSpPr txBox="1"/>
-          <p:nvPr/>
-        </p:nvSpPr>
-        <p:spPr>
-          <a:xfrm>
-            <a:off x="6355080" y="4069080"/>
-            <a:ext cx="5120640" cy="1554480"/>
-          </a:xfrm>
-          <a:prstGeom prst="rect">
-            <a:avLst/>
-          </a:prstGeom>
-          <a:noFill/>
-        </p:spPr>
-        <p:txBody>
-          <a:bodyPr wrap="square" lIns="0" rIns="0" tIns="0" bIns="0">
-            <a:spAutoFit/>
-          </a:bodyPr>
-          <a:lstStyle/>
-          <a:p>
-            <a:pPr algn="l">
-              <a:lnSpc>
-                <a:spcPts val="2176"/>
-              </a:lnSpc>
-              <a:spcAft>
-                <a:spcPts val="0"/>
-              </a:spcAft>
-            </a:pPr>
-            <a:r>
-              <a:rPr sz="1700" b="0" i="0">
-                <a:solidFill>
-                  <a:srgbClr val="212529"/>
-                </a:solidFill>
-                <a:latin typeface="Garamond"/>
-              </a:rPr>
-              <a:t>Working conditions inside schools. Do these patterns hold in other countries?</a:t>
-            </a:r>
-          </a:p>
-        </p:txBody>
-      </p:sp>
-      <p:cxnSp>
-        <p:nvCxnSpPr>
-          <p:cNvPr id="12" name="Connector 11"/>
-          <p:cNvCxnSpPr/>
-          <p:nvPr/>
-        </p:nvCxnSpPr>
-        <p:spPr>
-          <a:xfrm>
-            <a:off x="822960" y="5806440"/>
-            <a:ext cx="10543032" cy="0"/>
-          </a:xfrm>
-          <a:prstGeom prst="line">
-            <a:avLst/>
-          </a:prstGeom>
-          <a:ln w="12700">
-            <a:solidFill>
-              <a:srgbClr val="102D5E"/>
-            </a:solidFill>
-          </a:ln>
-        </p:spPr>
-        <p:style>
-          <a:lnRef idx="2">
-            <a:schemeClr val="accent1"/>
-          </a:lnRef>
-          <a:fillRef idx="0">
-            <a:schemeClr val="accent1"/>
-          </a:fillRef>
-          <a:effectRef idx="1">
-            <a:schemeClr val="accent1"/>
-          </a:effectRef>
-          <a:fontRef idx="minor">
-            <a:schemeClr val="tx1"/>
-          </a:fontRef>
-        </p:style>
-      </p:cxnSp>
-      <p:sp>
-        <p:nvSpPr>
-          <p:cNvPr id="13" name="TextBox 12"/>
-          <p:cNvSpPr txBox="1"/>
-          <p:nvPr/>
-        </p:nvSpPr>
-        <p:spPr>
-          <a:xfrm>
-            <a:off x="822960" y="5989320"/>
-            <a:ext cx="10789920" cy="457200"/>
-          </a:xfrm>
-          <a:prstGeom prst="rect">
-            <a:avLst/>
-          </a:prstGeom>
-          <a:noFill/>
-        </p:spPr>
-        <p:txBody>
-          <a:bodyPr wrap="square" lIns="0" rIns="0" tIns="0" bIns="0">
-            <a:spAutoFit/>
-          </a:bodyPr>
-          <a:lstStyle/>
-          <a:p>
-            <a:pPr algn="ctr">
-              <a:lnSpc>
-                <a:spcPts val="2560"/>
-              </a:lnSpc>
-              <a:spcAft>
-                <a:spcPts val="0"/>
-              </a:spcAft>
-            </a:pPr>
-            <a:r>
-              <a:rPr sz="2000" b="1" i="0">
-                <a:solidFill>
-                  <a:srgbClr val="102D5E"/>
-                </a:solidFill>
-                <a:latin typeface="Garamond"/>
-              </a:rPr>
-              <a:t>Across all three: economic security.</a:t>
+              <a:rPr sz="1800" b="0" i="1">
+                <a:solidFill>
+                  <a:srgbClr val="BED3EE"/>
+                </a:solidFill>
+                <a:latin typeface="Garamond"/>
+              </a:rPr>
+              <a:t>For discussion: what would bring teachers back in your country?</a:t>
             </a:r>
           </a:p>
         </p:txBody>
@@ -6095,7 +6266,7 @@
                 </a:solidFill>
                 <a:latin typeface="Garamond"/>
               </a:rPr>
-              <a:t>Open questions</a:t>
+              <a:t>Policy options for re-attraction</a:t>
             </a:r>
           </a:p>
         </p:txBody>
@@ -6143,8 +6314,8 @@
         </p:nvSpPr>
         <p:spPr>
           <a:xfrm>
-            <a:off x="822960" y="1554480"/>
-            <a:ext cx="10789920" cy="5120640"/>
+            <a:off x="822960" y="1325880"/>
+            <a:ext cx="5120640" cy="457200"/>
           </a:xfrm>
           <a:prstGeom prst="rect">
             <a:avLst/>
@@ -6159,153 +6330,376 @@
           <a:p>
             <a:pPr algn="l">
               <a:lnSpc>
-                <a:spcPts val="2560"/>
+                <a:spcPts val="2688"/>
               </a:lnSpc>
               <a:spcAft>
-                <a:spcPts val="2600"/>
+                <a:spcPts val="0"/>
               </a:spcAft>
             </a:pPr>
             <a:r>
-              <a:rPr sz="2000" b="1" i="0">
+              <a:rPr sz="2100" b="1" i="0">
                 <a:solidFill>
                   <a:srgbClr val="2D6CB5"/>
                 </a:solidFill>
                 <a:latin typeface="Garamond"/>
               </a:rPr>
-              <a:t>▪  </a:t>
-            </a:r>
-            <a:r>
-              <a:rPr sz="2000" b="1" i="0">
-                <a:solidFill>
-                  <a:srgbClr val="102D5E"/>
-                </a:solidFill>
-                <a:latin typeface="Garamond"/>
-              </a:rPr>
-              <a:t>Pay floors.  </a:t>
-            </a:r>
-            <a:r>
-              <a:rPr sz="2000" b="0" i="0">
-                <a:solidFill>
-                  <a:srgbClr val="212529"/>
-                </a:solidFill>
-                <a:latin typeface="Garamond"/>
-              </a:rPr>
-              <a:t>Leaving concentrates in the bottom two pay deciles. Would raising the floor retain more teachers than raising the average?</a:t>
-            </a:r>
-          </a:p>
+              <a:t>Short term and retirees</a:t>
+            </a:r>
+          </a:p>
+        </p:txBody>
+      </p:sp>
+      <p:sp>
+        <p:nvSpPr>
+          <p:cNvPr id="5" name="TextBox 4"/>
+          <p:cNvSpPr txBox="1"/>
+          <p:nvPr/>
+        </p:nvSpPr>
+        <p:spPr>
+          <a:xfrm>
+            <a:off x="822960" y="1828800"/>
+            <a:ext cx="5120640" cy="1554480"/>
+          </a:xfrm>
+          <a:prstGeom prst="rect">
+            <a:avLst/>
+          </a:prstGeom>
+          <a:noFill/>
+        </p:spPr>
+        <p:txBody>
+          <a:bodyPr wrap="square" lIns="0" rIns="0" tIns="0" bIns="0">
+            <a:spAutoFit/>
+          </a:bodyPr>
+          <a:lstStyle/>
           <a:p>
             <a:pPr algn="l">
               <a:lnSpc>
-                <a:spcPts val="2560"/>
+                <a:spcPts val="2176"/>
               </a:lnSpc>
               <a:spcAft>
-                <a:spcPts val="2600"/>
+                <a:spcPts val="0"/>
               </a:spcAft>
             </a:pPr>
             <a:r>
-              <a:rPr sz="2000" b="1" i="0">
-                <a:solidFill>
-                  <a:srgbClr val="2D6CB5"/>
-                </a:solidFill>
-                <a:latin typeface="Garamond"/>
-              </a:rPr>
-              <a:t>▪  </a:t>
-            </a:r>
-            <a:r>
-              <a:rPr sz="2000" b="1" i="0">
-                <a:solidFill>
-                  <a:srgbClr val="102D5E"/>
-                </a:solidFill>
-                <a:latin typeface="Garamond"/>
-              </a:rPr>
-              <a:t>Early careers.  </a:t>
-            </a:r>
-            <a:r>
-              <a:rPr sz="2000" b="0" i="0">
+              <a:rPr sz="1700" b="0" i="0">
                 <a:solidFill>
                   <a:srgbClr val="212529"/>
                 </a:solidFill>
                 <a:latin typeface="Garamond"/>
               </a:rPr>
-              <a:t>Exits peak in the first years of the career. Which policies move this margin — mentoring, stable placements, or pay?</a:t>
-            </a:r>
-          </a:p>
+              <a:t>A reserve for local shortages. They bring experience and can mentor new teachers. Make it easy to return, for example part-time or “double-dipping”.</a:t>
+            </a:r>
+          </a:p>
+        </p:txBody>
+      </p:sp>
+      <p:sp>
+        <p:nvSpPr>
+          <p:cNvPr id="6" name="TextBox 5"/>
+          <p:cNvSpPr txBox="1"/>
+          <p:nvPr/>
+        </p:nvSpPr>
+        <p:spPr>
+          <a:xfrm>
+            <a:off x="6355080" y="1325880"/>
+            <a:ext cx="5120640" cy="457200"/>
+          </a:xfrm>
+          <a:prstGeom prst="rect">
+            <a:avLst/>
+          </a:prstGeom>
+          <a:noFill/>
+        </p:spPr>
+        <p:txBody>
+          <a:bodyPr wrap="square" lIns="0" rIns="0" tIns="0" bIns="0">
+            <a:spAutoFit/>
+          </a:bodyPr>
+          <a:lstStyle/>
           <a:p>
             <a:pPr algn="l">
               <a:lnSpc>
-                <a:spcPts val="2560"/>
+                <a:spcPts val="2688"/>
               </a:lnSpc>
               <a:spcAft>
-                <a:spcPts val="2600"/>
+                <a:spcPts val="0"/>
               </a:spcAft>
             </a:pPr>
             <a:r>
-              <a:rPr sz="2000" b="1" i="0">
+              <a:rPr sz="2100" b="1" i="0">
                 <a:solidFill>
                   <a:srgbClr val="2D6CB5"/>
                 </a:solidFill>
                 <a:latin typeface="Garamond"/>
               </a:rPr>
-              <a:t>▪  </a:t>
-            </a:r>
-            <a:r>
-              <a:rPr sz="2000" b="1" i="0">
-                <a:solidFill>
-                  <a:srgbClr val="102D5E"/>
-                </a:solidFill>
-                <a:latin typeface="Garamond"/>
-              </a:rPr>
-              <a:t>Family exits.  </a:t>
-            </a:r>
-            <a:r>
-              <a:rPr sz="2000" b="0" i="0">
-                <a:solidFill>
-                  <a:srgbClr val="212529"/>
-                </a:solidFill>
-                <a:latin typeface="Garamond"/>
-              </a:rPr>
-              <a:t>Half of the early labor-force exits are mothers with a child at home. Is this an education policy problem or a child-care one?</a:t>
-            </a:r>
-          </a:p>
+              <a:t>Medium term and switchers</a:t>
+            </a:r>
+          </a:p>
+        </p:txBody>
+      </p:sp>
+      <p:sp>
+        <p:nvSpPr>
+          <p:cNvPr id="7" name="TextBox 6"/>
+          <p:cNvSpPr txBox="1"/>
+          <p:nvPr/>
+        </p:nvSpPr>
+        <p:spPr>
+          <a:xfrm>
+            <a:off x="6355080" y="1828800"/>
+            <a:ext cx="5120640" cy="1554480"/>
+          </a:xfrm>
+          <a:prstGeom prst="rect">
+            <a:avLst/>
+          </a:prstGeom>
+          <a:noFill/>
+        </p:spPr>
+        <p:txBody>
+          <a:bodyPr wrap="square" lIns="0" rIns="0" tIns="0" bIns="0">
+            <a:spAutoFit/>
+          </a:bodyPr>
+          <a:lstStyle/>
           <a:p>
             <a:pPr algn="l">
               <a:lnSpc>
-                <a:spcPts val="2560"/>
+                <a:spcPts val="2176"/>
               </a:lnSpc>
               <a:spcAft>
-                <a:spcPts val="2600"/>
+                <a:spcPts val="0"/>
               </a:spcAft>
             </a:pPr>
             <a:r>
-              <a:rPr sz="2000" b="1" i="0">
+              <a:rPr sz="1700" b="0" i="0">
+                <a:solidFill>
+                  <a:srgbClr val="212529"/>
+                </a:solidFill>
+                <a:latin typeface="Garamond"/>
+              </a:rPr>
+              <a:t>Early-career conditions (secure contracts, fair pay at the bottom) and support (mentoring). Learn why some move to jobs that do not require a degree.</a:t>
+            </a:r>
+          </a:p>
+        </p:txBody>
+      </p:sp>
+      <p:sp>
+        <p:nvSpPr>
+          <p:cNvPr id="8" name="TextBox 7"/>
+          <p:cNvSpPr txBox="1"/>
+          <p:nvPr/>
+        </p:nvSpPr>
+        <p:spPr>
+          <a:xfrm>
+            <a:off x="822960" y="3566160"/>
+            <a:ext cx="5120640" cy="457200"/>
+          </a:xfrm>
+          <a:prstGeom prst="rect">
+            <a:avLst/>
+          </a:prstGeom>
+          <a:noFill/>
+        </p:spPr>
+        <p:txBody>
+          <a:bodyPr wrap="square" lIns="0" rIns="0" tIns="0" bIns="0">
+            <a:spAutoFit/>
+          </a:bodyPr>
+          <a:lstStyle/>
+          <a:p>
+            <a:pPr algn="l">
+              <a:lnSpc>
+                <a:spcPts val="2688"/>
+              </a:lnSpc>
+              <a:spcAft>
+                <a:spcPts val="0"/>
+              </a:spcAft>
+            </a:pPr>
+            <a:r>
+              <a:rPr sz="2100" b="1" i="0">
                 <a:solidFill>
                   <a:srgbClr val="2D6CB5"/>
                 </a:solidFill>
                 <a:latin typeface="Garamond"/>
               </a:rPr>
-              <a:t>▪  </a:t>
-            </a:r>
-            <a:r>
-              <a:rPr sz="2000" b="1" i="0">
-                <a:solidFill>
-                  <a:srgbClr val="102D5E"/>
-                </a:solidFill>
-                <a:latin typeface="Garamond"/>
-              </a:rPr>
-              <a:t>Re-entry.  </a:t>
-            </a:r>
-            <a:r>
-              <a:rPr sz="2000" b="0" i="0">
+              <a:t>Long term and early exits</a:t>
+            </a:r>
+          </a:p>
+        </p:txBody>
+      </p:sp>
+      <p:sp>
+        <p:nvSpPr>
+          <p:cNvPr id="9" name="TextBox 8"/>
+          <p:cNvSpPr txBox="1"/>
+          <p:nvPr/>
+        </p:nvSpPr>
+        <p:spPr>
+          <a:xfrm>
+            <a:off x="822960" y="4069080"/>
+            <a:ext cx="5120640" cy="1554480"/>
+          </a:xfrm>
+          <a:prstGeom prst="rect">
+            <a:avLst/>
+          </a:prstGeom>
+          <a:noFill/>
+        </p:spPr>
+        <p:txBody>
+          <a:bodyPr wrap="square" lIns="0" rIns="0" tIns="0" bIns="0">
+            <a:spAutoFit/>
+          </a:bodyPr>
+          <a:lstStyle/>
+          <a:p>
+            <a:pPr algn="l">
+              <a:lnSpc>
+                <a:spcPts val="2176"/>
+              </a:lnSpc>
+              <a:spcAft>
+                <a:spcPts val="0"/>
+              </a:spcAft>
+            </a:pPr>
+            <a:r>
+              <a:rPr sz="1700" b="0" i="0">
                 <a:solidFill>
                   <a:srgbClr val="212529"/>
                 </a:solidFill>
                 <a:latin typeface="Garamond"/>
               </a:rPr>
-              <a:t>The young leave to study and mothers leave to care. How many could come back, and what would bring them back?</a:t>
-            </a:r>
-          </a:p>
+              <a:t>Flexibility, so those who want to return can do so in favoring conditions, and clear paths to return.</a:t>
+            </a:r>
+          </a:p>
+        </p:txBody>
+      </p:sp>
+      <p:sp>
+        <p:nvSpPr>
+          <p:cNvPr id="10" name="TextBox 9"/>
+          <p:cNvSpPr txBox="1"/>
+          <p:nvPr/>
+        </p:nvSpPr>
+        <p:spPr>
+          <a:xfrm>
+            <a:off x="6355080" y="3566160"/>
+            <a:ext cx="5120640" cy="457200"/>
+          </a:xfrm>
+          <a:prstGeom prst="rect">
+            <a:avLst/>
+          </a:prstGeom>
+          <a:noFill/>
+        </p:spPr>
+        <p:txBody>
+          <a:bodyPr wrap="square" lIns="0" rIns="0" tIns="0" bIns="0">
+            <a:spAutoFit/>
+          </a:bodyPr>
+          <a:lstStyle/>
           <a:p>
             <a:pPr algn="l">
+              <a:lnSpc>
+                <a:spcPts val="2688"/>
+              </a:lnSpc>
+              <a:spcAft>
+                <a:spcPts val="0"/>
+              </a:spcAft>
+            </a:pPr>
+            <a:r>
+              <a:rPr sz="2100" b="1" i="0">
+                <a:solidFill>
+                  <a:srgbClr val="2D6CB5"/>
+                </a:solidFill>
+                <a:latin typeface="Garamond"/>
+              </a:rPr>
+              <a:t>Research agenda</a:t>
+            </a:r>
+          </a:p>
+        </p:txBody>
+      </p:sp>
+      <p:sp>
+        <p:nvSpPr>
+          <p:cNvPr id="11" name="TextBox 10"/>
+          <p:cNvSpPr txBox="1"/>
+          <p:nvPr/>
+        </p:nvSpPr>
+        <p:spPr>
+          <a:xfrm>
+            <a:off x="6355080" y="4069080"/>
+            <a:ext cx="5120640" cy="1554480"/>
+          </a:xfrm>
+          <a:prstGeom prst="rect">
+            <a:avLst/>
+          </a:prstGeom>
+          <a:noFill/>
+        </p:spPr>
+        <p:txBody>
+          <a:bodyPr wrap="square" lIns="0" rIns="0" tIns="0" bIns="0">
+            <a:spAutoFit/>
+          </a:bodyPr>
+          <a:lstStyle/>
+          <a:p>
+            <a:pPr algn="l">
+              <a:lnSpc>
+                <a:spcPts val="2176"/>
+              </a:lnSpc>
+              <a:spcAft>
+                <a:spcPts val="0"/>
+              </a:spcAft>
+            </a:pPr>
+            <a:r>
+              <a:rPr sz="1700" b="0" i="0">
+                <a:solidFill>
+                  <a:srgbClr val="212529"/>
+                </a:solidFill>
+                <a:latin typeface="Garamond"/>
+              </a:rPr>
+              <a:t>Working conditions inside schools. Do these patterns hold in other countries?</a:t>
+            </a:r>
+          </a:p>
+        </p:txBody>
+      </p:sp>
+      <p:cxnSp>
+        <p:nvCxnSpPr>
+          <p:cNvPr id="12" name="Connector 11"/>
+          <p:cNvCxnSpPr/>
+          <p:nvPr/>
+        </p:nvCxnSpPr>
+        <p:spPr>
+          <a:xfrm>
+            <a:off x="822960" y="5806440"/>
+            <a:ext cx="10543032" cy="0"/>
+          </a:xfrm>
+          <a:prstGeom prst="line">
+            <a:avLst/>
+          </a:prstGeom>
+          <a:ln w="12700">
+            <a:solidFill>
+              <a:srgbClr val="102D5E"/>
+            </a:solidFill>
+          </a:ln>
+        </p:spPr>
+        <p:style>
+          <a:lnRef idx="2">
+            <a:schemeClr val="accent1"/>
+          </a:lnRef>
+          <a:fillRef idx="0">
+            <a:schemeClr val="accent1"/>
+          </a:fillRef>
+          <a:effectRef idx="1">
+            <a:schemeClr val="accent1"/>
+          </a:effectRef>
+          <a:fontRef idx="minor">
+            <a:schemeClr val="tx1"/>
+          </a:fontRef>
+        </p:style>
+      </p:cxnSp>
+      <p:sp>
+        <p:nvSpPr>
+          <p:cNvPr id="13" name="TextBox 12"/>
+          <p:cNvSpPr txBox="1"/>
+          <p:nvPr/>
+        </p:nvSpPr>
+        <p:spPr>
+          <a:xfrm>
+            <a:off x="822960" y="5989320"/>
+            <a:ext cx="10789920" cy="457200"/>
+          </a:xfrm>
+          <a:prstGeom prst="rect">
+            <a:avLst/>
+          </a:prstGeom>
+          <a:noFill/>
+        </p:spPr>
+        <p:txBody>
+          <a:bodyPr wrap="square" lIns="0" rIns="0" tIns="0" bIns="0">
+            <a:spAutoFit/>
+          </a:bodyPr>
+          <a:lstStyle/>
+          <a:p>
+            <a:pPr algn="ctr">
               <a:lnSpc>
                 <a:spcPts val="2560"/>
               </a:lnSpc>
@@ -6316,29 +6710,11 @@
             <a:r>
               <a:rPr sz="2000" b="1" i="0">
                 <a:solidFill>
-                  <a:srgbClr val="2D6CB5"/>
-                </a:solidFill>
-                <a:latin typeface="Garamond"/>
-              </a:rPr>
-              <a:t>▪  </a:t>
-            </a:r>
-            <a:r>
-              <a:rPr sz="2000" b="1" i="0">
-                <a:solidFill>
                   <a:srgbClr val="102D5E"/>
                 </a:solidFill>
                 <a:latin typeface="Garamond"/>
               </a:rPr>
-              <a:t>What we cannot see.  </a:t>
-            </a:r>
-            <a:r>
-              <a:rPr sz="2000" b="0" i="0">
-                <a:solidFill>
-                  <a:srgbClr val="212529"/>
-                </a:solidFill>
-                <a:latin typeface="Garamond"/>
-              </a:rPr>
-              <a:t>Working conditions and school climate are invisible in household data. What would it take to measure them every year?</a:t>
+              <a:t>Across all three: economic security.</a:t>
             </a:r>
           </a:p>
         </p:txBody>
@@ -6666,6 +7042,299 @@
                 <a:latin typeface="Garamond"/>
               </a:rPr>
               <a:t>The US official rate (NCES Teacher Follow-up Survey) appears only every 4–9 years, not annually.</a:t>
+            </a:r>
+          </a:p>
+        </p:txBody>
+      </p:sp>
+    </p:spTree>
+  </p:cSld>
+  <p:clrMapOvr>
+    <a:masterClrMapping/>
+  </p:clrMapOvr>
+</p:sld>
+</file>
+
+<file path=ppt/slides/slide20.xml><?xml version="1.0" encoding="utf-8"?>
+<p:sld xmlns:a="http://schemas.openxmlformats.org/drawingml/2006/main" xmlns:p="http://schemas.openxmlformats.org/presentationml/2006/main" xmlns:r="http://schemas.openxmlformats.org/officeDocument/2006/relationships">
+  <p:cSld>
+    <p:spTree>
+      <p:nvGrpSpPr>
+        <p:cNvPr id="1" name=""/>
+        <p:cNvGrpSpPr/>
+        <p:nvPr/>
+      </p:nvGrpSpPr>
+      <p:grpSpPr/>
+      <p:sp>
+        <p:nvSpPr>
+          <p:cNvPr id="2" name="TextBox 1"/>
+          <p:cNvSpPr txBox="1"/>
+          <p:nvPr/>
+        </p:nvSpPr>
+        <p:spPr>
+          <a:xfrm>
+            <a:off x="502920" y="219456"/>
+            <a:ext cx="11247120" cy="566928"/>
+          </a:xfrm>
+          <a:prstGeom prst="rect">
+            <a:avLst/>
+          </a:prstGeom>
+          <a:noFill/>
+        </p:spPr>
+        <p:txBody>
+          <a:bodyPr wrap="square" lIns="0" rIns="0" tIns="0" bIns="0"/>
+          <a:lstStyle/>
+          <a:p>
+            <a:r>
+              <a:rPr sz="2800" b="1">
+                <a:solidFill>
+                  <a:srgbClr val="102D5E"/>
+                </a:solidFill>
+                <a:latin typeface="Garamond"/>
+              </a:rPr>
+              <a:t>Open questions</a:t>
+            </a:r>
+          </a:p>
+        </p:txBody>
+      </p:sp>
+      <p:sp>
+        <p:nvSpPr>
+          <p:cNvPr id="3" name="TextBox 2"/>
+          <p:cNvSpPr txBox="1"/>
+          <p:nvPr/>
+        </p:nvSpPr>
+        <p:spPr>
+          <a:xfrm>
+            <a:off x="11384280" y="6446520"/>
+            <a:ext cx="640080" cy="292608"/>
+          </a:xfrm>
+          <a:prstGeom prst="rect">
+            <a:avLst/>
+          </a:prstGeom>
+          <a:noFill/>
+        </p:spPr>
+        <p:txBody>
+          <a:bodyPr wrap="none" lIns="0" rIns="0" tIns="0" bIns="0">
+            <a:spAutoFit/>
+          </a:bodyPr>
+          <a:lstStyle/>
+          <a:p>
+            <a:pPr algn="r"/>
+            <a:r>
+              <a:rPr sz="1100">
+                <a:solidFill>
+                  <a:srgbClr val="6B7480"/>
+                </a:solidFill>
+                <a:latin typeface="Garamond"/>
+              </a:rPr>
+              <a:t>20</a:t>
+            </a:r>
+          </a:p>
+        </p:txBody>
+      </p:sp>
+      <p:sp>
+        <p:nvSpPr>
+          <p:cNvPr id="4" name="TextBox 3"/>
+          <p:cNvSpPr txBox="1"/>
+          <p:nvPr/>
+        </p:nvSpPr>
+        <p:spPr>
+          <a:xfrm>
+            <a:off x="822960" y="1554480"/>
+            <a:ext cx="10789920" cy="5120640"/>
+          </a:xfrm>
+          <a:prstGeom prst="rect">
+            <a:avLst/>
+          </a:prstGeom>
+          <a:noFill/>
+        </p:spPr>
+        <p:txBody>
+          <a:bodyPr wrap="square" lIns="0" rIns="0" tIns="0" bIns="0">
+            <a:spAutoFit/>
+          </a:bodyPr>
+          <a:lstStyle/>
+          <a:p>
+            <a:pPr algn="l">
+              <a:lnSpc>
+                <a:spcPts val="2560"/>
+              </a:lnSpc>
+              <a:spcAft>
+                <a:spcPts val="2600"/>
+              </a:spcAft>
+            </a:pPr>
+            <a:r>
+              <a:rPr sz="2000" b="1" i="0">
+                <a:solidFill>
+                  <a:srgbClr val="2D6CB5"/>
+                </a:solidFill>
+                <a:latin typeface="Garamond"/>
+              </a:rPr>
+              <a:t>▪  </a:t>
+            </a:r>
+            <a:r>
+              <a:rPr sz="2000" b="1" i="0">
+                <a:solidFill>
+                  <a:srgbClr val="102D5E"/>
+                </a:solidFill>
+                <a:latin typeface="Garamond"/>
+              </a:rPr>
+              <a:t>Pay floors.  </a:t>
+            </a:r>
+            <a:r>
+              <a:rPr sz="2000" b="0" i="0">
+                <a:solidFill>
+                  <a:srgbClr val="212529"/>
+                </a:solidFill>
+                <a:latin typeface="Garamond"/>
+              </a:rPr>
+              <a:t>Leaving concentrates in the bottom two pay deciles. Would raising the floor retain more teachers than raising the average?</a:t>
+            </a:r>
+          </a:p>
+          <a:p>
+            <a:pPr algn="l">
+              <a:lnSpc>
+                <a:spcPts val="2560"/>
+              </a:lnSpc>
+              <a:spcAft>
+                <a:spcPts val="2600"/>
+              </a:spcAft>
+            </a:pPr>
+            <a:r>
+              <a:rPr sz="2000" b="1" i="0">
+                <a:solidFill>
+                  <a:srgbClr val="2D6CB5"/>
+                </a:solidFill>
+                <a:latin typeface="Garamond"/>
+              </a:rPr>
+              <a:t>▪  </a:t>
+            </a:r>
+            <a:r>
+              <a:rPr sz="2000" b="1" i="0">
+                <a:solidFill>
+                  <a:srgbClr val="102D5E"/>
+                </a:solidFill>
+                <a:latin typeface="Garamond"/>
+              </a:rPr>
+              <a:t>Early careers.  </a:t>
+            </a:r>
+            <a:r>
+              <a:rPr sz="2000" b="0" i="0">
+                <a:solidFill>
+                  <a:srgbClr val="212529"/>
+                </a:solidFill>
+                <a:latin typeface="Garamond"/>
+              </a:rPr>
+              <a:t>Exits peak in the first years of the career. Which policies move this margin — mentoring, stable placements, or pay?</a:t>
+            </a:r>
+          </a:p>
+          <a:p>
+            <a:pPr algn="l">
+              <a:lnSpc>
+                <a:spcPts val="2560"/>
+              </a:lnSpc>
+              <a:spcAft>
+                <a:spcPts val="2600"/>
+              </a:spcAft>
+            </a:pPr>
+            <a:r>
+              <a:rPr sz="2000" b="1" i="0">
+                <a:solidFill>
+                  <a:srgbClr val="2D6CB5"/>
+                </a:solidFill>
+                <a:latin typeface="Garamond"/>
+              </a:rPr>
+              <a:t>▪  </a:t>
+            </a:r>
+            <a:r>
+              <a:rPr sz="2000" b="1" i="0">
+                <a:solidFill>
+                  <a:srgbClr val="102D5E"/>
+                </a:solidFill>
+                <a:latin typeface="Garamond"/>
+              </a:rPr>
+              <a:t>Family exits.  </a:t>
+            </a:r>
+            <a:r>
+              <a:rPr sz="2000" b="0" i="0">
+                <a:solidFill>
+                  <a:srgbClr val="212529"/>
+                </a:solidFill>
+                <a:latin typeface="Garamond"/>
+              </a:rPr>
+              <a:t>Half of the early labor-force exits are mothers with a child at home. Is this an education policy problem or a child-care one?</a:t>
+            </a:r>
+          </a:p>
+          <a:p>
+            <a:pPr algn="l">
+              <a:lnSpc>
+                <a:spcPts val="2560"/>
+              </a:lnSpc>
+              <a:spcAft>
+                <a:spcPts val="2600"/>
+              </a:spcAft>
+            </a:pPr>
+            <a:r>
+              <a:rPr sz="2000" b="1" i="0">
+                <a:solidFill>
+                  <a:srgbClr val="2D6CB5"/>
+                </a:solidFill>
+                <a:latin typeface="Garamond"/>
+              </a:rPr>
+              <a:t>▪  </a:t>
+            </a:r>
+            <a:r>
+              <a:rPr sz="2000" b="1" i="0">
+                <a:solidFill>
+                  <a:srgbClr val="102D5E"/>
+                </a:solidFill>
+                <a:latin typeface="Garamond"/>
+              </a:rPr>
+              <a:t>Re-entry.  </a:t>
+            </a:r>
+            <a:r>
+              <a:rPr sz="2000" b="0" i="0">
+                <a:solidFill>
+                  <a:srgbClr val="212529"/>
+                </a:solidFill>
+                <a:latin typeface="Garamond"/>
+              </a:rPr>
+              <a:t>The young leave to study and mothers leave to care. How many could come back, and what would bring them back?</a:t>
+            </a:r>
+          </a:p>
+          <a:p>
+            <a:pPr algn="l">
+              <a:lnSpc>
+                <a:spcPts val="2560"/>
+              </a:lnSpc>
+              <a:spcAft>
+                <a:spcPts val="0"/>
+              </a:spcAft>
+            </a:pPr>
+            <a:r>
+              <a:rPr sz="2000" b="1" i="0">
+                <a:solidFill>
+                  <a:srgbClr val="2D6CB5"/>
+                </a:solidFill>
+                <a:latin typeface="Garamond"/>
+              </a:rPr>
+              <a:t>▪  </a:t>
+            </a:r>
+            <a:r>
+              <a:rPr sz="2000" b="1" i="0">
+                <a:solidFill>
+                  <a:srgbClr val="102D5E"/>
+                </a:solidFill>
+                <a:latin typeface="Garamond"/>
+              </a:rPr>
+              <a:t>What we cannot see.  </a:t>
+            </a:r>
+            <a:r>
+              <a:rPr sz="2000" b="0" i="0">
+                <a:solidFill>
+                  <a:srgbClr val="212529"/>
+                </a:solidFill>
+                <a:latin typeface="Garamond"/>
+              </a:rPr>
+              <a:t>Working conditions and school climate are invisible in household data. What would it take to measure them every year?</a:t>
             </a:r>
           </a:p>
         </p:txBody>
@@ -9835,4 +10504,324 @@
   </a:objectDefaults>
   <a:extraClrSchemeLst/>
 </a:theme>
+</file>
+
+<file path=ppt/theme/theme2.xml><?xml version="1.0" encoding="utf-8"?>
+<a:theme xmlns:a="http://schemas.openxmlformats.org/drawingml/2006/main" name="Office Theme">
+  <a:themeElements>
+    <a:clrScheme name="Office">
+      <a:dk1>
+        <a:sysClr val="windowText" lastClr="000000"/>
+      </a:dk1>
+      <a:lt1>
+        <a:sysClr val="window" lastClr="FFFFFF"/>
+      </a:lt1>
+      <a:dk2>
+        <a:srgbClr val="1F497D"/>
+      </a:dk2>
+      <a:lt2>
+        <a:srgbClr val="EEECE1"/>
+      </a:lt2>
+      <a:accent1>
+        <a:srgbClr val="4F81BD"/>
+      </a:accent1>
+      <a:accent2>
+        <a:srgbClr val="C0504D"/>
+      </a:accent2>
+      <a:accent3>
+        <a:srgbClr val="9BBB59"/>
+      </a:accent3>
+      <a:accent4>
+        <a:srgbClr val="8064A2"/>
+      </a:accent4>
+      <a:accent5>
+        <a:srgbClr val="4BACC6"/>
+      </a:accent5>
+      <a:accent6>
+        <a:srgbClr val="F79646"/>
+      </a:accent6>
+      <a:hlink>
+        <a:srgbClr val="0000FF"/>
+      </a:hlink>
+      <a:folHlink>
+        <a:srgbClr val="800080"/>
+      </a:folHlink>
+    </a:clrScheme>
+    <a:fontScheme name="Office">
+      <a:majorFont>
+        <a:latin typeface="Calibri"/>
+        <a:ea typeface=""/>
+        <a:cs typeface=""/>
+        <a:font script="Jpan" typeface="ＭＳ Ｐゴシック"/>
+        <a:font script="Hang" typeface="맑은 고딕"/>
+        <a:font script="Hans" typeface="宋体"/>
+        <a:font script="Hant" typeface="新細明體"/>
+        <a:font script="Arab" typeface="Times New Roman"/>
+        <a:font script="Hebr" typeface="Times New Roman"/>
+        <a:font script="Thai" typeface="Angsana New"/>
+        <a:font script="Ethi" typeface="Nyala"/>
+        <a:font script="Beng" typeface="Vrinda"/>
+        <a:font script="Gujr" typeface="Shruti"/>
+        <a:font script="Khmr" typeface="MoolBoran"/>
+        <a:font script="Knda" typeface="Tunga"/>
+        <a:font script="Guru" typeface="Raavi"/>
+        <a:font script="Cans" typeface="Euphemia"/>
+        <a:font script="Cher" typeface="Plantagenet Cherokee"/>
+        <a:font script="Yiii" typeface="Microsoft Yi Baiti"/>
+        <a:font script="Tibt" typeface="Microsoft Himalaya"/>
+        <a:font script="Thaa" typeface="MV Boli"/>
+        <a:font script="Deva" typeface="Mangal"/>
+        <a:font script="Telu" typeface="Gautami"/>
+        <a:font script="Taml" typeface="Latha"/>
+        <a:font script="Syrc" typeface="Estrangelo Edessa"/>
+        <a:font script="Orya" typeface="Kalinga"/>
+        <a:font script="Mlym" typeface="Kartika"/>
+        <a:font script="Laoo" typeface="DokChampa"/>
+        <a:font script="Sinh" typeface="Iskoola Pota"/>
+        <a:font script="Mong" typeface="Mongolian Baiti"/>
+        <a:font script="Viet" typeface="Times New Roman"/>
+        <a:font script="Uigh" typeface="Microsoft Uighur"/>
+        <a:font script="Geor" typeface="Sylfaen"/>
+      </a:majorFont>
+      <a:minorFont>
+        <a:latin typeface="Calibri"/>
+        <a:ea typeface=""/>
+        <a:cs typeface=""/>
+        <a:font script="Jpan" typeface="ＭＳ Ｐゴシック"/>
+        <a:font script="Hang" typeface="맑은 고딕"/>
+        <a:font script="Hans" typeface="宋体"/>
+        <a:font script="Hant" typeface="新細明體"/>
+        <a:font script="Arab" typeface="Arial"/>
+        <a:font script="Hebr" typeface="Arial"/>
+        <a:font script="Thai" typeface="Cordia New"/>
+        <a:font script="Ethi" typeface="Nyala"/>
+        <a:font script="Beng" typeface="Vrinda"/>
+        <a:font script="Gujr" typeface="Shruti"/>
+        <a:font script="Khmr" typeface="DaunPenh"/>
+        <a:font script="Knda" typeface="Tunga"/>
+        <a:font script="Guru" typeface="Raavi"/>
+        <a:font script="Cans" typeface="Euphemia"/>
+        <a:font script="Cher" typeface="Plantagenet Cherokee"/>
+        <a:font script="Yiii" typeface="Microsoft Yi Baiti"/>
+        <a:font script="Tibt" typeface="Microsoft Himalaya"/>
+        <a:font script="Thaa" typeface="MV Boli"/>
+        <a:font script="Deva" typeface="Mangal"/>
+        <a:font script="Telu" typeface="Gautami"/>
+        <a:font script="Taml" typeface="Latha"/>
+        <a:font script="Syrc" typeface="Estrangelo Edessa"/>
+        <a:font script="Orya" typeface="Kalinga"/>
+        <a:font script="Mlym" typeface="Kartika"/>
+        <a:font script="Laoo" typeface="DokChampa"/>
+        <a:font script="Sinh" typeface="Iskoola Pota"/>
+        <a:font script="Mong" typeface="Mongolian Baiti"/>
+        <a:font script="Viet" typeface="Arial"/>
+        <a:font script="Uigh" typeface="Microsoft Uighur"/>
+        <a:font script="Geor" typeface="Sylfaen"/>
+      </a:minorFont>
+    </a:fontScheme>
+    <a:fmtScheme name="Office">
+      <a:fillStyleLst>
+        <a:solidFill>
+          <a:schemeClr val="phClr"/>
+        </a:solidFill>
+        <a:gradFill rotWithShape="1">
+          <a:gsLst>
+            <a:gs pos="0">
+              <a:schemeClr val="phClr">
+                <a:tint val="50000"/>
+                <a:satMod val="300000"/>
+              </a:schemeClr>
+            </a:gs>
+            <a:gs pos="35000">
+              <a:schemeClr val="phClr">
+                <a:tint val="37000"/>
+                <a:satMod val="300000"/>
+              </a:schemeClr>
+            </a:gs>
+            <a:gs pos="100000">
+              <a:schemeClr val="phClr">
+                <a:tint val="15000"/>
+                <a:satMod val="350000"/>
+              </a:schemeClr>
+            </a:gs>
+          </a:gsLst>
+          <a:lin ang="16200000" scaled="1"/>
+        </a:gradFill>
+        <a:gradFill rotWithShape="1">
+          <a:gsLst>
+            <a:gs pos="0">
+              <a:schemeClr val="phClr">
+                <a:tint val="100000"/>
+                <a:shade val="100000"/>
+                <a:satMod val="130000"/>
+              </a:schemeClr>
+            </a:gs>
+            <a:gs pos="100000">
+              <a:schemeClr val="phClr">
+                <a:tint val="50000"/>
+                <a:shade val="100000"/>
+                <a:satMod val="350000"/>
+              </a:schemeClr>
+            </a:gs>
+          </a:gsLst>
+          <a:lin ang="16200000" scaled="0"/>
+        </a:gradFill>
+      </a:fillStyleLst>
+      <a:lnStyleLst>
+        <a:ln w="9525" cap="flat" cmpd="sng" algn="ctr">
+          <a:solidFill>
+            <a:schemeClr val="phClr">
+              <a:shade val="95000"/>
+              <a:satMod val="105000"/>
+            </a:schemeClr>
+          </a:solidFill>
+          <a:prstDash val="solid"/>
+        </a:ln>
+        <a:ln w="25400" cap="flat" cmpd="sng" algn="ctr">
+          <a:solidFill>
+            <a:schemeClr val="phClr"/>
+          </a:solidFill>
+          <a:prstDash val="solid"/>
+        </a:ln>
+        <a:ln w="38100" cap="flat" cmpd="sng" algn="ctr">
+          <a:solidFill>
+            <a:schemeClr val="phClr"/>
+          </a:solidFill>
+          <a:prstDash val="solid"/>
+        </a:ln>
+      </a:lnStyleLst>
+      <a:effectStyleLst>
+        <a:effectStyle>
+          <a:effectLst>
+            <a:outerShdw blurRad="40000" dist="20000" dir="5400000" rotWithShape="0">
+              <a:srgbClr val="000000">
+                <a:alpha val="38000"/>
+              </a:srgbClr>
+            </a:outerShdw>
+          </a:effectLst>
+        </a:effectStyle>
+        <a:effectStyle>
+          <a:effectLst>
+            <a:outerShdw blurRad="40000" dist="23000" dir="5400000" rotWithShape="0">
+              <a:srgbClr val="000000">
+                <a:alpha val="35000"/>
+              </a:srgbClr>
+            </a:outerShdw>
+          </a:effectLst>
+        </a:effectStyle>
+        <a:effectStyle>
+          <a:effectLst>
+            <a:outerShdw blurRad="40000" dist="23000" dir="5400000" rotWithShape="0">
+              <a:srgbClr val="000000">
+                <a:alpha val="35000"/>
+              </a:srgbClr>
+            </a:outerShdw>
+          </a:effectLst>
+          <a:scene3d>
+            <a:camera prst="orthographicFront">
+              <a:rot lat="0" lon="0" rev="0"/>
+            </a:camera>
+            <a:lightRig rig="threePt" dir="t">
+              <a:rot lat="0" lon="0" rev="1200000"/>
+            </a:lightRig>
+          </a:scene3d>
+          <a:sp3d>
+            <a:bevelT w="63500" h="25400"/>
+          </a:sp3d>
+        </a:effectStyle>
+      </a:effectStyleLst>
+      <a:bgFillStyleLst>
+        <a:solidFill>
+          <a:schemeClr val="phClr"/>
+        </a:solidFill>
+        <a:gradFill rotWithShape="1">
+          <a:gsLst>
+            <a:gs pos="0">
+              <a:schemeClr val="phClr">
+                <a:tint val="40000"/>
+                <a:satMod val="350000"/>
+              </a:schemeClr>
+            </a:gs>
+            <a:gs pos="40000">
+              <a:schemeClr val="phClr">
+                <a:tint val="45000"/>
+                <a:shade val="99000"/>
+                <a:satMod val="350000"/>
+              </a:schemeClr>
+            </a:gs>
+            <a:gs pos="100000">
+              <a:schemeClr val="phClr">
+                <a:shade val="20000"/>
+                <a:satMod val="255000"/>
+              </a:schemeClr>
+            </a:gs>
+          </a:gsLst>
+          <a:path path="circle">
+            <a:fillToRect l="50000" t="-80000" r="50000" b="180000"/>
+          </a:path>
+        </a:gradFill>
+        <a:gradFill rotWithShape="1">
+          <a:gsLst>
+            <a:gs pos="0">
+              <a:schemeClr val="phClr">
+                <a:tint val="80000"/>
+                <a:satMod val="300000"/>
+              </a:schemeClr>
+            </a:gs>
+            <a:gs pos="100000">
+              <a:schemeClr val="phClr">
+                <a:shade val="30000"/>
+                <a:satMod val="200000"/>
+              </a:schemeClr>
+            </a:gs>
+          </a:gsLst>
+          <a:path path="circle">
+            <a:fillToRect l="50000" t="50000" r="50000" b="50000"/>
+          </a:path>
+        </a:gradFill>
+      </a:bgFillStyleLst>
+    </a:fmtScheme>
+  </a:themeElements>
+  <a:objectDefaults>
+    <a:spDef>
+      <a:spPr/>
+      <a:bodyPr/>
+      <a:lstStyle/>
+      <a:style>
+        <a:lnRef idx="1">
+          <a:schemeClr val="accent1"/>
+        </a:lnRef>
+        <a:fillRef idx="3">
+          <a:schemeClr val="accent1"/>
+        </a:fillRef>
+        <a:effectRef idx="2">
+          <a:schemeClr val="accent1"/>
+        </a:effectRef>
+        <a:fontRef idx="minor">
+          <a:schemeClr val="lt1"/>
+        </a:fontRef>
+      </a:style>
+    </a:spDef>
+    <a:lnDef>
+      <a:spPr/>
+      <a:bodyPr/>
+      <a:lstStyle/>
+      <a:style>
+        <a:lnRef idx="2">
+          <a:schemeClr val="accent1"/>
+        </a:lnRef>
+        <a:fillRef idx="0">
+          <a:schemeClr val="accent1"/>
+        </a:fillRef>
+        <a:effectRef idx="1">
+          <a:schemeClr val="accent1"/>
+        </a:effectRef>
+        <a:fontRef idx="minor">
+          <a:schemeClr val="tx1"/>
+        </a:fontRef>
+      </a:style>
+    </a:lnDef>
+  </a:objectDefaults>
+  <a:extraClrSchemeLst/>
+</a:theme>
 </file>
</xml_diff>